<commit_message>
docs: enable offline PowerPoint Morph architecture camera transitions
</commit_message>
<xml_diff>
--- a/doc/presentation/운영진단_에이전트_5분발표.pptx
+++ b/doc/presentation/운영진단_에이전트_5분발표.pptx
@@ -7956,7 +7956,7 @@
     </p:bg>
     <p:spTree>
       <p:nvGrpSpPr>
-        <p:cNvPr id="1" name=""/>
+        <p:cNvPr id="1" name="!!Slide03_Object1"/>
         <p:cNvGrpSpPr/>
         <p:nvPr/>
       </p:nvGrpSpPr>
@@ -7970,7 +7970,7 @@
       </p:grpSpPr>
       <p:sp>
         <p:nvSpPr>
-          <p:cNvPr name="TextBox 2" id="2"/>
+          <p:cNvPr name="!!Slide03_Object2" id="2"/>
           <p:cNvSpPr txBox="true"/>
           <p:nvPr/>
         </p:nvSpPr>
@@ -8011,7 +8011,7 @@
       </p:sp>
       <p:sp>
         <p:nvSpPr>
-          <p:cNvPr name="TextBox 3" id="3"/>
+          <p:cNvPr name="!!Slide03_Object3" id="3"/>
           <p:cNvSpPr txBox="true"/>
           <p:nvPr/>
         </p:nvSpPr>
@@ -8052,7 +8052,7 @@
       </p:sp>
       <p:sp>
         <p:nvSpPr>
-          <p:cNvPr name="AutoShape 4" id="4"/>
+          <p:cNvPr name="!!Slide03_Object4" id="4"/>
           <p:cNvSpPr/>
           <p:nvPr/>
         </p:nvSpPr>
@@ -8076,7 +8076,7 @@
       </p:sp>
       <p:sp>
         <p:nvSpPr>
-          <p:cNvPr name="TextBox 5" id="5"/>
+          <p:cNvPr name="!!Slide03_Object5" id="5"/>
           <p:cNvSpPr txBox="true"/>
           <p:nvPr/>
         </p:nvSpPr>
@@ -8117,7 +8117,7 @@
       </p:sp>
       <p:sp>
         <p:nvSpPr>
-          <p:cNvPr name="TextBox 6" id="6"/>
+          <p:cNvPr name="!!Slide03_Object6" id="6"/>
           <p:cNvSpPr txBox="true"/>
           <p:nvPr/>
         </p:nvSpPr>
@@ -8156,67 +8156,34 @@
           </a:p>
         </p:txBody>
       </p:sp>
-      <p:grpSp>
-        <p:nvGrpSpPr>
-          <p:cNvPr name="Group 7" id="7"/>
-          <p:cNvGrpSpPr/>
+      <p:pic>
+        <p:nvPicPr>
+          <p:cNvPr id="7" name="!!ArchitectureCamera" descr="같은 아키텍처 원본 이미지. PowerPoint 변환(Morph)으로 확대·이동."/>
+          <p:cNvPicPr>
+            <a:picLocks noChangeAspect="1"/>
+          </p:cNvPicPr>
           <p:nvPr/>
-        </p:nvGrpSpPr>
-        <p:grpSpPr>
-          <a:xfrm rot="0">
+        </p:nvPicPr>
+        <p:blipFill>
+          <a:blip r:embed="rId3"/>
+          <a:srcRect l="0" t="0" r="0" b="0"/>
+          <a:stretch>
+            <a:fillRect/>
+          </a:stretch>
+        </p:blipFill>
+        <p:spPr>
+          <a:xfrm>
             <a:off x="3050257" y="2381250"/>
-            <a:ext cx="12187485" cy="6858000"/>
-            <a:chOff x="0" y="0"/>
-            <a:chExt cx="16249980" cy="9144000"/>
-          </a:xfrm>
-        </p:grpSpPr>
-        <p:sp>
-          <p:nvSpPr>
-            <p:cNvPr name="Freeform 8" id="8"/>
-            <p:cNvSpPr/>
-            <p:nvPr/>
-          </p:nvSpPr>
-          <p:spPr>
-            <a:xfrm flipH="false" flipV="false" rot="0">
-              <a:off x="0" y="0"/>
-              <a:ext cx="16250031" cy="9144000"/>
-            </a:xfrm>
-            <a:custGeom>
-              <a:avLst/>
-              <a:gdLst/>
-              <a:ahLst/>
-              <a:cxnLst/>
-              <a:rect r="r" b="b" t="t" l="l"/>
-              <a:pathLst>
-                <a:path h="9144000" w="16250031">
-                  <a:moveTo>
-                    <a:pt x="0" y="0"/>
-                  </a:moveTo>
-                  <a:lnTo>
-                    <a:pt x="16250031" y="0"/>
-                  </a:lnTo>
-                  <a:lnTo>
-                    <a:pt x="16250031" y="9144000"/>
-                  </a:lnTo>
-                  <a:lnTo>
-                    <a:pt x="0" y="9144000"/>
-                  </a:lnTo>
-                  <a:lnTo>
-                    <a:pt x="0" y="0"/>
-                  </a:lnTo>
-                  <a:close/>
-                </a:path>
-              </a:pathLst>
-            </a:custGeom>
-            <a:blipFill>
-              <a:blip r:embed="rId3"/>
-              <a:stretch>
-                <a:fillRect l="0" t="0" r="0" b="0"/>
-              </a:stretch>
-            </a:blipFill>
-          </p:spPr>
-        </p:sp>
-      </p:grpSp>
+            <a:ext cx="12187523" cy="6858000"/>
+          </a:xfrm>
+          <a:prstGeom prst="rect">
+            <a:avLst/>
+          </a:prstGeom>
+          <a:ln>
+            <a:noFill/>
+          </a:ln>
+        </p:spPr>
+      </p:pic>
     </p:spTree>
   </p:cSld>
   <p:clrMapOvr>
@@ -8237,7 +8204,7 @@
     </p:bg>
     <p:spTree>
       <p:nvGrpSpPr>
-        <p:cNvPr id="1" name=""/>
+        <p:cNvPr id="1" name="!!Slide04_Object1"/>
         <p:cNvGrpSpPr/>
         <p:nvPr/>
       </p:nvGrpSpPr>
@@ -8251,7 +8218,7 @@
       </p:grpSpPr>
       <p:sp>
         <p:nvSpPr>
-          <p:cNvPr name="TextBox 2" id="2"/>
+          <p:cNvPr name="!!Slide04_Object2" id="2"/>
           <p:cNvSpPr txBox="true"/>
           <p:nvPr/>
         </p:nvSpPr>
@@ -8292,7 +8259,7 @@
       </p:sp>
       <p:sp>
         <p:nvSpPr>
-          <p:cNvPr name="TextBox 3" id="3"/>
+          <p:cNvPr name="!!Slide04_Object3" id="3"/>
           <p:cNvSpPr txBox="true"/>
           <p:nvPr/>
         </p:nvSpPr>
@@ -8333,7 +8300,7 @@
       </p:sp>
       <p:sp>
         <p:nvSpPr>
-          <p:cNvPr name="AutoShape 4" id="4"/>
+          <p:cNvPr name="!!Slide04_Object4" id="4"/>
           <p:cNvSpPr/>
           <p:nvPr/>
         </p:nvSpPr>
@@ -8357,7 +8324,7 @@
       </p:sp>
       <p:sp>
         <p:nvSpPr>
-          <p:cNvPr name="TextBox 5" id="5"/>
+          <p:cNvPr name="!!Slide04_Object5" id="5"/>
           <p:cNvSpPr txBox="true"/>
           <p:nvPr/>
         </p:nvSpPr>
@@ -8398,7 +8365,7 @@
       </p:sp>
       <p:sp>
         <p:nvSpPr>
-          <p:cNvPr name="TextBox 6" id="6"/>
+          <p:cNvPr name="!!Slide04_Object6" id="6"/>
           <p:cNvSpPr txBox="true"/>
           <p:nvPr/>
         </p:nvSpPr>
@@ -8439,7 +8406,7 @@
       </p:sp>
       <p:sp>
         <p:nvSpPr>
-          <p:cNvPr name="TextBox 7" id="7"/>
+          <p:cNvPr name="!!Slide04_Object7" id="7"/>
           <p:cNvSpPr txBox="true"/>
           <p:nvPr/>
         </p:nvSpPr>
@@ -8478,70 +8445,37 @@
           </a:p>
         </p:txBody>
       </p:sp>
-      <p:grpSp>
-        <p:nvGrpSpPr>
-          <p:cNvPr name="Group 8" id="8"/>
-          <p:cNvGrpSpPr/>
+      <p:pic>
+        <p:nvPicPr>
+          <p:cNvPr id="8" name="!!ArchitectureCamera" descr="같은 아키텍처 원본 이미지. PowerPoint 변환(Morph)으로 확대·이동."/>
+          <p:cNvPicPr>
+            <a:picLocks noChangeAspect="1"/>
+          </p:cNvPicPr>
           <p:nvPr/>
-        </p:nvGrpSpPr>
-        <p:grpSpPr>
-          <a:xfrm rot="0">
+        </p:nvPicPr>
+        <p:blipFill>
+          <a:blip r:embed="rId3"/>
+          <a:srcRect l="34667" t="23104" r="34667" b="34246"/>
+          <a:stretch>
+            <a:fillRect/>
+          </a:stretch>
+        </p:blipFill>
+        <p:spPr>
+          <a:xfrm>
             <a:off x="2345798" y="3228975"/>
-            <a:ext cx="7424204" cy="5810250"/>
-            <a:chOff x="0" y="0"/>
-            <a:chExt cx="9898939" cy="7747000"/>
-          </a:xfrm>
-        </p:grpSpPr>
-        <p:sp>
-          <p:nvSpPr>
-            <p:cNvPr name="Freeform 9" id="9"/>
-            <p:cNvSpPr/>
-            <p:nvPr/>
-          </p:nvSpPr>
-          <p:spPr>
-            <a:xfrm flipH="false" flipV="false" rot="0">
-              <a:off x="0" y="0"/>
-              <a:ext cx="9898888" cy="7747000"/>
-            </a:xfrm>
-            <a:custGeom>
-              <a:avLst/>
-              <a:gdLst/>
-              <a:ahLst/>
-              <a:cxnLst/>
-              <a:rect r="r" b="b" t="t" l="l"/>
-              <a:pathLst>
-                <a:path h="7747000" w="9898888">
-                  <a:moveTo>
-                    <a:pt x="0" y="0"/>
-                  </a:moveTo>
-                  <a:lnTo>
-                    <a:pt x="9898888" y="0"/>
-                  </a:lnTo>
-                  <a:lnTo>
-                    <a:pt x="9898888" y="7747000"/>
-                  </a:lnTo>
-                  <a:lnTo>
-                    <a:pt x="0" y="7747000"/>
-                  </a:lnTo>
-                  <a:lnTo>
-                    <a:pt x="0" y="0"/>
-                  </a:lnTo>
-                  <a:close/>
-                </a:path>
-              </a:pathLst>
-            </a:custGeom>
-            <a:blipFill>
-              <a:blip r:embed="rId3"/>
-              <a:stretch>
-                <a:fillRect l="-113047" t="-54171" r="-113048" b="-80295"/>
-              </a:stretch>
-            </a:blipFill>
-          </p:spPr>
-        </p:sp>
-      </p:grpSp>
-      <p:sp>
-        <p:nvSpPr>
-          <p:cNvPr name="TextBox 10" id="10"/>
+            <a:ext cx="7424166" cy="5810250"/>
+          </a:xfrm>
+          <a:prstGeom prst="rect">
+            <a:avLst/>
+          </a:prstGeom>
+          <a:ln>
+            <a:noFill/>
+          </a:ln>
+        </p:spPr>
+      </p:pic>
+      <p:sp>
+        <p:nvSpPr>
+          <p:cNvPr name="!!Slide04_Object10" id="10"/>
           <p:cNvSpPr txBox="true"/>
           <p:nvPr/>
         </p:nvSpPr>
@@ -8601,7 +8535,7 @@
       </p:sp>
       <p:sp>
         <p:nvSpPr>
-          <p:cNvPr name="TextBox 11" id="11"/>
+          <p:cNvPr name="!!Slide04_Object11" id="11"/>
           <p:cNvSpPr txBox="true"/>
           <p:nvPr/>
         </p:nvSpPr>
@@ -8642,7 +8576,7 @@
       </p:sp>
       <p:sp>
         <p:nvSpPr>
-          <p:cNvPr name="TextBox 12" id="12"/>
+          <p:cNvPr name="!!Slide04_Object12" id="12"/>
           <p:cNvSpPr txBox="true"/>
           <p:nvPr/>
         </p:nvSpPr>
@@ -8702,7 +8636,7 @@
       </p:sp>
       <p:sp>
         <p:nvSpPr>
-          <p:cNvPr name="TextBox 13" id="13"/>
+          <p:cNvPr name="!!Slide04_Object13" id="13"/>
           <p:cNvSpPr txBox="true"/>
           <p:nvPr/>
         </p:nvSpPr>
@@ -8743,7 +8677,7 @@
       </p:sp>
       <p:sp>
         <p:nvSpPr>
-          <p:cNvPr name="TextBox 14" id="14"/>
+          <p:cNvPr name="!!Slide04_Object14" id="14"/>
           <p:cNvSpPr txBox="true"/>
           <p:nvPr/>
         </p:nvSpPr>
@@ -8806,9 +8740,18 @@
   <p:clrMapOvr>
     <a:masterClrMapping/>
   </p:clrMapOvr>
-  <p:transition spd="slow">
-    <p:fade/>
-  </p:transition>
+  <mc:AlternateContent xmlns:mc="http://schemas.openxmlformats.org/markup-compatibility/2006">
+    <mc:Choice xmlns:p159="http://schemas.microsoft.com/office/powerpoint/2015/09/main" Requires="p159">
+      <p:transition xmlns:p14="http://schemas.microsoft.com/office/powerpoint/2010/main" spd="slow" advClick="1" p14:dur="1400">
+        <p159:morph option="byObject"/>
+      </p:transition>
+    </mc:Choice>
+    <mc:Fallback>
+      <p:transition spd="slow" advClick="1">
+        <p:fade/>
+      </p:transition>
+    </mc:Fallback>
+  </mc:AlternateContent>
 </p:sld>
 </file>
 
@@ -8824,7 +8767,7 @@
     </p:bg>
     <p:spTree>
       <p:nvGrpSpPr>
-        <p:cNvPr id="1" name=""/>
+        <p:cNvPr id="1" name="!!Slide05_Object1"/>
         <p:cNvGrpSpPr/>
         <p:nvPr/>
       </p:nvGrpSpPr>
@@ -8838,7 +8781,7 @@
       </p:grpSpPr>
       <p:sp>
         <p:nvSpPr>
-          <p:cNvPr name="TextBox 2" id="2"/>
+          <p:cNvPr name="!!Slide05_Object2" id="2"/>
           <p:cNvSpPr txBox="true"/>
           <p:nvPr/>
         </p:nvSpPr>
@@ -8879,7 +8822,7 @@
       </p:sp>
       <p:sp>
         <p:nvSpPr>
-          <p:cNvPr name="TextBox 3" id="3"/>
+          <p:cNvPr name="!!Slide05_Object3" id="3"/>
           <p:cNvSpPr txBox="true"/>
           <p:nvPr/>
         </p:nvSpPr>
@@ -8920,7 +8863,7 @@
       </p:sp>
       <p:sp>
         <p:nvSpPr>
-          <p:cNvPr name="AutoShape 4" id="4"/>
+          <p:cNvPr name="!!Slide05_Object4" id="4"/>
           <p:cNvSpPr/>
           <p:nvPr/>
         </p:nvSpPr>
@@ -8944,7 +8887,7 @@
       </p:sp>
       <p:sp>
         <p:nvSpPr>
-          <p:cNvPr name="TextBox 5" id="5"/>
+          <p:cNvPr name="!!Slide05_Object5" id="5"/>
           <p:cNvSpPr txBox="true"/>
           <p:nvPr/>
         </p:nvSpPr>
@@ -8985,7 +8928,7 @@
       </p:sp>
       <p:sp>
         <p:nvSpPr>
-          <p:cNvPr name="TextBox 6" id="6"/>
+          <p:cNvPr name="!!Slide05_Object6" id="6"/>
           <p:cNvSpPr txBox="true"/>
           <p:nvPr/>
         </p:nvSpPr>
@@ -9026,7 +8969,7 @@
       </p:sp>
       <p:sp>
         <p:nvSpPr>
-          <p:cNvPr name="TextBox 7" id="7"/>
+          <p:cNvPr name="!!Slide05_Object7" id="7"/>
           <p:cNvSpPr txBox="true"/>
           <p:nvPr/>
         </p:nvSpPr>
@@ -9065,70 +9008,37 @@
           </a:p>
         </p:txBody>
       </p:sp>
-      <p:grpSp>
-        <p:nvGrpSpPr>
-          <p:cNvPr name="Group 8" id="8"/>
-          <p:cNvGrpSpPr/>
+      <p:pic>
+        <p:nvPicPr>
+          <p:cNvPr id="8" name="!!ArchitectureCamera" descr="같은 아키텍처 원본 이미지. PowerPoint 변환(Morph)으로 확대·이동."/>
+          <p:cNvPicPr>
+            <a:picLocks noChangeAspect="1"/>
+          </p:cNvPicPr>
           <p:nvPr/>
-        </p:nvGrpSpPr>
-        <p:grpSpPr>
-          <a:xfrm rot="0">
+        </p:nvPicPr>
+        <p:blipFill>
+          <a:blip r:embed="rId3"/>
+          <a:srcRect l="1000" t="23104" r="68333" b="34245"/>
+          <a:stretch>
+            <a:fillRect/>
+          </a:stretch>
+        </p:blipFill>
+        <p:spPr>
+          <a:xfrm>
             <a:off x="2345798" y="3228975"/>
-            <a:ext cx="7424204" cy="5810250"/>
-            <a:chOff x="0" y="0"/>
-            <a:chExt cx="9898939" cy="7747000"/>
-          </a:xfrm>
-        </p:grpSpPr>
-        <p:sp>
-          <p:nvSpPr>
-            <p:cNvPr name="Freeform 9" id="9"/>
-            <p:cNvSpPr/>
-            <p:nvPr/>
-          </p:nvSpPr>
-          <p:spPr>
-            <a:xfrm flipH="false" flipV="false" rot="0">
-              <a:off x="0" y="0"/>
-              <a:ext cx="9898888" cy="7747000"/>
-            </a:xfrm>
-            <a:custGeom>
-              <a:avLst/>
-              <a:gdLst/>
-              <a:ahLst/>
-              <a:cxnLst/>
-              <a:rect r="r" b="b" t="t" l="l"/>
-              <a:pathLst>
-                <a:path h="7747000" w="9898888">
-                  <a:moveTo>
-                    <a:pt x="0" y="0"/>
-                  </a:moveTo>
-                  <a:lnTo>
-                    <a:pt x="9898888" y="0"/>
-                  </a:lnTo>
-                  <a:lnTo>
-                    <a:pt x="9898888" y="7747000"/>
-                  </a:lnTo>
-                  <a:lnTo>
-                    <a:pt x="0" y="7747000"/>
-                  </a:lnTo>
-                  <a:lnTo>
-                    <a:pt x="0" y="0"/>
-                  </a:lnTo>
-                  <a:close/>
-                </a:path>
-              </a:pathLst>
-            </a:custGeom>
-            <a:blipFill>
-              <a:blip r:embed="rId3"/>
-              <a:stretch>
-                <a:fillRect l="-3260" t="-54169" r="-222824" b="-80289"/>
-              </a:stretch>
-            </a:blipFill>
-          </p:spPr>
-        </p:sp>
-      </p:grpSp>
-      <p:sp>
-        <p:nvSpPr>
-          <p:cNvPr name="TextBox 10" id="10"/>
+            <a:ext cx="7424166" cy="5810250"/>
+          </a:xfrm>
+          <a:prstGeom prst="rect">
+            <a:avLst/>
+          </a:prstGeom>
+          <a:ln>
+            <a:noFill/>
+          </a:ln>
+        </p:spPr>
+      </p:pic>
+      <p:sp>
+        <p:nvSpPr>
+          <p:cNvPr name="!!Slide05_Object10" id="10"/>
           <p:cNvSpPr txBox="true"/>
           <p:nvPr/>
         </p:nvSpPr>
@@ -9188,7 +9098,7 @@
       </p:sp>
       <p:sp>
         <p:nvSpPr>
-          <p:cNvPr name="TextBox 11" id="11"/>
+          <p:cNvPr name="!!Slide05_Object11" id="11"/>
           <p:cNvSpPr txBox="true"/>
           <p:nvPr/>
         </p:nvSpPr>
@@ -9229,7 +9139,7 @@
       </p:sp>
       <p:sp>
         <p:nvSpPr>
-          <p:cNvPr name="TextBox 12" id="12"/>
+          <p:cNvPr name="!!Slide05_Object12" id="12"/>
           <p:cNvSpPr txBox="true"/>
           <p:nvPr/>
         </p:nvSpPr>
@@ -9289,7 +9199,7 @@
       </p:sp>
       <p:sp>
         <p:nvSpPr>
-          <p:cNvPr name="TextBox 13" id="13"/>
+          <p:cNvPr name="!!Slide05_Object13" id="13"/>
           <p:cNvSpPr txBox="true"/>
           <p:nvPr/>
         </p:nvSpPr>
@@ -9330,7 +9240,7 @@
       </p:sp>
       <p:sp>
         <p:nvSpPr>
-          <p:cNvPr name="TextBox 14" id="14"/>
+          <p:cNvPr name="!!Slide05_Object14" id="14"/>
           <p:cNvSpPr txBox="true"/>
           <p:nvPr/>
         </p:nvSpPr>
@@ -9393,9 +9303,18 @@
   <p:clrMapOvr>
     <a:masterClrMapping/>
   </p:clrMapOvr>
-  <p:transition spd="slow">
-    <p:fade/>
-  </p:transition>
+  <mc:AlternateContent xmlns:mc="http://schemas.openxmlformats.org/markup-compatibility/2006">
+    <mc:Choice xmlns:p159="http://schemas.microsoft.com/office/powerpoint/2015/09/main" Requires="p159">
+      <p:transition xmlns:p14="http://schemas.microsoft.com/office/powerpoint/2010/main" spd="slow" advClick="1" p14:dur="1400">
+        <p159:morph option="byObject"/>
+      </p:transition>
+    </mc:Choice>
+    <mc:Fallback>
+      <p:transition spd="slow" advClick="1">
+        <p:fade/>
+      </p:transition>
+    </mc:Fallback>
+  </mc:AlternateContent>
 </p:sld>
 </file>
 
@@ -9411,7 +9330,7 @@
     </p:bg>
     <p:spTree>
       <p:nvGrpSpPr>
-        <p:cNvPr id="1" name=""/>
+        <p:cNvPr id="1" name="!!Slide06_Object1"/>
         <p:cNvGrpSpPr/>
         <p:nvPr/>
       </p:nvGrpSpPr>
@@ -9425,7 +9344,7 @@
       </p:grpSpPr>
       <p:sp>
         <p:nvSpPr>
-          <p:cNvPr name="TextBox 2" id="2"/>
+          <p:cNvPr name="!!Slide06_Object2" id="2"/>
           <p:cNvSpPr txBox="true"/>
           <p:nvPr/>
         </p:nvSpPr>
@@ -9466,7 +9385,7 @@
       </p:sp>
       <p:sp>
         <p:nvSpPr>
-          <p:cNvPr name="TextBox 3" id="3"/>
+          <p:cNvPr name="!!Slide06_Object3" id="3"/>
           <p:cNvSpPr txBox="true"/>
           <p:nvPr/>
         </p:nvSpPr>
@@ -9507,7 +9426,7 @@
       </p:sp>
       <p:sp>
         <p:nvSpPr>
-          <p:cNvPr name="AutoShape 4" id="4"/>
+          <p:cNvPr name="!!Slide06_Object4" id="4"/>
           <p:cNvSpPr/>
           <p:nvPr/>
         </p:nvSpPr>
@@ -9531,7 +9450,7 @@
       </p:sp>
       <p:sp>
         <p:nvSpPr>
-          <p:cNvPr name="TextBox 5" id="5"/>
+          <p:cNvPr name="!!Slide06_Object5" id="5"/>
           <p:cNvSpPr txBox="true"/>
           <p:nvPr/>
         </p:nvSpPr>
@@ -9572,7 +9491,7 @@
       </p:sp>
       <p:sp>
         <p:nvSpPr>
-          <p:cNvPr name="TextBox 6" id="6"/>
+          <p:cNvPr name="!!Slide06_Object6" id="6"/>
           <p:cNvSpPr txBox="true"/>
           <p:nvPr/>
         </p:nvSpPr>
@@ -9613,7 +9532,7 @@
       </p:sp>
       <p:sp>
         <p:nvSpPr>
-          <p:cNvPr name="TextBox 7" id="7"/>
+          <p:cNvPr name="!!Slide06_Object7" id="7"/>
           <p:cNvSpPr txBox="true"/>
           <p:nvPr/>
         </p:nvSpPr>
@@ -9652,70 +9571,37 @@
           </a:p>
         </p:txBody>
       </p:sp>
-      <p:grpSp>
-        <p:nvGrpSpPr>
-          <p:cNvPr name="Group 8" id="8"/>
-          <p:cNvGrpSpPr/>
+      <p:pic>
+        <p:nvPicPr>
+          <p:cNvPr id="8" name="!!ArchitectureCamera" descr="같은 아키텍처 원본 이미지. PowerPoint 변환(Morph)으로 확대·이동."/>
+          <p:cNvPicPr>
+            <a:picLocks noChangeAspect="1"/>
+          </p:cNvPicPr>
           <p:nvPr/>
-        </p:nvGrpSpPr>
-        <p:grpSpPr>
-          <a:xfrm rot="0">
+        </p:nvPicPr>
+        <p:blipFill>
+          <a:blip r:embed="rId3"/>
+          <a:srcRect l="69000" t="17180" r="1000" b="24767"/>
+          <a:stretch>
+            <a:fillRect/>
+          </a:stretch>
+        </p:blipFill>
+        <p:spPr>
+          <a:xfrm>
             <a:off x="3389928" y="3228975"/>
-            <a:ext cx="5335943" cy="5810250"/>
-            <a:chOff x="0" y="0"/>
-            <a:chExt cx="7114591" cy="7747000"/>
-          </a:xfrm>
-        </p:grpSpPr>
-        <p:sp>
-          <p:nvSpPr>
-            <p:cNvPr name="Freeform 9" id="9"/>
-            <p:cNvSpPr/>
-            <p:nvPr/>
-          </p:nvSpPr>
-          <p:spPr>
-            <a:xfrm flipH="false" flipV="false" rot="0">
-              <a:off x="0" y="0"/>
-              <a:ext cx="7114540" cy="7747000"/>
-            </a:xfrm>
-            <a:custGeom>
-              <a:avLst/>
-              <a:gdLst/>
-              <a:ahLst/>
-              <a:cxnLst/>
-              <a:rect r="r" b="b" t="t" l="l"/>
-              <a:pathLst>
-                <a:path h="7747000" w="7114540">
-                  <a:moveTo>
-                    <a:pt x="0" y="0"/>
-                  </a:moveTo>
-                  <a:lnTo>
-                    <a:pt x="7114540" y="0"/>
-                  </a:lnTo>
-                  <a:lnTo>
-                    <a:pt x="7114540" y="7747000"/>
-                  </a:lnTo>
-                  <a:lnTo>
-                    <a:pt x="0" y="7747000"/>
-                  </a:lnTo>
-                  <a:lnTo>
-                    <a:pt x="0" y="0"/>
-                  </a:lnTo>
-                  <a:close/>
-                </a:path>
-              </a:pathLst>
-            </a:custGeom>
-            <a:blipFill>
-              <a:blip r:embed="rId3"/>
-              <a:stretch>
-                <a:fillRect l="-230001" t="-29593" r="-3334" b="-42663"/>
-              </a:stretch>
-            </a:blipFill>
-          </p:spPr>
-        </p:sp>
-      </p:grpSp>
-      <p:sp>
-        <p:nvSpPr>
-          <p:cNvPr name="TextBox 10" id="10"/>
+            <a:ext cx="5335905" cy="5810250"/>
+          </a:xfrm>
+          <a:prstGeom prst="rect">
+            <a:avLst/>
+          </a:prstGeom>
+          <a:ln>
+            <a:noFill/>
+          </a:ln>
+        </p:spPr>
+      </p:pic>
+      <p:sp>
+        <p:nvSpPr>
+          <p:cNvPr name="!!Slide06_Object10" id="10"/>
           <p:cNvSpPr txBox="true"/>
           <p:nvPr/>
         </p:nvSpPr>
@@ -9775,7 +9661,7 @@
       </p:sp>
       <p:sp>
         <p:nvSpPr>
-          <p:cNvPr name="TextBox 11" id="11"/>
+          <p:cNvPr name="!!Slide06_Object11" id="11"/>
           <p:cNvSpPr txBox="true"/>
           <p:nvPr/>
         </p:nvSpPr>
@@ -9816,7 +9702,7 @@
       </p:sp>
       <p:sp>
         <p:nvSpPr>
-          <p:cNvPr name="TextBox 12" id="12"/>
+          <p:cNvPr name="!!Slide06_Object12" id="12"/>
           <p:cNvSpPr txBox="true"/>
           <p:nvPr/>
         </p:nvSpPr>
@@ -9895,7 +9781,7 @@
       </p:sp>
       <p:sp>
         <p:nvSpPr>
-          <p:cNvPr name="TextBox 13" id="13"/>
+          <p:cNvPr name="!!Slide06_Object13" id="13"/>
           <p:cNvSpPr txBox="true"/>
           <p:nvPr/>
         </p:nvSpPr>
@@ -9936,7 +9822,7 @@
       </p:sp>
       <p:sp>
         <p:nvSpPr>
-          <p:cNvPr name="TextBox 14" id="14"/>
+          <p:cNvPr name="!!Slide06_Object14" id="14"/>
           <p:cNvSpPr txBox="true"/>
           <p:nvPr/>
         </p:nvSpPr>
@@ -10018,9 +9904,18 @@
   <p:clrMapOvr>
     <a:masterClrMapping/>
   </p:clrMapOvr>
-  <p:transition spd="slow">
-    <p:fade/>
-  </p:transition>
+  <mc:AlternateContent xmlns:mc="http://schemas.openxmlformats.org/markup-compatibility/2006">
+    <mc:Choice xmlns:p159="http://schemas.microsoft.com/office/powerpoint/2015/09/main" Requires="p159">
+      <p:transition xmlns:p14="http://schemas.microsoft.com/office/powerpoint/2010/main" spd="slow" advClick="1" p14:dur="1400">
+        <p159:morph option="byObject"/>
+      </p:transition>
+    </mc:Choice>
+    <mc:Fallback>
+      <p:transition spd="slow" advClick="1">
+        <p:fade/>
+      </p:transition>
+    </mc:Fallback>
+  </mc:AlternateContent>
 </p:sld>
 </file>
 
@@ -10036,7 +9931,7 @@
     </p:bg>
     <p:spTree>
       <p:nvGrpSpPr>
-        <p:cNvPr id="1" name=""/>
+        <p:cNvPr id="1" name="!!Slide07_Object1"/>
         <p:cNvGrpSpPr/>
         <p:nvPr/>
       </p:nvGrpSpPr>
@@ -10050,7 +9945,7 @@
       </p:grpSpPr>
       <p:sp>
         <p:nvSpPr>
-          <p:cNvPr name="TextBox 2" id="2"/>
+          <p:cNvPr name="!!Slide07_Object2" id="2"/>
           <p:cNvSpPr txBox="true"/>
           <p:nvPr/>
         </p:nvSpPr>
@@ -10091,7 +9986,7 @@
       </p:sp>
       <p:sp>
         <p:nvSpPr>
-          <p:cNvPr name="TextBox 3" id="3"/>
+          <p:cNvPr name="!!Slide07_Object3" id="3"/>
           <p:cNvSpPr txBox="true"/>
           <p:nvPr/>
         </p:nvSpPr>
@@ -10132,7 +10027,7 @@
       </p:sp>
       <p:sp>
         <p:nvSpPr>
-          <p:cNvPr name="AutoShape 4" id="4"/>
+          <p:cNvPr name="!!Slide07_Object4" id="4"/>
           <p:cNvSpPr/>
           <p:nvPr/>
         </p:nvSpPr>
@@ -10156,7 +10051,7 @@
       </p:sp>
       <p:sp>
         <p:nvSpPr>
-          <p:cNvPr name="TextBox 5" id="5"/>
+          <p:cNvPr name="!!Slide07_Object5" id="5"/>
           <p:cNvSpPr txBox="true"/>
           <p:nvPr/>
         </p:nvSpPr>
@@ -10197,7 +10092,7 @@
       </p:sp>
       <p:sp>
         <p:nvSpPr>
-          <p:cNvPr name="TextBox 6" id="6"/>
+          <p:cNvPr name="!!Slide07_Object6" id="6"/>
           <p:cNvSpPr txBox="true"/>
           <p:nvPr/>
         </p:nvSpPr>
@@ -10238,7 +10133,7 @@
       </p:sp>
       <p:sp>
         <p:nvSpPr>
-          <p:cNvPr name="TextBox 7" id="7"/>
+          <p:cNvPr name="!!Slide07_Object7" id="7"/>
           <p:cNvSpPr txBox="true"/>
           <p:nvPr/>
         </p:nvSpPr>
@@ -10277,70 +10172,37 @@
           </a:p>
         </p:txBody>
       </p:sp>
-      <p:grpSp>
-        <p:nvGrpSpPr>
-          <p:cNvPr name="Group 8" id="8"/>
-          <p:cNvGrpSpPr/>
+      <p:pic>
+        <p:nvPicPr>
+          <p:cNvPr id="8" name="!!ArchitectureCamera" descr="같은 아키텍처 원본 이미지. PowerPoint 변환(Morph)으로 확대·이동."/>
+          <p:cNvPicPr>
+            <a:picLocks noChangeAspect="1"/>
+          </p:cNvPicPr>
           <p:nvPr/>
-        </p:nvGrpSpPr>
-        <p:grpSpPr>
-          <a:xfrm rot="0">
+        </p:nvPicPr>
+        <p:blipFill>
+          <a:blip r:embed="rId3"/>
+          <a:srcRect l="1333" t="1185" r="36000" b="81044"/>
+          <a:stretch>
+            <a:fillRect/>
+          </a:stretch>
+        </p:blipFill>
+        <p:spPr>
+          <a:xfrm>
             <a:off x="914400" y="3381375"/>
-            <a:ext cx="16459200" cy="2626471"/>
-            <a:chOff x="0" y="0"/>
-            <a:chExt cx="21945600" cy="3501962"/>
-          </a:xfrm>
-        </p:grpSpPr>
-        <p:sp>
-          <p:nvSpPr>
-            <p:cNvPr name="Freeform 9" id="9"/>
-            <p:cNvSpPr/>
-            <p:nvPr/>
-          </p:nvSpPr>
-          <p:spPr>
-            <a:xfrm flipH="false" flipV="false" rot="0">
-              <a:off x="0" y="0"/>
-              <a:ext cx="21945600" cy="3501898"/>
-            </a:xfrm>
-            <a:custGeom>
-              <a:avLst/>
-              <a:gdLst/>
-              <a:ahLst/>
-              <a:cxnLst/>
-              <a:rect r="r" b="b" t="t" l="l"/>
-              <a:pathLst>
-                <a:path h="3501898" w="21945600">
-                  <a:moveTo>
-                    <a:pt x="0" y="0"/>
-                  </a:moveTo>
-                  <a:lnTo>
-                    <a:pt x="21945600" y="0"/>
-                  </a:lnTo>
-                  <a:lnTo>
-                    <a:pt x="21945600" y="3501898"/>
-                  </a:lnTo>
-                  <a:lnTo>
-                    <a:pt x="0" y="3501898"/>
-                  </a:lnTo>
-                  <a:lnTo>
-                    <a:pt x="0" y="0"/>
-                  </a:lnTo>
-                  <a:close/>
-                </a:path>
-              </a:pathLst>
-            </a:custGeom>
-            <a:blipFill>
-              <a:blip r:embed="rId3"/>
-              <a:stretch>
-                <a:fillRect l="-2127" t="-6668" r="-57446" b="-456046"/>
-              </a:stretch>
-            </a:blipFill>
-          </p:spPr>
-        </p:sp>
-      </p:grpSp>
-      <p:sp>
-        <p:nvSpPr>
-          <p:cNvPr name="TextBox 10" id="10"/>
+            <a:ext cx="16459200" cy="2626423"/>
+          </a:xfrm>
+          <a:prstGeom prst="rect">
+            <a:avLst/>
+          </a:prstGeom>
+          <a:ln>
+            <a:noFill/>
+          </a:ln>
+        </p:spPr>
+      </p:pic>
+      <p:sp>
+        <p:nvSpPr>
+          <p:cNvPr name="!!Slide07_Object10" id="10"/>
           <p:cNvSpPr txBox="true"/>
           <p:nvPr/>
         </p:nvSpPr>
@@ -10381,7 +10243,7 @@
       </p:sp>
       <p:sp>
         <p:nvSpPr>
-          <p:cNvPr name="TextBox 11" id="11"/>
+          <p:cNvPr name="!!Slide07_Object11" id="11"/>
           <p:cNvSpPr txBox="true"/>
           <p:nvPr/>
         </p:nvSpPr>
@@ -10441,7 +10303,7 @@
       </p:sp>
       <p:sp>
         <p:nvSpPr>
-          <p:cNvPr name="TextBox 12" id="12"/>
+          <p:cNvPr name="!!Slide07_Object12" id="12"/>
           <p:cNvSpPr txBox="true"/>
           <p:nvPr/>
         </p:nvSpPr>
@@ -10482,7 +10344,7 @@
       </p:sp>
       <p:sp>
         <p:nvSpPr>
-          <p:cNvPr name="TextBox 13" id="13"/>
+          <p:cNvPr name="!!Slide07_Object13" id="13"/>
           <p:cNvSpPr txBox="true"/>
           <p:nvPr/>
         </p:nvSpPr>
@@ -10545,9 +10407,18 @@
   <p:clrMapOvr>
     <a:masterClrMapping/>
   </p:clrMapOvr>
-  <p:transition spd="slow">
-    <p:fade/>
-  </p:transition>
+  <mc:AlternateContent xmlns:mc="http://schemas.openxmlformats.org/markup-compatibility/2006">
+    <mc:Choice xmlns:p159="http://schemas.microsoft.com/office/powerpoint/2015/09/main" Requires="p159">
+      <p:transition xmlns:p14="http://schemas.microsoft.com/office/powerpoint/2010/main" spd="slow" advClick="1" p14:dur="1400">
+        <p159:morph option="byObject"/>
+      </p:transition>
+    </mc:Choice>
+    <mc:Fallback>
+      <p:transition spd="slow" advClick="1">
+        <p:fade/>
+      </p:transition>
+    </mc:Fallback>
+  </mc:AlternateContent>
 </p:sld>
 </file>
 

</xml_diff>

<commit_message>
docs: prioritize hypothesis investigation and evidence validation
</commit_message>
<xml_diff>
--- a/doc/presentation/운영진단_에이전트_5분발표.pptx
+++ b/doc/presentation/운영진단_에이전트_5분발표.pptx
@@ -2,31 +2,31 @@
 <file path=ppt/presentation.xml><?xml version="1.0" encoding="utf-8"?>
 <p:presentation xmlns:p="http://schemas.openxmlformats.org/presentationml/2006/main" embedTrueTypeFonts="1" saveSubsetFonts="0">
   <p:sldMasterIdLst>
-    <p:sldMasterId xmlns:r="http://schemas.openxmlformats.org/officeDocument/2006/relationships" id="2147483648" r:id="Ra61c84c9893d41f1"/>
+    <p:sldMasterId xmlns:r="http://schemas.openxmlformats.org/officeDocument/2006/relationships" id="2147483648" r:id="Re95cdfc4b54d4b2a"/>
   </p:sldMasterIdLst>
   <p:notesMasterIdLst>
-    <p:notesMasterId xmlns:r="http://schemas.openxmlformats.org/officeDocument/2006/relationships" r:id="R9aee8c86b3794d7a"/>
+    <p:notesMasterId xmlns:r="http://schemas.openxmlformats.org/officeDocument/2006/relationships" r:id="R26afe174143a48e5"/>
   </p:notesMasterIdLst>
   <p:sldIdLst>
-    <p:sldId xmlns:r="http://schemas.openxmlformats.org/officeDocument/2006/relationships" id="256" r:id="R4d184cb1d43946b8"/>
-    <p:sldId xmlns:r="http://schemas.openxmlformats.org/officeDocument/2006/relationships" id="257" r:id="R2a5f7301ff7b423e"/>
-    <p:sldId xmlns:r="http://schemas.openxmlformats.org/officeDocument/2006/relationships" id="258" r:id="Rde76abc9aaaf4f58"/>
-    <p:sldId xmlns:r="http://schemas.openxmlformats.org/officeDocument/2006/relationships" id="259" r:id="Rbc0cdea59ce14c31"/>
-    <p:sldId xmlns:r="http://schemas.openxmlformats.org/officeDocument/2006/relationships" id="260" r:id="R215c3bf6f27541fb"/>
-    <p:sldId xmlns:r="http://schemas.openxmlformats.org/officeDocument/2006/relationships" id="261" r:id="Re0c14c216d474b7f"/>
-    <p:sldId xmlns:r="http://schemas.openxmlformats.org/officeDocument/2006/relationships" id="262" r:id="R52febb0fa92c473b"/>
-    <p:sldId xmlns:r="http://schemas.openxmlformats.org/officeDocument/2006/relationships" id="263" r:id="Rf87d54ebc2d94df1"/>
+    <p:sldId xmlns:r="http://schemas.openxmlformats.org/officeDocument/2006/relationships" id="256" r:id="R9cf88116324847d5"/>
+    <p:sldId xmlns:r="http://schemas.openxmlformats.org/officeDocument/2006/relationships" id="257" r:id="R2323b67d36da44ca"/>
+    <p:sldId xmlns:r="http://schemas.openxmlformats.org/officeDocument/2006/relationships" id="258" r:id="R0b70010a82aa4c3d"/>
+    <p:sldId xmlns:r="http://schemas.openxmlformats.org/officeDocument/2006/relationships" id="259" r:id="Rbfd64f5b64fe4884"/>
+    <p:sldId xmlns:r="http://schemas.openxmlformats.org/officeDocument/2006/relationships" id="260" r:id="R009f07c010244430"/>
+    <p:sldId xmlns:r="http://schemas.openxmlformats.org/officeDocument/2006/relationships" id="261" r:id="R460b1a9d9e6c4dbb"/>
+    <p:sldId xmlns:r="http://schemas.openxmlformats.org/officeDocument/2006/relationships" id="262" r:id="R61499a516e454d5a"/>
+    <p:sldId xmlns:r="http://schemas.openxmlformats.org/officeDocument/2006/relationships" id="263" r:id="R66cb1b7c1bd24c1a"/>
   </p:sldIdLst>
   <p:sldSz cx="18288000" cy="10287000"/>
   <p:notesSz cx="6858000" cy="9144000"/>
   <p:embeddedFontLst>
     <p:embeddedFont>
       <p:font typeface="Noto Sans Bold"/>
-      <p:regular xmlns:r="http://schemas.openxmlformats.org/officeDocument/2006/relationships" r:id="R91e7cca4c7fa4f26"/>
+      <p:regular xmlns:r="http://schemas.openxmlformats.org/officeDocument/2006/relationships" r:id="R633a2f4cfed5474f"/>
     </p:embeddedFont>
     <p:embeddedFont>
       <p:font typeface="Noto Sans Kr"/>
-      <p:regular xmlns:r="http://schemas.openxmlformats.org/officeDocument/2006/relationships" r:id="R86dbab3110f24e49"/>
+      <p:regular xmlns:r="http://schemas.openxmlformats.org/officeDocument/2006/relationships" r:id="R0d27aebcfc454a9e"/>
     </p:embeddedFont>
   </p:embeddedFontLst>
   <p:defaultTextStyle>
@@ -733,7 +733,7 @@
           <a:lstStyle xmlns:a="http://schemas.openxmlformats.org/drawingml/2006/main"/>
           <a:p xmlns:a="http://schemas.openxmlformats.org/drawingml/2006/main">
             <a:r>
-              <a:t>해결 과제와 개선 이유</a:t>
+              <a:t>핵심 개선: 추가 조사와 근거 검증</a:t>
             </a:r>
           </a:p>
           <a:p xmlns:a="http://schemas.openxmlformats.org/drawingml/2006/main">
@@ -758,7 +758,7 @@
           </a:p>
           <a:p xmlns:a="http://schemas.openxmlformats.org/drawingml/2006/main">
             <a:r>
-              <a:t>기존에는 업무 외 입력에도 모델을 호출했고, 경고만으로 원인을 추정하면 조치가 잘못될 수 있었습니다. 조회 실패와 수치 오류도 답변 신뢰도를 낮췄습니다. 그래서 호출 전 입력 검사, 가설을 구별하는 추가 관측, 성공 근거 보존과 사실 검증을 연결했습니다. 화면에는 결론뿐 아니라 판단이 달라진 이유도 남깁니다.</a:t>
+              <a:t>개선의 중심은 가설 기반 추가 조사와 근거 검증입니다. 초기 경고만으로는 원인을 구별하기 어려워 가설별로 필요한 관측을 더 수집하도록 바꿨습니다. 보고서는 조회 수치와 출처, 허용 조치를 코드로 검사하고, 반복 검증에 실패하면 관측 사실만 안내합니다. 입력 검사와 부분 실패 격리, 기록 복원은 이를 뒷받침하는 보조 안정성 기능입니다.</a:t>
             </a:r>
           </a:p>
           <a:p xmlns:a="http://schemas.openxmlformats.org/drawingml/2006/main">
@@ -773,7 +773,7 @@
           </a:p>
           <a:p xmlns:a="http://schemas.openxmlformats.org/drawingml/2006/main">
             <a:r>
-              <a:t>기존 문제와 개선 동작을 한 행씩 연결한다.</a:t>
+              <a:t>표 첫 행의 가설 기반 추가 조사, 둘째 행의 근거 검증을 먼저 설명한다. 아래 보조 안정성 기능은 한 문장으로 짚는다.</a:t>
             </a:r>
           </a:p>
           <a:p xmlns:a="http://schemas.openxmlformats.org/drawingml/2006/main">
@@ -789,6 +789,21 @@
           <a:p xmlns:a="http://schemas.openxmlformats.org/drawingml/2006/main">
             <a:r>
               <a:t>https://github.com/beshurl/skala-ai-mini-project/blob/main/README.md</a:t>
+            </a:r>
+          </a:p>
+          <a:p xmlns:a="http://schemas.openxmlformats.org/drawingml/2006/main">
+            <a:r>
+              <a:t>https://github.com/beshurl/skala-ai-mini-project/blob/main/agent/investigation.py</a:t>
+            </a:r>
+          </a:p>
+          <a:p xmlns:a="http://schemas.openxmlformats.org/drawingml/2006/main">
+            <a:r>
+              <a:t>https://github.com/beshurl/skala-ai-mini-project/blob/main/agent/validation.py</a:t>
+            </a:r>
+          </a:p>
+          <a:p xmlns:a="http://schemas.openxmlformats.org/drawingml/2006/main">
+            <a:r>
+              <a:t>https://github.com/beshurl/skala-ai-mini-project/blob/main/agent/reporting.py</a:t>
             </a:r>
           </a:p>
           <a:p xmlns:a="http://schemas.openxmlformats.org/drawingml/2006/main">
@@ -873,7 +888,7 @@
           <a:lstStyle xmlns:a="http://schemas.openxmlformats.org/drawingml/2006/main"/>
           <a:p xmlns:a="http://schemas.openxmlformats.org/drawingml/2006/main">
             <a:r>
-              <a:t>추가 관측에 따라 달라지는 판단</a:t>
+              <a:t>추가 관측으로 구별한 두 사례</a:t>
             </a:r>
           </a:p>
           <a:p xmlns:a="http://schemas.openxmlformats.org/drawingml/2006/main">
@@ -898,7 +913,7 @@
           </a:p>
           <a:p xmlns:a="http://schemas.openxmlformats.org/drawingml/2006/main">
             <a:r>
-              <a:t>두 사례는 처음 CPU 91%와 배치 경고가 같았습니다. 하지만 한 사례는 배치 기여 86%와 중복 작업이 확인돼 배치 가설을 교차 지지했습니다. 다른 사례는 배치 기여가 5%여서 반증했고, 요청 처리 88%와 요청량 3.2배가 요청량 가설을 교차 지지했습니다. 같은 경고에서도 추가 관측에 따라 판단을 구별하는 것이 핵심입니다. 자료가 부족하거나 상충하면 보류합니다. 다음 장에서 그 조사 과정을 설명하겠습니다.</a:t>
+              <a:t>먼저 조사 결과를 비교하겠습니다. 두 사례의 최초 CPU는 91%이고 배치 경고도 같았습니다. 왼쪽은 배치 CPU 기여 86%와 중복 작업 2건, 겹침 4분이 확인돼 배치 가설을 교차 지지했습니다. 오른쪽은 배치 기여가 5%여서 반증했고, 요청 처리 기여 88%와 요청량 3.2배가 요청량 가설을 교차 지지했습니다. 같은 경고를 추가 관측에 따라 구별한 결과입니다. 수치는 실제 LLM으로 실행한 교육용 합성 사례입니다.</a:t>
             </a:r>
           </a:p>
           <a:p xmlns:a="http://schemas.openxmlformats.org/drawingml/2006/main">
@@ -913,7 +928,7 @@
           </a:p>
           <a:p xmlns:a="http://schemas.openxmlformats.org/drawingml/2006/main">
             <a:r>
-              <a:t>공통 첫 조회를 짚은 뒤 두 사례의 추가 관측과 판정을 비교한다. 단순 경고 조회와 가설을 구별하는 조사의 차이를 설명한다.</a:t>
+              <a:t>공통 초기 증상과 두 사례의 관측·판단 결과만 비교한다. 질문 선택과 종료·재작성 절차는 다음 장에서 설명한다.</a:t>
             </a:r>
           </a:p>
           <a:p xmlns:a="http://schemas.openxmlformats.org/drawingml/2006/main">
@@ -1023,7 +1038,7 @@
           <a:lstStyle xmlns:a="http://schemas.openxmlformats.org/drawingml/2006/main"/>
           <a:p xmlns:a="http://schemas.openxmlformats.org/drawingml/2006/main">
             <a:r>
-              <a:t>가설을 구별하는 추가 조사</a:t>
+              <a:t>가설 조사와 근거 검증 절차</a:t>
             </a:r>
           </a:p>
           <a:p xmlns:a="http://schemas.openxmlformats.org/drawingml/2006/main">
@@ -1048,7 +1063,7 @@
           </a:p>
           <a:p xmlns:a="http://schemas.openxmlformats.org/drawingml/2006/main">
             <a:r>
-              <a:t>방금 요청량 사례에서 판단이 바뀐 과정을 화면으로 보겠습니다. 먼저 관측을 읽기 전에 가설별 지지와 반증 조건을 고정합니다. LLM은 아직 수행하지 않은 허용 질문 중에서 어떤 관측이 가설을 구별할지 선택합니다. MCP가 관측을 가져오면 코드는 정해진 수치 조건과 대조해 상태를 갱신합니다. 부족하면 다음 질문을 고르되 같은 5분 구간에서 최대 네 번만 조회합니다. 두 종류 관측이 한 가설을 지지하고 경쟁 가설이 반증되면 조기 종료하고, 관측이 없거나 상충하면 보류합니다. 화면에는 추가 조사 이유, 실제 관측, 판단 전후와 종료 이유를 함께 남깁니다. 현재 CPU 세 가설과 교육용 합성 관측에 적용했습니다.</a:t>
+              <a:t>이 판단을 만드는 절차는 네 단계입니다. 먼저 관측을 읽기 전에 가설별 지지와 반증 조건을 고정합니다. 다음으로 LLM이 허용된 미수행 질문을 선택하고 MCP가 읽기 전용으로 관측을 수집합니다. 코드는 조건과 대조해 가설을 갱신하고, 부족하면 같은 5분 구간에서 중복 없이 최대 네 번 조사합니다. 서로 다른 관측이 교차 지지하고 경쟁 가설이 반증되면 조기 종료하며, 부족하거나 상충하면 보류합니다. 그다음 보고서의 수치와 출처, 허용 조치를 검사합니다. 작성은 최대 세 번이며 반복 실패하면 확인한 관측만 안내합니다. 오른쪽 화면에는 조사 이유, 관측, 판단 전후와 종료 이유를 남깁니다.</a:t>
             </a:r>
           </a:p>
           <a:p xmlns:a="http://schemas.openxmlformats.org/drawingml/2006/main">
@@ -1063,7 +1078,7 @@
           </a:p>
           <a:p xmlns:a="http://schemas.openxmlformats.org/drawingml/2006/main">
             <a:r>
-              <a:t>왼쪽 네 처리 단계와 오른쪽 배치 반증·요청량 교차 지지 화면을 연결한다.</a:t>
+              <a:t>왼쪽의 기준 고정·관측 선택·판정·보고서 검증을 순서대로 짚는다. 오른쪽에서는 조사 이유와 판정 이력이 표시되는 위치만 보여주고, 3번의 수치를 다시 읽지 않는다.</a:t>
             </a:r>
           </a:p>
           <a:p xmlns:a="http://schemas.openxmlformats.org/drawingml/2006/main">
@@ -1083,7 +1098,17 @@
           </a:p>
           <a:p xmlns:a="http://schemas.openxmlformats.org/drawingml/2006/main">
             <a:r>
-              <a:t>https://github.com/beshurl/skala-ai-mini-project/blob/main/agent/contracts.py</a:t>
+              <a:t>https://github.com/beshurl/skala-ai-mini-project/blob/main/agent/graph.py</a:t>
+            </a:r>
+          </a:p>
+          <a:p xmlns:a="http://schemas.openxmlformats.org/drawingml/2006/main">
+            <a:r>
+              <a:t>https://github.com/beshurl/skala-ai-mini-project/blob/main/agent/reporting.py</a:t>
+            </a:r>
+          </a:p>
+          <a:p xmlns:a="http://schemas.openxmlformats.org/drawingml/2006/main">
+            <a:r>
+              <a:t>https://github.com/beshurl/skala-ai-mini-project/blob/main/agent/validation.py</a:t>
             </a:r>
           </a:p>
           <a:p xmlns:a="http://schemas.openxmlformats.org/drawingml/2006/main">
@@ -1094,11 +1119,6 @@
           <a:p xmlns:a="http://schemas.openxmlformats.org/drawingml/2006/main">
             <a:r>
               <a:t>https://github.com/beshurl/skala-ai-mini-project/blob/main/artifacts/screenshots/investigation-traffic-desktop.png</a:t>
-            </a:r>
-          </a:p>
-          <a:p xmlns:a="http://schemas.openxmlformats.org/drawingml/2006/main">
-            <a:r>
-              <a:t>https://github.com/beshurl/skala-ai-mini-project/blob/main/artifacts/investigation_evaluation.json</a:t>
             </a:r>
           </a:p>
           <a:p xmlns:a="http://schemas.openxmlformats.org/drawingml/2006/main">
@@ -4785,17 +4805,17 @@
   </p:cSld>
   <p:clrMap bg1="lt1" tx1="dk1" bg2="lt2" tx2="dk2" accent1="accent1" accent2="accent2" accent3="accent3" accent4="accent4" accent5="accent5" accent6="accent6" hlink="hlink" folHlink="folHlink"/>
   <p:sldLayoutIdLst>
-    <p:sldLayoutId xmlns:r="http://schemas.openxmlformats.org/officeDocument/2006/relationships" id="2147483649" r:id="Rf5efd89a9e964248"/>
-    <p:sldLayoutId xmlns:r="http://schemas.openxmlformats.org/officeDocument/2006/relationships" id="2147483650" r:id="Rbafbf9b6cc614ffd"/>
-    <p:sldLayoutId xmlns:r="http://schemas.openxmlformats.org/officeDocument/2006/relationships" id="2147483651" r:id="Rc576dbf0d42d4bbd"/>
-    <p:sldLayoutId xmlns:r="http://schemas.openxmlformats.org/officeDocument/2006/relationships" id="2147483652" r:id="R2ef3c84c514747ee"/>
-    <p:sldLayoutId xmlns:r="http://schemas.openxmlformats.org/officeDocument/2006/relationships" id="2147483653" r:id="Rbcb4e6b221cd4bc5"/>
-    <p:sldLayoutId xmlns:r="http://schemas.openxmlformats.org/officeDocument/2006/relationships" id="2147483654" r:id="Rf3e28fbbeed04254"/>
-    <p:sldLayoutId xmlns:r="http://schemas.openxmlformats.org/officeDocument/2006/relationships" id="2147483655" r:id="R40b021d9e85342ca"/>
-    <p:sldLayoutId xmlns:r="http://schemas.openxmlformats.org/officeDocument/2006/relationships" id="2147483656" r:id="R0817b970b6834598"/>
-    <p:sldLayoutId xmlns:r="http://schemas.openxmlformats.org/officeDocument/2006/relationships" id="2147483657" r:id="R149c11f9567c433c"/>
-    <p:sldLayoutId xmlns:r="http://schemas.openxmlformats.org/officeDocument/2006/relationships" id="2147483658" r:id="R5f549ca291c746e8"/>
-    <p:sldLayoutId xmlns:r="http://schemas.openxmlformats.org/officeDocument/2006/relationships" id="2147483659" r:id="R4bb8bab362b1448c"/>
+    <p:sldLayoutId xmlns:r="http://schemas.openxmlformats.org/officeDocument/2006/relationships" id="2147483649" r:id="R5967adad73de4d4d"/>
+    <p:sldLayoutId xmlns:r="http://schemas.openxmlformats.org/officeDocument/2006/relationships" id="2147483650" r:id="Re27cfd25d80b4c2e"/>
+    <p:sldLayoutId xmlns:r="http://schemas.openxmlformats.org/officeDocument/2006/relationships" id="2147483651" r:id="R7205b17b97bb46e5"/>
+    <p:sldLayoutId xmlns:r="http://schemas.openxmlformats.org/officeDocument/2006/relationships" id="2147483652" r:id="R3b56602280004425"/>
+    <p:sldLayoutId xmlns:r="http://schemas.openxmlformats.org/officeDocument/2006/relationships" id="2147483653" r:id="Rb3166178531c43cf"/>
+    <p:sldLayoutId xmlns:r="http://schemas.openxmlformats.org/officeDocument/2006/relationships" id="2147483654" r:id="R1d792c9cbced4468"/>
+    <p:sldLayoutId xmlns:r="http://schemas.openxmlformats.org/officeDocument/2006/relationships" id="2147483655" r:id="Rea5249dcf9d04f53"/>
+    <p:sldLayoutId xmlns:r="http://schemas.openxmlformats.org/officeDocument/2006/relationships" id="2147483656" r:id="R9ac51deaa6b54b1d"/>
+    <p:sldLayoutId xmlns:r="http://schemas.openxmlformats.org/officeDocument/2006/relationships" id="2147483657" r:id="Rf829205948d94051"/>
+    <p:sldLayoutId xmlns:r="http://schemas.openxmlformats.org/officeDocument/2006/relationships" id="2147483658" r:id="Rfc550c5f78a54a7e"/>
+    <p:sldLayoutId xmlns:r="http://schemas.openxmlformats.org/officeDocument/2006/relationships" id="2147483659" r:id="R563100de253941fa"/>
   </p:sldLayoutIdLst>
   <p:txStyles>
     <p:titleStyle>
@@ -6430,7 +6450,7 @@
           <p:cNvPr id="7" name="">
             <a:extLst xmlns:a="http://schemas.openxmlformats.org/drawingml/2006/main">
               <a:ext uri="{FF2B5EF4-FFF2-40B4-BE49-F238E27FC236}">
-                <a16:creationId xmlns:a16="http://schemas.microsoft.com/office/drawing/2014/main" id="{D0111C21-68E8-423A-81AA-3F2DFAB3FC49}"/>
+                <a16:creationId xmlns:a16="http://schemas.microsoft.com/office/drawing/2014/main" id="{BDAC5354-7261-474D-8418-3804E8AE1CFD}"/>
               </a:ext>
             </a:extLst>
           </p:cNvPr>
@@ -6440,7 +6460,7 @@
           <p:nvPr/>
         </p:nvPicPr>
         <p:blipFill>
-          <a:blip xmlns:r="http://schemas.openxmlformats.org/officeDocument/2006/relationships" xmlns:a="http://schemas.openxmlformats.org/drawingml/2006/main" r:embed="R7d61c2a1c55f4dfc"/>
+          <a:blip xmlns:r="http://schemas.openxmlformats.org/officeDocument/2006/relationships" xmlns:a="http://schemas.openxmlformats.org/drawingml/2006/main" r:embed="R5b8164d91c6c4664"/>
           <a:stretch xmlns:a="http://schemas.openxmlformats.org/drawingml/2006/main"/>
         </p:blipFill>
         <p:spPr>
@@ -6626,7 +6646,7 @@
           <p:cNvPr id="9" name="cover-rule">
             <a:extLst xmlns:a="http://schemas.openxmlformats.org/drawingml/2006/main">
               <a:ext uri="{FF2B5EF4-FFF2-40B4-BE49-F238E27FC236}">
-                <a16:creationId xmlns:a16="http://schemas.microsoft.com/office/drawing/2014/main" id="{AC59FBB1-AA33-449F-BEA8-EA2DA85DA66B}"/>
+                <a16:creationId xmlns:a16="http://schemas.microsoft.com/office/drawing/2014/main" id="{39A83B44-20E4-4685-9539-1B96963BE1C6}"/>
               </a:ext>
             </a:extLst>
           </p:cNvPr>
@@ -6679,10 +6699,10 @@
       </p:grpSpPr>
       <p:sp>
         <p:nvSpPr>
-          <p:cNvPr id="9" name="section-label">
+          <p:cNvPr id="11" name="section-label">
             <a:extLst xmlns:a="http://schemas.openxmlformats.org/drawingml/2006/main">
               <a:ext uri="{FF2B5EF4-FFF2-40B4-BE49-F238E27FC236}">
-                <a16:creationId xmlns:a16="http://schemas.microsoft.com/office/drawing/2014/main" id="{C0980BBA-E45A-4BB8-8C72-E18E7E5A674A}"/>
+                <a16:creationId xmlns:a16="http://schemas.microsoft.com/office/drawing/2014/main" id="{417707A7-22EC-4728-9FDC-568E079100BA}"/>
               </a:ext>
             </a:extLst>
           </p:cNvPr>
@@ -6720,7 +6740,6 @@
               </a:defRPr>
             </a:defPPr>
             <a:lvl1pPr algn="l">
-              <a:buNone/>
               <a:defRPr sz="1950" b="1">
                 <a:solidFill>
                   <a:srgbClr val="2B5BEB"/>
@@ -6731,7 +6750,6 @@
               </a:defRPr>
             </a:lvl1pPr>
             <a:lvl2pPr algn="l">
-              <a:buNone/>
               <a:defRPr sz="1950" b="1">
                 <a:solidFill>
                   <a:srgbClr val="2B5BEB"/>
@@ -6742,7 +6760,6 @@
               </a:defRPr>
             </a:lvl2pPr>
             <a:lvl3pPr algn="l">
-              <a:buNone/>
               <a:defRPr sz="1950" b="1">
                 <a:solidFill>
                   <a:srgbClr val="2B5BEB"/>
@@ -6753,7 +6770,6 @@
               </a:defRPr>
             </a:lvl3pPr>
             <a:lvl4pPr algn="l">
-              <a:buNone/>
               <a:defRPr sz="1950" b="1">
                 <a:solidFill>
                   <a:srgbClr val="2B5BEB"/>
@@ -6764,7 +6780,6 @@
               </a:defRPr>
             </a:lvl4pPr>
             <a:lvl5pPr algn="l">
-              <a:buNone/>
               <a:defRPr sz="1950" b="1">
                 <a:solidFill>
                   <a:srgbClr val="2B5BEB"/>
@@ -6775,7 +6790,6 @@
               </a:defRPr>
             </a:lvl5pPr>
             <a:lvl6pPr algn="l">
-              <a:buNone/>
               <a:defRPr sz="1950" b="1">
                 <a:solidFill>
                   <a:srgbClr val="2B5BEB"/>
@@ -6786,7 +6800,6 @@
               </a:defRPr>
             </a:lvl6pPr>
             <a:lvl7pPr algn="l">
-              <a:buNone/>
               <a:defRPr sz="1950" b="1">
                 <a:solidFill>
                   <a:srgbClr val="2B5BEB"/>
@@ -6797,7 +6810,6 @@
               </a:defRPr>
             </a:lvl7pPr>
             <a:lvl8pPr algn="l">
-              <a:buNone/>
               <a:defRPr sz="1950" b="1">
                 <a:solidFill>
                   <a:srgbClr val="2B5BEB"/>
@@ -6808,7 +6820,6 @@
               </a:defRPr>
             </a:lvl8pPr>
             <a:lvl9pPr algn="l">
-              <a:buNone/>
               <a:defRPr sz="1950" b="1">
                 <a:solidFill>
                   <a:srgbClr val="2B5BEB"/>
@@ -6821,7 +6832,6 @@
           </a:lstStyle>
           <a:p xmlns:a="http://schemas.openxmlformats.org/drawingml/2006/main">
             <a:pPr algn="l">
-              <a:buNone/>
               <a:defRPr sz="1950" b="1">
                 <a:solidFill>
                   <a:srgbClr val="2B5BEB"/>
@@ -6840,7 +6850,7 @@
                 <a:ea typeface="Noto Sans Bold"/>
                 <a:cs typeface="Noto Sans Bold"/>
               </a:rPr>
-              <a:t>문제와 개선</a:t>
+              <a:t>문제와 핵심 개선</a:t>
             </a:r>
           </a:p>
         </p:txBody>
@@ -6850,7 +6860,7 @@
           <p:cNvPr id="2" name="page-number">
             <a:extLst xmlns:a="http://schemas.openxmlformats.org/drawingml/2006/main">
               <a:ext uri="{FF2B5EF4-FFF2-40B4-BE49-F238E27FC236}">
-                <a16:creationId xmlns:a16="http://schemas.microsoft.com/office/drawing/2014/main" id="{07A6C1FF-0FDF-4ED1-85DF-B68D1CDF327D}"/>
+                <a16:creationId xmlns:a16="http://schemas.microsoft.com/office/drawing/2014/main" id="{9119994B-7D0E-4541-93F4-24A9FB881725}"/>
               </a:ext>
             </a:extLst>
           </p:cNvPr>
@@ -6888,7 +6898,6 @@
               </a:defRPr>
             </a:defPPr>
             <a:lvl1pPr algn="r">
-              <a:buNone/>
               <a:defRPr sz="1950" b="0">
                 <a:solidFill>
                   <a:srgbClr val="566A80"/>
@@ -6899,7 +6908,6 @@
               </a:defRPr>
             </a:lvl1pPr>
             <a:lvl2pPr algn="r">
-              <a:buNone/>
               <a:defRPr sz="1950" b="0">
                 <a:solidFill>
                   <a:srgbClr val="566A80"/>
@@ -6910,7 +6918,6 @@
               </a:defRPr>
             </a:lvl2pPr>
             <a:lvl3pPr algn="r">
-              <a:buNone/>
               <a:defRPr sz="1950" b="0">
                 <a:solidFill>
                   <a:srgbClr val="566A80"/>
@@ -6921,7 +6928,6 @@
               </a:defRPr>
             </a:lvl3pPr>
             <a:lvl4pPr algn="r">
-              <a:buNone/>
               <a:defRPr sz="1950" b="0">
                 <a:solidFill>
                   <a:srgbClr val="566A80"/>
@@ -6932,7 +6938,6 @@
               </a:defRPr>
             </a:lvl4pPr>
             <a:lvl5pPr algn="r">
-              <a:buNone/>
               <a:defRPr sz="1950" b="0">
                 <a:solidFill>
                   <a:srgbClr val="566A80"/>
@@ -6943,7 +6948,6 @@
               </a:defRPr>
             </a:lvl5pPr>
             <a:lvl6pPr algn="r">
-              <a:buNone/>
               <a:defRPr sz="1950" b="0">
                 <a:solidFill>
                   <a:srgbClr val="566A80"/>
@@ -6954,7 +6958,6 @@
               </a:defRPr>
             </a:lvl6pPr>
             <a:lvl7pPr algn="r">
-              <a:buNone/>
               <a:defRPr sz="1950" b="0">
                 <a:solidFill>
                   <a:srgbClr val="566A80"/>
@@ -6965,7 +6968,6 @@
               </a:defRPr>
             </a:lvl7pPr>
             <a:lvl8pPr algn="r">
-              <a:buNone/>
               <a:defRPr sz="1950" b="0">
                 <a:solidFill>
                   <a:srgbClr val="566A80"/>
@@ -6976,7 +6978,6 @@
               </a:defRPr>
             </a:lvl8pPr>
             <a:lvl9pPr algn="r">
-              <a:buNone/>
               <a:defRPr sz="1950" b="0">
                 <a:solidFill>
                   <a:srgbClr val="566A80"/>
@@ -6989,7 +6990,6 @@
           </a:lstStyle>
           <a:p xmlns:a="http://schemas.openxmlformats.org/drawingml/2006/main">
             <a:pPr algn="r">
-              <a:buNone/>
               <a:defRPr sz="1950" b="0">
                 <a:solidFill>
                   <a:srgbClr val="566A80"/>
@@ -7018,7 +7018,7 @@
           <p:cNvPr id="3" name="slide-title">
             <a:extLst xmlns:a="http://schemas.openxmlformats.org/drawingml/2006/main">
               <a:ext uri="{FF2B5EF4-FFF2-40B4-BE49-F238E27FC236}">
-                <a16:creationId xmlns:a16="http://schemas.microsoft.com/office/drawing/2014/main" id="{EEA2E550-E907-465F-96E9-F08579DBB174}"/>
+                <a16:creationId xmlns:a16="http://schemas.microsoft.com/office/drawing/2014/main" id="{6A81AC6A-B036-432D-AC8D-439EA2C8E4B7}"/>
               </a:ext>
             </a:extLst>
           </p:cNvPr>
@@ -7056,7 +7056,6 @@
               </a:defRPr>
             </a:defPPr>
             <a:lvl1pPr algn="l">
-              <a:buNone/>
               <a:defRPr sz="5100" b="1">
                 <a:solidFill>
                   <a:srgbClr val="122C46"/>
@@ -7067,7 +7066,6 @@
               </a:defRPr>
             </a:lvl1pPr>
             <a:lvl2pPr algn="l">
-              <a:buNone/>
               <a:defRPr sz="5100" b="1">
                 <a:solidFill>
                   <a:srgbClr val="122C46"/>
@@ -7078,7 +7076,6 @@
               </a:defRPr>
             </a:lvl2pPr>
             <a:lvl3pPr algn="l">
-              <a:buNone/>
               <a:defRPr sz="5100" b="1">
                 <a:solidFill>
                   <a:srgbClr val="122C46"/>
@@ -7089,7 +7086,6 @@
               </a:defRPr>
             </a:lvl3pPr>
             <a:lvl4pPr algn="l">
-              <a:buNone/>
               <a:defRPr sz="5100" b="1">
                 <a:solidFill>
                   <a:srgbClr val="122C46"/>
@@ -7100,7 +7096,6 @@
               </a:defRPr>
             </a:lvl4pPr>
             <a:lvl5pPr algn="l">
-              <a:buNone/>
               <a:defRPr sz="5100" b="1">
                 <a:solidFill>
                   <a:srgbClr val="122C46"/>
@@ -7111,7 +7106,6 @@
               </a:defRPr>
             </a:lvl5pPr>
             <a:lvl6pPr algn="l">
-              <a:buNone/>
               <a:defRPr sz="5100" b="1">
                 <a:solidFill>
                   <a:srgbClr val="122C46"/>
@@ -7122,7 +7116,6 @@
               </a:defRPr>
             </a:lvl6pPr>
             <a:lvl7pPr algn="l">
-              <a:buNone/>
               <a:defRPr sz="5100" b="1">
                 <a:solidFill>
                   <a:srgbClr val="122C46"/>
@@ -7133,7 +7126,6 @@
               </a:defRPr>
             </a:lvl7pPr>
             <a:lvl8pPr algn="l">
-              <a:buNone/>
               <a:defRPr sz="5100" b="1">
                 <a:solidFill>
                   <a:srgbClr val="122C46"/>
@@ -7144,7 +7136,6 @@
               </a:defRPr>
             </a:lvl8pPr>
             <a:lvl9pPr algn="l">
-              <a:buNone/>
               <a:defRPr sz="5100" b="1">
                 <a:solidFill>
                   <a:srgbClr val="122C46"/>
@@ -7157,7 +7148,6 @@
           </a:lstStyle>
           <a:p xmlns:a="http://schemas.openxmlformats.org/drawingml/2006/main">
             <a:pPr algn="l">
-              <a:buNone/>
               <a:defRPr sz="5100" b="1">
                 <a:solidFill>
                   <a:srgbClr val="122C46"/>
@@ -7176,7 +7166,7 @@
                 <a:ea typeface="Noto Sans Bold"/>
                 <a:cs typeface="Noto Sans Bold"/>
               </a:rPr>
-              <a:t>해결 과제와 개선 이유</a:t>
+              <a:t>핵심 개선: 추가 조사와 근거 검증</a:t>
             </a:r>
           </a:p>
         </p:txBody>
@@ -7186,7 +7176,7 @@
           <p:cNvPr id="4" name="slide-subtitle">
             <a:extLst xmlns:a="http://schemas.openxmlformats.org/drawingml/2006/main">
               <a:ext uri="{FF2B5EF4-FFF2-40B4-BE49-F238E27FC236}">
-                <a16:creationId xmlns:a16="http://schemas.microsoft.com/office/drawing/2014/main" id="{86D14941-B374-4C60-8B75-EF8051A8CEEE}"/>
+                <a16:creationId xmlns:a16="http://schemas.microsoft.com/office/drawing/2014/main" id="{F340EA74-8EDB-4785-9263-0F3E096E3429}"/>
               </a:ext>
             </a:extLst>
           </p:cNvPr>
@@ -7224,7 +7214,6 @@
               </a:defRPr>
             </a:defPPr>
             <a:lvl1pPr algn="l">
-              <a:buNone/>
               <a:defRPr sz="2400" b="0">
                 <a:solidFill>
                   <a:srgbClr val="566A80"/>
@@ -7235,7 +7224,6 @@
               </a:defRPr>
             </a:lvl1pPr>
             <a:lvl2pPr algn="l">
-              <a:buNone/>
               <a:defRPr sz="2400" b="0">
                 <a:solidFill>
                   <a:srgbClr val="566A80"/>
@@ -7246,7 +7234,6 @@
               </a:defRPr>
             </a:lvl2pPr>
             <a:lvl3pPr algn="l">
-              <a:buNone/>
               <a:defRPr sz="2400" b="0">
                 <a:solidFill>
                   <a:srgbClr val="566A80"/>
@@ -7257,7 +7244,6 @@
               </a:defRPr>
             </a:lvl3pPr>
             <a:lvl4pPr algn="l">
-              <a:buNone/>
               <a:defRPr sz="2400" b="0">
                 <a:solidFill>
                   <a:srgbClr val="566A80"/>
@@ -7268,7 +7254,6 @@
               </a:defRPr>
             </a:lvl4pPr>
             <a:lvl5pPr algn="l">
-              <a:buNone/>
               <a:defRPr sz="2400" b="0">
                 <a:solidFill>
                   <a:srgbClr val="566A80"/>
@@ -7279,7 +7264,6 @@
               </a:defRPr>
             </a:lvl5pPr>
             <a:lvl6pPr algn="l">
-              <a:buNone/>
               <a:defRPr sz="2400" b="0">
                 <a:solidFill>
                   <a:srgbClr val="566A80"/>
@@ -7290,7 +7274,6 @@
               </a:defRPr>
             </a:lvl6pPr>
             <a:lvl7pPr algn="l">
-              <a:buNone/>
               <a:defRPr sz="2400" b="0">
                 <a:solidFill>
                   <a:srgbClr val="566A80"/>
@@ -7301,7 +7284,6 @@
               </a:defRPr>
             </a:lvl7pPr>
             <a:lvl8pPr algn="l">
-              <a:buNone/>
               <a:defRPr sz="2400" b="0">
                 <a:solidFill>
                   <a:srgbClr val="566A80"/>
@@ -7312,7 +7294,6 @@
               </a:defRPr>
             </a:lvl8pPr>
             <a:lvl9pPr algn="l">
-              <a:buNone/>
               <a:defRPr sz="2400" b="0">
                 <a:solidFill>
                   <a:srgbClr val="566A80"/>
@@ -7325,7 +7306,6 @@
           </a:lstStyle>
           <a:p xmlns:a="http://schemas.openxmlformats.org/drawingml/2006/main">
             <a:pPr algn="l">
-              <a:buNone/>
               <a:defRPr sz="2400" b="0">
                 <a:solidFill>
                   <a:srgbClr val="566A80"/>
@@ -7344,7 +7324,7 @@
                 <a:ea typeface="Noto Sans Kr"/>
                 <a:cs typeface="Noto Sans Kr"/>
               </a:rPr>
-              <a:t>불필요한 호출과 성급한 원인 추정을 줄이는 방향으로 개선했습니다.</a:t>
+              <a:t>가설을 구별할 관측을 수집하고, 근거로 확인한 내용을 보고합니다.</a:t>
             </a:r>
           </a:p>
         </p:txBody>
@@ -7354,7 +7334,7 @@
           <p:cNvPr id="5" name="scope-note">
             <a:extLst xmlns:a="http://schemas.openxmlformats.org/drawingml/2006/main">
               <a:ext uri="{FF2B5EF4-FFF2-40B4-BE49-F238E27FC236}">
-                <a16:creationId xmlns:a16="http://schemas.microsoft.com/office/drawing/2014/main" id="{80D03D4A-9A07-41A0-B389-DA5ABF53258C}"/>
+                <a16:creationId xmlns:a16="http://schemas.microsoft.com/office/drawing/2014/main" id="{E58FD673-79AC-4DD0-94CE-820895C1E3CB}"/>
               </a:ext>
             </a:extLst>
           </p:cNvPr>
@@ -7392,7 +7372,6 @@
               </a:defRPr>
             </a:defPPr>
             <a:lvl1pPr algn="l">
-              <a:buNone/>
               <a:defRPr sz="1800" b="0">
                 <a:solidFill>
                   <a:srgbClr val="566A80"/>
@@ -7403,7 +7382,6 @@
               </a:defRPr>
             </a:lvl1pPr>
             <a:lvl2pPr algn="l">
-              <a:buNone/>
               <a:defRPr sz="1800" b="0">
                 <a:solidFill>
                   <a:srgbClr val="566A80"/>
@@ -7414,7 +7392,6 @@
               </a:defRPr>
             </a:lvl2pPr>
             <a:lvl3pPr algn="l">
-              <a:buNone/>
               <a:defRPr sz="1800" b="0">
                 <a:solidFill>
                   <a:srgbClr val="566A80"/>
@@ -7425,7 +7402,6 @@
               </a:defRPr>
             </a:lvl3pPr>
             <a:lvl4pPr algn="l">
-              <a:buNone/>
               <a:defRPr sz="1800" b="0">
                 <a:solidFill>
                   <a:srgbClr val="566A80"/>
@@ -7436,7 +7412,6 @@
               </a:defRPr>
             </a:lvl4pPr>
             <a:lvl5pPr algn="l">
-              <a:buNone/>
               <a:defRPr sz="1800" b="0">
                 <a:solidFill>
                   <a:srgbClr val="566A80"/>
@@ -7447,7 +7422,6 @@
               </a:defRPr>
             </a:lvl5pPr>
             <a:lvl6pPr algn="l">
-              <a:buNone/>
               <a:defRPr sz="1800" b="0">
                 <a:solidFill>
                   <a:srgbClr val="566A80"/>
@@ -7458,7 +7432,6 @@
               </a:defRPr>
             </a:lvl6pPr>
             <a:lvl7pPr algn="l">
-              <a:buNone/>
               <a:defRPr sz="1800" b="0">
                 <a:solidFill>
                   <a:srgbClr val="566A80"/>
@@ -7469,7 +7442,6 @@
               </a:defRPr>
             </a:lvl7pPr>
             <a:lvl8pPr algn="l">
-              <a:buNone/>
               <a:defRPr sz="1800" b="0">
                 <a:solidFill>
                   <a:srgbClr val="566A80"/>
@@ -7480,7 +7452,6 @@
               </a:defRPr>
             </a:lvl8pPr>
             <a:lvl9pPr algn="l">
-              <a:buNone/>
               <a:defRPr sz="1800" b="0">
                 <a:solidFill>
                   <a:srgbClr val="566A80"/>
@@ -7493,7 +7464,6 @@
           </a:lstStyle>
           <a:p xmlns:a="http://schemas.openxmlformats.org/drawingml/2006/main">
             <a:pPr algn="l">
-              <a:buNone/>
               <a:defRPr sz="1800" b="0">
                 <a:solidFill>
                   <a:srgbClr val="566A80"/>
@@ -7512,7 +7482,7 @@
                 <a:ea typeface="Noto Sans Kr"/>
                 <a:cs typeface="Noto Sans Kr"/>
               </a:rPr>
-              <a:t>결론과 함께 조사 이유·관측·판단 변경 과정을 화면에 남깁니다.</a:t>
+              <a:t>원인 판단과 보고서의 근거를 코드·관측 기록으로 확인합니다.</a:t>
             </a:r>
           </a:p>
         </p:txBody>
@@ -7522,7 +7492,7 @@
           <p:cNvPr id="6" name="footer-rule">
             <a:extLst xmlns:a="http://schemas.openxmlformats.org/drawingml/2006/main">
               <a:ext uri="{FF2B5EF4-FFF2-40B4-BE49-F238E27FC236}">
-                <a16:creationId xmlns:a16="http://schemas.microsoft.com/office/drawing/2014/main" id="{8EDCE14B-72A3-4C57-8B4D-03FE68C1141C}"/>
+                <a16:creationId xmlns:a16="http://schemas.microsoft.com/office/drawing/2014/main" id="{5A23AABD-1E4A-43DD-9E78-DC4F89F3C9D9}"/>
               </a:ext>
             </a:extLst>
           </p:cNvPr>
@@ -7549,7 +7519,7 @@
           <p:cNvPr id="7" name="footer">
             <a:extLst xmlns:a="http://schemas.openxmlformats.org/drawingml/2006/main">
               <a:ext uri="{FF2B5EF4-FFF2-40B4-BE49-F238E27FC236}">
-                <a16:creationId xmlns:a16="http://schemas.microsoft.com/office/drawing/2014/main" id="{A11F6A1F-61F3-45BC-8FD9-CA2981937CB7}"/>
+                <a16:creationId xmlns:a16="http://schemas.microsoft.com/office/drawing/2014/main" id="{C7BD6933-C451-4CAD-85B8-EB7B55E9625C}"/>
               </a:ext>
             </a:extLst>
           </p:cNvPr>
@@ -7587,7 +7557,6 @@
               </a:defRPr>
             </a:defPPr>
             <a:lvl1pPr algn="l">
-              <a:buNone/>
               <a:defRPr sz="1650" b="0">
                 <a:solidFill>
                   <a:srgbClr val="566A80"/>
@@ -7598,7 +7567,6 @@
               </a:defRPr>
             </a:lvl1pPr>
             <a:lvl2pPr algn="l">
-              <a:buNone/>
               <a:defRPr sz="1650" b="0">
                 <a:solidFill>
                   <a:srgbClr val="566A80"/>
@@ -7609,7 +7577,6 @@
               </a:defRPr>
             </a:lvl2pPr>
             <a:lvl3pPr algn="l">
-              <a:buNone/>
               <a:defRPr sz="1650" b="0">
                 <a:solidFill>
                   <a:srgbClr val="566A80"/>
@@ -7620,7 +7587,6 @@
               </a:defRPr>
             </a:lvl3pPr>
             <a:lvl4pPr algn="l">
-              <a:buNone/>
               <a:defRPr sz="1650" b="0">
                 <a:solidFill>
                   <a:srgbClr val="566A80"/>
@@ -7631,7 +7597,6 @@
               </a:defRPr>
             </a:lvl4pPr>
             <a:lvl5pPr algn="l">
-              <a:buNone/>
               <a:defRPr sz="1650" b="0">
                 <a:solidFill>
                   <a:srgbClr val="566A80"/>
@@ -7642,7 +7607,6 @@
               </a:defRPr>
             </a:lvl5pPr>
             <a:lvl6pPr algn="l">
-              <a:buNone/>
               <a:defRPr sz="1650" b="0">
                 <a:solidFill>
                   <a:srgbClr val="566A80"/>
@@ -7653,7 +7617,6 @@
               </a:defRPr>
             </a:lvl6pPr>
             <a:lvl7pPr algn="l">
-              <a:buNone/>
               <a:defRPr sz="1650" b="0">
                 <a:solidFill>
                   <a:srgbClr val="566A80"/>
@@ -7664,7 +7627,6 @@
               </a:defRPr>
             </a:lvl7pPr>
             <a:lvl8pPr algn="l">
-              <a:buNone/>
               <a:defRPr sz="1650" b="0">
                 <a:solidFill>
                   <a:srgbClr val="566A80"/>
@@ -7675,7 +7637,6 @@
               </a:defRPr>
             </a:lvl8pPr>
             <a:lvl9pPr algn="l">
-              <a:buNone/>
               <a:defRPr sz="1650" b="0">
                 <a:solidFill>
                   <a:srgbClr val="566A80"/>
@@ -7688,7 +7649,6 @@
           </a:lstStyle>
           <a:p xmlns:a="http://schemas.openxmlformats.org/drawingml/2006/main">
             <a:pPr algn="l">
-              <a:buNone/>
               <a:defRPr sz="1650" b="0">
                 <a:solidFill>
                   <a:srgbClr val="566A80"/>
@@ -7717,7 +7677,7 @@
           <p:cNvPr id="8" name="">
             <a:extLst xmlns:a="http://schemas.openxmlformats.org/drawingml/2006/main">
               <a:ext uri="{FF2B5EF4-FFF2-40B4-BE49-F238E27FC236}">
-                <a16:creationId xmlns:a16="http://schemas.microsoft.com/office/drawing/2014/main" id="{A034153A-2236-48ED-9026-6AD7D8F907B7}"/>
+                <a16:creationId xmlns:a16="http://schemas.microsoft.com/office/drawing/2014/main" id="{6100E25F-BC72-47CB-A0E6-ECA4254F7CCE}"/>
               </a:ext>
             </a:extLst>
           </p:cNvPr>
@@ -7726,7 +7686,7 @@
         </p:nvGraphicFramePr>
         <p:xfrm>
           <a:off xmlns:a="http://schemas.openxmlformats.org/drawingml/2006/main" x="1143000" y="3429000"/>
-          <a:ext xmlns:a="http://schemas.openxmlformats.org/drawingml/2006/main" cx="16002000" cy="4953000"/>
+          <a:ext xmlns:a="http://schemas.openxmlformats.org/drawingml/2006/main" cx="16002000" cy="3962400"/>
         </p:xfrm>
         <a:graphic xmlns:a="http://schemas.openxmlformats.org/drawingml/2006/main">
           <a:graphicData uri="http://schemas.openxmlformats.org/drawingml/2006/table">
@@ -7736,7 +7696,7 @@
                 <a:gridCol w="7239000"/>
                 <a:gridCol w="8763000"/>
               </a:tblGrid>
-              <a:tr h="666750">
+              <a:tr h="609600">
                 <a:tc>
                   <a:txBody>
                     <a:bodyPr/>
@@ -7751,7 +7711,7 @@
                           <a:ea typeface="Noto Sans Bold"/>
                           <a:cs typeface="Noto Sans Bold"/>
                         </a:rPr>
-                        <a:t>기존 문제</a:t>
+                        <a:t>기존 한계</a:t>
                       </a:r>
                     </a:p>
                   </a:txBody>
@@ -7799,7 +7759,7 @@
                           <a:ea typeface="Noto Sans Bold"/>
                           <a:cs typeface="Noto Sans Bold"/>
                         </a:rPr>
-                        <a:t>개선한 동작</a:t>
+                        <a:t>핵심 개선</a:t>
                       </a:r>
                     </a:p>
                   </a:txBody>
@@ -7828,7 +7788,7 @@
                   </a:tcPr>
                 </a:tc>
               </a:tr>
-              <a:tr h="1428750">
+              <a:tr h="1676400">
                 <a:tc>
                   <a:txBody>
                     <a:bodyPr/>
@@ -7843,7 +7803,7 @@
                           <a:ea typeface="Noto Sans Kr"/>
                           <a:cs typeface="Noto Sans Kr"/>
                         </a:rPr>
-                        <a:t>업무 외 입력도 모델 호출</a:t>
+                        <a:t>경고·초기 지표만으로 원인 추정</a:t>
                       </a:r>
                     </a:p>
                     <a:p>
@@ -7856,7 +7816,7 @@
                           <a:ea typeface="Noto Sans Kr"/>
                           <a:cs typeface="Noto Sans Kr"/>
                         </a:rPr>
-                        <a:t>조사 가치가 낮은 요청의 비용 발생</a:t>
+                        <a:t>가설을 구별할 근거가 부족</a:t>
                       </a:r>
                     </a:p>
                   </a:txBody>
@@ -7898,7 +7858,7 @@
                           <a:ea typeface="Noto Sans Kr"/>
                           <a:cs typeface="Noto Sans Kr"/>
                         </a:rPr>
-                        <a:t>호출 전 로컬 입력 검사</a:t>
+                        <a:t>가설 기반 추가 조사</a:t>
                       </a:r>
                     </a:p>
                     <a:p>
@@ -7911,7 +7871,7 @@
                           <a:ea typeface="Noto Sans Kr"/>
                           <a:cs typeface="Noto Sans Kr"/>
                         </a:rPr>
-                        <a:t>대상·후속 질문 맥락 보존</a:t>
+                        <a:t>질문 선택·추가 관측·가설 갱신</a:t>
                       </a:r>
                     </a:p>
                   </a:txBody>
@@ -7934,7 +7894,7 @@
                   </a:tcPr>
                 </a:tc>
               </a:tr>
-              <a:tr h="1428750">
+              <a:tr h="1676400">
                 <a:tc>
                   <a:txBody>
                     <a:bodyPr/>
@@ -7949,7 +7909,7 @@
                           <a:ea typeface="Noto Sans Kr"/>
                           <a:cs typeface="Noto Sans Kr"/>
                         </a:rPr>
-                        <a:t>경고만으로 원인 추정</a:t>
+                        <a:t>답변의 사실 여부를 확인하기 어려움</a:t>
                       </a:r>
                     </a:p>
                     <a:p>
@@ -7962,7 +7922,7 @@
                           <a:ea typeface="Noto Sans Kr"/>
                           <a:cs typeface="Noto Sans Kr"/>
                         </a:rPr>
-                        <a:t>원인을 구별할 관측이 부족</a:t>
+                        <a:t>조회값·출처·조치 조건 확인이 필요</a:t>
                       </a:r>
                     </a:p>
                   </a:txBody>
@@ -8004,7 +7964,7 @@
                           <a:ea typeface="Noto Sans Kr"/>
                           <a:cs typeface="Noto Sans Kr"/>
                         </a:rPr>
-                        <a:t>가설별 지지·반증 조건 고정</a:t>
+                        <a:t>관측 수치·출처·조치 조건 검증</a:t>
                       </a:r>
                     </a:p>
                     <a:p>
@@ -8017,113 +7977,7 @@
                           <a:ea typeface="Noto Sans Kr"/>
                           <a:cs typeface="Noto Sans Kr"/>
                         </a:rPr>
-                        <a:t>추가 관측으로 판단 갱신</a:t>
-                      </a:r>
-                    </a:p>
-                  </a:txBody>
-                  <a:tcPr marL="266700" marR="228600" marT="114300" marB="114300" anchor="ctr">
-                    <a:lnR w="9525">
-                      <a:solidFill>
-                        <a:srgbClr val="DDE5EE"/>
-                      </a:solidFill>
-                      <a:prstDash val="solid"/>
-                    </a:lnR>
-                    <a:lnB w="9525">
-                      <a:solidFill>
-                        <a:srgbClr val="DDE5EE"/>
-                      </a:solidFill>
-                      <a:prstDash val="solid"/>
-                    </a:lnB>
-                    <a:solidFill>
-                      <a:srgbClr val="FFFFFF"/>
-                    </a:solidFill>
-                  </a:tcPr>
-                </a:tc>
-              </a:tr>
-              <a:tr h="1428750">
-                <a:tc>
-                  <a:txBody>
-                    <a:bodyPr/>
-                    <a:lstStyle/>
-                    <a:p>
-                      <a:r>
-                        <a:rPr sz="2400">
-                          <a:solidFill>
-                            <a:srgbClr val="122C46"/>
-                          </a:solidFill>
-                          <a:latin typeface="Noto Sans Kr"/>
-                          <a:ea typeface="Noto Sans Kr"/>
-                          <a:cs typeface="Noto Sans Kr"/>
-                        </a:rPr>
-                        <a:t>조회 실패·근거 누락·수치 오류</a:t>
-                      </a:r>
-                    </a:p>
-                    <a:p>
-                      <a:r>
-                        <a:rPr sz="2400">
-                          <a:solidFill>
-                            <a:srgbClr val="122C46"/>
-                          </a:solidFill>
-                          <a:latin typeface="Noto Sans Kr"/>
-                          <a:ea typeface="Noto Sans Kr"/>
-                          <a:cs typeface="Noto Sans Kr"/>
-                        </a:rPr>
-                        <a:t>답변의 신뢰도 확인이 어려움</a:t>
-                      </a:r>
-                    </a:p>
-                  </a:txBody>
-                  <a:tcPr marL="266700" marR="228600" marT="114300" marB="114300" anchor="ctr">
-                    <a:lnL w="9525">
-                      <a:solidFill>
-                        <a:srgbClr val="DDE5EE"/>
-                      </a:solidFill>
-                      <a:prstDash val="solid"/>
-                    </a:lnL>
-                    <a:lnR w="9525">
-                      <a:solidFill>
-                        <a:srgbClr val="DDE5EE"/>
-                      </a:solidFill>
-                      <a:prstDash val="solid"/>
-                    </a:lnR>
-                    <a:lnB w="9525">
-                      <a:solidFill>
-                        <a:srgbClr val="DDE5EE"/>
-                      </a:solidFill>
-                      <a:prstDash val="solid"/>
-                    </a:lnB>
-                    <a:solidFill>
-                      <a:srgbClr val="FFFFFF"/>
-                    </a:solidFill>
-                  </a:tcPr>
-                </a:tc>
-                <a:tc>
-                  <a:txBody>
-                    <a:bodyPr/>
-                    <a:lstStyle/>
-                    <a:p>
-                      <a:r>
-                        <a:rPr sz="2400">
-                          <a:solidFill>
-                            <a:srgbClr val="122C46"/>
-                          </a:solidFill>
-                          <a:latin typeface="Noto Sans Kr"/>
-                          <a:ea typeface="Noto Sans Kr"/>
-                          <a:cs typeface="Noto Sans Kr"/>
-                        </a:rPr>
-                        <a:t>성공 근거 보존·부분 실패 안내</a:t>
-                      </a:r>
-                    </a:p>
-                    <a:p>
-                      <a:r>
-                        <a:rPr sz="2400">
-                          <a:solidFill>
-                            <a:srgbClr val="122C46"/>
-                          </a:solidFill>
-                          <a:latin typeface="Noto Sans Kr"/>
-                          <a:ea typeface="Noto Sans Kr"/>
-                          <a:cs typeface="Noto Sans Kr"/>
-                        </a:rPr>
-                        <a:t>출처·수치·허용 조치 검증</a:t>
+                        <a:t>반복 검증 실패 시 관측만 안내</a:t>
                       </a:r>
                     </a:p>
                   </a:txBody>
@@ -8150,6 +8004,322 @@
           </a:graphicData>
         </a:graphic>
       </p:graphicFrame>
+      <p:sp>
+        <p:nvSpPr>
+          <p:cNvPr id="9" name="supporting-features-label">
+            <a:extLst xmlns:a="http://schemas.openxmlformats.org/drawingml/2006/main">
+              <a:ext uri="{FF2B5EF4-FFF2-40B4-BE49-F238E27FC236}">
+                <a16:creationId xmlns:a16="http://schemas.microsoft.com/office/drawing/2014/main" id="{492BD73D-590C-4F3D-927A-258F1DD35067}"/>
+              </a:ext>
+            </a:extLst>
+          </p:cNvPr>
+          <p:cNvSpPr>
+            <a:spLocks xmlns:a="http://schemas.openxmlformats.org/drawingml/2006/main" noGrp="1"/>
+          </p:cNvSpPr>
+          <p:nvPr/>
+        </p:nvSpPr>
+        <p:spPr>
+          <a:xfrm xmlns:a="http://schemas.openxmlformats.org/drawingml/2006/main">
+            <a:off x="1143000" y="7981950"/>
+            <a:ext cx="2381250" cy="476250"/>
+          </a:xfrm>
+          <a:prstGeom xmlns:a="http://schemas.openxmlformats.org/drawingml/2006/main" prst="rect">
+            <a:avLst/>
+          </a:prstGeom>
+          <a:noFill xmlns:a="http://schemas.openxmlformats.org/drawingml/2006/main"/>
+          <a:ln xmlns:a="http://schemas.openxmlformats.org/drawingml/2006/main" w="0">
+            <a:noFill/>
+          </a:ln>
+        </p:spPr>
+        <p:txBody>
+          <a:bodyPr xmlns:a="http://schemas.openxmlformats.org/drawingml/2006/main" wrap="none" lIns="0" tIns="0" rIns="0" bIns="0" anchor="t">
+            <a:noAutofit/>
+          </a:bodyPr>
+          <a:lstStyle xmlns:a="http://schemas.openxmlformats.org/drawingml/2006/main">
+            <a:defPPr algn="l">
+              <a:defRPr sz="2250" b="1">
+                <a:solidFill>
+                  <a:srgbClr val="2B5BEB"/>
+                </a:solidFill>
+                <a:latin typeface="Noto Sans Bold"/>
+                <a:ea typeface="Noto Sans Bold"/>
+                <a:cs typeface="Noto Sans Bold"/>
+              </a:defRPr>
+            </a:defPPr>
+            <a:lvl1pPr algn="l">
+              <a:defRPr sz="2250" b="1">
+                <a:solidFill>
+                  <a:srgbClr val="2B5BEB"/>
+                </a:solidFill>
+                <a:latin typeface="Noto Sans Bold"/>
+                <a:ea typeface="Noto Sans Bold"/>
+                <a:cs typeface="Noto Sans Bold"/>
+              </a:defRPr>
+            </a:lvl1pPr>
+            <a:lvl2pPr algn="l">
+              <a:defRPr sz="2250" b="1">
+                <a:solidFill>
+                  <a:srgbClr val="2B5BEB"/>
+                </a:solidFill>
+                <a:latin typeface="Noto Sans Bold"/>
+                <a:ea typeface="Noto Sans Bold"/>
+                <a:cs typeface="Noto Sans Bold"/>
+              </a:defRPr>
+            </a:lvl2pPr>
+            <a:lvl3pPr algn="l">
+              <a:defRPr sz="2250" b="1">
+                <a:solidFill>
+                  <a:srgbClr val="2B5BEB"/>
+                </a:solidFill>
+                <a:latin typeface="Noto Sans Bold"/>
+                <a:ea typeface="Noto Sans Bold"/>
+                <a:cs typeface="Noto Sans Bold"/>
+              </a:defRPr>
+            </a:lvl3pPr>
+            <a:lvl4pPr algn="l">
+              <a:defRPr sz="2250" b="1">
+                <a:solidFill>
+                  <a:srgbClr val="2B5BEB"/>
+                </a:solidFill>
+                <a:latin typeface="Noto Sans Bold"/>
+                <a:ea typeface="Noto Sans Bold"/>
+                <a:cs typeface="Noto Sans Bold"/>
+              </a:defRPr>
+            </a:lvl4pPr>
+            <a:lvl5pPr algn="l">
+              <a:defRPr sz="2250" b="1">
+                <a:solidFill>
+                  <a:srgbClr val="2B5BEB"/>
+                </a:solidFill>
+                <a:latin typeface="Noto Sans Bold"/>
+                <a:ea typeface="Noto Sans Bold"/>
+                <a:cs typeface="Noto Sans Bold"/>
+              </a:defRPr>
+            </a:lvl5pPr>
+            <a:lvl6pPr algn="l">
+              <a:defRPr sz="2250" b="1">
+                <a:solidFill>
+                  <a:srgbClr val="2B5BEB"/>
+                </a:solidFill>
+                <a:latin typeface="Noto Sans Bold"/>
+                <a:ea typeface="Noto Sans Bold"/>
+                <a:cs typeface="Noto Sans Bold"/>
+              </a:defRPr>
+            </a:lvl6pPr>
+            <a:lvl7pPr algn="l">
+              <a:defRPr sz="2250" b="1">
+                <a:solidFill>
+                  <a:srgbClr val="2B5BEB"/>
+                </a:solidFill>
+                <a:latin typeface="Noto Sans Bold"/>
+                <a:ea typeface="Noto Sans Bold"/>
+                <a:cs typeface="Noto Sans Bold"/>
+              </a:defRPr>
+            </a:lvl7pPr>
+            <a:lvl8pPr algn="l">
+              <a:defRPr sz="2250" b="1">
+                <a:solidFill>
+                  <a:srgbClr val="2B5BEB"/>
+                </a:solidFill>
+                <a:latin typeface="Noto Sans Bold"/>
+                <a:ea typeface="Noto Sans Bold"/>
+                <a:cs typeface="Noto Sans Bold"/>
+              </a:defRPr>
+            </a:lvl8pPr>
+            <a:lvl9pPr algn="l">
+              <a:defRPr sz="2250" b="1">
+                <a:solidFill>
+                  <a:srgbClr val="2B5BEB"/>
+                </a:solidFill>
+                <a:latin typeface="Noto Sans Bold"/>
+                <a:ea typeface="Noto Sans Bold"/>
+                <a:cs typeface="Noto Sans Bold"/>
+              </a:defRPr>
+            </a:lvl9pPr>
+          </a:lstStyle>
+          <a:p xmlns:a="http://schemas.openxmlformats.org/drawingml/2006/main">
+            <a:pPr algn="l">
+              <a:defRPr sz="2250" b="1">
+                <a:solidFill>
+                  <a:srgbClr val="2B5BEB"/>
+                </a:solidFill>
+                <a:latin typeface="Noto Sans Bold"/>
+                <a:ea typeface="Noto Sans Bold"/>
+                <a:cs typeface="Noto Sans Bold"/>
+              </a:defRPr>
+            </a:pPr>
+            <a:r>
+              <a:rPr sz="2250" b="1">
+                <a:solidFill>
+                  <a:srgbClr val="2B5BEB"/>
+                </a:solidFill>
+                <a:latin typeface="Noto Sans Bold"/>
+                <a:ea typeface="Noto Sans Bold"/>
+                <a:cs typeface="Noto Sans Bold"/>
+              </a:rPr>
+              <a:t>보조 안정성</a:t>
+            </a:r>
+          </a:p>
+        </p:txBody>
+      </p:sp>
+      <p:sp>
+        <p:nvSpPr>
+          <p:cNvPr id="10" name="supporting-features">
+            <a:extLst xmlns:a="http://schemas.openxmlformats.org/drawingml/2006/main">
+              <a:ext uri="{FF2B5EF4-FFF2-40B4-BE49-F238E27FC236}">
+                <a16:creationId xmlns:a16="http://schemas.microsoft.com/office/drawing/2014/main" id="{5B869E42-4EA3-4191-A1EF-DD2613351976}"/>
+              </a:ext>
+            </a:extLst>
+          </p:cNvPr>
+          <p:cNvSpPr>
+            <a:spLocks xmlns:a="http://schemas.openxmlformats.org/drawingml/2006/main" noGrp="1"/>
+          </p:cNvSpPr>
+          <p:nvPr/>
+        </p:nvSpPr>
+        <p:spPr>
+          <a:xfrm xmlns:a="http://schemas.openxmlformats.org/drawingml/2006/main">
+            <a:off x="3905250" y="7981950"/>
+            <a:ext cx="13239750" cy="476250"/>
+          </a:xfrm>
+          <a:prstGeom xmlns:a="http://schemas.openxmlformats.org/drawingml/2006/main" prst="rect">
+            <a:avLst/>
+          </a:prstGeom>
+          <a:noFill xmlns:a="http://schemas.openxmlformats.org/drawingml/2006/main"/>
+          <a:ln xmlns:a="http://schemas.openxmlformats.org/drawingml/2006/main" w="0">
+            <a:noFill/>
+          </a:ln>
+        </p:spPr>
+        <p:txBody>
+          <a:bodyPr xmlns:a="http://schemas.openxmlformats.org/drawingml/2006/main" wrap="none" lIns="0" tIns="0" rIns="0" bIns="0" anchor="t">
+            <a:noAutofit/>
+          </a:bodyPr>
+          <a:lstStyle xmlns:a="http://schemas.openxmlformats.org/drawingml/2006/main">
+            <a:defPPr algn="l">
+              <a:defRPr sz="2250" b="0">
+                <a:solidFill>
+                  <a:srgbClr val="566A80"/>
+                </a:solidFill>
+                <a:latin typeface="Noto Sans Kr"/>
+                <a:ea typeface="Noto Sans Kr"/>
+                <a:cs typeface="Noto Sans Kr"/>
+              </a:defRPr>
+            </a:defPPr>
+            <a:lvl1pPr algn="l">
+              <a:defRPr sz="2250" b="0">
+                <a:solidFill>
+                  <a:srgbClr val="566A80"/>
+                </a:solidFill>
+                <a:latin typeface="Noto Sans Kr"/>
+                <a:ea typeface="Noto Sans Kr"/>
+                <a:cs typeface="Noto Sans Kr"/>
+              </a:defRPr>
+            </a:lvl1pPr>
+            <a:lvl2pPr algn="l">
+              <a:defRPr sz="2250" b="0">
+                <a:solidFill>
+                  <a:srgbClr val="566A80"/>
+                </a:solidFill>
+                <a:latin typeface="Noto Sans Kr"/>
+                <a:ea typeface="Noto Sans Kr"/>
+                <a:cs typeface="Noto Sans Kr"/>
+              </a:defRPr>
+            </a:lvl2pPr>
+            <a:lvl3pPr algn="l">
+              <a:defRPr sz="2250" b="0">
+                <a:solidFill>
+                  <a:srgbClr val="566A80"/>
+                </a:solidFill>
+                <a:latin typeface="Noto Sans Kr"/>
+                <a:ea typeface="Noto Sans Kr"/>
+                <a:cs typeface="Noto Sans Kr"/>
+              </a:defRPr>
+            </a:lvl3pPr>
+            <a:lvl4pPr algn="l">
+              <a:defRPr sz="2250" b="0">
+                <a:solidFill>
+                  <a:srgbClr val="566A80"/>
+                </a:solidFill>
+                <a:latin typeface="Noto Sans Kr"/>
+                <a:ea typeface="Noto Sans Kr"/>
+                <a:cs typeface="Noto Sans Kr"/>
+              </a:defRPr>
+            </a:lvl4pPr>
+            <a:lvl5pPr algn="l">
+              <a:defRPr sz="2250" b="0">
+                <a:solidFill>
+                  <a:srgbClr val="566A80"/>
+                </a:solidFill>
+                <a:latin typeface="Noto Sans Kr"/>
+                <a:ea typeface="Noto Sans Kr"/>
+                <a:cs typeface="Noto Sans Kr"/>
+              </a:defRPr>
+            </a:lvl5pPr>
+            <a:lvl6pPr algn="l">
+              <a:defRPr sz="2250" b="0">
+                <a:solidFill>
+                  <a:srgbClr val="566A80"/>
+                </a:solidFill>
+                <a:latin typeface="Noto Sans Kr"/>
+                <a:ea typeface="Noto Sans Kr"/>
+                <a:cs typeface="Noto Sans Kr"/>
+              </a:defRPr>
+            </a:lvl6pPr>
+            <a:lvl7pPr algn="l">
+              <a:defRPr sz="2250" b="0">
+                <a:solidFill>
+                  <a:srgbClr val="566A80"/>
+                </a:solidFill>
+                <a:latin typeface="Noto Sans Kr"/>
+                <a:ea typeface="Noto Sans Kr"/>
+                <a:cs typeface="Noto Sans Kr"/>
+              </a:defRPr>
+            </a:lvl7pPr>
+            <a:lvl8pPr algn="l">
+              <a:defRPr sz="2250" b="0">
+                <a:solidFill>
+                  <a:srgbClr val="566A80"/>
+                </a:solidFill>
+                <a:latin typeface="Noto Sans Kr"/>
+                <a:ea typeface="Noto Sans Kr"/>
+                <a:cs typeface="Noto Sans Kr"/>
+              </a:defRPr>
+            </a:lvl8pPr>
+            <a:lvl9pPr algn="l">
+              <a:defRPr sz="2250" b="0">
+                <a:solidFill>
+                  <a:srgbClr val="566A80"/>
+                </a:solidFill>
+                <a:latin typeface="Noto Sans Kr"/>
+                <a:ea typeface="Noto Sans Kr"/>
+                <a:cs typeface="Noto Sans Kr"/>
+              </a:defRPr>
+            </a:lvl9pPr>
+          </a:lstStyle>
+          <a:p xmlns:a="http://schemas.openxmlformats.org/drawingml/2006/main">
+            <a:pPr algn="l">
+              <a:defRPr sz="2250" b="0">
+                <a:solidFill>
+                  <a:srgbClr val="566A80"/>
+                </a:solidFill>
+                <a:latin typeface="Noto Sans Kr"/>
+                <a:ea typeface="Noto Sans Kr"/>
+                <a:cs typeface="Noto Sans Kr"/>
+              </a:defRPr>
+            </a:pPr>
+            <a:r>
+              <a:rPr sz="2250" b="0">
+                <a:solidFill>
+                  <a:srgbClr val="566A80"/>
+                </a:solidFill>
+                <a:latin typeface="Noto Sans Kr"/>
+                <a:ea typeface="Noto Sans Kr"/>
+                <a:cs typeface="Noto Sans Kr"/>
+              </a:rPr>
+              <a:t>입력 검사·대상 확인·부분 실패 격리·기록 복원</a:t>
+            </a:r>
+          </a:p>
+        </p:txBody>
+      </p:sp>
     </p:spTree>
     <p:extLst>
       <p:ext uri="{BB962C8B-B14F-4D97-AF65-F5344CB8AC3E}">
@@ -8222,6 +8392,7 @@
               </a:defRPr>
             </a:defPPr>
             <a:lvl1pPr algn="l">
+              <a:buNone/>
               <a:defRPr sz="1950" b="1">
                 <a:solidFill>
                   <a:srgbClr val="2B5BEB"/>
@@ -8232,6 +8403,7 @@
               </a:defRPr>
             </a:lvl1pPr>
             <a:lvl2pPr algn="l">
+              <a:buNone/>
               <a:defRPr sz="1950" b="1">
                 <a:solidFill>
                   <a:srgbClr val="2B5BEB"/>
@@ -8242,6 +8414,7 @@
               </a:defRPr>
             </a:lvl2pPr>
             <a:lvl3pPr algn="l">
+              <a:buNone/>
               <a:defRPr sz="1950" b="1">
                 <a:solidFill>
                   <a:srgbClr val="2B5BEB"/>
@@ -8252,6 +8425,7 @@
               </a:defRPr>
             </a:lvl3pPr>
             <a:lvl4pPr algn="l">
+              <a:buNone/>
               <a:defRPr sz="1950" b="1">
                 <a:solidFill>
                   <a:srgbClr val="2B5BEB"/>
@@ -8262,6 +8436,7 @@
               </a:defRPr>
             </a:lvl4pPr>
             <a:lvl5pPr algn="l">
+              <a:buNone/>
               <a:defRPr sz="1950" b="1">
                 <a:solidFill>
                   <a:srgbClr val="2B5BEB"/>
@@ -8272,6 +8447,7 @@
               </a:defRPr>
             </a:lvl5pPr>
             <a:lvl6pPr algn="l">
+              <a:buNone/>
               <a:defRPr sz="1950" b="1">
                 <a:solidFill>
                   <a:srgbClr val="2B5BEB"/>
@@ -8282,6 +8458,7 @@
               </a:defRPr>
             </a:lvl6pPr>
             <a:lvl7pPr algn="l">
+              <a:buNone/>
               <a:defRPr sz="1950" b="1">
                 <a:solidFill>
                   <a:srgbClr val="2B5BEB"/>
@@ -8292,6 +8469,7 @@
               </a:defRPr>
             </a:lvl7pPr>
             <a:lvl8pPr algn="l">
+              <a:buNone/>
               <a:defRPr sz="1950" b="1">
                 <a:solidFill>
                   <a:srgbClr val="2B5BEB"/>
@@ -8302,6 +8480,7 @@
               </a:defRPr>
             </a:lvl8pPr>
             <a:lvl9pPr algn="l">
+              <a:buNone/>
               <a:defRPr sz="1950" b="1">
                 <a:solidFill>
                   <a:srgbClr val="2B5BEB"/>
@@ -8314,6 +8493,7 @@
           </a:lstStyle>
           <a:p xmlns:a="http://schemas.openxmlformats.org/drawingml/2006/main">
             <a:pPr algn="l">
+              <a:buNone/>
               <a:defRPr sz="1950" b="1">
                 <a:solidFill>
                   <a:srgbClr val="2B5BEB"/>
@@ -8332,7 +8512,7 @@
                 <a:ea typeface="Noto Sans Bold"/>
                 <a:cs typeface="Noto Sans Bold"/>
               </a:rPr>
-              <a:t>핵심 개선 효과</a:t>
+              <a:t>구현 결과: 사례 비교</a:t>
             </a:r>
           </a:p>
         </p:txBody>
@@ -8380,6 +8560,7 @@
               </a:defRPr>
             </a:defPPr>
             <a:lvl1pPr algn="r">
+              <a:buNone/>
               <a:defRPr sz="1950" b="0">
                 <a:solidFill>
                   <a:srgbClr val="566A80"/>
@@ -8390,6 +8571,7 @@
               </a:defRPr>
             </a:lvl1pPr>
             <a:lvl2pPr algn="r">
+              <a:buNone/>
               <a:defRPr sz="1950" b="0">
                 <a:solidFill>
                   <a:srgbClr val="566A80"/>
@@ -8400,6 +8582,7 @@
               </a:defRPr>
             </a:lvl2pPr>
             <a:lvl3pPr algn="r">
+              <a:buNone/>
               <a:defRPr sz="1950" b="0">
                 <a:solidFill>
                   <a:srgbClr val="566A80"/>
@@ -8410,6 +8593,7 @@
               </a:defRPr>
             </a:lvl3pPr>
             <a:lvl4pPr algn="r">
+              <a:buNone/>
               <a:defRPr sz="1950" b="0">
                 <a:solidFill>
                   <a:srgbClr val="566A80"/>
@@ -8420,6 +8604,7 @@
               </a:defRPr>
             </a:lvl4pPr>
             <a:lvl5pPr algn="r">
+              <a:buNone/>
               <a:defRPr sz="1950" b="0">
                 <a:solidFill>
                   <a:srgbClr val="566A80"/>
@@ -8430,6 +8615,7 @@
               </a:defRPr>
             </a:lvl5pPr>
             <a:lvl6pPr algn="r">
+              <a:buNone/>
               <a:defRPr sz="1950" b="0">
                 <a:solidFill>
                   <a:srgbClr val="566A80"/>
@@ -8440,6 +8626,7 @@
               </a:defRPr>
             </a:lvl6pPr>
             <a:lvl7pPr algn="r">
+              <a:buNone/>
               <a:defRPr sz="1950" b="0">
                 <a:solidFill>
                   <a:srgbClr val="566A80"/>
@@ -8450,6 +8637,7 @@
               </a:defRPr>
             </a:lvl7pPr>
             <a:lvl8pPr algn="r">
+              <a:buNone/>
               <a:defRPr sz="1950" b="0">
                 <a:solidFill>
                   <a:srgbClr val="566A80"/>
@@ -8460,6 +8648,7 @@
               </a:defRPr>
             </a:lvl8pPr>
             <a:lvl9pPr algn="r">
+              <a:buNone/>
               <a:defRPr sz="1950" b="0">
                 <a:solidFill>
                   <a:srgbClr val="566A80"/>
@@ -8472,6 +8661,7 @@
           </a:lstStyle>
           <a:p xmlns:a="http://schemas.openxmlformats.org/drawingml/2006/main">
             <a:pPr algn="r">
+              <a:buNone/>
               <a:defRPr sz="1950" b="0">
                 <a:solidFill>
                   <a:srgbClr val="566A80"/>
@@ -8538,6 +8728,7 @@
               </a:defRPr>
             </a:defPPr>
             <a:lvl1pPr algn="l">
+              <a:buNone/>
               <a:defRPr sz="5100" b="1">
                 <a:solidFill>
                   <a:srgbClr val="122C46"/>
@@ -8548,6 +8739,7 @@
               </a:defRPr>
             </a:lvl1pPr>
             <a:lvl2pPr algn="l">
+              <a:buNone/>
               <a:defRPr sz="5100" b="1">
                 <a:solidFill>
                   <a:srgbClr val="122C46"/>
@@ -8558,6 +8750,7 @@
               </a:defRPr>
             </a:lvl2pPr>
             <a:lvl3pPr algn="l">
+              <a:buNone/>
               <a:defRPr sz="5100" b="1">
                 <a:solidFill>
                   <a:srgbClr val="122C46"/>
@@ -8568,6 +8761,7 @@
               </a:defRPr>
             </a:lvl3pPr>
             <a:lvl4pPr algn="l">
+              <a:buNone/>
               <a:defRPr sz="5100" b="1">
                 <a:solidFill>
                   <a:srgbClr val="122C46"/>
@@ -8578,6 +8772,7 @@
               </a:defRPr>
             </a:lvl4pPr>
             <a:lvl5pPr algn="l">
+              <a:buNone/>
               <a:defRPr sz="5100" b="1">
                 <a:solidFill>
                   <a:srgbClr val="122C46"/>
@@ -8588,6 +8783,7 @@
               </a:defRPr>
             </a:lvl5pPr>
             <a:lvl6pPr algn="l">
+              <a:buNone/>
               <a:defRPr sz="5100" b="1">
                 <a:solidFill>
                   <a:srgbClr val="122C46"/>
@@ -8598,6 +8794,7 @@
               </a:defRPr>
             </a:lvl6pPr>
             <a:lvl7pPr algn="l">
+              <a:buNone/>
               <a:defRPr sz="5100" b="1">
                 <a:solidFill>
                   <a:srgbClr val="122C46"/>
@@ -8608,6 +8805,7 @@
               </a:defRPr>
             </a:lvl7pPr>
             <a:lvl8pPr algn="l">
+              <a:buNone/>
               <a:defRPr sz="5100" b="1">
                 <a:solidFill>
                   <a:srgbClr val="122C46"/>
@@ -8618,6 +8816,7 @@
               </a:defRPr>
             </a:lvl8pPr>
             <a:lvl9pPr algn="l">
+              <a:buNone/>
               <a:defRPr sz="5100" b="1">
                 <a:solidFill>
                   <a:srgbClr val="122C46"/>
@@ -8630,6 +8829,7 @@
           </a:lstStyle>
           <a:p xmlns:a="http://schemas.openxmlformats.org/drawingml/2006/main">
             <a:pPr algn="l">
+              <a:buNone/>
               <a:defRPr sz="5100" b="1">
                 <a:solidFill>
                   <a:srgbClr val="122C46"/>
@@ -8648,7 +8848,7 @@
                 <a:ea typeface="Noto Sans Bold"/>
                 <a:cs typeface="Noto Sans Bold"/>
               </a:rPr>
-              <a:t>추가 관측에 따라 달라지는 판단</a:t>
+              <a:t>추가 관측으로 구별한 두 사례</a:t>
             </a:r>
           </a:p>
         </p:txBody>
@@ -8696,6 +8896,7 @@
               </a:defRPr>
             </a:defPPr>
             <a:lvl1pPr algn="l">
+              <a:buNone/>
               <a:defRPr sz="2400" b="0">
                 <a:solidFill>
                   <a:srgbClr val="566A80"/>
@@ -8706,6 +8907,7 @@
               </a:defRPr>
             </a:lvl1pPr>
             <a:lvl2pPr algn="l">
+              <a:buNone/>
               <a:defRPr sz="2400" b="0">
                 <a:solidFill>
                   <a:srgbClr val="566A80"/>
@@ -8716,6 +8918,7 @@
               </a:defRPr>
             </a:lvl2pPr>
             <a:lvl3pPr algn="l">
+              <a:buNone/>
               <a:defRPr sz="2400" b="0">
                 <a:solidFill>
                   <a:srgbClr val="566A80"/>
@@ -8726,6 +8929,7 @@
               </a:defRPr>
             </a:lvl3pPr>
             <a:lvl4pPr algn="l">
+              <a:buNone/>
               <a:defRPr sz="2400" b="0">
                 <a:solidFill>
                   <a:srgbClr val="566A80"/>
@@ -8736,6 +8940,7 @@
               </a:defRPr>
             </a:lvl4pPr>
             <a:lvl5pPr algn="l">
+              <a:buNone/>
               <a:defRPr sz="2400" b="0">
                 <a:solidFill>
                   <a:srgbClr val="566A80"/>
@@ -8746,6 +8951,7 @@
               </a:defRPr>
             </a:lvl5pPr>
             <a:lvl6pPr algn="l">
+              <a:buNone/>
               <a:defRPr sz="2400" b="0">
                 <a:solidFill>
                   <a:srgbClr val="566A80"/>
@@ -8756,6 +8962,7 @@
               </a:defRPr>
             </a:lvl6pPr>
             <a:lvl7pPr algn="l">
+              <a:buNone/>
               <a:defRPr sz="2400" b="0">
                 <a:solidFill>
                   <a:srgbClr val="566A80"/>
@@ -8766,6 +8973,7 @@
               </a:defRPr>
             </a:lvl7pPr>
             <a:lvl8pPr algn="l">
+              <a:buNone/>
               <a:defRPr sz="2400" b="0">
                 <a:solidFill>
                   <a:srgbClr val="566A80"/>
@@ -8776,6 +8984,7 @@
               </a:defRPr>
             </a:lvl8pPr>
             <a:lvl9pPr algn="l">
+              <a:buNone/>
               <a:defRPr sz="2400" b="0">
                 <a:solidFill>
                   <a:srgbClr val="566A80"/>
@@ -8788,6 +8997,7 @@
           </a:lstStyle>
           <a:p xmlns:a="http://schemas.openxmlformats.org/drawingml/2006/main">
             <a:pPr algn="l">
+              <a:buNone/>
               <a:defRPr sz="2400" b="0">
                 <a:solidFill>
                   <a:srgbClr val="566A80"/>
@@ -8806,7 +9016,7 @@
                 <a:ea typeface="Noto Sans Kr"/>
                 <a:cs typeface="Noto Sans Kr"/>
               </a:rPr>
-              <a:t>첫 지표와 경고가 같아도, 원인을 구별할 관측을 더 수집합니다.</a:t>
+              <a:t>최초 CPU 91%와 배치 경고가 같은 두 사례의 판단 결과입니다.</a:t>
             </a:r>
           </a:p>
         </p:txBody>
@@ -8854,6 +9064,7 @@
               </a:defRPr>
             </a:defPPr>
             <a:lvl1pPr algn="l">
+              <a:buNone/>
               <a:defRPr sz="1800" b="0">
                 <a:solidFill>
                   <a:srgbClr val="566A80"/>
@@ -8864,6 +9075,7 @@
               </a:defRPr>
             </a:lvl1pPr>
             <a:lvl2pPr algn="l">
+              <a:buNone/>
               <a:defRPr sz="1800" b="0">
                 <a:solidFill>
                   <a:srgbClr val="566A80"/>
@@ -8874,6 +9086,7 @@
               </a:defRPr>
             </a:lvl2pPr>
             <a:lvl3pPr algn="l">
+              <a:buNone/>
               <a:defRPr sz="1800" b="0">
                 <a:solidFill>
                   <a:srgbClr val="566A80"/>
@@ -8884,6 +9097,7 @@
               </a:defRPr>
             </a:lvl3pPr>
             <a:lvl4pPr algn="l">
+              <a:buNone/>
               <a:defRPr sz="1800" b="0">
                 <a:solidFill>
                   <a:srgbClr val="566A80"/>
@@ -8894,6 +9108,7 @@
               </a:defRPr>
             </a:lvl4pPr>
             <a:lvl5pPr algn="l">
+              <a:buNone/>
               <a:defRPr sz="1800" b="0">
                 <a:solidFill>
                   <a:srgbClr val="566A80"/>
@@ -8904,6 +9119,7 @@
               </a:defRPr>
             </a:lvl5pPr>
             <a:lvl6pPr algn="l">
+              <a:buNone/>
               <a:defRPr sz="1800" b="0">
                 <a:solidFill>
                   <a:srgbClr val="566A80"/>
@@ -8914,6 +9130,7 @@
               </a:defRPr>
             </a:lvl6pPr>
             <a:lvl7pPr algn="l">
+              <a:buNone/>
               <a:defRPr sz="1800" b="0">
                 <a:solidFill>
                   <a:srgbClr val="566A80"/>
@@ -8924,6 +9141,7 @@
               </a:defRPr>
             </a:lvl7pPr>
             <a:lvl8pPr algn="l">
+              <a:buNone/>
               <a:defRPr sz="1800" b="0">
                 <a:solidFill>
                   <a:srgbClr val="566A80"/>
@@ -8934,6 +9152,7 @@
               </a:defRPr>
             </a:lvl8pPr>
             <a:lvl9pPr algn="l">
+              <a:buNone/>
               <a:defRPr sz="1800" b="0">
                 <a:solidFill>
                   <a:srgbClr val="566A80"/>
@@ -8946,6 +9165,7 @@
           </a:lstStyle>
           <a:p xmlns:a="http://schemas.openxmlformats.org/drawingml/2006/main">
             <a:pPr algn="l">
+              <a:buNone/>
               <a:defRPr sz="1800" b="0">
                 <a:solidFill>
                   <a:srgbClr val="566A80"/>
@@ -8964,7 +9184,7 @@
                 <a:ea typeface="Noto Sans Kr"/>
                 <a:cs typeface="Noto Sans Kr"/>
               </a:rPr>
-              <a:t>관측 부족·상충 시 판단 보류 / 교육용 합성 관측의 실제 LLM 실행 사례, 인과 확정과 구분</a:t>
+              <a:t>2026-10-21 실제 LLM 보존 실행 / 교육용 합성 관측, 교차 지지는 인과 확정과 구분</a:t>
             </a:r>
           </a:p>
         </p:txBody>
@@ -8974,7 +9194,7 @@
           <p:cNvPr id="6" name="footer-rule">
             <a:extLst xmlns:a="http://schemas.openxmlformats.org/drawingml/2006/main">
               <a:ext uri="{FF2B5EF4-FFF2-40B4-BE49-F238E27FC236}">
-                <a16:creationId xmlns:a16="http://schemas.microsoft.com/office/drawing/2014/main" id="{E31335C3-DF50-4AB3-BE64-5CA4A7EB1F37}"/>
+                <a16:creationId xmlns:a16="http://schemas.microsoft.com/office/drawing/2014/main" id="{BBB62D4E-3D55-494B-AA40-106C550D7A27}"/>
               </a:ext>
             </a:extLst>
           </p:cNvPr>
@@ -9039,6 +9259,7 @@
               </a:defRPr>
             </a:defPPr>
             <a:lvl1pPr algn="l">
+              <a:buNone/>
               <a:defRPr sz="1650" b="0">
                 <a:solidFill>
                   <a:srgbClr val="566A80"/>
@@ -9049,6 +9270,7 @@
               </a:defRPr>
             </a:lvl1pPr>
             <a:lvl2pPr algn="l">
+              <a:buNone/>
               <a:defRPr sz="1650" b="0">
                 <a:solidFill>
                   <a:srgbClr val="566A80"/>
@@ -9059,6 +9281,7 @@
               </a:defRPr>
             </a:lvl2pPr>
             <a:lvl3pPr algn="l">
+              <a:buNone/>
               <a:defRPr sz="1650" b="0">
                 <a:solidFill>
                   <a:srgbClr val="566A80"/>
@@ -9069,6 +9292,7 @@
               </a:defRPr>
             </a:lvl3pPr>
             <a:lvl4pPr algn="l">
+              <a:buNone/>
               <a:defRPr sz="1650" b="0">
                 <a:solidFill>
                   <a:srgbClr val="566A80"/>
@@ -9079,6 +9303,7 @@
               </a:defRPr>
             </a:lvl4pPr>
             <a:lvl5pPr algn="l">
+              <a:buNone/>
               <a:defRPr sz="1650" b="0">
                 <a:solidFill>
                   <a:srgbClr val="566A80"/>
@@ -9089,6 +9314,7 @@
               </a:defRPr>
             </a:lvl5pPr>
             <a:lvl6pPr algn="l">
+              <a:buNone/>
               <a:defRPr sz="1650" b="0">
                 <a:solidFill>
                   <a:srgbClr val="566A80"/>
@@ -9099,6 +9325,7 @@
               </a:defRPr>
             </a:lvl6pPr>
             <a:lvl7pPr algn="l">
+              <a:buNone/>
               <a:defRPr sz="1650" b="0">
                 <a:solidFill>
                   <a:srgbClr val="566A80"/>
@@ -9109,6 +9336,7 @@
               </a:defRPr>
             </a:lvl7pPr>
             <a:lvl8pPr algn="l">
+              <a:buNone/>
               <a:defRPr sz="1650" b="0">
                 <a:solidFill>
                   <a:srgbClr val="566A80"/>
@@ -9119,6 +9347,7 @@
               </a:defRPr>
             </a:lvl8pPr>
             <a:lvl9pPr algn="l">
+              <a:buNone/>
               <a:defRPr sz="1650" b="0">
                 <a:solidFill>
                   <a:srgbClr val="566A80"/>
@@ -9131,6 +9360,7 @@
           </a:lstStyle>
           <a:p xmlns:a="http://schemas.openxmlformats.org/drawingml/2006/main">
             <a:pPr algn="l">
+              <a:buNone/>
               <a:defRPr sz="1650" b="0">
                 <a:solidFill>
                   <a:srgbClr val="566A80"/>
@@ -9197,6 +9427,7 @@
               </a:defRPr>
             </a:defPPr>
             <a:lvl1pPr algn="l">
+              <a:buNone/>
               <a:defRPr sz="2550" b="1">
                 <a:solidFill>
                   <a:srgbClr val="2B5BEB"/>
@@ -9207,6 +9438,7 @@
               </a:defRPr>
             </a:lvl1pPr>
             <a:lvl2pPr algn="l">
+              <a:buNone/>
               <a:defRPr sz="2550" b="1">
                 <a:solidFill>
                   <a:srgbClr val="2B5BEB"/>
@@ -9217,6 +9449,7 @@
               </a:defRPr>
             </a:lvl2pPr>
             <a:lvl3pPr algn="l">
+              <a:buNone/>
               <a:defRPr sz="2550" b="1">
                 <a:solidFill>
                   <a:srgbClr val="2B5BEB"/>
@@ -9227,6 +9460,7 @@
               </a:defRPr>
             </a:lvl3pPr>
             <a:lvl4pPr algn="l">
+              <a:buNone/>
               <a:defRPr sz="2550" b="1">
                 <a:solidFill>
                   <a:srgbClr val="2B5BEB"/>
@@ -9237,6 +9471,7 @@
               </a:defRPr>
             </a:lvl4pPr>
             <a:lvl5pPr algn="l">
+              <a:buNone/>
               <a:defRPr sz="2550" b="1">
                 <a:solidFill>
                   <a:srgbClr val="2B5BEB"/>
@@ -9247,6 +9482,7 @@
               </a:defRPr>
             </a:lvl5pPr>
             <a:lvl6pPr algn="l">
+              <a:buNone/>
               <a:defRPr sz="2550" b="1">
                 <a:solidFill>
                   <a:srgbClr val="2B5BEB"/>
@@ -9257,6 +9493,7 @@
               </a:defRPr>
             </a:lvl6pPr>
             <a:lvl7pPr algn="l">
+              <a:buNone/>
               <a:defRPr sz="2550" b="1">
                 <a:solidFill>
                   <a:srgbClr val="2B5BEB"/>
@@ -9267,6 +9504,7 @@
               </a:defRPr>
             </a:lvl7pPr>
             <a:lvl8pPr algn="l">
+              <a:buNone/>
               <a:defRPr sz="2550" b="1">
                 <a:solidFill>
                   <a:srgbClr val="2B5BEB"/>
@@ -9277,6 +9515,7 @@
               </a:defRPr>
             </a:lvl8pPr>
             <a:lvl9pPr algn="l">
+              <a:buNone/>
               <a:defRPr sz="2550" b="1">
                 <a:solidFill>
                   <a:srgbClr val="2B5BEB"/>
@@ -9289,6 +9528,7 @@
           </a:lstStyle>
           <a:p xmlns:a="http://schemas.openxmlformats.org/drawingml/2006/main">
             <a:pPr algn="l">
+              <a:buNone/>
               <a:defRPr sz="2550" b="1">
                 <a:solidFill>
                   <a:srgbClr val="2B5BEB"/>
@@ -9355,6 +9595,7 @@
               </a:defRPr>
             </a:defPPr>
             <a:lvl1pPr algn="l">
+              <a:buNone/>
               <a:defRPr sz="2850" b="1">
                 <a:solidFill>
                   <a:srgbClr val="122C46"/>
@@ -9365,6 +9606,7 @@
               </a:defRPr>
             </a:lvl1pPr>
             <a:lvl2pPr algn="l">
+              <a:buNone/>
               <a:defRPr sz="2850" b="1">
                 <a:solidFill>
                   <a:srgbClr val="122C46"/>
@@ -9375,6 +9617,7 @@
               </a:defRPr>
             </a:lvl2pPr>
             <a:lvl3pPr algn="l">
+              <a:buNone/>
               <a:defRPr sz="2850" b="1">
                 <a:solidFill>
                   <a:srgbClr val="122C46"/>
@@ -9385,6 +9628,7 @@
               </a:defRPr>
             </a:lvl3pPr>
             <a:lvl4pPr algn="l">
+              <a:buNone/>
               <a:defRPr sz="2850" b="1">
                 <a:solidFill>
                   <a:srgbClr val="122C46"/>
@@ -9395,6 +9639,7 @@
               </a:defRPr>
             </a:lvl4pPr>
             <a:lvl5pPr algn="l">
+              <a:buNone/>
               <a:defRPr sz="2850" b="1">
                 <a:solidFill>
                   <a:srgbClr val="122C46"/>
@@ -9405,6 +9650,7 @@
               </a:defRPr>
             </a:lvl5pPr>
             <a:lvl6pPr algn="l">
+              <a:buNone/>
               <a:defRPr sz="2850" b="1">
                 <a:solidFill>
                   <a:srgbClr val="122C46"/>
@@ -9415,6 +9661,7 @@
               </a:defRPr>
             </a:lvl6pPr>
             <a:lvl7pPr algn="l">
+              <a:buNone/>
               <a:defRPr sz="2850" b="1">
                 <a:solidFill>
                   <a:srgbClr val="122C46"/>
@@ -9425,6 +9672,7 @@
               </a:defRPr>
             </a:lvl7pPr>
             <a:lvl8pPr algn="l">
+              <a:buNone/>
               <a:defRPr sz="2850" b="1">
                 <a:solidFill>
                   <a:srgbClr val="122C46"/>
@@ -9435,6 +9683,7 @@
               </a:defRPr>
             </a:lvl8pPr>
             <a:lvl9pPr algn="l">
+              <a:buNone/>
               <a:defRPr sz="2850" b="1">
                 <a:solidFill>
                   <a:srgbClr val="122C46"/>
@@ -9447,6 +9696,7 @@
           </a:lstStyle>
           <a:p xmlns:a="http://schemas.openxmlformats.org/drawingml/2006/main">
             <a:pPr algn="l">
+              <a:buNone/>
               <a:defRPr sz="2850" b="1">
                 <a:solidFill>
                   <a:srgbClr val="122C46"/>
@@ -9475,7 +9725,7 @@
           <p:cNvPr id="10" name="shared-input-rule">
             <a:extLst xmlns:a="http://schemas.openxmlformats.org/drawingml/2006/main">
               <a:ext uri="{FF2B5EF4-FFF2-40B4-BE49-F238E27FC236}">
-                <a16:creationId xmlns:a16="http://schemas.microsoft.com/office/drawing/2014/main" id="{6A3B0994-97D1-4594-B3D0-9D05356957D6}"/>
+                <a16:creationId xmlns:a16="http://schemas.microsoft.com/office/drawing/2014/main" id="{4D83B1D3-C04D-48D1-801E-4F9B796271E7}"/>
               </a:ext>
             </a:extLst>
           </p:cNvPr>
@@ -9502,7 +9752,7 @@
           <p:cNvPr id="11" name="">
             <a:extLst xmlns:a="http://schemas.openxmlformats.org/drawingml/2006/main">
               <a:ext uri="{FF2B5EF4-FFF2-40B4-BE49-F238E27FC236}">
-                <a16:creationId xmlns:a16="http://schemas.microsoft.com/office/drawing/2014/main" id="{6F31E5ED-45B7-4E57-8563-050C53D0971A}"/>
+                <a16:creationId xmlns:a16="http://schemas.microsoft.com/office/drawing/2014/main" id="{140BB491-4270-4131-BDA4-34FCE1DC7C42}"/>
               </a:ext>
             </a:extLst>
           </p:cNvPr>
@@ -10200,7 +10450,7 @@
                 <a:ea typeface="Noto Sans Bold"/>
                 <a:cs typeface="Noto Sans Bold"/>
               </a:rPr>
-              <a:t>가설 기반 조사</a:t>
+              <a:t>핵심 기능: 처리 절차</a:t>
             </a:r>
           </a:p>
         </p:txBody>
@@ -10536,7 +10786,7 @@
                 <a:ea typeface="Noto Sans Bold"/>
                 <a:cs typeface="Noto Sans Bold"/>
               </a:rPr>
-              <a:t>가설을 구별하는 추가 조사</a:t>
+              <a:t>가설 조사와 근거 검증 절차</a:t>
             </a:r>
           </a:p>
         </p:txBody>
@@ -10704,7 +10954,7 @@
                 <a:ea typeface="Noto Sans Kr"/>
                 <a:cs typeface="Noto Sans Kr"/>
               </a:rPr>
-              <a:t>조회 전에 조건을 고정하고, 새 관측으로 가설의 상태를 갱신합니다.</a:t>
+              <a:t>질문 선택은 LLM이, 조건 대조와 종료 판단은 코드가 담당합니다.</a:t>
             </a:r>
           </a:p>
         </p:txBody>
@@ -10872,7 +11122,7 @@
                 <a:ea typeface="Noto Sans Kr"/>
                 <a:cs typeface="Noto Sans Kr"/>
               </a:rPr>
-              <a:t>현재 범위: CPU 세 가설·교육용 합성 관측 / 동일 5분·추가 조회 최대 4회</a:t>
+              <a:t>추가 조회 최대 4회·동일 5분 구간 / CPU 세 가설·교육용 합성 관측</a:t>
             </a:r>
           </a:p>
         </p:txBody>
@@ -10882,7 +11132,7 @@
           <p:cNvPr id="6" name="footer-rule">
             <a:extLst xmlns:a="http://schemas.openxmlformats.org/drawingml/2006/main">
               <a:ext uri="{FF2B5EF4-FFF2-40B4-BE49-F238E27FC236}">
-                <a16:creationId xmlns:a16="http://schemas.microsoft.com/office/drawing/2014/main" id="{EDCE35CD-3DFC-40B5-B322-BBA83BDF07B0}"/>
+                <a16:creationId xmlns:a16="http://schemas.microsoft.com/office/drawing/2014/main" id="{8C3A63D0-D76C-4050-98E3-271E036B6E10}"/>
               </a:ext>
             </a:extLst>
           </p:cNvPr>
@@ -11403,7 +11653,7 @@
                 <a:ea typeface="Noto Sans Bold"/>
                 <a:cs typeface="Noto Sans Bold"/>
               </a:rPr>
-              <a:t>사전 조건</a:t>
+              <a:t>판정 기준 고정</a:t>
             </a:r>
           </a:p>
         </p:txBody>
@@ -11571,7 +11821,7 @@
                 <a:ea typeface="Noto Sans Kr"/>
                 <a:cs typeface="Noto Sans Kr"/>
               </a:rPr>
-              <a:t>조회 전에 지지·반증 기준 기록</a:t>
+              <a:t>조회 전에 지지·반증 조건 기록</a:t>
             </a:r>
           </a:p>
         </p:txBody>
@@ -11907,7 +12157,7 @@
                 <a:ea typeface="Noto Sans Bold"/>
                 <a:cs typeface="Noto Sans Bold"/>
               </a:rPr>
-              <a:t>질문 선택</a:t>
+              <a:t>관측 선택·수집</a:t>
             </a:r>
           </a:p>
         </p:txBody>
@@ -12075,7 +12325,7 @@
                 <a:ea typeface="Noto Sans Kr"/>
                 <a:cs typeface="Noto Sans Kr"/>
               </a:rPr>
-              <a:t>LLM이 허용된 미수행 질문 선택</a:t>
+              <a:t>LLM 질문 선택, MCP 읽기 전용 조회</a:t>
             </a:r>
           </a:p>
         </p:txBody>
@@ -12411,7 +12661,7 @@
                 <a:ea typeface="Noto Sans Bold"/>
                 <a:cs typeface="Noto Sans Bold"/>
               </a:rPr>
-              <a:t>관측 대조</a:t>
+              <a:t>판정·다음 조사</a:t>
             </a:r>
           </a:p>
         </p:txBody>
@@ -12579,7 +12829,7 @@
                 <a:ea typeface="Noto Sans Kr"/>
                 <a:cs typeface="Noto Sans Kr"/>
               </a:rPr>
-              <a:t>MCP 관측을 코드 조건과 비교</a:t>
+              <a:t>코드 대조 후 반복·종료·보류</a:t>
             </a:r>
           </a:p>
         </p:txBody>
@@ -12915,7 +13165,7 @@
                 <a:ea typeface="Noto Sans Bold"/>
                 <a:cs typeface="Noto Sans Bold"/>
               </a:rPr>
-              <a:t>종료 판단</a:t>
+              <a:t>보고서 근거 검증</a:t>
             </a:r>
           </a:p>
         </p:txBody>
@@ -13083,7 +13333,7 @@
                 <a:ea typeface="Noto Sans Kr"/>
                 <a:cs typeface="Noto Sans Kr"/>
               </a:rPr>
-              <a:t>교차 지지·반증 또는 판단 보류</a:t>
+              <a:t>수치·출처·조치 검사, 작성 최대 3회</a:t>
             </a:r>
           </a:p>
         </p:txBody>
@@ -13093,7 +13343,7 @@
           <p:cNvPr id="20" name="">
             <a:extLst xmlns:a="http://schemas.openxmlformats.org/drawingml/2006/main">
               <a:ext uri="{FF2B5EF4-FFF2-40B4-BE49-F238E27FC236}">
-                <a16:creationId xmlns:a16="http://schemas.microsoft.com/office/drawing/2014/main" id="{4605D347-6B1D-4816-8629-668321C3C4D0}"/>
+                <a16:creationId xmlns:a16="http://schemas.microsoft.com/office/drawing/2014/main" id="{24D7E3C0-357C-4234-ACF9-D87BA661E2D6}"/>
               </a:ext>
             </a:extLst>
           </p:cNvPr>
@@ -13103,7 +13353,7 @@
           <p:nvPr/>
         </p:nvPicPr>
         <p:blipFill>
-          <a:blip xmlns:r="http://schemas.openxmlformats.org/officeDocument/2006/relationships" xmlns:a="http://schemas.openxmlformats.org/drawingml/2006/main" r:embed="R6bda9daeb6f64748"/>
+          <a:blip xmlns:r="http://schemas.openxmlformats.org/officeDocument/2006/relationships" xmlns:a="http://schemas.openxmlformats.org/drawingml/2006/main" r:embed="R64d6d1d53a694e8f"/>
           <a:srcRect xmlns:a="http://schemas.openxmlformats.org/drawingml/2006/main" l="19000" t="41000" r="24000" b="9000"/>
           <a:stretch xmlns:a="http://schemas.openxmlformats.org/drawingml/2006/main"/>
         </p:blipFill>
@@ -13280,7 +13530,7 @@
                 <a:ea typeface="Noto Sans Bold"/>
                 <a:cs typeface="Noto Sans Bold"/>
               </a:rPr>
-              <a:t>배치 기여 5% 반증</a:t>
+              <a:t>화면에 남기는 기록</a:t>
             </a:r>
           </a:p>
           <a:p xmlns:a="http://schemas.openxmlformats.org/drawingml/2006/main">
@@ -13304,7 +13554,7 @@
                 <a:ea typeface="Noto Sans Bold"/>
                 <a:cs typeface="Noto Sans Bold"/>
               </a:rPr>
-              <a:t>요청 처리 88%·요청량 3.2배 교차 지지</a:t>
+              <a:t>조사 이유·관측·판단 전후·종료 이유</a:t>
             </a:r>
           </a:p>
         </p:txBody>
@@ -14183,7 +14433,7 @@
           <p:cNvPr id="6" name="footer-rule">
             <a:extLst xmlns:a="http://schemas.openxmlformats.org/drawingml/2006/main">
               <a:ext uri="{FF2B5EF4-FFF2-40B4-BE49-F238E27FC236}">
-                <a16:creationId xmlns:a16="http://schemas.microsoft.com/office/drawing/2014/main" id="{E5EE1D15-C01B-42A9-B2D1-016F3B4E1091}"/>
+                <a16:creationId xmlns:a16="http://schemas.microsoft.com/office/drawing/2014/main" id="{0FB52F66-668F-4442-B0C5-D33100E62BC6}"/>
               </a:ext>
             </a:extLst>
           </p:cNvPr>
@@ -14378,7 +14628,7 @@
           <p:cNvPr id="8" name="architecture-link">
             <a:extLst xmlns:a="http://schemas.openxmlformats.org/drawingml/2006/main">
               <a:ext uri="{FF2B5EF4-FFF2-40B4-BE49-F238E27FC236}">
-                <a16:creationId xmlns:a16="http://schemas.microsoft.com/office/drawing/2014/main" id="{02C7639E-BDE4-4F92-A68F-58694FF94301}"/>
+                <a16:creationId xmlns:a16="http://schemas.microsoft.com/office/drawing/2014/main" id="{A1713870-F5C9-454A-B6B2-D7AAF40A9CBE}"/>
               </a:ext>
             </a:extLst>
           </p:cNvPr>
@@ -14406,7 +14656,7 @@
           <p:cNvPr id="9" name="architecture-link">
             <a:extLst xmlns:a="http://schemas.openxmlformats.org/drawingml/2006/main">
               <a:ext uri="{FF2B5EF4-FFF2-40B4-BE49-F238E27FC236}">
-                <a16:creationId xmlns:a16="http://schemas.microsoft.com/office/drawing/2014/main" id="{015E2E36-44E7-4D2E-96D7-8D48D6ACADCD}"/>
+                <a16:creationId xmlns:a16="http://schemas.microsoft.com/office/drawing/2014/main" id="{AA8A6FB2-41A7-40AB-8EF7-81038147B59F}"/>
               </a:ext>
             </a:extLst>
           </p:cNvPr>
@@ -14770,7 +15020,7 @@
           <p:cNvPr id="12" name="architecture-link">
             <a:extLst xmlns:a="http://schemas.openxmlformats.org/drawingml/2006/main">
               <a:ext uri="{FF2B5EF4-FFF2-40B4-BE49-F238E27FC236}">
-                <a16:creationId xmlns:a16="http://schemas.microsoft.com/office/drawing/2014/main" id="{3AC2C614-0105-4579-B976-BE84BF9AB8B8}"/>
+                <a16:creationId xmlns:a16="http://schemas.microsoft.com/office/drawing/2014/main" id="{937475E4-CBB4-4930-959E-BA8C7C047E96}"/>
               </a:ext>
             </a:extLst>
           </p:cNvPr>
@@ -14966,7 +15216,7 @@
           <p:cNvPr id="14" name="architecture-link">
             <a:extLst xmlns:a="http://schemas.openxmlformats.org/drawingml/2006/main">
               <a:ext uri="{FF2B5EF4-FFF2-40B4-BE49-F238E27FC236}">
-                <a16:creationId xmlns:a16="http://schemas.microsoft.com/office/drawing/2014/main" id="{2079A68C-9282-4665-99E3-5D5E8F4D3991}"/>
+                <a16:creationId xmlns:a16="http://schemas.microsoft.com/office/drawing/2014/main" id="{E5C2F2B4-3F03-4B2C-8D49-339D0C862380}"/>
               </a:ext>
             </a:extLst>
           </p:cNvPr>
@@ -14994,7 +15244,7 @@
           <p:cNvPr id="15" name="architecture-link">
             <a:extLst xmlns:a="http://schemas.openxmlformats.org/drawingml/2006/main">
               <a:ext uri="{FF2B5EF4-FFF2-40B4-BE49-F238E27FC236}">
-                <a16:creationId xmlns:a16="http://schemas.microsoft.com/office/drawing/2014/main" id="{96CD06D9-4B26-425A-AF1E-A4A046984C8F}"/>
+                <a16:creationId xmlns:a16="http://schemas.microsoft.com/office/drawing/2014/main" id="{B832E522-3599-49F5-B9F4-F812448FF966}"/>
               </a:ext>
             </a:extLst>
           </p:cNvPr>
@@ -15023,7 +15273,7 @@
           <p:cNvPr id="16" name="architecture-link">
             <a:extLst xmlns:a="http://schemas.openxmlformats.org/drawingml/2006/main">
               <a:ext uri="{FF2B5EF4-FFF2-40B4-BE49-F238E27FC236}">
-                <a16:creationId xmlns:a16="http://schemas.microsoft.com/office/drawing/2014/main" id="{F901218E-DC6B-4BFC-B9AD-3EDDCEA342C5}"/>
+                <a16:creationId xmlns:a16="http://schemas.microsoft.com/office/drawing/2014/main" id="{F6114A70-0558-411C-A32F-CCD930EBFFF9}"/>
               </a:ext>
             </a:extLst>
           </p:cNvPr>
@@ -15051,7 +15301,7 @@
           <p:cNvPr id="17" name="architecture-link">
             <a:extLst xmlns:a="http://schemas.openxmlformats.org/drawingml/2006/main">
               <a:ext uri="{FF2B5EF4-FFF2-40B4-BE49-F238E27FC236}">
-                <a16:creationId xmlns:a16="http://schemas.microsoft.com/office/drawing/2014/main" id="{57B20721-7FF9-46B8-85DB-BBD593EB3162}"/>
+                <a16:creationId xmlns:a16="http://schemas.microsoft.com/office/drawing/2014/main" id="{1D05C341-4BF0-4BB8-BACA-2776BEE23012}"/>
               </a:ext>
             </a:extLst>
           </p:cNvPr>
@@ -15079,7 +15329,7 @@
           <p:cNvPr id="18" name="architecture-link">
             <a:extLst xmlns:a="http://schemas.openxmlformats.org/drawingml/2006/main">
               <a:ext uri="{FF2B5EF4-FFF2-40B4-BE49-F238E27FC236}">
-                <a16:creationId xmlns:a16="http://schemas.microsoft.com/office/drawing/2014/main" id="{E00643DE-5AA7-4CAA-918A-C89EFBB5627B}"/>
+                <a16:creationId xmlns:a16="http://schemas.microsoft.com/office/drawing/2014/main" id="{88438076-CD21-4278-8EC0-5E02E4FB2B7C}"/>
               </a:ext>
             </a:extLst>
           </p:cNvPr>
@@ -17797,7 +18047,7 @@
           <p:cNvPr id="6" name="footer-rule">
             <a:extLst xmlns:a="http://schemas.openxmlformats.org/drawingml/2006/main">
               <a:ext uri="{FF2B5EF4-FFF2-40B4-BE49-F238E27FC236}">
-                <a16:creationId xmlns:a16="http://schemas.microsoft.com/office/drawing/2014/main" id="{7E96B55F-EFD0-4F98-BB7A-3CA644B8FC59}"/>
+                <a16:creationId xmlns:a16="http://schemas.microsoft.com/office/drawing/2014/main" id="{4D2874E0-56D1-4A37-9B92-2481CD3F909D}"/>
               </a:ext>
             </a:extLst>
           </p:cNvPr>
@@ -18712,7 +18962,7 @@
           <p:cNvPr id="12" name="">
             <a:extLst xmlns:a="http://schemas.openxmlformats.org/drawingml/2006/main">
               <a:ext uri="{FF2B5EF4-FFF2-40B4-BE49-F238E27FC236}">
-                <a16:creationId xmlns:a16="http://schemas.microsoft.com/office/drawing/2014/main" id="{53E08306-CD69-4438-A156-BAC38E311A36}"/>
+                <a16:creationId xmlns:a16="http://schemas.microsoft.com/office/drawing/2014/main" id="{F3EA304C-696F-4183-830C-F442BAB5CD6B}"/>
               </a:ext>
             </a:extLst>
           </p:cNvPr>
@@ -20166,7 +20416,7 @@
           <p:cNvPr id="6" name="footer-rule">
             <a:extLst xmlns:a="http://schemas.openxmlformats.org/drawingml/2006/main">
               <a:ext uri="{FF2B5EF4-FFF2-40B4-BE49-F238E27FC236}">
-                <a16:creationId xmlns:a16="http://schemas.microsoft.com/office/drawing/2014/main" id="{BDAC7B1C-230F-400C-B875-06FF85E6DE5D}"/>
+                <a16:creationId xmlns:a16="http://schemas.microsoft.com/office/drawing/2014/main" id="{05F6568B-5E18-43AC-85BF-5DA1958B0DA2}"/>
               </a:ext>
             </a:extLst>
           </p:cNvPr>
@@ -21369,7 +21619,7 @@
           <p:cNvPr id="14" name="metric-rule-1">
             <a:extLst xmlns:a="http://schemas.openxmlformats.org/drawingml/2006/main">
               <a:ext uri="{FF2B5EF4-FFF2-40B4-BE49-F238E27FC236}">
-                <a16:creationId xmlns:a16="http://schemas.microsoft.com/office/drawing/2014/main" id="{E7F4DFBB-CD99-4C22-8D30-B2B5FB94BBF2}"/>
+                <a16:creationId xmlns:a16="http://schemas.microsoft.com/office/drawing/2014/main" id="{D66FC603-E5ED-4121-AEBD-2A500DA497D5}"/>
               </a:ext>
             </a:extLst>
           </p:cNvPr>
@@ -21396,7 +21646,7 @@
           <p:cNvPr id="15" name="metric-rule-2">
             <a:extLst xmlns:a="http://schemas.openxmlformats.org/drawingml/2006/main">
               <a:ext uri="{FF2B5EF4-FFF2-40B4-BE49-F238E27FC236}">
-                <a16:creationId xmlns:a16="http://schemas.microsoft.com/office/drawing/2014/main" id="{4026063A-D549-422C-A1DC-A954D206F0CC}"/>
+                <a16:creationId xmlns:a16="http://schemas.microsoft.com/office/drawing/2014/main" id="{8AD37474-2893-49D5-A617-D9D520B83C82}"/>
               </a:ext>
             </a:extLst>
           </p:cNvPr>
@@ -21591,7 +21841,7 @@
           <p:cNvPr id="17" name="">
             <a:extLst xmlns:a="http://schemas.openxmlformats.org/drawingml/2006/main">
               <a:ext uri="{FF2B5EF4-FFF2-40B4-BE49-F238E27FC236}">
-                <a16:creationId xmlns:a16="http://schemas.microsoft.com/office/drawing/2014/main" id="{32ED34C0-A7D5-4845-BF28-8F89C644D9B0}"/>
+                <a16:creationId xmlns:a16="http://schemas.microsoft.com/office/drawing/2014/main" id="{4B916CFB-E86C-44A9-BD9B-2E1660790268}"/>
               </a:ext>
             </a:extLst>
           </p:cNvPr>
@@ -22971,7 +23221,7 @@
           <p:cNvPr id="6" name="footer-rule">
             <a:extLst xmlns:a="http://schemas.openxmlformats.org/drawingml/2006/main">
               <a:ext uri="{FF2B5EF4-FFF2-40B4-BE49-F238E27FC236}">
-                <a16:creationId xmlns:a16="http://schemas.microsoft.com/office/drawing/2014/main" id="{C86FDACC-5E99-4A33-BF13-565614236D2F}"/>
+                <a16:creationId xmlns:a16="http://schemas.microsoft.com/office/drawing/2014/main" id="{6AD0D53B-7B46-4CE2-A0D4-83862D1AB2AB}"/>
               </a:ext>
             </a:extLst>
           </p:cNvPr>
@@ -23166,7 +23416,7 @@
           <p:cNvPr id="8" name="">
             <a:extLst xmlns:a="http://schemas.openxmlformats.org/drawingml/2006/main">
               <a:ext uri="{FF2B5EF4-FFF2-40B4-BE49-F238E27FC236}">
-                <a16:creationId xmlns:a16="http://schemas.microsoft.com/office/drawing/2014/main" id="{A5BC0FF0-B5FD-4FAC-8D01-8E1D64D116B8}"/>
+                <a16:creationId xmlns:a16="http://schemas.microsoft.com/office/drawing/2014/main" id="{9C73DE21-C2E3-4BCE-BA1D-326DB9C4C2E0}"/>
               </a:ext>
             </a:extLst>
           </p:cNvPr>

</xml_diff>

<commit_message>
docs: show actual LLM validation screen on slide six
</commit_message>
<xml_diff>
--- a/doc/presentation/운영진단_에이전트_5분발표.pptx
+++ b/doc/presentation/운영진단_에이전트_5분발표.pptx
@@ -2,31 +2,31 @@
 <file path=ppt/presentation.xml><?xml version="1.0" encoding="utf-8"?>
 <p:presentation xmlns:p="http://schemas.openxmlformats.org/presentationml/2006/main" embedTrueTypeFonts="1" saveSubsetFonts="0">
   <p:sldMasterIdLst>
-    <p:sldMasterId xmlns:r="http://schemas.openxmlformats.org/officeDocument/2006/relationships" id="2147483648" r:id="Rbf3155fc245744b1"/>
+    <p:sldMasterId xmlns:r="http://schemas.openxmlformats.org/officeDocument/2006/relationships" id="2147483648" r:id="Rd9dedfffd8fd4d00"/>
   </p:sldMasterIdLst>
   <p:notesMasterIdLst>
-    <p:notesMasterId xmlns:r="http://schemas.openxmlformats.org/officeDocument/2006/relationships" r:id="R4ca0b0efbead4cab"/>
+    <p:notesMasterId xmlns:r="http://schemas.openxmlformats.org/officeDocument/2006/relationships" r:id="R595ba1f0f5944d2c"/>
   </p:notesMasterIdLst>
   <p:sldIdLst>
-    <p:sldId xmlns:r="http://schemas.openxmlformats.org/officeDocument/2006/relationships" id="256" r:id="Rea0eb12965ac4597"/>
-    <p:sldId xmlns:r="http://schemas.openxmlformats.org/officeDocument/2006/relationships" id="257" r:id="Rb16e2eb6c5864b8a"/>
-    <p:sldId xmlns:r="http://schemas.openxmlformats.org/officeDocument/2006/relationships" id="258" r:id="R01a917663bd149e4"/>
-    <p:sldId xmlns:r="http://schemas.openxmlformats.org/officeDocument/2006/relationships" id="259" r:id="Rbeb017b1127b4326"/>
-    <p:sldId xmlns:r="http://schemas.openxmlformats.org/officeDocument/2006/relationships" id="260" r:id="R524d7640ef1546e4"/>
-    <p:sldId xmlns:r="http://schemas.openxmlformats.org/officeDocument/2006/relationships" id="261" r:id="R3afdf6bfe7cc4456"/>
-    <p:sldId xmlns:r="http://schemas.openxmlformats.org/officeDocument/2006/relationships" id="262" r:id="R7d0953357f04494f"/>
-    <p:sldId xmlns:r="http://schemas.openxmlformats.org/officeDocument/2006/relationships" id="263" r:id="R14c3eba6137e43ae"/>
+    <p:sldId xmlns:r="http://schemas.openxmlformats.org/officeDocument/2006/relationships" id="256" r:id="R82b5d21b194443a0"/>
+    <p:sldId xmlns:r="http://schemas.openxmlformats.org/officeDocument/2006/relationships" id="257" r:id="R975263f577ba4bb3"/>
+    <p:sldId xmlns:r="http://schemas.openxmlformats.org/officeDocument/2006/relationships" id="258" r:id="R34c628c7d239420f"/>
+    <p:sldId xmlns:r="http://schemas.openxmlformats.org/officeDocument/2006/relationships" id="259" r:id="R4dc60d0c043746cb"/>
+    <p:sldId xmlns:r="http://schemas.openxmlformats.org/officeDocument/2006/relationships" id="260" r:id="R98d9229ed5324a66"/>
+    <p:sldId xmlns:r="http://schemas.openxmlformats.org/officeDocument/2006/relationships" id="261" r:id="Rb2e8370bf9ee4349"/>
+    <p:sldId xmlns:r="http://schemas.openxmlformats.org/officeDocument/2006/relationships" id="262" r:id="Rc47859c29ecb4749"/>
+    <p:sldId xmlns:r="http://schemas.openxmlformats.org/officeDocument/2006/relationships" id="263" r:id="R81960451033846d4"/>
   </p:sldIdLst>
   <p:sldSz cx="18288000" cy="10287000"/>
   <p:notesSz cx="6858000" cy="9144000"/>
   <p:embeddedFontLst>
     <p:embeddedFont>
       <p:font typeface="Noto Sans Bold"/>
-      <p:regular xmlns:r="http://schemas.openxmlformats.org/officeDocument/2006/relationships" r:id="R5bed231d93f94047"/>
+      <p:regular xmlns:r="http://schemas.openxmlformats.org/officeDocument/2006/relationships" r:id="Re2ec74a51a1e4a25"/>
     </p:embeddedFont>
     <p:embeddedFont>
       <p:font typeface="Noto Sans Kr"/>
-      <p:regular xmlns:r="http://schemas.openxmlformats.org/officeDocument/2006/relationships" r:id="R59bfee895f4f4b95"/>
+      <p:regular xmlns:r="http://schemas.openxmlformats.org/officeDocument/2006/relationships" r:id="R428dec6ece114b3f"/>
     </p:embeddedFont>
   </p:embeddedFontLst>
   <p:defaultTextStyle>
@@ -1438,7 +1438,7 @@
           <a:lstStyle xmlns:a="http://schemas.openxmlformats.org/drawingml/2006/main"/>
           <a:p xmlns:a="http://schemas.openxmlformats.org/drawingml/2006/main">
             <a:r>
-              <a:t>적용 기술과 재작성 실행 결과</a:t>
+              <a:t>적용 기술과 실제 검증 화면</a:t>
             </a:r>
           </a:p>
           <a:p xmlns:a="http://schemas.openxmlformats.org/drawingml/2006/main">
@@ -1463,7 +1463,7 @@
           </a:p>
           <a:p xmlns:a="http://schemas.openxmlformats.org/drawingml/2006/main">
             <a:r>
-              <a:t>왼쪽은 기술별 역할이고, 오른쪽은 실제 배치 사례의 작성 기록입니다. RAG는 CPU 급증 대응 절차 등 관련 런북 세 종을 검색했습니다. 첫 초안은 확인 가능한 다음 행동이 빠져 코드 검사에서 불합격했습니다. 피드백을 반영한 두 번째 작성에서는 허용된 조치가 포함돼 통과했습니다. 즉, 이 사례는 재작성 한 번이 실제로 발생한 기록입니다. 대상과 수치, 근거 ID와 조치 조건을 코드가 검사하고, Judge는 별도 품질 평가를 담당합니다.</a:t>
+              <a:t>왼쪽은 기술별 역할이고, 오른쪽은 실제 프론트의 보고서 검증 화면입니다. RAG는 CPU 급증 대응 절차 등 관련 런북 세 종을 검색했습니다. 10월 22일 실제 Ollama로 다시 실행했을 때, 첫 초안은 확인 가능한 다음 행동이 빠져 코드 검사에서 불합격했습니다. 피드백을 반영한 두 번째 작성은 통과했고, 화면에도 작성 두 회와 재작성 한 회가 표시됩니다. 여섯 검증 항목이 확인됐으며, Judge는 이 검사와 구분한 별도 품질 평가입니다.</a:t>
             </a:r>
           </a:p>
           <a:p xmlns:a="http://schemas.openxmlformats.org/drawingml/2006/main">
@@ -1493,7 +1493,7 @@
           </a:p>
           <a:p xmlns:a="http://schemas.openxmlformats.org/drawingml/2006/main">
             <a:r>
-              <a:t>왼쪽 RAG 검색 결과와 오른쪽 실제 1차 불합격·2차 합격 이벤트를 짚는다. 재작성 1회가 발생한 보존 실행임을 설명한다.</a:t>
+              <a:t>오른쪽 실제 프론트 화면에서 모든 검증 통과, 여섯 검증 항목, 작성 2회·재작성 1회를 짚는다. 1차 누락 사유는 저장한 실행 이벤트에서 확인한 내용이며, 이 화면 자체는 최종 검증 상태다.</a:t>
             </a:r>
           </a:p>
           <a:p xmlns:a="http://schemas.openxmlformats.org/drawingml/2006/main">
@@ -1533,6 +1533,16 @@
           </a:p>
           <a:p xmlns:a="http://schemas.openxmlformats.org/drawingml/2006/main">
             <a:r>
+              <a:t>https://github.com/beshurl/skala-ai-mini-project/blob/main/doc/presentation/assets/live-validation-20261022.png</a:t>
+            </a:r>
+          </a:p>
+          <a:p xmlns:a="http://schemas.openxmlformats.org/drawingml/2006/main">
+            <a:r>
+              <a:t>https://github.com/beshurl/skala-ai-mini-project/blob/main/doc/presentation/assets/live-validation-20261022.json</a:t>
+            </a:r>
+          </a:p>
+          <a:p xmlns:a="http://schemas.openxmlformats.org/drawingml/2006/main">
+            <a:r>
               <a:t/>
             </a:r>
           </a:p>
@@ -1543,7 +1553,7 @@
           </a:p>
           <a:p xmlns:a="http://schemas.openxmlformats.org/drawingml/2006/main">
             <a:r>
-              <a:t>보존된 2026-10-21 검증 결과. 관측은 교육용 합성 데이터. 계획·작성은 실제 Ollama qwen3.5:2b, 별도 Judge는 qwen3:8b. 입력 검사와 도입 전 가설 평가의 범위를 구분. 교차 지지는 인과 확정과 구분.</a:t>
+              <a:t>6번은 2026-10-22 실제 Ollama qwen3.5:2b 재실행 화면. 관측은 교육용 합성 데이터. 이번 실행에서 Judge 재평가·원격 추적 재조회는 하지 않았으며 7번의 2026-10-21 보존 평가와 구분한다.</a:t>
             </a:r>
           </a:p>
         </p:txBody>
@@ -4890,17 +4900,17 @@
   </p:cSld>
   <p:clrMap bg1="lt1" tx1="dk1" bg2="lt2" tx2="dk2" accent1="accent1" accent2="accent2" accent3="accent3" accent4="accent4" accent5="accent5" accent6="accent6" hlink="hlink" folHlink="folHlink"/>
   <p:sldLayoutIdLst>
-    <p:sldLayoutId xmlns:r="http://schemas.openxmlformats.org/officeDocument/2006/relationships" id="2147483649" r:id="Rd542c041d3b54631"/>
-    <p:sldLayoutId xmlns:r="http://schemas.openxmlformats.org/officeDocument/2006/relationships" id="2147483650" r:id="Ra39d8d5fcbea4dce"/>
-    <p:sldLayoutId xmlns:r="http://schemas.openxmlformats.org/officeDocument/2006/relationships" id="2147483651" r:id="R30ffd791aa2c48c2"/>
-    <p:sldLayoutId xmlns:r="http://schemas.openxmlformats.org/officeDocument/2006/relationships" id="2147483652" r:id="Rfd155ed9bfdc495e"/>
-    <p:sldLayoutId xmlns:r="http://schemas.openxmlformats.org/officeDocument/2006/relationships" id="2147483653" r:id="R46c3d26c6fd44d87"/>
-    <p:sldLayoutId xmlns:r="http://schemas.openxmlformats.org/officeDocument/2006/relationships" id="2147483654" r:id="R7d336b01be17464a"/>
-    <p:sldLayoutId xmlns:r="http://schemas.openxmlformats.org/officeDocument/2006/relationships" id="2147483655" r:id="R6fa5ce65dc0842b5"/>
-    <p:sldLayoutId xmlns:r="http://schemas.openxmlformats.org/officeDocument/2006/relationships" id="2147483656" r:id="R473597f816a140ba"/>
-    <p:sldLayoutId xmlns:r="http://schemas.openxmlformats.org/officeDocument/2006/relationships" id="2147483657" r:id="Rc6728de021f74392"/>
-    <p:sldLayoutId xmlns:r="http://schemas.openxmlformats.org/officeDocument/2006/relationships" id="2147483658" r:id="R6647e434f77147b5"/>
-    <p:sldLayoutId xmlns:r="http://schemas.openxmlformats.org/officeDocument/2006/relationships" id="2147483659" r:id="R587514972bc04fa3"/>
+    <p:sldLayoutId xmlns:r="http://schemas.openxmlformats.org/officeDocument/2006/relationships" id="2147483649" r:id="R28b0a815a4c342fb"/>
+    <p:sldLayoutId xmlns:r="http://schemas.openxmlformats.org/officeDocument/2006/relationships" id="2147483650" r:id="R5a2ecd8fc8784945"/>
+    <p:sldLayoutId xmlns:r="http://schemas.openxmlformats.org/officeDocument/2006/relationships" id="2147483651" r:id="R5b3f4e59573d4ca5"/>
+    <p:sldLayoutId xmlns:r="http://schemas.openxmlformats.org/officeDocument/2006/relationships" id="2147483652" r:id="R7066e5acafdd4b99"/>
+    <p:sldLayoutId xmlns:r="http://schemas.openxmlformats.org/officeDocument/2006/relationships" id="2147483653" r:id="Rf7ae56ef302a4f07"/>
+    <p:sldLayoutId xmlns:r="http://schemas.openxmlformats.org/officeDocument/2006/relationships" id="2147483654" r:id="R8d17c1fc2ace4953"/>
+    <p:sldLayoutId xmlns:r="http://schemas.openxmlformats.org/officeDocument/2006/relationships" id="2147483655" r:id="Rf5505557abd04f4f"/>
+    <p:sldLayoutId xmlns:r="http://schemas.openxmlformats.org/officeDocument/2006/relationships" id="2147483656" r:id="R6e871bae8dbf451c"/>
+    <p:sldLayoutId xmlns:r="http://schemas.openxmlformats.org/officeDocument/2006/relationships" id="2147483657" r:id="Rcdea45ce7c9b4166"/>
+    <p:sldLayoutId xmlns:r="http://schemas.openxmlformats.org/officeDocument/2006/relationships" id="2147483658" r:id="R5e46125a129645f6"/>
+    <p:sldLayoutId xmlns:r="http://schemas.openxmlformats.org/officeDocument/2006/relationships" id="2147483659" r:id="R737fa8c1497d4bdf"/>
   </p:sldLayoutIdLst>
   <p:txStyles>
     <p:titleStyle>
@@ -6535,7 +6545,7 @@
           <p:cNvPr id="7" name="">
             <a:extLst xmlns:a="http://schemas.openxmlformats.org/drawingml/2006/main">
               <a:ext uri="{FF2B5EF4-FFF2-40B4-BE49-F238E27FC236}">
-                <a16:creationId xmlns:a16="http://schemas.microsoft.com/office/drawing/2014/main" id="{E826F215-58EA-4F78-BF5C-A16CFCAE449A}"/>
+                <a16:creationId xmlns:a16="http://schemas.microsoft.com/office/drawing/2014/main" id="{18B93153-3291-4BF7-AB63-22CE89147489}"/>
               </a:ext>
             </a:extLst>
           </p:cNvPr>
@@ -6545,7 +6555,7 @@
           <p:nvPr/>
         </p:nvPicPr>
         <p:blipFill>
-          <a:blip xmlns:r="http://schemas.openxmlformats.org/officeDocument/2006/relationships" xmlns:a="http://schemas.openxmlformats.org/drawingml/2006/main" r:embed="Rf6b5652f27b4404b"/>
+          <a:blip xmlns:r="http://schemas.openxmlformats.org/officeDocument/2006/relationships" xmlns:a="http://schemas.openxmlformats.org/drawingml/2006/main" r:embed="R443a406128814aa4"/>
           <a:stretch xmlns:a="http://schemas.openxmlformats.org/drawingml/2006/main"/>
         </p:blipFill>
         <p:spPr>
@@ -6731,7 +6741,7 @@
           <p:cNvPr id="9" name="cover-rule">
             <a:extLst xmlns:a="http://schemas.openxmlformats.org/drawingml/2006/main">
               <a:ext uri="{FF2B5EF4-FFF2-40B4-BE49-F238E27FC236}">
-                <a16:creationId xmlns:a16="http://schemas.microsoft.com/office/drawing/2014/main" id="{4909386D-A3B7-43CD-B3B5-72B076CBBC9D}"/>
+                <a16:creationId xmlns:a16="http://schemas.microsoft.com/office/drawing/2014/main" id="{5CA45356-8639-4EBD-805C-C5116709A9B9}"/>
               </a:ext>
             </a:extLst>
           </p:cNvPr>
@@ -7627,7 +7637,7 @@
           <p:cNvPr id="6" name="footer-rule">
             <a:extLst xmlns:a="http://schemas.openxmlformats.org/drawingml/2006/main">
               <a:ext uri="{FF2B5EF4-FFF2-40B4-BE49-F238E27FC236}">
-                <a16:creationId xmlns:a16="http://schemas.microsoft.com/office/drawing/2014/main" id="{C1CEFBFC-2FDA-4EE3-96B0-4D26EDCB718A}"/>
+                <a16:creationId xmlns:a16="http://schemas.microsoft.com/office/drawing/2014/main" id="{6678DE10-754F-4619-8EDE-1527F50BB2A0}"/>
               </a:ext>
             </a:extLst>
           </p:cNvPr>
@@ -7822,7 +7832,7 @@
           <p:cNvPr id="8" name="">
             <a:extLst xmlns:a="http://schemas.openxmlformats.org/drawingml/2006/main">
               <a:ext uri="{FF2B5EF4-FFF2-40B4-BE49-F238E27FC236}">
-                <a16:creationId xmlns:a16="http://schemas.microsoft.com/office/drawing/2014/main" id="{782070D2-FC48-432D-B520-89B466D4FA01}"/>
+                <a16:creationId xmlns:a16="http://schemas.microsoft.com/office/drawing/2014/main" id="{759A79F0-3F2D-4B3F-BBC2-CB984BE98F81}"/>
               </a:ext>
             </a:extLst>
           </p:cNvPr>
@@ -8557,6 +8567,7 @@
               </a:defRPr>
             </a:defPPr>
             <a:lvl1pPr algn="l">
+              <a:buNone/>
               <a:defRPr sz="1950" b="1">
                 <a:solidFill>
                   <a:srgbClr val="2B5BEB"/>
@@ -8567,6 +8578,7 @@
               </a:defRPr>
             </a:lvl1pPr>
             <a:lvl2pPr algn="l">
+              <a:buNone/>
               <a:defRPr sz="1950" b="1">
                 <a:solidFill>
                   <a:srgbClr val="2B5BEB"/>
@@ -8577,6 +8589,7 @@
               </a:defRPr>
             </a:lvl2pPr>
             <a:lvl3pPr algn="l">
+              <a:buNone/>
               <a:defRPr sz="1950" b="1">
                 <a:solidFill>
                   <a:srgbClr val="2B5BEB"/>
@@ -8587,6 +8600,7 @@
               </a:defRPr>
             </a:lvl3pPr>
             <a:lvl4pPr algn="l">
+              <a:buNone/>
               <a:defRPr sz="1950" b="1">
                 <a:solidFill>
                   <a:srgbClr val="2B5BEB"/>
@@ -8597,6 +8611,7 @@
               </a:defRPr>
             </a:lvl4pPr>
             <a:lvl5pPr algn="l">
+              <a:buNone/>
               <a:defRPr sz="1950" b="1">
                 <a:solidFill>
                   <a:srgbClr val="2B5BEB"/>
@@ -8607,6 +8622,7 @@
               </a:defRPr>
             </a:lvl5pPr>
             <a:lvl6pPr algn="l">
+              <a:buNone/>
               <a:defRPr sz="1950" b="1">
                 <a:solidFill>
                   <a:srgbClr val="2B5BEB"/>
@@ -8617,6 +8633,7 @@
               </a:defRPr>
             </a:lvl6pPr>
             <a:lvl7pPr algn="l">
+              <a:buNone/>
               <a:defRPr sz="1950" b="1">
                 <a:solidFill>
                   <a:srgbClr val="2B5BEB"/>
@@ -8627,6 +8644,7 @@
               </a:defRPr>
             </a:lvl7pPr>
             <a:lvl8pPr algn="l">
+              <a:buNone/>
               <a:defRPr sz="1950" b="1">
                 <a:solidFill>
                   <a:srgbClr val="2B5BEB"/>
@@ -8637,6 +8655,7 @@
               </a:defRPr>
             </a:lvl8pPr>
             <a:lvl9pPr algn="l">
+              <a:buNone/>
               <a:defRPr sz="1950" b="1">
                 <a:solidFill>
                   <a:srgbClr val="2B5BEB"/>
@@ -8649,6 +8668,7 @@
           </a:lstStyle>
           <a:p xmlns:a="http://schemas.openxmlformats.org/drawingml/2006/main">
             <a:pPr algn="l">
+              <a:buNone/>
               <a:defRPr sz="1950" b="1">
                 <a:solidFill>
                   <a:srgbClr val="2B5BEB"/>
@@ -8715,6 +8735,7 @@
               </a:defRPr>
             </a:defPPr>
             <a:lvl1pPr algn="r">
+              <a:buNone/>
               <a:defRPr sz="1950" b="0">
                 <a:solidFill>
                   <a:srgbClr val="566A80"/>
@@ -8725,6 +8746,7 @@
               </a:defRPr>
             </a:lvl1pPr>
             <a:lvl2pPr algn="r">
+              <a:buNone/>
               <a:defRPr sz="1950" b="0">
                 <a:solidFill>
                   <a:srgbClr val="566A80"/>
@@ -8735,6 +8757,7 @@
               </a:defRPr>
             </a:lvl2pPr>
             <a:lvl3pPr algn="r">
+              <a:buNone/>
               <a:defRPr sz="1950" b="0">
                 <a:solidFill>
                   <a:srgbClr val="566A80"/>
@@ -8745,6 +8768,7 @@
               </a:defRPr>
             </a:lvl3pPr>
             <a:lvl4pPr algn="r">
+              <a:buNone/>
               <a:defRPr sz="1950" b="0">
                 <a:solidFill>
                   <a:srgbClr val="566A80"/>
@@ -8755,6 +8779,7 @@
               </a:defRPr>
             </a:lvl4pPr>
             <a:lvl5pPr algn="r">
+              <a:buNone/>
               <a:defRPr sz="1950" b="0">
                 <a:solidFill>
                   <a:srgbClr val="566A80"/>
@@ -8765,6 +8790,7 @@
               </a:defRPr>
             </a:lvl5pPr>
             <a:lvl6pPr algn="r">
+              <a:buNone/>
               <a:defRPr sz="1950" b="0">
                 <a:solidFill>
                   <a:srgbClr val="566A80"/>
@@ -8775,6 +8801,7 @@
               </a:defRPr>
             </a:lvl6pPr>
             <a:lvl7pPr algn="r">
+              <a:buNone/>
               <a:defRPr sz="1950" b="0">
                 <a:solidFill>
                   <a:srgbClr val="566A80"/>
@@ -8785,6 +8812,7 @@
               </a:defRPr>
             </a:lvl7pPr>
             <a:lvl8pPr algn="r">
+              <a:buNone/>
               <a:defRPr sz="1950" b="0">
                 <a:solidFill>
                   <a:srgbClr val="566A80"/>
@@ -8795,6 +8823,7 @@
               </a:defRPr>
             </a:lvl8pPr>
             <a:lvl9pPr algn="r">
+              <a:buNone/>
               <a:defRPr sz="1950" b="0">
                 <a:solidFill>
                   <a:srgbClr val="566A80"/>
@@ -8807,6 +8836,7 @@
           </a:lstStyle>
           <a:p xmlns:a="http://schemas.openxmlformats.org/drawingml/2006/main">
             <a:pPr algn="r">
+              <a:buNone/>
               <a:defRPr sz="1950" b="0">
                 <a:solidFill>
                   <a:srgbClr val="566A80"/>
@@ -8873,6 +8903,7 @@
               </a:defRPr>
             </a:defPPr>
             <a:lvl1pPr algn="l">
+              <a:buNone/>
               <a:defRPr sz="5100" b="1">
                 <a:solidFill>
                   <a:srgbClr val="122C46"/>
@@ -8883,6 +8914,7 @@
               </a:defRPr>
             </a:lvl1pPr>
             <a:lvl2pPr algn="l">
+              <a:buNone/>
               <a:defRPr sz="5100" b="1">
                 <a:solidFill>
                   <a:srgbClr val="122C46"/>
@@ -8893,6 +8925,7 @@
               </a:defRPr>
             </a:lvl2pPr>
             <a:lvl3pPr algn="l">
+              <a:buNone/>
               <a:defRPr sz="5100" b="1">
                 <a:solidFill>
                   <a:srgbClr val="122C46"/>
@@ -8903,6 +8936,7 @@
               </a:defRPr>
             </a:lvl3pPr>
             <a:lvl4pPr algn="l">
+              <a:buNone/>
               <a:defRPr sz="5100" b="1">
                 <a:solidFill>
                   <a:srgbClr val="122C46"/>
@@ -8913,6 +8947,7 @@
               </a:defRPr>
             </a:lvl4pPr>
             <a:lvl5pPr algn="l">
+              <a:buNone/>
               <a:defRPr sz="5100" b="1">
                 <a:solidFill>
                   <a:srgbClr val="122C46"/>
@@ -8923,6 +8958,7 @@
               </a:defRPr>
             </a:lvl5pPr>
             <a:lvl6pPr algn="l">
+              <a:buNone/>
               <a:defRPr sz="5100" b="1">
                 <a:solidFill>
                   <a:srgbClr val="122C46"/>
@@ -8933,6 +8969,7 @@
               </a:defRPr>
             </a:lvl6pPr>
             <a:lvl7pPr algn="l">
+              <a:buNone/>
               <a:defRPr sz="5100" b="1">
                 <a:solidFill>
                   <a:srgbClr val="122C46"/>
@@ -8943,6 +8980,7 @@
               </a:defRPr>
             </a:lvl7pPr>
             <a:lvl8pPr algn="l">
+              <a:buNone/>
               <a:defRPr sz="5100" b="1">
                 <a:solidFill>
                   <a:srgbClr val="122C46"/>
@@ -8953,6 +8991,7 @@
               </a:defRPr>
             </a:lvl8pPr>
             <a:lvl9pPr algn="l">
+              <a:buNone/>
               <a:defRPr sz="5100" b="1">
                 <a:solidFill>
                   <a:srgbClr val="122C46"/>
@@ -8965,6 +9004,7 @@
           </a:lstStyle>
           <a:p xmlns:a="http://schemas.openxmlformats.org/drawingml/2006/main">
             <a:pPr algn="l">
+              <a:buNone/>
               <a:defRPr sz="5100" b="1">
                 <a:solidFill>
                   <a:srgbClr val="122C46"/>
@@ -9031,6 +9071,7 @@
               </a:defRPr>
             </a:defPPr>
             <a:lvl1pPr algn="l">
+              <a:buNone/>
               <a:defRPr sz="2400" b="0">
                 <a:solidFill>
                   <a:srgbClr val="566A80"/>
@@ -9041,6 +9082,7 @@
               </a:defRPr>
             </a:lvl1pPr>
             <a:lvl2pPr algn="l">
+              <a:buNone/>
               <a:defRPr sz="2400" b="0">
                 <a:solidFill>
                   <a:srgbClr val="566A80"/>
@@ -9051,6 +9093,7 @@
               </a:defRPr>
             </a:lvl2pPr>
             <a:lvl3pPr algn="l">
+              <a:buNone/>
               <a:defRPr sz="2400" b="0">
                 <a:solidFill>
                   <a:srgbClr val="566A80"/>
@@ -9061,6 +9104,7 @@
               </a:defRPr>
             </a:lvl3pPr>
             <a:lvl4pPr algn="l">
+              <a:buNone/>
               <a:defRPr sz="2400" b="0">
                 <a:solidFill>
                   <a:srgbClr val="566A80"/>
@@ -9071,6 +9115,7 @@
               </a:defRPr>
             </a:lvl4pPr>
             <a:lvl5pPr algn="l">
+              <a:buNone/>
               <a:defRPr sz="2400" b="0">
                 <a:solidFill>
                   <a:srgbClr val="566A80"/>
@@ -9081,6 +9126,7 @@
               </a:defRPr>
             </a:lvl5pPr>
             <a:lvl6pPr algn="l">
+              <a:buNone/>
               <a:defRPr sz="2400" b="0">
                 <a:solidFill>
                   <a:srgbClr val="566A80"/>
@@ -9091,6 +9137,7 @@
               </a:defRPr>
             </a:lvl6pPr>
             <a:lvl7pPr algn="l">
+              <a:buNone/>
               <a:defRPr sz="2400" b="0">
                 <a:solidFill>
                   <a:srgbClr val="566A80"/>
@@ -9101,6 +9148,7 @@
               </a:defRPr>
             </a:lvl7pPr>
             <a:lvl8pPr algn="l">
+              <a:buNone/>
               <a:defRPr sz="2400" b="0">
                 <a:solidFill>
                   <a:srgbClr val="566A80"/>
@@ -9111,6 +9159,7 @@
               </a:defRPr>
             </a:lvl8pPr>
             <a:lvl9pPr algn="l">
+              <a:buNone/>
               <a:defRPr sz="2400" b="0">
                 <a:solidFill>
                   <a:srgbClr val="566A80"/>
@@ -9123,6 +9172,7 @@
           </a:lstStyle>
           <a:p xmlns:a="http://schemas.openxmlformats.org/drawingml/2006/main">
             <a:pPr algn="l">
+              <a:buNone/>
               <a:defRPr sz="2400" b="0">
                 <a:solidFill>
                   <a:srgbClr val="566A80"/>
@@ -9189,6 +9239,7 @@
               </a:defRPr>
             </a:defPPr>
             <a:lvl1pPr algn="l">
+              <a:buNone/>
               <a:defRPr sz="1800" b="0">
                 <a:solidFill>
                   <a:srgbClr val="566A80"/>
@@ -9199,6 +9250,7 @@
               </a:defRPr>
             </a:lvl1pPr>
             <a:lvl2pPr algn="l">
+              <a:buNone/>
               <a:defRPr sz="1800" b="0">
                 <a:solidFill>
                   <a:srgbClr val="566A80"/>
@@ -9209,6 +9261,7 @@
               </a:defRPr>
             </a:lvl2pPr>
             <a:lvl3pPr algn="l">
+              <a:buNone/>
               <a:defRPr sz="1800" b="0">
                 <a:solidFill>
                   <a:srgbClr val="566A80"/>
@@ -9219,6 +9272,7 @@
               </a:defRPr>
             </a:lvl3pPr>
             <a:lvl4pPr algn="l">
+              <a:buNone/>
               <a:defRPr sz="1800" b="0">
                 <a:solidFill>
                   <a:srgbClr val="566A80"/>
@@ -9229,6 +9283,7 @@
               </a:defRPr>
             </a:lvl4pPr>
             <a:lvl5pPr algn="l">
+              <a:buNone/>
               <a:defRPr sz="1800" b="0">
                 <a:solidFill>
                   <a:srgbClr val="566A80"/>
@@ -9239,6 +9294,7 @@
               </a:defRPr>
             </a:lvl5pPr>
             <a:lvl6pPr algn="l">
+              <a:buNone/>
               <a:defRPr sz="1800" b="0">
                 <a:solidFill>
                   <a:srgbClr val="566A80"/>
@@ -9249,6 +9305,7 @@
               </a:defRPr>
             </a:lvl6pPr>
             <a:lvl7pPr algn="l">
+              <a:buNone/>
               <a:defRPr sz="1800" b="0">
                 <a:solidFill>
                   <a:srgbClr val="566A80"/>
@@ -9259,6 +9316,7 @@
               </a:defRPr>
             </a:lvl7pPr>
             <a:lvl8pPr algn="l">
+              <a:buNone/>
               <a:defRPr sz="1800" b="0">
                 <a:solidFill>
                   <a:srgbClr val="566A80"/>
@@ -9269,6 +9327,7 @@
               </a:defRPr>
             </a:lvl8pPr>
             <a:lvl9pPr algn="l">
+              <a:buNone/>
               <a:defRPr sz="1800" b="0">
                 <a:solidFill>
                   <a:srgbClr val="566A80"/>
@@ -9281,6 +9340,7 @@
           </a:lstStyle>
           <a:p xmlns:a="http://schemas.openxmlformats.org/drawingml/2006/main">
             <a:pPr algn="l">
+              <a:buNone/>
               <a:defRPr sz="1800" b="0">
                 <a:solidFill>
                   <a:srgbClr val="566A80"/>
@@ -9309,7 +9369,7 @@
           <p:cNvPr id="6" name="footer-rule">
             <a:extLst xmlns:a="http://schemas.openxmlformats.org/drawingml/2006/main">
               <a:ext uri="{FF2B5EF4-FFF2-40B4-BE49-F238E27FC236}">
-                <a16:creationId xmlns:a16="http://schemas.microsoft.com/office/drawing/2014/main" id="{BFC45613-69D0-418C-A250-242E3CBE8AFD}"/>
+                <a16:creationId xmlns:a16="http://schemas.microsoft.com/office/drawing/2014/main" id="{6C825383-1D2F-4284-83D9-BA4B062CABB4}"/>
               </a:ext>
             </a:extLst>
           </p:cNvPr>
@@ -9374,6 +9434,7 @@
               </a:defRPr>
             </a:defPPr>
             <a:lvl1pPr algn="l">
+              <a:buNone/>
               <a:defRPr sz="1650" b="0">
                 <a:solidFill>
                   <a:srgbClr val="566A80"/>
@@ -9384,6 +9445,7 @@
               </a:defRPr>
             </a:lvl1pPr>
             <a:lvl2pPr algn="l">
+              <a:buNone/>
               <a:defRPr sz="1650" b="0">
                 <a:solidFill>
                   <a:srgbClr val="566A80"/>
@@ -9394,6 +9456,7 @@
               </a:defRPr>
             </a:lvl2pPr>
             <a:lvl3pPr algn="l">
+              <a:buNone/>
               <a:defRPr sz="1650" b="0">
                 <a:solidFill>
                   <a:srgbClr val="566A80"/>
@@ -9404,6 +9467,7 @@
               </a:defRPr>
             </a:lvl3pPr>
             <a:lvl4pPr algn="l">
+              <a:buNone/>
               <a:defRPr sz="1650" b="0">
                 <a:solidFill>
                   <a:srgbClr val="566A80"/>
@@ -9414,6 +9478,7 @@
               </a:defRPr>
             </a:lvl4pPr>
             <a:lvl5pPr algn="l">
+              <a:buNone/>
               <a:defRPr sz="1650" b="0">
                 <a:solidFill>
                   <a:srgbClr val="566A80"/>
@@ -9424,6 +9489,7 @@
               </a:defRPr>
             </a:lvl5pPr>
             <a:lvl6pPr algn="l">
+              <a:buNone/>
               <a:defRPr sz="1650" b="0">
                 <a:solidFill>
                   <a:srgbClr val="566A80"/>
@@ -9434,6 +9500,7 @@
               </a:defRPr>
             </a:lvl6pPr>
             <a:lvl7pPr algn="l">
+              <a:buNone/>
               <a:defRPr sz="1650" b="0">
                 <a:solidFill>
                   <a:srgbClr val="566A80"/>
@@ -9444,6 +9511,7 @@
               </a:defRPr>
             </a:lvl7pPr>
             <a:lvl8pPr algn="l">
+              <a:buNone/>
               <a:defRPr sz="1650" b="0">
                 <a:solidFill>
                   <a:srgbClr val="566A80"/>
@@ -9454,6 +9522,7 @@
               </a:defRPr>
             </a:lvl8pPr>
             <a:lvl9pPr algn="l">
+              <a:buNone/>
               <a:defRPr sz="1650" b="0">
                 <a:solidFill>
                   <a:srgbClr val="566A80"/>
@@ -9466,6 +9535,7 @@
           </a:lstStyle>
           <a:p xmlns:a="http://schemas.openxmlformats.org/drawingml/2006/main">
             <a:pPr algn="l">
+              <a:buNone/>
               <a:defRPr sz="1650" b="0">
                 <a:solidFill>
                   <a:srgbClr val="566A80"/>
@@ -9532,6 +9602,7 @@
               </a:defRPr>
             </a:defPPr>
             <a:lvl1pPr algn="l">
+              <a:buNone/>
               <a:defRPr sz="2250" b="1">
                 <a:solidFill>
                   <a:srgbClr val="2B5BEB"/>
@@ -9542,6 +9613,7 @@
               </a:defRPr>
             </a:lvl1pPr>
             <a:lvl2pPr algn="l">
+              <a:buNone/>
               <a:defRPr sz="2250" b="1">
                 <a:solidFill>
                   <a:srgbClr val="2B5BEB"/>
@@ -9552,6 +9624,7 @@
               </a:defRPr>
             </a:lvl2pPr>
             <a:lvl3pPr algn="l">
+              <a:buNone/>
               <a:defRPr sz="2250" b="1">
                 <a:solidFill>
                   <a:srgbClr val="2B5BEB"/>
@@ -9562,6 +9635,7 @@
               </a:defRPr>
             </a:lvl3pPr>
             <a:lvl4pPr algn="l">
+              <a:buNone/>
               <a:defRPr sz="2250" b="1">
                 <a:solidFill>
                   <a:srgbClr val="2B5BEB"/>
@@ -9572,6 +9646,7 @@
               </a:defRPr>
             </a:lvl4pPr>
             <a:lvl5pPr algn="l">
+              <a:buNone/>
               <a:defRPr sz="2250" b="1">
                 <a:solidFill>
                   <a:srgbClr val="2B5BEB"/>
@@ -9582,6 +9657,7 @@
               </a:defRPr>
             </a:lvl5pPr>
             <a:lvl6pPr algn="l">
+              <a:buNone/>
               <a:defRPr sz="2250" b="1">
                 <a:solidFill>
                   <a:srgbClr val="2B5BEB"/>
@@ -9592,6 +9668,7 @@
               </a:defRPr>
             </a:lvl6pPr>
             <a:lvl7pPr algn="l">
+              <a:buNone/>
               <a:defRPr sz="2250" b="1">
                 <a:solidFill>
                   <a:srgbClr val="2B5BEB"/>
@@ -9602,6 +9679,7 @@
               </a:defRPr>
             </a:lvl7pPr>
             <a:lvl8pPr algn="l">
+              <a:buNone/>
               <a:defRPr sz="2250" b="1">
                 <a:solidFill>
                   <a:srgbClr val="2B5BEB"/>
@@ -9612,6 +9690,7 @@
               </a:defRPr>
             </a:lvl8pPr>
             <a:lvl9pPr algn="l">
+              <a:buNone/>
               <a:defRPr sz="2250" b="1">
                 <a:solidFill>
                   <a:srgbClr val="2B5BEB"/>
@@ -9624,6 +9703,7 @@
           </a:lstStyle>
           <a:p xmlns:a="http://schemas.openxmlformats.org/drawingml/2006/main">
             <a:pPr algn="l">
+              <a:buNone/>
               <a:defRPr sz="2250" b="1">
                 <a:solidFill>
                   <a:srgbClr val="2B5BEB"/>
@@ -9690,6 +9770,7 @@
               </a:defRPr>
             </a:defPPr>
             <a:lvl1pPr algn="l">
+              <a:buNone/>
               <a:defRPr sz="2250" b="0">
                 <a:solidFill>
                   <a:srgbClr val="122C46"/>
@@ -9700,6 +9781,7 @@
               </a:defRPr>
             </a:lvl1pPr>
             <a:lvl2pPr algn="l">
+              <a:buNone/>
               <a:defRPr sz="2250" b="0">
                 <a:solidFill>
                   <a:srgbClr val="122C46"/>
@@ -9710,6 +9792,7 @@
               </a:defRPr>
             </a:lvl2pPr>
             <a:lvl3pPr algn="l">
+              <a:buNone/>
               <a:defRPr sz="2250" b="0">
                 <a:solidFill>
                   <a:srgbClr val="122C46"/>
@@ -9720,6 +9803,7 @@
               </a:defRPr>
             </a:lvl3pPr>
             <a:lvl4pPr algn="l">
+              <a:buNone/>
               <a:defRPr sz="2250" b="0">
                 <a:solidFill>
                   <a:srgbClr val="122C46"/>
@@ -9730,6 +9814,7 @@
               </a:defRPr>
             </a:lvl4pPr>
             <a:lvl5pPr algn="l">
+              <a:buNone/>
               <a:defRPr sz="2250" b="0">
                 <a:solidFill>
                   <a:srgbClr val="122C46"/>
@@ -9740,6 +9825,7 @@
               </a:defRPr>
             </a:lvl5pPr>
             <a:lvl6pPr algn="l">
+              <a:buNone/>
               <a:defRPr sz="2250" b="0">
                 <a:solidFill>
                   <a:srgbClr val="122C46"/>
@@ -9750,6 +9836,7 @@
               </a:defRPr>
             </a:lvl6pPr>
             <a:lvl7pPr algn="l">
+              <a:buNone/>
               <a:defRPr sz="2250" b="0">
                 <a:solidFill>
                   <a:srgbClr val="122C46"/>
@@ -9760,6 +9847,7 @@
               </a:defRPr>
             </a:lvl7pPr>
             <a:lvl8pPr algn="l">
+              <a:buNone/>
               <a:defRPr sz="2250" b="0">
                 <a:solidFill>
                   <a:srgbClr val="122C46"/>
@@ -9770,6 +9858,7 @@
               </a:defRPr>
             </a:lvl8pPr>
             <a:lvl9pPr algn="l">
+              <a:buNone/>
               <a:defRPr sz="2250" b="0">
                 <a:solidFill>
                   <a:srgbClr val="122C46"/>
@@ -9782,6 +9871,7 @@
           </a:lstStyle>
           <a:p xmlns:a="http://schemas.openxmlformats.org/drawingml/2006/main">
             <a:pPr algn="l">
+              <a:buNone/>
               <a:defRPr sz="2250" b="0">
                 <a:solidFill>
                   <a:srgbClr val="122C46"/>
@@ -9805,6 +9895,7 @@
           </a:p>
           <a:p xmlns:a="http://schemas.openxmlformats.org/drawingml/2006/main">
             <a:pPr algn="l">
+              <a:buNone/>
               <a:defRPr sz="2250" b="0">
                 <a:solidFill>
                   <a:srgbClr val="122C46"/>
@@ -9833,7 +9924,7 @@
           <p:cNvPr id="10" name="">
             <a:extLst xmlns:a="http://schemas.openxmlformats.org/drawingml/2006/main">
               <a:ext uri="{FF2B5EF4-FFF2-40B4-BE49-F238E27FC236}">
-                <a16:creationId xmlns:a16="http://schemas.microsoft.com/office/drawing/2014/main" id="{5713B832-8124-4CB6-B0B8-50CD62985630}"/>
+                <a16:creationId xmlns:a16="http://schemas.microsoft.com/office/drawing/2014/main" id="{75644472-1036-4226-A1BF-1DC801DA8C9D}"/>
               </a:ext>
             </a:extLst>
           </p:cNvPr>
@@ -10229,6 +10320,7 @@
               </a:defRPr>
             </a:defPPr>
             <a:lvl1pPr algn="l">
+              <a:buNone/>
               <a:defRPr sz="2250" b="1">
                 <a:solidFill>
                   <a:srgbClr val="122C46"/>
@@ -10239,6 +10331,7 @@
               </a:defRPr>
             </a:lvl1pPr>
             <a:lvl2pPr algn="l">
+              <a:buNone/>
               <a:defRPr sz="2250" b="1">
                 <a:solidFill>
                   <a:srgbClr val="122C46"/>
@@ -10249,6 +10342,7 @@
               </a:defRPr>
             </a:lvl2pPr>
             <a:lvl3pPr algn="l">
+              <a:buNone/>
               <a:defRPr sz="2250" b="1">
                 <a:solidFill>
                   <a:srgbClr val="122C46"/>
@@ -10259,6 +10353,7 @@
               </a:defRPr>
             </a:lvl3pPr>
             <a:lvl4pPr algn="l">
+              <a:buNone/>
               <a:defRPr sz="2250" b="1">
                 <a:solidFill>
                   <a:srgbClr val="122C46"/>
@@ -10269,6 +10364,7 @@
               </a:defRPr>
             </a:lvl4pPr>
             <a:lvl5pPr algn="l">
+              <a:buNone/>
               <a:defRPr sz="2250" b="1">
                 <a:solidFill>
                   <a:srgbClr val="122C46"/>
@@ -10279,6 +10375,7 @@
               </a:defRPr>
             </a:lvl5pPr>
             <a:lvl6pPr algn="l">
+              <a:buNone/>
               <a:defRPr sz="2250" b="1">
                 <a:solidFill>
                   <a:srgbClr val="122C46"/>
@@ -10289,6 +10386,7 @@
               </a:defRPr>
             </a:lvl6pPr>
             <a:lvl7pPr algn="l">
+              <a:buNone/>
               <a:defRPr sz="2250" b="1">
                 <a:solidFill>
                   <a:srgbClr val="122C46"/>
@@ -10299,6 +10397,7 @@
               </a:defRPr>
             </a:lvl7pPr>
             <a:lvl8pPr algn="l">
+              <a:buNone/>
               <a:defRPr sz="2250" b="1">
                 <a:solidFill>
                   <a:srgbClr val="122C46"/>
@@ -10309,6 +10408,7 @@
               </a:defRPr>
             </a:lvl8pPr>
             <a:lvl9pPr algn="l">
+              <a:buNone/>
               <a:defRPr sz="2250" b="1">
                 <a:solidFill>
                   <a:srgbClr val="122C46"/>
@@ -10321,6 +10421,7 @@
           </a:lstStyle>
           <a:p xmlns:a="http://schemas.openxmlformats.org/drawingml/2006/main">
             <a:pPr algn="l">
+              <a:buNone/>
               <a:defRPr sz="2250" b="1">
                 <a:solidFill>
                   <a:srgbClr val="122C46"/>
@@ -11218,7 +11319,7 @@
           <p:cNvPr id="6" name="footer-rule">
             <a:extLst xmlns:a="http://schemas.openxmlformats.org/drawingml/2006/main">
               <a:ext uri="{FF2B5EF4-FFF2-40B4-BE49-F238E27FC236}">
-                <a16:creationId xmlns:a16="http://schemas.microsoft.com/office/drawing/2014/main" id="{EC789ABD-434E-47C7-821D-9D01E1678CD7}"/>
+                <a16:creationId xmlns:a16="http://schemas.microsoft.com/office/drawing/2014/main" id="{3EA4BC4D-D15F-4373-94C3-BF5B934D9DD1}"/>
               </a:ext>
             </a:extLst>
           </p:cNvPr>
@@ -13429,7 +13530,7 @@
           <p:cNvPr id="20" name="">
             <a:extLst xmlns:a="http://schemas.openxmlformats.org/drawingml/2006/main">
               <a:ext uri="{FF2B5EF4-FFF2-40B4-BE49-F238E27FC236}">
-                <a16:creationId xmlns:a16="http://schemas.microsoft.com/office/drawing/2014/main" id="{47BF2659-113E-46F1-8C4B-162DDC606936}"/>
+                <a16:creationId xmlns:a16="http://schemas.microsoft.com/office/drawing/2014/main" id="{B284B7DF-EBC1-47CE-9060-8138FD9D0D88}"/>
               </a:ext>
             </a:extLst>
           </p:cNvPr>
@@ -13439,7 +13540,7 @@
           <p:nvPr/>
         </p:nvPicPr>
         <p:blipFill>
-          <a:blip xmlns:r="http://schemas.openxmlformats.org/officeDocument/2006/relationships" xmlns:a="http://schemas.openxmlformats.org/drawingml/2006/main" r:embed="R30a29eb5736e4517"/>
+          <a:blip xmlns:r="http://schemas.openxmlformats.org/officeDocument/2006/relationships" xmlns:a="http://schemas.openxmlformats.org/drawingml/2006/main" r:embed="R6a29252292404dc2"/>
           <a:srcRect xmlns:a="http://schemas.openxmlformats.org/drawingml/2006/main" l="19000" t="41000" r="24000" b="9000"/>
           <a:stretch xmlns:a="http://schemas.openxmlformats.org/drawingml/2006/main"/>
         </p:blipFill>
@@ -14519,7 +14620,7 @@
           <p:cNvPr id="6" name="footer-rule">
             <a:extLst xmlns:a="http://schemas.openxmlformats.org/drawingml/2006/main">
               <a:ext uri="{FF2B5EF4-FFF2-40B4-BE49-F238E27FC236}">
-                <a16:creationId xmlns:a16="http://schemas.microsoft.com/office/drawing/2014/main" id="{2F1BD57F-4E0E-4BA0-805D-4E460B4965B8}"/>
+                <a16:creationId xmlns:a16="http://schemas.microsoft.com/office/drawing/2014/main" id="{46095F37-403B-4381-AA71-9AF15A742E44}"/>
               </a:ext>
             </a:extLst>
           </p:cNvPr>
@@ -14714,7 +14815,7 @@
           <p:cNvPr id="8" name="architecture-link">
             <a:extLst xmlns:a="http://schemas.openxmlformats.org/drawingml/2006/main">
               <a:ext uri="{FF2B5EF4-FFF2-40B4-BE49-F238E27FC236}">
-                <a16:creationId xmlns:a16="http://schemas.microsoft.com/office/drawing/2014/main" id="{A5BCE8C3-C0D4-4F1E-9710-316BD2501362}"/>
+                <a16:creationId xmlns:a16="http://schemas.microsoft.com/office/drawing/2014/main" id="{B930400F-8601-47D6-AF81-0FA94E4B8C38}"/>
               </a:ext>
             </a:extLst>
           </p:cNvPr>
@@ -14742,7 +14843,7 @@
           <p:cNvPr id="9" name="architecture-link">
             <a:extLst xmlns:a="http://schemas.openxmlformats.org/drawingml/2006/main">
               <a:ext uri="{FF2B5EF4-FFF2-40B4-BE49-F238E27FC236}">
-                <a16:creationId xmlns:a16="http://schemas.microsoft.com/office/drawing/2014/main" id="{B6FDE4B8-F279-41EA-95FD-6CF308778174}"/>
+                <a16:creationId xmlns:a16="http://schemas.microsoft.com/office/drawing/2014/main" id="{29C1F7E6-292E-433F-90DA-DF58F685719B}"/>
               </a:ext>
             </a:extLst>
           </p:cNvPr>
@@ -15106,7 +15207,7 @@
           <p:cNvPr id="12" name="architecture-link">
             <a:extLst xmlns:a="http://schemas.openxmlformats.org/drawingml/2006/main">
               <a:ext uri="{FF2B5EF4-FFF2-40B4-BE49-F238E27FC236}">
-                <a16:creationId xmlns:a16="http://schemas.microsoft.com/office/drawing/2014/main" id="{0F3F0567-7D50-4D5A-9542-6CE7B9674F3E}"/>
+                <a16:creationId xmlns:a16="http://schemas.microsoft.com/office/drawing/2014/main" id="{62842D1A-1D02-436B-8B54-478E4B735D2A}"/>
               </a:ext>
             </a:extLst>
           </p:cNvPr>
@@ -15302,7 +15403,7 @@
           <p:cNvPr id="14" name="architecture-link">
             <a:extLst xmlns:a="http://schemas.openxmlformats.org/drawingml/2006/main">
               <a:ext uri="{FF2B5EF4-FFF2-40B4-BE49-F238E27FC236}">
-                <a16:creationId xmlns:a16="http://schemas.microsoft.com/office/drawing/2014/main" id="{FE0DEA6F-23DD-4D7A-8F7D-172AEC278E49}"/>
+                <a16:creationId xmlns:a16="http://schemas.microsoft.com/office/drawing/2014/main" id="{60E636DA-60F8-432E-B213-7F2103F2E173}"/>
               </a:ext>
             </a:extLst>
           </p:cNvPr>
@@ -15330,7 +15431,7 @@
           <p:cNvPr id="15" name="architecture-link">
             <a:extLst xmlns:a="http://schemas.openxmlformats.org/drawingml/2006/main">
               <a:ext uri="{FF2B5EF4-FFF2-40B4-BE49-F238E27FC236}">
-                <a16:creationId xmlns:a16="http://schemas.microsoft.com/office/drawing/2014/main" id="{F6021DDA-152E-401A-A160-12C6D6C67136}"/>
+                <a16:creationId xmlns:a16="http://schemas.microsoft.com/office/drawing/2014/main" id="{7F924EA7-2542-4342-AA00-6EAE1557D68E}"/>
               </a:ext>
             </a:extLst>
           </p:cNvPr>
@@ -15359,7 +15460,7 @@
           <p:cNvPr id="16" name="architecture-link">
             <a:extLst xmlns:a="http://schemas.openxmlformats.org/drawingml/2006/main">
               <a:ext uri="{FF2B5EF4-FFF2-40B4-BE49-F238E27FC236}">
-                <a16:creationId xmlns:a16="http://schemas.microsoft.com/office/drawing/2014/main" id="{16FAB149-F429-4394-865B-5086D05FB786}"/>
+                <a16:creationId xmlns:a16="http://schemas.microsoft.com/office/drawing/2014/main" id="{B16CD55B-C360-4498-96B8-1B4719D831D3}"/>
               </a:ext>
             </a:extLst>
           </p:cNvPr>
@@ -15387,7 +15488,7 @@
           <p:cNvPr id="17" name="architecture-link">
             <a:extLst xmlns:a="http://schemas.openxmlformats.org/drawingml/2006/main">
               <a:ext uri="{FF2B5EF4-FFF2-40B4-BE49-F238E27FC236}">
-                <a16:creationId xmlns:a16="http://schemas.microsoft.com/office/drawing/2014/main" id="{86D75295-831C-4B1C-9D1B-4E9576C40649}"/>
+                <a16:creationId xmlns:a16="http://schemas.microsoft.com/office/drawing/2014/main" id="{A45969A9-A596-4218-B7A6-565090793DCA}"/>
               </a:ext>
             </a:extLst>
           </p:cNvPr>
@@ -15415,7 +15516,7 @@
           <p:cNvPr id="18" name="architecture-link">
             <a:extLst xmlns:a="http://schemas.openxmlformats.org/drawingml/2006/main">
               <a:ext uri="{FF2B5EF4-FFF2-40B4-BE49-F238E27FC236}">
-                <a16:creationId xmlns:a16="http://schemas.microsoft.com/office/drawing/2014/main" id="{3113A971-29BB-4244-9E70-60651BABC6AC}"/>
+                <a16:creationId xmlns:a16="http://schemas.microsoft.com/office/drawing/2014/main" id="{FE9369FD-BD85-4454-B231-52CCF380BC0C}"/>
               </a:ext>
             </a:extLst>
           </p:cNvPr>
@@ -17331,6 +17432,7 @@
               </a:defRPr>
             </a:defPPr>
             <a:lvl1pPr algn="l">
+              <a:buNone/>
               <a:defRPr sz="1950" b="1">
                 <a:solidFill>
                   <a:srgbClr val="2B5BEB"/>
@@ -17341,6 +17443,7 @@
               </a:defRPr>
             </a:lvl1pPr>
             <a:lvl2pPr algn="l">
+              <a:buNone/>
               <a:defRPr sz="1950" b="1">
                 <a:solidFill>
                   <a:srgbClr val="2B5BEB"/>
@@ -17351,6 +17454,7 @@
               </a:defRPr>
             </a:lvl2pPr>
             <a:lvl3pPr algn="l">
+              <a:buNone/>
               <a:defRPr sz="1950" b="1">
                 <a:solidFill>
                   <a:srgbClr val="2B5BEB"/>
@@ -17361,6 +17465,7 @@
               </a:defRPr>
             </a:lvl3pPr>
             <a:lvl4pPr algn="l">
+              <a:buNone/>
               <a:defRPr sz="1950" b="1">
                 <a:solidFill>
                   <a:srgbClr val="2B5BEB"/>
@@ -17371,6 +17476,7 @@
               </a:defRPr>
             </a:lvl4pPr>
             <a:lvl5pPr algn="l">
+              <a:buNone/>
               <a:defRPr sz="1950" b="1">
                 <a:solidFill>
                   <a:srgbClr val="2B5BEB"/>
@@ -17381,6 +17487,7 @@
               </a:defRPr>
             </a:lvl5pPr>
             <a:lvl6pPr algn="l">
+              <a:buNone/>
               <a:defRPr sz="1950" b="1">
                 <a:solidFill>
                   <a:srgbClr val="2B5BEB"/>
@@ -17391,6 +17498,7 @@
               </a:defRPr>
             </a:lvl6pPr>
             <a:lvl7pPr algn="l">
+              <a:buNone/>
               <a:defRPr sz="1950" b="1">
                 <a:solidFill>
                   <a:srgbClr val="2B5BEB"/>
@@ -17401,6 +17509,7 @@
               </a:defRPr>
             </a:lvl7pPr>
             <a:lvl8pPr algn="l">
+              <a:buNone/>
               <a:defRPr sz="1950" b="1">
                 <a:solidFill>
                   <a:srgbClr val="2B5BEB"/>
@@ -17411,6 +17520,7 @@
               </a:defRPr>
             </a:lvl8pPr>
             <a:lvl9pPr algn="l">
+              <a:buNone/>
               <a:defRPr sz="1950" b="1">
                 <a:solidFill>
                   <a:srgbClr val="2B5BEB"/>
@@ -17423,6 +17533,7 @@
           </a:lstStyle>
           <a:p xmlns:a="http://schemas.openxmlformats.org/drawingml/2006/main">
             <a:pPr algn="l">
+              <a:buNone/>
               <a:defRPr sz="1950" b="1">
                 <a:solidFill>
                   <a:srgbClr val="2B5BEB"/>
@@ -17489,6 +17600,7 @@
               </a:defRPr>
             </a:defPPr>
             <a:lvl1pPr algn="r">
+              <a:buNone/>
               <a:defRPr sz="1950" b="0">
                 <a:solidFill>
                   <a:srgbClr val="566A80"/>
@@ -17499,6 +17611,7 @@
               </a:defRPr>
             </a:lvl1pPr>
             <a:lvl2pPr algn="r">
+              <a:buNone/>
               <a:defRPr sz="1950" b="0">
                 <a:solidFill>
                   <a:srgbClr val="566A80"/>
@@ -17509,6 +17622,7 @@
               </a:defRPr>
             </a:lvl2pPr>
             <a:lvl3pPr algn="r">
+              <a:buNone/>
               <a:defRPr sz="1950" b="0">
                 <a:solidFill>
                   <a:srgbClr val="566A80"/>
@@ -17519,6 +17633,7 @@
               </a:defRPr>
             </a:lvl3pPr>
             <a:lvl4pPr algn="r">
+              <a:buNone/>
               <a:defRPr sz="1950" b="0">
                 <a:solidFill>
                   <a:srgbClr val="566A80"/>
@@ -17529,6 +17644,7 @@
               </a:defRPr>
             </a:lvl4pPr>
             <a:lvl5pPr algn="r">
+              <a:buNone/>
               <a:defRPr sz="1950" b="0">
                 <a:solidFill>
                   <a:srgbClr val="566A80"/>
@@ -17539,6 +17655,7 @@
               </a:defRPr>
             </a:lvl5pPr>
             <a:lvl6pPr algn="r">
+              <a:buNone/>
               <a:defRPr sz="1950" b="0">
                 <a:solidFill>
                   <a:srgbClr val="566A80"/>
@@ -17549,6 +17666,7 @@
               </a:defRPr>
             </a:lvl6pPr>
             <a:lvl7pPr algn="r">
+              <a:buNone/>
               <a:defRPr sz="1950" b="0">
                 <a:solidFill>
                   <a:srgbClr val="566A80"/>
@@ -17559,6 +17677,7 @@
               </a:defRPr>
             </a:lvl7pPr>
             <a:lvl8pPr algn="r">
+              <a:buNone/>
               <a:defRPr sz="1950" b="0">
                 <a:solidFill>
                   <a:srgbClr val="566A80"/>
@@ -17569,6 +17688,7 @@
               </a:defRPr>
             </a:lvl8pPr>
             <a:lvl9pPr algn="r">
+              <a:buNone/>
               <a:defRPr sz="1950" b="0">
                 <a:solidFill>
                   <a:srgbClr val="566A80"/>
@@ -17581,6 +17701,7 @@
           </a:lstStyle>
           <a:p xmlns:a="http://schemas.openxmlformats.org/drawingml/2006/main">
             <a:pPr algn="r">
+              <a:buNone/>
               <a:defRPr sz="1950" b="0">
                 <a:solidFill>
                   <a:srgbClr val="566A80"/>
@@ -17647,6 +17768,7 @@
               </a:defRPr>
             </a:defPPr>
             <a:lvl1pPr algn="l">
+              <a:buNone/>
               <a:defRPr sz="5100" b="1">
                 <a:solidFill>
                   <a:srgbClr val="122C46"/>
@@ -17657,6 +17779,7 @@
               </a:defRPr>
             </a:lvl1pPr>
             <a:lvl2pPr algn="l">
+              <a:buNone/>
               <a:defRPr sz="5100" b="1">
                 <a:solidFill>
                   <a:srgbClr val="122C46"/>
@@ -17667,6 +17790,7 @@
               </a:defRPr>
             </a:lvl2pPr>
             <a:lvl3pPr algn="l">
+              <a:buNone/>
               <a:defRPr sz="5100" b="1">
                 <a:solidFill>
                   <a:srgbClr val="122C46"/>
@@ -17677,6 +17801,7 @@
               </a:defRPr>
             </a:lvl3pPr>
             <a:lvl4pPr algn="l">
+              <a:buNone/>
               <a:defRPr sz="5100" b="1">
                 <a:solidFill>
                   <a:srgbClr val="122C46"/>
@@ -17687,6 +17812,7 @@
               </a:defRPr>
             </a:lvl4pPr>
             <a:lvl5pPr algn="l">
+              <a:buNone/>
               <a:defRPr sz="5100" b="1">
                 <a:solidFill>
                   <a:srgbClr val="122C46"/>
@@ -17697,6 +17823,7 @@
               </a:defRPr>
             </a:lvl5pPr>
             <a:lvl6pPr algn="l">
+              <a:buNone/>
               <a:defRPr sz="5100" b="1">
                 <a:solidFill>
                   <a:srgbClr val="122C46"/>
@@ -17707,6 +17834,7 @@
               </a:defRPr>
             </a:lvl6pPr>
             <a:lvl7pPr algn="l">
+              <a:buNone/>
               <a:defRPr sz="5100" b="1">
                 <a:solidFill>
                   <a:srgbClr val="122C46"/>
@@ -17717,6 +17845,7 @@
               </a:defRPr>
             </a:lvl7pPr>
             <a:lvl8pPr algn="l">
+              <a:buNone/>
               <a:defRPr sz="5100" b="1">
                 <a:solidFill>
                   <a:srgbClr val="122C46"/>
@@ -17727,6 +17856,7 @@
               </a:defRPr>
             </a:lvl8pPr>
             <a:lvl9pPr algn="l">
+              <a:buNone/>
               <a:defRPr sz="5100" b="1">
                 <a:solidFill>
                   <a:srgbClr val="122C46"/>
@@ -17739,6 +17869,7 @@
           </a:lstStyle>
           <a:p xmlns:a="http://schemas.openxmlformats.org/drawingml/2006/main">
             <a:pPr algn="l">
+              <a:buNone/>
               <a:defRPr sz="5100" b="1">
                 <a:solidFill>
                   <a:srgbClr val="122C46"/>
@@ -17757,7 +17888,7 @@
                 <a:ea typeface="Noto Sans Bold"/>
                 <a:cs typeface="Noto Sans Bold"/>
               </a:rPr>
-              <a:t>적용 기술과 재작성 실행 결과</a:t>
+              <a:t>적용 기술과 실제 검증 화면</a:t>
             </a:r>
           </a:p>
         </p:txBody>
@@ -17805,6 +17936,7 @@
               </a:defRPr>
             </a:defPPr>
             <a:lvl1pPr algn="l">
+              <a:buNone/>
               <a:defRPr sz="2400" b="0">
                 <a:solidFill>
                   <a:srgbClr val="566A80"/>
@@ -17815,6 +17947,7 @@
               </a:defRPr>
             </a:lvl1pPr>
             <a:lvl2pPr algn="l">
+              <a:buNone/>
               <a:defRPr sz="2400" b="0">
                 <a:solidFill>
                   <a:srgbClr val="566A80"/>
@@ -17825,6 +17958,7 @@
               </a:defRPr>
             </a:lvl2pPr>
             <a:lvl3pPr algn="l">
+              <a:buNone/>
               <a:defRPr sz="2400" b="0">
                 <a:solidFill>
                   <a:srgbClr val="566A80"/>
@@ -17835,6 +17969,7 @@
               </a:defRPr>
             </a:lvl3pPr>
             <a:lvl4pPr algn="l">
+              <a:buNone/>
               <a:defRPr sz="2400" b="0">
                 <a:solidFill>
                   <a:srgbClr val="566A80"/>
@@ -17845,6 +17980,7 @@
               </a:defRPr>
             </a:lvl4pPr>
             <a:lvl5pPr algn="l">
+              <a:buNone/>
               <a:defRPr sz="2400" b="0">
                 <a:solidFill>
                   <a:srgbClr val="566A80"/>
@@ -17855,6 +17991,7 @@
               </a:defRPr>
             </a:lvl5pPr>
             <a:lvl6pPr algn="l">
+              <a:buNone/>
               <a:defRPr sz="2400" b="0">
                 <a:solidFill>
                   <a:srgbClr val="566A80"/>
@@ -17865,6 +18002,7 @@
               </a:defRPr>
             </a:lvl6pPr>
             <a:lvl7pPr algn="l">
+              <a:buNone/>
               <a:defRPr sz="2400" b="0">
                 <a:solidFill>
                   <a:srgbClr val="566A80"/>
@@ -17875,6 +18013,7 @@
               </a:defRPr>
             </a:lvl7pPr>
             <a:lvl8pPr algn="l">
+              <a:buNone/>
               <a:defRPr sz="2400" b="0">
                 <a:solidFill>
                   <a:srgbClr val="566A80"/>
@@ -17885,6 +18024,7 @@
               </a:defRPr>
             </a:lvl8pPr>
             <a:lvl9pPr algn="l">
+              <a:buNone/>
               <a:defRPr sz="2400" b="0">
                 <a:solidFill>
                   <a:srgbClr val="566A80"/>
@@ -17897,6 +18037,7 @@
           </a:lstStyle>
           <a:p xmlns:a="http://schemas.openxmlformats.org/drawingml/2006/main">
             <a:pPr algn="l">
+              <a:buNone/>
               <a:defRPr sz="2400" b="0">
                 <a:solidFill>
                   <a:srgbClr val="566A80"/>
@@ -17915,7 +18056,7 @@
                 <a:ea typeface="Noto Sans Kr"/>
                 <a:cs typeface="Noto Sans Kr"/>
               </a:rPr>
-              <a:t>검색 결과와 코드 검증의 재작성 동작을 실제 실행 기록으로 확인했습니다.</a:t>
+              <a:t>RAG 검색과 근거 검증의 결과를 실제 프론트에서 확인했습니다.</a:t>
             </a:r>
           </a:p>
         </p:txBody>
@@ -17963,6 +18104,7 @@
               </a:defRPr>
             </a:defPPr>
             <a:lvl1pPr algn="l">
+              <a:buNone/>
               <a:defRPr sz="1800" b="0">
                 <a:solidFill>
                   <a:srgbClr val="566A80"/>
@@ -17973,6 +18115,7 @@
               </a:defRPr>
             </a:lvl1pPr>
             <a:lvl2pPr algn="l">
+              <a:buNone/>
               <a:defRPr sz="1800" b="0">
                 <a:solidFill>
                   <a:srgbClr val="566A80"/>
@@ -17983,6 +18126,7 @@
               </a:defRPr>
             </a:lvl2pPr>
             <a:lvl3pPr algn="l">
+              <a:buNone/>
               <a:defRPr sz="1800" b="0">
                 <a:solidFill>
                   <a:srgbClr val="566A80"/>
@@ -17993,6 +18137,7 @@
               </a:defRPr>
             </a:lvl3pPr>
             <a:lvl4pPr algn="l">
+              <a:buNone/>
               <a:defRPr sz="1800" b="0">
                 <a:solidFill>
                   <a:srgbClr val="566A80"/>
@@ -18003,6 +18148,7 @@
               </a:defRPr>
             </a:lvl4pPr>
             <a:lvl5pPr algn="l">
+              <a:buNone/>
               <a:defRPr sz="1800" b="0">
                 <a:solidFill>
                   <a:srgbClr val="566A80"/>
@@ -18013,6 +18159,7 @@
               </a:defRPr>
             </a:lvl5pPr>
             <a:lvl6pPr algn="l">
+              <a:buNone/>
               <a:defRPr sz="1800" b="0">
                 <a:solidFill>
                   <a:srgbClr val="566A80"/>
@@ -18023,6 +18170,7 @@
               </a:defRPr>
             </a:lvl6pPr>
             <a:lvl7pPr algn="l">
+              <a:buNone/>
               <a:defRPr sz="1800" b="0">
                 <a:solidFill>
                   <a:srgbClr val="566A80"/>
@@ -18033,6 +18181,7 @@
               </a:defRPr>
             </a:lvl7pPr>
             <a:lvl8pPr algn="l">
+              <a:buNone/>
               <a:defRPr sz="1800" b="0">
                 <a:solidFill>
                   <a:srgbClr val="566A80"/>
@@ -18043,6 +18192,7 @@
               </a:defRPr>
             </a:lvl8pPr>
             <a:lvl9pPr algn="l">
+              <a:buNone/>
               <a:defRPr sz="1800" b="0">
                 <a:solidFill>
                   <a:srgbClr val="566A80"/>
@@ -18055,6 +18205,7 @@
           </a:lstStyle>
           <a:p xmlns:a="http://schemas.openxmlformats.org/drawingml/2006/main">
             <a:pPr algn="l">
+              <a:buNone/>
               <a:defRPr sz="1800" b="0">
                 <a:solidFill>
                   <a:srgbClr val="566A80"/>
@@ -18073,7 +18224,7 @@
                 <a:ea typeface="Noto Sans Kr"/>
                 <a:cs typeface="Noto Sans Kr"/>
               </a:rPr>
-              <a:t>2026-10-21 batch 보존 실행 / 총 2회 작성·코드 검증 통과 / Judge는 별도 품질 평가</a:t>
+              <a:t>2026-10-22 실제 Ollama 재실행·프론트 캡처 / 교육용 합성 관측 / Judge는 별도 품질 평가</a:t>
             </a:r>
           </a:p>
         </p:txBody>
@@ -18083,7 +18234,7 @@
           <p:cNvPr id="6" name="footer-rule">
             <a:extLst xmlns:a="http://schemas.openxmlformats.org/drawingml/2006/main">
               <a:ext uri="{FF2B5EF4-FFF2-40B4-BE49-F238E27FC236}">
-                <a16:creationId xmlns:a16="http://schemas.microsoft.com/office/drawing/2014/main" id="{64E28199-9704-4F88-9E9A-A31357F9BE83}"/>
+                <a16:creationId xmlns:a16="http://schemas.microsoft.com/office/drawing/2014/main" id="{F3FF57B9-869B-4749-BB7A-8D2B35D65914}"/>
               </a:ext>
             </a:extLst>
           </p:cNvPr>
@@ -18148,6 +18299,7 @@
               </a:defRPr>
             </a:defPPr>
             <a:lvl1pPr algn="l">
+              <a:buNone/>
               <a:defRPr sz="1650" b="0">
                 <a:solidFill>
                   <a:srgbClr val="566A80"/>
@@ -18158,6 +18310,7 @@
               </a:defRPr>
             </a:lvl1pPr>
             <a:lvl2pPr algn="l">
+              <a:buNone/>
               <a:defRPr sz="1650" b="0">
                 <a:solidFill>
                   <a:srgbClr val="566A80"/>
@@ -18168,6 +18321,7 @@
               </a:defRPr>
             </a:lvl2pPr>
             <a:lvl3pPr algn="l">
+              <a:buNone/>
               <a:defRPr sz="1650" b="0">
                 <a:solidFill>
                   <a:srgbClr val="566A80"/>
@@ -18178,6 +18332,7 @@
               </a:defRPr>
             </a:lvl3pPr>
             <a:lvl4pPr algn="l">
+              <a:buNone/>
               <a:defRPr sz="1650" b="0">
                 <a:solidFill>
                   <a:srgbClr val="566A80"/>
@@ -18188,6 +18343,7 @@
               </a:defRPr>
             </a:lvl4pPr>
             <a:lvl5pPr algn="l">
+              <a:buNone/>
               <a:defRPr sz="1650" b="0">
                 <a:solidFill>
                   <a:srgbClr val="566A80"/>
@@ -18198,6 +18354,7 @@
               </a:defRPr>
             </a:lvl5pPr>
             <a:lvl6pPr algn="l">
+              <a:buNone/>
               <a:defRPr sz="1650" b="0">
                 <a:solidFill>
                   <a:srgbClr val="566A80"/>
@@ -18208,6 +18365,7 @@
               </a:defRPr>
             </a:lvl6pPr>
             <a:lvl7pPr algn="l">
+              <a:buNone/>
               <a:defRPr sz="1650" b="0">
                 <a:solidFill>
                   <a:srgbClr val="566A80"/>
@@ -18218,6 +18376,7 @@
               </a:defRPr>
             </a:lvl7pPr>
             <a:lvl8pPr algn="l">
+              <a:buNone/>
               <a:defRPr sz="1650" b="0">
                 <a:solidFill>
                   <a:srgbClr val="566A80"/>
@@ -18228,6 +18387,7 @@
               </a:defRPr>
             </a:lvl8pPr>
             <a:lvl9pPr algn="l">
+              <a:buNone/>
               <a:defRPr sz="1650" b="0">
                 <a:solidFill>
                   <a:srgbClr val="566A80"/>
@@ -18240,6 +18400,7 @@
           </a:lstStyle>
           <a:p xmlns:a="http://schemas.openxmlformats.org/drawingml/2006/main">
             <a:pPr algn="l">
+              <a:buNone/>
               <a:defRPr sz="1650" b="0">
                 <a:solidFill>
                   <a:srgbClr val="566A80"/>
@@ -18268,7 +18429,7 @@
           <p:cNvPr id="8" name="">
             <a:extLst xmlns:a="http://schemas.openxmlformats.org/drawingml/2006/main">
               <a:ext uri="{FF2B5EF4-FFF2-40B4-BE49-F238E27FC236}">
-                <a16:creationId xmlns:a16="http://schemas.microsoft.com/office/drawing/2014/main" id="{3AD19F0A-052A-424B-A54B-C0ED19761750}"/>
+                <a16:creationId xmlns:a16="http://schemas.microsoft.com/office/drawing/2014/main" id="{94B40EA3-C170-4F4E-9BA2-1C635349DB3E}"/>
               </a:ext>
             </a:extLst>
           </p:cNvPr>
@@ -18852,6 +19013,7 @@
               </a:defRPr>
             </a:defPPr>
             <a:lvl1pPr algn="l">
+              <a:buNone/>
               <a:defRPr sz="1950" b="0">
                 <a:solidFill>
                   <a:srgbClr val="566A80"/>
@@ -18862,6 +19024,7 @@
               </a:defRPr>
             </a:lvl1pPr>
             <a:lvl2pPr algn="l">
+              <a:buNone/>
               <a:defRPr sz="1950" b="0">
                 <a:solidFill>
                   <a:srgbClr val="566A80"/>
@@ -18872,6 +19035,7 @@
               </a:defRPr>
             </a:lvl2pPr>
             <a:lvl3pPr algn="l">
+              <a:buNone/>
               <a:defRPr sz="1950" b="0">
                 <a:solidFill>
                   <a:srgbClr val="566A80"/>
@@ -18882,6 +19046,7 @@
               </a:defRPr>
             </a:lvl3pPr>
             <a:lvl4pPr algn="l">
+              <a:buNone/>
               <a:defRPr sz="1950" b="0">
                 <a:solidFill>
                   <a:srgbClr val="566A80"/>
@@ -18892,6 +19057,7 @@
               </a:defRPr>
             </a:lvl4pPr>
             <a:lvl5pPr algn="l">
+              <a:buNone/>
               <a:defRPr sz="1950" b="0">
                 <a:solidFill>
                   <a:srgbClr val="566A80"/>
@@ -18902,6 +19068,7 @@
               </a:defRPr>
             </a:lvl5pPr>
             <a:lvl6pPr algn="l">
+              <a:buNone/>
               <a:defRPr sz="1950" b="0">
                 <a:solidFill>
                   <a:srgbClr val="566A80"/>
@@ -18912,6 +19079,7 @@
               </a:defRPr>
             </a:lvl6pPr>
             <a:lvl7pPr algn="l">
+              <a:buNone/>
               <a:defRPr sz="1950" b="0">
                 <a:solidFill>
                   <a:srgbClr val="566A80"/>
@@ -18922,6 +19090,7 @@
               </a:defRPr>
             </a:lvl7pPr>
             <a:lvl8pPr algn="l">
+              <a:buNone/>
               <a:defRPr sz="1950" b="0">
                 <a:solidFill>
                   <a:srgbClr val="566A80"/>
@@ -18932,6 +19101,7 @@
               </a:defRPr>
             </a:lvl8pPr>
             <a:lvl9pPr algn="l">
+              <a:buNone/>
               <a:defRPr sz="1950" b="0">
                 <a:solidFill>
                   <a:srgbClr val="566A80"/>
@@ -18944,6 +19114,7 @@
           </a:lstStyle>
           <a:p xmlns:a="http://schemas.openxmlformats.org/drawingml/2006/main">
             <a:pPr algn="l">
+              <a:buNone/>
               <a:defRPr sz="1950" b="0">
                 <a:solidFill>
                   <a:srgbClr val="566A80"/>
@@ -18969,10 +19140,10 @@
       </p:sp>
       <p:sp>
         <p:nvSpPr>
-          <p:cNvPr id="10" name="validation-example-title">
+          <p:cNvPr id="15" name="validation-screenshot-title">
             <a:extLst xmlns:a="http://schemas.openxmlformats.org/drawingml/2006/main">
               <a:ext uri="{FF2B5EF4-FFF2-40B4-BE49-F238E27FC236}">
-                <a16:creationId xmlns:a16="http://schemas.microsoft.com/office/drawing/2014/main" id="{4F29B1C2-08A8-4502-91E2-43636D53B131}"/>
+                <a16:creationId xmlns:a16="http://schemas.microsoft.com/office/drawing/2014/main" id="{5E1A6FDE-0EF8-4165-B20C-1F4680E3AA50}"/>
               </a:ext>
             </a:extLst>
           </p:cNvPr>
@@ -18984,164 +19155,6 @@
         <p:spPr>
           <a:xfrm xmlns:a="http://schemas.openxmlformats.org/drawingml/2006/main">
             <a:off x="9144000" y="3333750"/>
-            <a:ext cx="8001000" cy="523875"/>
-          </a:xfrm>
-          <a:prstGeom xmlns:a="http://schemas.openxmlformats.org/drawingml/2006/main" prst="rect">
-            <a:avLst/>
-          </a:prstGeom>
-          <a:noFill xmlns:a="http://schemas.openxmlformats.org/drawingml/2006/main"/>
-          <a:ln xmlns:a="http://schemas.openxmlformats.org/drawingml/2006/main" w="0">
-            <a:noFill/>
-          </a:ln>
-        </p:spPr>
-        <p:txBody>
-          <a:bodyPr xmlns:a="http://schemas.openxmlformats.org/drawingml/2006/main" wrap="none" lIns="0" tIns="0" rIns="0" bIns="0" anchor="t">
-            <a:noAutofit/>
-          </a:bodyPr>
-          <a:lstStyle xmlns:a="http://schemas.openxmlformats.org/drawingml/2006/main">
-            <a:defPPr algn="l">
-              <a:defRPr sz="2550" b="1">
-                <a:solidFill>
-                  <a:srgbClr val="2B5BEB"/>
-                </a:solidFill>
-                <a:latin typeface="Noto Sans Bold"/>
-                <a:ea typeface="Noto Sans Bold"/>
-                <a:cs typeface="Noto Sans Bold"/>
-              </a:defRPr>
-            </a:defPPr>
-            <a:lvl1pPr algn="l">
-              <a:defRPr sz="2550" b="1">
-                <a:solidFill>
-                  <a:srgbClr val="2B5BEB"/>
-                </a:solidFill>
-                <a:latin typeface="Noto Sans Bold"/>
-                <a:ea typeface="Noto Sans Bold"/>
-                <a:cs typeface="Noto Sans Bold"/>
-              </a:defRPr>
-            </a:lvl1pPr>
-            <a:lvl2pPr algn="l">
-              <a:defRPr sz="2550" b="1">
-                <a:solidFill>
-                  <a:srgbClr val="2B5BEB"/>
-                </a:solidFill>
-                <a:latin typeface="Noto Sans Bold"/>
-                <a:ea typeface="Noto Sans Bold"/>
-                <a:cs typeface="Noto Sans Bold"/>
-              </a:defRPr>
-            </a:lvl2pPr>
-            <a:lvl3pPr algn="l">
-              <a:defRPr sz="2550" b="1">
-                <a:solidFill>
-                  <a:srgbClr val="2B5BEB"/>
-                </a:solidFill>
-                <a:latin typeface="Noto Sans Bold"/>
-                <a:ea typeface="Noto Sans Bold"/>
-                <a:cs typeface="Noto Sans Bold"/>
-              </a:defRPr>
-            </a:lvl3pPr>
-            <a:lvl4pPr algn="l">
-              <a:defRPr sz="2550" b="1">
-                <a:solidFill>
-                  <a:srgbClr val="2B5BEB"/>
-                </a:solidFill>
-                <a:latin typeface="Noto Sans Bold"/>
-                <a:ea typeface="Noto Sans Bold"/>
-                <a:cs typeface="Noto Sans Bold"/>
-              </a:defRPr>
-            </a:lvl4pPr>
-            <a:lvl5pPr algn="l">
-              <a:defRPr sz="2550" b="1">
-                <a:solidFill>
-                  <a:srgbClr val="2B5BEB"/>
-                </a:solidFill>
-                <a:latin typeface="Noto Sans Bold"/>
-                <a:ea typeface="Noto Sans Bold"/>
-                <a:cs typeface="Noto Sans Bold"/>
-              </a:defRPr>
-            </a:lvl5pPr>
-            <a:lvl6pPr algn="l">
-              <a:defRPr sz="2550" b="1">
-                <a:solidFill>
-                  <a:srgbClr val="2B5BEB"/>
-                </a:solidFill>
-                <a:latin typeface="Noto Sans Bold"/>
-                <a:ea typeface="Noto Sans Bold"/>
-                <a:cs typeface="Noto Sans Bold"/>
-              </a:defRPr>
-            </a:lvl6pPr>
-            <a:lvl7pPr algn="l">
-              <a:defRPr sz="2550" b="1">
-                <a:solidFill>
-                  <a:srgbClr val="2B5BEB"/>
-                </a:solidFill>
-                <a:latin typeface="Noto Sans Bold"/>
-                <a:ea typeface="Noto Sans Bold"/>
-                <a:cs typeface="Noto Sans Bold"/>
-              </a:defRPr>
-            </a:lvl7pPr>
-            <a:lvl8pPr algn="l">
-              <a:defRPr sz="2550" b="1">
-                <a:solidFill>
-                  <a:srgbClr val="2B5BEB"/>
-                </a:solidFill>
-                <a:latin typeface="Noto Sans Bold"/>
-                <a:ea typeface="Noto Sans Bold"/>
-                <a:cs typeface="Noto Sans Bold"/>
-              </a:defRPr>
-            </a:lvl8pPr>
-            <a:lvl9pPr algn="l">
-              <a:defRPr sz="2550" b="1">
-                <a:solidFill>
-                  <a:srgbClr val="2B5BEB"/>
-                </a:solidFill>
-                <a:latin typeface="Noto Sans Bold"/>
-                <a:ea typeface="Noto Sans Bold"/>
-                <a:cs typeface="Noto Sans Bold"/>
-              </a:defRPr>
-            </a:lvl9pPr>
-          </a:lstStyle>
-          <a:p xmlns:a="http://schemas.openxmlformats.org/drawingml/2006/main">
-            <a:pPr algn="l">
-              <a:defRPr sz="2550" b="1">
-                <a:solidFill>
-                  <a:srgbClr val="2B5BEB"/>
-                </a:solidFill>
-                <a:latin typeface="Noto Sans Bold"/>
-                <a:ea typeface="Noto Sans Bold"/>
-                <a:cs typeface="Noto Sans Bold"/>
-              </a:defRPr>
-            </a:pPr>
-            <a:r>
-              <a:rPr sz="2550" b="1">
-                <a:solidFill>
-                  <a:srgbClr val="2B5BEB"/>
-                </a:solidFill>
-                <a:latin typeface="Noto Sans Bold"/>
-                <a:ea typeface="Noto Sans Bold"/>
-                <a:cs typeface="Noto Sans Bold"/>
-              </a:rPr>
-              <a:t>실제 배치 사례의 작성 기록</a:t>
-            </a:r>
-          </a:p>
-        </p:txBody>
-      </p:sp>
-      <p:sp>
-        <p:nvSpPr>
-          <p:cNvPr id="11" name="validation-trigger">
-            <a:extLst xmlns:a="http://schemas.openxmlformats.org/drawingml/2006/main">
-              <a:ext uri="{FF2B5EF4-FFF2-40B4-BE49-F238E27FC236}">
-                <a16:creationId xmlns:a16="http://schemas.microsoft.com/office/drawing/2014/main" id="{C1616FBD-8D6F-4C62-B982-726C6DD6112A}"/>
-              </a:ext>
-            </a:extLst>
-          </p:cNvPr>
-          <p:cNvSpPr>
-            <a:spLocks xmlns:a="http://schemas.openxmlformats.org/drawingml/2006/main" noGrp="1"/>
-          </p:cNvSpPr>
-          <p:nvPr/>
-        </p:nvSpPr>
-        <p:spPr>
-          <a:xfrm xmlns:a="http://schemas.openxmlformats.org/drawingml/2006/main">
-            <a:off x="9144000" y="4000500"/>
             <a:ext cx="8001000" cy="476250"/>
           </a:xfrm>
           <a:prstGeom xmlns:a="http://schemas.openxmlformats.org/drawingml/2006/main" prst="rect">
@@ -19157,596 +19170,161 @@
             <a:noAutofit/>
           </a:bodyPr>
           <a:lstStyle xmlns:a="http://schemas.openxmlformats.org/drawingml/2006/main">
-            <a:defPPr algn="l">
-              <a:defRPr sz="2100" b="0">
-                <a:solidFill>
-                  <a:srgbClr val="566A80"/>
-                </a:solidFill>
-                <a:latin typeface="Noto Sans Kr"/>
-                <a:ea typeface="Noto Sans Kr"/>
-                <a:cs typeface="Noto Sans Kr"/>
+            <a:defPPr>
+              <a:defRPr sz="2550" b="1">
+                <a:solidFill>
+                  <a:srgbClr val="2B5BEB"/>
+                </a:solidFill>
+                <a:latin typeface="Noto Sans Bold"/>
+                <a:ea typeface="Noto Sans Bold"/>
+                <a:cs typeface="Noto Sans Bold"/>
               </a:defRPr>
             </a:defPPr>
-            <a:lvl1pPr algn="l">
-              <a:defRPr sz="2100" b="0">
-                <a:solidFill>
-                  <a:srgbClr val="566A80"/>
-                </a:solidFill>
-                <a:latin typeface="Noto Sans Kr"/>
-                <a:ea typeface="Noto Sans Kr"/>
-                <a:cs typeface="Noto Sans Kr"/>
+            <a:lvl1pPr>
+              <a:defRPr sz="2550" b="1">
+                <a:solidFill>
+                  <a:srgbClr val="2B5BEB"/>
+                </a:solidFill>
+                <a:latin typeface="Noto Sans Bold"/>
+                <a:ea typeface="Noto Sans Bold"/>
+                <a:cs typeface="Noto Sans Bold"/>
               </a:defRPr>
             </a:lvl1pPr>
-            <a:lvl2pPr algn="l">
-              <a:defRPr sz="2100" b="0">
-                <a:solidFill>
-                  <a:srgbClr val="566A80"/>
-                </a:solidFill>
-                <a:latin typeface="Noto Sans Kr"/>
-                <a:ea typeface="Noto Sans Kr"/>
-                <a:cs typeface="Noto Sans Kr"/>
+            <a:lvl2pPr>
+              <a:defRPr sz="2550" b="1">
+                <a:solidFill>
+                  <a:srgbClr val="2B5BEB"/>
+                </a:solidFill>
+                <a:latin typeface="Noto Sans Bold"/>
+                <a:ea typeface="Noto Sans Bold"/>
+                <a:cs typeface="Noto Sans Bold"/>
               </a:defRPr>
             </a:lvl2pPr>
-            <a:lvl3pPr algn="l">
-              <a:defRPr sz="2100" b="0">
-                <a:solidFill>
-                  <a:srgbClr val="566A80"/>
-                </a:solidFill>
-                <a:latin typeface="Noto Sans Kr"/>
-                <a:ea typeface="Noto Sans Kr"/>
-                <a:cs typeface="Noto Sans Kr"/>
+            <a:lvl3pPr>
+              <a:defRPr sz="2550" b="1">
+                <a:solidFill>
+                  <a:srgbClr val="2B5BEB"/>
+                </a:solidFill>
+                <a:latin typeface="Noto Sans Bold"/>
+                <a:ea typeface="Noto Sans Bold"/>
+                <a:cs typeface="Noto Sans Bold"/>
               </a:defRPr>
             </a:lvl3pPr>
-            <a:lvl4pPr algn="l">
-              <a:defRPr sz="2100" b="0">
-                <a:solidFill>
-                  <a:srgbClr val="566A80"/>
-                </a:solidFill>
-                <a:latin typeface="Noto Sans Kr"/>
-                <a:ea typeface="Noto Sans Kr"/>
-                <a:cs typeface="Noto Sans Kr"/>
+            <a:lvl4pPr>
+              <a:defRPr sz="2550" b="1">
+                <a:solidFill>
+                  <a:srgbClr val="2B5BEB"/>
+                </a:solidFill>
+                <a:latin typeface="Noto Sans Bold"/>
+                <a:ea typeface="Noto Sans Bold"/>
+                <a:cs typeface="Noto Sans Bold"/>
               </a:defRPr>
             </a:lvl4pPr>
-            <a:lvl5pPr algn="l">
-              <a:defRPr sz="2100" b="0">
-                <a:solidFill>
-                  <a:srgbClr val="566A80"/>
-                </a:solidFill>
-                <a:latin typeface="Noto Sans Kr"/>
-                <a:ea typeface="Noto Sans Kr"/>
-                <a:cs typeface="Noto Sans Kr"/>
+            <a:lvl5pPr>
+              <a:defRPr sz="2550" b="1">
+                <a:solidFill>
+                  <a:srgbClr val="2B5BEB"/>
+                </a:solidFill>
+                <a:latin typeface="Noto Sans Bold"/>
+                <a:ea typeface="Noto Sans Bold"/>
+                <a:cs typeface="Noto Sans Bold"/>
               </a:defRPr>
             </a:lvl5pPr>
-            <a:lvl6pPr algn="l">
-              <a:defRPr sz="2100" b="0">
-                <a:solidFill>
-                  <a:srgbClr val="566A80"/>
-                </a:solidFill>
-                <a:latin typeface="Noto Sans Kr"/>
-                <a:ea typeface="Noto Sans Kr"/>
-                <a:cs typeface="Noto Sans Kr"/>
+            <a:lvl6pPr>
+              <a:defRPr sz="2550" b="1">
+                <a:solidFill>
+                  <a:srgbClr val="2B5BEB"/>
+                </a:solidFill>
+                <a:latin typeface="Noto Sans Bold"/>
+                <a:ea typeface="Noto Sans Bold"/>
+                <a:cs typeface="Noto Sans Bold"/>
               </a:defRPr>
             </a:lvl6pPr>
-            <a:lvl7pPr algn="l">
-              <a:defRPr sz="2100" b="0">
-                <a:solidFill>
-                  <a:srgbClr val="566A80"/>
-                </a:solidFill>
-                <a:latin typeface="Noto Sans Kr"/>
-                <a:ea typeface="Noto Sans Kr"/>
-                <a:cs typeface="Noto Sans Kr"/>
+            <a:lvl7pPr>
+              <a:defRPr sz="2550" b="1">
+                <a:solidFill>
+                  <a:srgbClr val="2B5BEB"/>
+                </a:solidFill>
+                <a:latin typeface="Noto Sans Bold"/>
+                <a:ea typeface="Noto Sans Bold"/>
+                <a:cs typeface="Noto Sans Bold"/>
               </a:defRPr>
             </a:lvl7pPr>
-            <a:lvl8pPr algn="l">
-              <a:defRPr sz="2100" b="0">
-                <a:solidFill>
-                  <a:srgbClr val="566A80"/>
-                </a:solidFill>
-                <a:latin typeface="Noto Sans Kr"/>
-                <a:ea typeface="Noto Sans Kr"/>
-                <a:cs typeface="Noto Sans Kr"/>
+            <a:lvl8pPr>
+              <a:defRPr sz="2550" b="1">
+                <a:solidFill>
+                  <a:srgbClr val="2B5BEB"/>
+                </a:solidFill>
+                <a:latin typeface="Noto Sans Bold"/>
+                <a:ea typeface="Noto Sans Bold"/>
+                <a:cs typeface="Noto Sans Bold"/>
               </a:defRPr>
             </a:lvl8pPr>
-            <a:lvl9pPr algn="l">
-              <a:defRPr sz="2100" b="0">
-                <a:solidFill>
-                  <a:srgbClr val="566A80"/>
-                </a:solidFill>
-                <a:latin typeface="Noto Sans Kr"/>
-                <a:ea typeface="Noto Sans Kr"/>
-                <a:cs typeface="Noto Sans Kr"/>
+            <a:lvl9pPr>
+              <a:defRPr sz="2550" b="1">
+                <a:solidFill>
+                  <a:srgbClr val="2B5BEB"/>
+                </a:solidFill>
+                <a:latin typeface="Noto Sans Bold"/>
+                <a:ea typeface="Noto Sans Bold"/>
+                <a:cs typeface="Noto Sans Bold"/>
               </a:defRPr>
             </a:lvl9pPr>
           </a:lstStyle>
           <a:p xmlns:a="http://schemas.openxmlformats.org/drawingml/2006/main">
-            <a:pPr algn="l">
-              <a:defRPr sz="2100" b="0">
-                <a:solidFill>
-                  <a:srgbClr val="566A80"/>
-                </a:solidFill>
-                <a:latin typeface="Noto Sans Kr"/>
-                <a:ea typeface="Noto Sans Kr"/>
-                <a:cs typeface="Noto Sans Kr"/>
+            <a:pPr>
+              <a:defRPr sz="2550" b="1">
+                <a:solidFill>
+                  <a:srgbClr val="2B5BEB"/>
+                </a:solidFill>
+                <a:latin typeface="Noto Sans Bold"/>
+                <a:ea typeface="Noto Sans Bold"/>
+                <a:cs typeface="Noto Sans Bold"/>
               </a:defRPr>
             </a:pPr>
             <a:r>
-              <a:rPr sz="2100" b="0">
-                <a:solidFill>
-                  <a:srgbClr val="566A80"/>
-                </a:solidFill>
-                <a:latin typeface="Noto Sans Kr"/>
-                <a:ea typeface="Noto Sans Kr"/>
-                <a:cs typeface="Noto Sans Kr"/>
+              <a:rPr sz="2550" b="1">
+                <a:solidFill>
+                  <a:srgbClr val="2B5BEB"/>
+                </a:solidFill>
+                <a:latin typeface="Noto Sans Bold"/>
+                <a:ea typeface="Noto Sans Bold"/>
+                <a:cs typeface="Noto Sans Bold"/>
               </a:rPr>
-              <a:t>첫 초안에서 확인 가능한 다음 행동 누락</a:t>
+              <a:t>실제 프론트의 최종 검증 결과</a:t>
             </a:r>
           </a:p>
         </p:txBody>
       </p:sp>
-      <p:graphicFrame>
-        <p:nvGraphicFramePr>
-          <p:cNvPr id="12" name="">
+      <p:pic>
+        <p:nvPicPr>
+          <p:cNvPr id="16" name="">
             <a:extLst xmlns:a="http://schemas.openxmlformats.org/drawingml/2006/main">
               <a:ext uri="{FF2B5EF4-FFF2-40B4-BE49-F238E27FC236}">
-                <a16:creationId xmlns:a16="http://schemas.microsoft.com/office/drawing/2014/main" id="{CD58FA70-6624-4E14-80B6-9E3C4B9BAED3}"/>
+                <a16:creationId xmlns:a16="http://schemas.microsoft.com/office/drawing/2014/main" id="{83CDB313-DA00-4E1B-B1AF-7B732EF55B14}"/>
               </a:ext>
             </a:extLst>
           </p:cNvPr>
-          <p:cNvGraphicFramePr/>
+          <p:cNvPicPr>
+            <a:picLocks xmlns:a="http://schemas.openxmlformats.org/drawingml/2006/main" noChangeAspect="1"/>
+          </p:cNvPicPr>
           <p:nvPr/>
-        </p:nvGraphicFramePr>
-        <p:xfrm>
-          <a:off xmlns:a="http://schemas.openxmlformats.org/drawingml/2006/main" x="9144000" y="4762500"/>
-          <a:ext xmlns:a="http://schemas.openxmlformats.org/drawingml/2006/main" cx="8001000" cy="2667000"/>
-        </p:xfrm>
-        <a:graphic xmlns:a="http://schemas.openxmlformats.org/drawingml/2006/main">
-          <a:graphicData uri="http://schemas.openxmlformats.org/drawingml/2006/table">
-            <a:tbl>
-              <a:tblPr firstRow="0" bandRow="0"/>
-              <a:tblGrid>
-                <a:gridCol w="1714500"/>
-                <a:gridCol w="6286500"/>
-              </a:tblGrid>
-              <a:tr h="533400">
-                <a:tc>
-                  <a:txBody>
-                    <a:bodyPr/>
-                    <a:lstStyle/>
-                    <a:p>
-                      <a:r>
-                        <a:rPr sz="1950" b="1">
-                          <a:solidFill>
-                            <a:srgbClr val="FFFFFF"/>
-                          </a:solidFill>
-                          <a:latin typeface="Noto Sans Bold"/>
-                          <a:ea typeface="Noto Sans Bold"/>
-                          <a:cs typeface="Noto Sans Bold"/>
-                        </a:rPr>
-                        <a:t>단계</a:t>
-                      </a:r>
-                    </a:p>
-                  </a:txBody>
-                  <a:tcPr marL="266700" marR="228600" marT="114300" marB="114300" anchor="ctr">
-                    <a:lnL w="9525">
-                      <a:solidFill>
-                        <a:srgbClr val="DDE5EE"/>
-                      </a:solidFill>
-                      <a:prstDash val="solid"/>
-                    </a:lnL>
-                    <a:lnR w="9525">
-                      <a:solidFill>
-                        <a:srgbClr val="DDE5EE"/>
-                      </a:solidFill>
-                      <a:prstDash val="solid"/>
-                    </a:lnR>
-                    <a:lnT w="9525">
-                      <a:solidFill>
-                        <a:srgbClr val="DDE5EE"/>
-                      </a:solidFill>
-                      <a:prstDash val="solid"/>
-                    </a:lnT>
-                    <a:lnB w="9525">
-                      <a:solidFill>
-                        <a:srgbClr val="DDE5EE"/>
-                      </a:solidFill>
-                      <a:prstDash val="solid"/>
-                    </a:lnB>
-                    <a:solidFill>
-                      <a:srgbClr val="112840"/>
-                    </a:solidFill>
-                  </a:tcPr>
-                </a:tc>
-                <a:tc>
-                  <a:txBody>
-                    <a:bodyPr/>
-                    <a:lstStyle/>
-                    <a:p>
-                      <a:r>
-                        <a:rPr sz="1950" b="1">
-                          <a:solidFill>
-                            <a:srgbClr val="FFFFFF"/>
-                          </a:solidFill>
-                          <a:latin typeface="Noto Sans Bold"/>
-                          <a:ea typeface="Noto Sans Bold"/>
-                          <a:cs typeface="Noto Sans Bold"/>
-                        </a:rPr>
-                        <a:t>저장된 실행 이벤트 요약</a:t>
-                      </a:r>
-                    </a:p>
-                  </a:txBody>
-                  <a:tcPr marL="266700" marR="228600" marT="114300" marB="114300" anchor="ctr">
-                    <a:lnR w="9525">
-                      <a:solidFill>
-                        <a:srgbClr val="DDE5EE"/>
-                      </a:solidFill>
-                      <a:prstDash val="solid"/>
-                    </a:lnR>
-                    <a:lnT w="9525">
-                      <a:solidFill>
-                        <a:srgbClr val="DDE5EE"/>
-                      </a:solidFill>
-                      <a:prstDash val="solid"/>
-                    </a:lnT>
-                    <a:lnB w="9525">
-                      <a:solidFill>
-                        <a:srgbClr val="DDE5EE"/>
-                      </a:solidFill>
-                      <a:prstDash val="solid"/>
-                    </a:lnB>
-                    <a:solidFill>
-                      <a:srgbClr val="112840"/>
-                    </a:solidFill>
-                  </a:tcPr>
-                </a:tc>
-              </a:tr>
-              <a:tr h="1066800">
-                <a:tc>
-                  <a:txBody>
-                    <a:bodyPr/>
-                    <a:lstStyle/>
-                    <a:p>
-                      <a:r>
-                        <a:rPr sz="2100">
-                          <a:solidFill>
-                            <a:srgbClr val="122C46"/>
-                          </a:solidFill>
-                          <a:latin typeface="Noto Sans Kr"/>
-                          <a:ea typeface="Noto Sans Kr"/>
-                          <a:cs typeface="Noto Sans Kr"/>
-                        </a:rPr>
-                        <a:t>1차 검사</a:t>
-                      </a:r>
-                    </a:p>
-                  </a:txBody>
-                  <a:tcPr marL="266700" marR="228600" marT="114300" marB="114300" anchor="ctr">
-                    <a:lnL w="9525">
-                      <a:solidFill>
-                        <a:srgbClr val="DDE5EE"/>
-                      </a:solidFill>
-                      <a:prstDash val="solid"/>
-                    </a:lnL>
-                    <a:lnR w="9525">
-                      <a:solidFill>
-                        <a:srgbClr val="DDE5EE"/>
-                      </a:solidFill>
-                      <a:prstDash val="solid"/>
-                    </a:lnR>
-                    <a:lnB w="9525">
-                      <a:solidFill>
-                        <a:srgbClr val="DDE5EE"/>
-                      </a:solidFill>
-                      <a:prstDash val="solid"/>
-                    </a:lnB>
-                    <a:solidFill>
-                      <a:srgbClr val="FFFFFF"/>
-                    </a:solidFill>
-                  </a:tcPr>
-                </a:tc>
-                <a:tc>
-                  <a:txBody>
-                    <a:bodyPr/>
-                    <a:lstStyle/>
-                    <a:p>
-                      <a:r>
-                        <a:rPr sz="2100">
-                          <a:solidFill>
-                            <a:srgbClr val="122C46"/>
-                          </a:solidFill>
-                          <a:latin typeface="Noto Sans Kr"/>
-                          <a:ea typeface="Noto Sans Kr"/>
-                          <a:cs typeface="Noto Sans Kr"/>
-                        </a:rPr>
-                        <a:t>불합격</a:t>
-                      </a:r>
-                    </a:p>
-                    <a:p>
-                      <a:r>
-                        <a:rPr sz="2100">
-                          <a:solidFill>
-                            <a:srgbClr val="122C46"/>
-                          </a:solidFill>
-                          <a:latin typeface="Noto Sans Kr"/>
-                          <a:ea typeface="Noto Sans Kr"/>
-                          <a:cs typeface="Noto Sans Kr"/>
-                        </a:rPr>
-                        <a:t>확인 가능한 다음 행동 누락</a:t>
-                      </a:r>
-                    </a:p>
-                  </a:txBody>
-                  <a:tcPr marL="266700" marR="228600" marT="114300" marB="114300" anchor="ctr">
-                    <a:lnR w="9525">
-                      <a:solidFill>
-                        <a:srgbClr val="DDE5EE"/>
-                      </a:solidFill>
-                      <a:prstDash val="solid"/>
-                    </a:lnR>
-                    <a:lnB w="9525">
-                      <a:solidFill>
-                        <a:srgbClr val="DDE5EE"/>
-                      </a:solidFill>
-                      <a:prstDash val="solid"/>
-                    </a:lnB>
-                    <a:solidFill>
-                      <a:srgbClr val="FFFFFF"/>
-                    </a:solidFill>
-                  </a:tcPr>
-                </a:tc>
-              </a:tr>
-              <a:tr h="1066800">
-                <a:tc>
-                  <a:txBody>
-                    <a:bodyPr/>
-                    <a:lstStyle/>
-                    <a:p>
-                      <a:r>
-                        <a:rPr sz="2100">
-                          <a:solidFill>
-                            <a:srgbClr val="122C46"/>
-                          </a:solidFill>
-                          <a:latin typeface="Noto Sans Kr"/>
-                          <a:ea typeface="Noto Sans Kr"/>
-                          <a:cs typeface="Noto Sans Kr"/>
-                        </a:rPr>
-                        <a:t>2차 검사</a:t>
-                      </a:r>
-                    </a:p>
-                  </a:txBody>
-                  <a:tcPr marL="266700" marR="228600" marT="114300" marB="114300" anchor="ctr">
-                    <a:lnL w="9525">
-                      <a:solidFill>
-                        <a:srgbClr val="DDE5EE"/>
-                      </a:solidFill>
-                      <a:prstDash val="solid"/>
-                    </a:lnL>
-                    <a:lnR w="9525">
-                      <a:solidFill>
-                        <a:srgbClr val="DDE5EE"/>
-                      </a:solidFill>
-                      <a:prstDash val="solid"/>
-                    </a:lnR>
-                    <a:lnB w="9525">
-                      <a:solidFill>
-                        <a:srgbClr val="DDE5EE"/>
-                      </a:solidFill>
-                      <a:prstDash val="solid"/>
-                    </a:lnB>
-                    <a:solidFill>
-                      <a:srgbClr val="FFFFFF"/>
-                    </a:solidFill>
-                  </a:tcPr>
-                </a:tc>
-                <a:tc>
-                  <a:txBody>
-                    <a:bodyPr/>
-                    <a:lstStyle/>
-                    <a:p>
-                      <a:r>
-                        <a:rPr sz="2100">
-                          <a:solidFill>
-                            <a:srgbClr val="122C46"/>
-                          </a:solidFill>
-                          <a:latin typeface="Noto Sans Kr"/>
-                          <a:ea typeface="Noto Sans Kr"/>
-                          <a:cs typeface="Noto Sans Kr"/>
-                        </a:rPr>
-                        <a:t>합격</a:t>
-                      </a:r>
-                    </a:p>
-                    <a:p>
-                      <a:r>
-                        <a:rPr sz="2100">
-                          <a:solidFill>
-                            <a:srgbClr val="122C46"/>
-                          </a:solidFill>
-                          <a:latin typeface="Noto Sans Kr"/>
-                          <a:ea typeface="Noto Sans Kr"/>
-                          <a:cs typeface="Noto Sans Kr"/>
-                        </a:rPr>
-                        <a:t>CPU 대응 권장 조치 포함</a:t>
-                      </a:r>
-                    </a:p>
-                  </a:txBody>
-                  <a:tcPr marL="266700" marR="228600" marT="114300" marB="114300" anchor="ctr">
-                    <a:lnR w="9525">
-                      <a:solidFill>
-                        <a:srgbClr val="DDE5EE"/>
-                      </a:solidFill>
-                      <a:prstDash val="solid"/>
-                    </a:lnR>
-                    <a:lnB w="9525">
-                      <a:solidFill>
-                        <a:srgbClr val="DDE5EE"/>
-                      </a:solidFill>
-                      <a:prstDash val="solid"/>
-                    </a:lnB>
-                    <a:solidFill>
-                      <a:srgbClr val="FFFFFF"/>
-                    </a:solidFill>
-                  </a:tcPr>
-                </a:tc>
-              </a:tr>
-            </a:tbl>
-          </a:graphicData>
-        </a:graphic>
-      </p:graphicFrame>
-      <p:sp>
-        <p:nvSpPr>
-          <p:cNvPr id="13" name="actual-rewrite-result">
-            <a:extLst xmlns:a="http://schemas.openxmlformats.org/drawingml/2006/main">
-              <a:ext uri="{FF2B5EF4-FFF2-40B4-BE49-F238E27FC236}">
-                <a16:creationId xmlns:a16="http://schemas.microsoft.com/office/drawing/2014/main" id="{654B9CD4-67E9-4EF7-ABC1-50EA5FAA91AB}"/>
-              </a:ext>
-            </a:extLst>
-          </p:cNvPr>
-          <p:cNvSpPr>
-            <a:spLocks xmlns:a="http://schemas.openxmlformats.org/drawingml/2006/main" noGrp="1"/>
-          </p:cNvSpPr>
-          <p:nvPr/>
-        </p:nvSpPr>
+        </p:nvPicPr>
+        <p:blipFill>
+          <a:blip xmlns:r="http://schemas.openxmlformats.org/officeDocument/2006/relationships" xmlns:a="http://schemas.openxmlformats.org/drawingml/2006/main" r:embed="Ra8663917e0584216"/>
+          <a:srcRect xmlns:a="http://schemas.openxmlformats.org/drawingml/2006/main" l="78516" t="35833" r="1953" b="41944"/>
+          <a:stretch xmlns:a="http://schemas.openxmlformats.org/drawingml/2006/main"/>
+        </p:blipFill>
         <p:spPr>
           <a:xfrm xmlns:a="http://schemas.openxmlformats.org/drawingml/2006/main">
-            <a:off x="9144000" y="7877175"/>
-            <a:ext cx="8001000" cy="619125"/>
+            <a:off x="9334500" y="3905250"/>
+            <a:ext cx="7239000" cy="4632960"/>
           </a:xfrm>
           <a:prstGeom xmlns:a="http://schemas.openxmlformats.org/drawingml/2006/main" prst="rect">
             <a:avLst/>
           </a:prstGeom>
-          <a:noFill xmlns:a="http://schemas.openxmlformats.org/drawingml/2006/main"/>
-          <a:ln xmlns:a="http://schemas.openxmlformats.org/drawingml/2006/main" w="0">
-            <a:noFill/>
-          </a:ln>
         </p:spPr>
-        <p:txBody>
-          <a:bodyPr xmlns:a="http://schemas.openxmlformats.org/drawingml/2006/main" wrap="none" lIns="0" tIns="0" rIns="0" bIns="0" anchor="t">
-            <a:noAutofit/>
-          </a:bodyPr>
-          <a:lstStyle xmlns:a="http://schemas.openxmlformats.org/drawingml/2006/main">
-            <a:defPPr algn="l">
-              <a:defRPr sz="3300" b="1">
-                <a:solidFill>
-                  <a:srgbClr val="087F7A"/>
-                </a:solidFill>
-                <a:latin typeface="Noto Sans Bold"/>
-                <a:ea typeface="Noto Sans Bold"/>
-                <a:cs typeface="Noto Sans Bold"/>
-              </a:defRPr>
-            </a:defPPr>
-            <a:lvl1pPr algn="l">
-              <a:defRPr sz="3300" b="1">
-                <a:solidFill>
-                  <a:srgbClr val="087F7A"/>
-                </a:solidFill>
-                <a:latin typeface="Noto Sans Bold"/>
-                <a:ea typeface="Noto Sans Bold"/>
-                <a:cs typeface="Noto Sans Bold"/>
-              </a:defRPr>
-            </a:lvl1pPr>
-            <a:lvl2pPr algn="l">
-              <a:defRPr sz="3300" b="1">
-                <a:solidFill>
-                  <a:srgbClr val="087F7A"/>
-                </a:solidFill>
-                <a:latin typeface="Noto Sans Bold"/>
-                <a:ea typeface="Noto Sans Bold"/>
-                <a:cs typeface="Noto Sans Bold"/>
-              </a:defRPr>
-            </a:lvl2pPr>
-            <a:lvl3pPr algn="l">
-              <a:defRPr sz="3300" b="1">
-                <a:solidFill>
-                  <a:srgbClr val="087F7A"/>
-                </a:solidFill>
-                <a:latin typeface="Noto Sans Bold"/>
-                <a:ea typeface="Noto Sans Bold"/>
-                <a:cs typeface="Noto Sans Bold"/>
-              </a:defRPr>
-            </a:lvl3pPr>
-            <a:lvl4pPr algn="l">
-              <a:defRPr sz="3300" b="1">
-                <a:solidFill>
-                  <a:srgbClr val="087F7A"/>
-                </a:solidFill>
-                <a:latin typeface="Noto Sans Bold"/>
-                <a:ea typeface="Noto Sans Bold"/>
-                <a:cs typeface="Noto Sans Bold"/>
-              </a:defRPr>
-            </a:lvl4pPr>
-            <a:lvl5pPr algn="l">
-              <a:defRPr sz="3300" b="1">
-                <a:solidFill>
-                  <a:srgbClr val="087F7A"/>
-                </a:solidFill>
-                <a:latin typeface="Noto Sans Bold"/>
-                <a:ea typeface="Noto Sans Bold"/>
-                <a:cs typeface="Noto Sans Bold"/>
-              </a:defRPr>
-            </a:lvl5pPr>
-            <a:lvl6pPr algn="l">
-              <a:defRPr sz="3300" b="1">
-                <a:solidFill>
-                  <a:srgbClr val="087F7A"/>
-                </a:solidFill>
-                <a:latin typeface="Noto Sans Bold"/>
-                <a:ea typeface="Noto Sans Bold"/>
-                <a:cs typeface="Noto Sans Bold"/>
-              </a:defRPr>
-            </a:lvl6pPr>
-            <a:lvl7pPr algn="l">
-              <a:defRPr sz="3300" b="1">
-                <a:solidFill>
-                  <a:srgbClr val="087F7A"/>
-                </a:solidFill>
-                <a:latin typeface="Noto Sans Bold"/>
-                <a:ea typeface="Noto Sans Bold"/>
-                <a:cs typeface="Noto Sans Bold"/>
-              </a:defRPr>
-            </a:lvl7pPr>
-            <a:lvl8pPr algn="l">
-              <a:defRPr sz="3300" b="1">
-                <a:solidFill>
-                  <a:srgbClr val="087F7A"/>
-                </a:solidFill>
-                <a:latin typeface="Noto Sans Bold"/>
-                <a:ea typeface="Noto Sans Bold"/>
-                <a:cs typeface="Noto Sans Bold"/>
-              </a:defRPr>
-            </a:lvl8pPr>
-            <a:lvl9pPr algn="l">
-              <a:defRPr sz="3300" b="1">
-                <a:solidFill>
-                  <a:srgbClr val="087F7A"/>
-                </a:solidFill>
-                <a:latin typeface="Noto Sans Bold"/>
-                <a:ea typeface="Noto Sans Bold"/>
-                <a:cs typeface="Noto Sans Bold"/>
-              </a:defRPr>
-            </a:lvl9pPr>
-          </a:lstStyle>
-          <a:p xmlns:a="http://schemas.openxmlformats.org/drawingml/2006/main">
-            <a:pPr algn="l">
-              <a:defRPr sz="3300" b="1">
-                <a:solidFill>
-                  <a:srgbClr val="087F7A"/>
-                </a:solidFill>
-                <a:latin typeface="Noto Sans Bold"/>
-                <a:ea typeface="Noto Sans Bold"/>
-                <a:cs typeface="Noto Sans Bold"/>
-              </a:defRPr>
-            </a:pPr>
-            <a:r>
-              <a:rPr sz="3300" b="1">
-                <a:solidFill>
-                  <a:srgbClr val="087F7A"/>
-                </a:solidFill>
-                <a:latin typeface="Noto Sans Bold"/>
-                <a:ea typeface="Noto Sans Bold"/>
-                <a:cs typeface="Noto Sans Bold"/>
-              </a:rPr>
-              <a:t>재작성 1회 후 통과</a:t>
-            </a:r>
-          </a:p>
-        </p:txBody>
-      </p:sp>
+      </p:pic>
     </p:spTree>
     <p:extLst>
       <p:ext uri="{BB962C8B-B14F-4D97-AF65-F5344CB8AC3E}">
@@ -19819,6 +19397,7 @@
               </a:defRPr>
             </a:defPPr>
             <a:lvl1pPr algn="l">
+              <a:buNone/>
               <a:defRPr sz="1950" b="1">
                 <a:solidFill>
                   <a:srgbClr val="2B5BEB"/>
@@ -19829,6 +19408,7 @@
               </a:defRPr>
             </a:lvl1pPr>
             <a:lvl2pPr algn="l">
+              <a:buNone/>
               <a:defRPr sz="1950" b="1">
                 <a:solidFill>
                   <a:srgbClr val="2B5BEB"/>
@@ -19839,6 +19419,7 @@
               </a:defRPr>
             </a:lvl2pPr>
             <a:lvl3pPr algn="l">
+              <a:buNone/>
               <a:defRPr sz="1950" b="1">
                 <a:solidFill>
                   <a:srgbClr val="2B5BEB"/>
@@ -19849,6 +19430,7 @@
               </a:defRPr>
             </a:lvl3pPr>
             <a:lvl4pPr algn="l">
+              <a:buNone/>
               <a:defRPr sz="1950" b="1">
                 <a:solidFill>
                   <a:srgbClr val="2B5BEB"/>
@@ -19859,6 +19441,7 @@
               </a:defRPr>
             </a:lvl4pPr>
             <a:lvl5pPr algn="l">
+              <a:buNone/>
               <a:defRPr sz="1950" b="1">
                 <a:solidFill>
                   <a:srgbClr val="2B5BEB"/>
@@ -19869,6 +19452,7 @@
               </a:defRPr>
             </a:lvl5pPr>
             <a:lvl6pPr algn="l">
+              <a:buNone/>
               <a:defRPr sz="1950" b="1">
                 <a:solidFill>
                   <a:srgbClr val="2B5BEB"/>
@@ -19879,6 +19463,7 @@
               </a:defRPr>
             </a:lvl6pPr>
             <a:lvl7pPr algn="l">
+              <a:buNone/>
               <a:defRPr sz="1950" b="1">
                 <a:solidFill>
                   <a:srgbClr val="2B5BEB"/>
@@ -19889,6 +19474,7 @@
               </a:defRPr>
             </a:lvl7pPr>
             <a:lvl8pPr algn="l">
+              <a:buNone/>
               <a:defRPr sz="1950" b="1">
                 <a:solidFill>
                   <a:srgbClr val="2B5BEB"/>
@@ -19899,6 +19485,7 @@
               </a:defRPr>
             </a:lvl8pPr>
             <a:lvl9pPr algn="l">
+              <a:buNone/>
               <a:defRPr sz="1950" b="1">
                 <a:solidFill>
                   <a:srgbClr val="2B5BEB"/>
@@ -19911,6 +19498,7 @@
           </a:lstStyle>
           <a:p xmlns:a="http://schemas.openxmlformats.org/drawingml/2006/main">
             <a:pPr algn="l">
+              <a:buNone/>
               <a:defRPr sz="1950" b="1">
                 <a:solidFill>
                   <a:srgbClr val="2B5BEB"/>
@@ -19977,6 +19565,7 @@
               </a:defRPr>
             </a:defPPr>
             <a:lvl1pPr algn="r">
+              <a:buNone/>
               <a:defRPr sz="1950" b="0">
                 <a:solidFill>
                   <a:srgbClr val="566A80"/>
@@ -19987,6 +19576,7 @@
               </a:defRPr>
             </a:lvl1pPr>
             <a:lvl2pPr algn="r">
+              <a:buNone/>
               <a:defRPr sz="1950" b="0">
                 <a:solidFill>
                   <a:srgbClr val="566A80"/>
@@ -19997,6 +19587,7 @@
               </a:defRPr>
             </a:lvl2pPr>
             <a:lvl3pPr algn="r">
+              <a:buNone/>
               <a:defRPr sz="1950" b="0">
                 <a:solidFill>
                   <a:srgbClr val="566A80"/>
@@ -20007,6 +19598,7 @@
               </a:defRPr>
             </a:lvl3pPr>
             <a:lvl4pPr algn="r">
+              <a:buNone/>
               <a:defRPr sz="1950" b="0">
                 <a:solidFill>
                   <a:srgbClr val="566A80"/>
@@ -20017,6 +19609,7 @@
               </a:defRPr>
             </a:lvl4pPr>
             <a:lvl5pPr algn="r">
+              <a:buNone/>
               <a:defRPr sz="1950" b="0">
                 <a:solidFill>
                   <a:srgbClr val="566A80"/>
@@ -20027,6 +19620,7 @@
               </a:defRPr>
             </a:lvl5pPr>
             <a:lvl6pPr algn="r">
+              <a:buNone/>
               <a:defRPr sz="1950" b="0">
                 <a:solidFill>
                   <a:srgbClr val="566A80"/>
@@ -20037,6 +19631,7 @@
               </a:defRPr>
             </a:lvl6pPr>
             <a:lvl7pPr algn="r">
+              <a:buNone/>
               <a:defRPr sz="1950" b="0">
                 <a:solidFill>
                   <a:srgbClr val="566A80"/>
@@ -20047,6 +19642,7 @@
               </a:defRPr>
             </a:lvl7pPr>
             <a:lvl8pPr algn="r">
+              <a:buNone/>
               <a:defRPr sz="1950" b="0">
                 <a:solidFill>
                   <a:srgbClr val="566A80"/>
@@ -20057,6 +19653,7 @@
               </a:defRPr>
             </a:lvl8pPr>
             <a:lvl9pPr algn="r">
+              <a:buNone/>
               <a:defRPr sz="1950" b="0">
                 <a:solidFill>
                   <a:srgbClr val="566A80"/>
@@ -20069,6 +19666,7 @@
           </a:lstStyle>
           <a:p xmlns:a="http://schemas.openxmlformats.org/drawingml/2006/main">
             <a:pPr algn="r">
+              <a:buNone/>
               <a:defRPr sz="1950" b="0">
                 <a:solidFill>
                   <a:srgbClr val="566A80"/>
@@ -20135,6 +19733,7 @@
               </a:defRPr>
             </a:defPPr>
             <a:lvl1pPr algn="l">
+              <a:buNone/>
               <a:defRPr sz="5100" b="1">
                 <a:solidFill>
                   <a:srgbClr val="122C46"/>
@@ -20145,6 +19744,7 @@
               </a:defRPr>
             </a:lvl1pPr>
             <a:lvl2pPr algn="l">
+              <a:buNone/>
               <a:defRPr sz="5100" b="1">
                 <a:solidFill>
                   <a:srgbClr val="122C46"/>
@@ -20155,6 +19755,7 @@
               </a:defRPr>
             </a:lvl2pPr>
             <a:lvl3pPr algn="l">
+              <a:buNone/>
               <a:defRPr sz="5100" b="1">
                 <a:solidFill>
                   <a:srgbClr val="122C46"/>
@@ -20165,6 +19766,7 @@
               </a:defRPr>
             </a:lvl3pPr>
             <a:lvl4pPr algn="l">
+              <a:buNone/>
               <a:defRPr sz="5100" b="1">
                 <a:solidFill>
                   <a:srgbClr val="122C46"/>
@@ -20175,6 +19777,7 @@
               </a:defRPr>
             </a:lvl4pPr>
             <a:lvl5pPr algn="l">
+              <a:buNone/>
               <a:defRPr sz="5100" b="1">
                 <a:solidFill>
                   <a:srgbClr val="122C46"/>
@@ -20185,6 +19788,7 @@
               </a:defRPr>
             </a:lvl5pPr>
             <a:lvl6pPr algn="l">
+              <a:buNone/>
               <a:defRPr sz="5100" b="1">
                 <a:solidFill>
                   <a:srgbClr val="122C46"/>
@@ -20195,6 +19799,7 @@
               </a:defRPr>
             </a:lvl6pPr>
             <a:lvl7pPr algn="l">
+              <a:buNone/>
               <a:defRPr sz="5100" b="1">
                 <a:solidFill>
                   <a:srgbClr val="122C46"/>
@@ -20205,6 +19810,7 @@
               </a:defRPr>
             </a:lvl7pPr>
             <a:lvl8pPr algn="l">
+              <a:buNone/>
               <a:defRPr sz="5100" b="1">
                 <a:solidFill>
                   <a:srgbClr val="122C46"/>
@@ -20215,6 +19821,7 @@
               </a:defRPr>
             </a:lvl8pPr>
             <a:lvl9pPr algn="l">
+              <a:buNone/>
               <a:defRPr sz="5100" b="1">
                 <a:solidFill>
                   <a:srgbClr val="122C46"/>
@@ -20227,6 +19834,7 @@
           </a:lstStyle>
           <a:p xmlns:a="http://schemas.openxmlformats.org/drawingml/2006/main">
             <a:pPr algn="l">
+              <a:buNone/>
               <a:defRPr sz="5100" b="1">
                 <a:solidFill>
                   <a:srgbClr val="122C46"/>
@@ -20293,6 +19901,7 @@
               </a:defRPr>
             </a:defPPr>
             <a:lvl1pPr algn="l">
+              <a:buNone/>
               <a:defRPr sz="2400" b="0">
                 <a:solidFill>
                   <a:srgbClr val="566A80"/>
@@ -20303,6 +19912,7 @@
               </a:defRPr>
             </a:lvl1pPr>
             <a:lvl2pPr algn="l">
+              <a:buNone/>
               <a:defRPr sz="2400" b="0">
                 <a:solidFill>
                   <a:srgbClr val="566A80"/>
@@ -20313,6 +19923,7 @@
               </a:defRPr>
             </a:lvl2pPr>
             <a:lvl3pPr algn="l">
+              <a:buNone/>
               <a:defRPr sz="2400" b="0">
                 <a:solidFill>
                   <a:srgbClr val="566A80"/>
@@ -20323,6 +19934,7 @@
               </a:defRPr>
             </a:lvl3pPr>
             <a:lvl4pPr algn="l">
+              <a:buNone/>
               <a:defRPr sz="2400" b="0">
                 <a:solidFill>
                   <a:srgbClr val="566A80"/>
@@ -20333,6 +19945,7 @@
               </a:defRPr>
             </a:lvl4pPr>
             <a:lvl5pPr algn="l">
+              <a:buNone/>
               <a:defRPr sz="2400" b="0">
                 <a:solidFill>
                   <a:srgbClr val="566A80"/>
@@ -20343,6 +19956,7 @@
               </a:defRPr>
             </a:lvl5pPr>
             <a:lvl6pPr algn="l">
+              <a:buNone/>
               <a:defRPr sz="2400" b="0">
                 <a:solidFill>
                   <a:srgbClr val="566A80"/>
@@ -20353,6 +19967,7 @@
               </a:defRPr>
             </a:lvl6pPr>
             <a:lvl7pPr algn="l">
+              <a:buNone/>
               <a:defRPr sz="2400" b="0">
                 <a:solidFill>
                   <a:srgbClr val="566A80"/>
@@ -20363,6 +19978,7 @@
               </a:defRPr>
             </a:lvl7pPr>
             <a:lvl8pPr algn="l">
+              <a:buNone/>
               <a:defRPr sz="2400" b="0">
                 <a:solidFill>
                   <a:srgbClr val="566A80"/>
@@ -20373,6 +19989,7 @@
               </a:defRPr>
             </a:lvl8pPr>
             <a:lvl9pPr algn="l">
+              <a:buNone/>
               <a:defRPr sz="2400" b="0">
                 <a:solidFill>
                   <a:srgbClr val="566A80"/>
@@ -20385,6 +20002,7 @@
           </a:lstStyle>
           <a:p xmlns:a="http://schemas.openxmlformats.org/drawingml/2006/main">
             <a:pPr algn="l">
+              <a:buNone/>
               <a:defRPr sz="2400" b="0">
                 <a:solidFill>
                   <a:srgbClr val="566A80"/>
@@ -20451,6 +20069,7 @@
               </a:defRPr>
             </a:defPPr>
             <a:lvl1pPr algn="l">
+              <a:buNone/>
               <a:defRPr sz="1800" b="0">
                 <a:solidFill>
                   <a:srgbClr val="566A80"/>
@@ -20461,6 +20080,7 @@
               </a:defRPr>
             </a:lvl1pPr>
             <a:lvl2pPr algn="l">
+              <a:buNone/>
               <a:defRPr sz="1800" b="0">
                 <a:solidFill>
                   <a:srgbClr val="566A80"/>
@@ -20471,6 +20091,7 @@
               </a:defRPr>
             </a:lvl2pPr>
             <a:lvl3pPr algn="l">
+              <a:buNone/>
               <a:defRPr sz="1800" b="0">
                 <a:solidFill>
                   <a:srgbClr val="566A80"/>
@@ -20481,6 +20102,7 @@
               </a:defRPr>
             </a:lvl3pPr>
             <a:lvl4pPr algn="l">
+              <a:buNone/>
               <a:defRPr sz="1800" b="0">
                 <a:solidFill>
                   <a:srgbClr val="566A80"/>
@@ -20491,6 +20113,7 @@
               </a:defRPr>
             </a:lvl4pPr>
             <a:lvl5pPr algn="l">
+              <a:buNone/>
               <a:defRPr sz="1800" b="0">
                 <a:solidFill>
                   <a:srgbClr val="566A80"/>
@@ -20501,6 +20124,7 @@
               </a:defRPr>
             </a:lvl5pPr>
             <a:lvl6pPr algn="l">
+              <a:buNone/>
               <a:defRPr sz="1800" b="0">
                 <a:solidFill>
                   <a:srgbClr val="566A80"/>
@@ -20511,6 +20135,7 @@
               </a:defRPr>
             </a:lvl6pPr>
             <a:lvl7pPr algn="l">
+              <a:buNone/>
               <a:defRPr sz="1800" b="0">
                 <a:solidFill>
                   <a:srgbClr val="566A80"/>
@@ -20521,6 +20146,7 @@
               </a:defRPr>
             </a:lvl7pPr>
             <a:lvl8pPr algn="l">
+              <a:buNone/>
               <a:defRPr sz="1800" b="0">
                 <a:solidFill>
                   <a:srgbClr val="566A80"/>
@@ -20531,6 +20157,7 @@
               </a:defRPr>
             </a:lvl8pPr>
             <a:lvl9pPr algn="l">
+              <a:buNone/>
               <a:defRPr sz="1800" b="0">
                 <a:solidFill>
                   <a:srgbClr val="566A80"/>
@@ -20543,6 +20170,7 @@
           </a:lstStyle>
           <a:p xmlns:a="http://schemas.openxmlformats.org/drawingml/2006/main">
             <a:pPr algn="l">
+              <a:buNone/>
               <a:defRPr sz="1800" b="0">
                 <a:solidFill>
                   <a:srgbClr val="566A80"/>
@@ -20571,7 +20199,7 @@
           <p:cNvPr id="6" name="footer-rule">
             <a:extLst xmlns:a="http://schemas.openxmlformats.org/drawingml/2006/main">
               <a:ext uri="{FF2B5EF4-FFF2-40B4-BE49-F238E27FC236}">
-                <a16:creationId xmlns:a16="http://schemas.microsoft.com/office/drawing/2014/main" id="{30B495B0-6B5B-42EB-ABA0-EE5E78C23B7A}"/>
+                <a16:creationId xmlns:a16="http://schemas.microsoft.com/office/drawing/2014/main" id="{A9070377-A011-4917-B281-EFBA2D17500F}"/>
               </a:ext>
             </a:extLst>
           </p:cNvPr>
@@ -20636,6 +20264,7 @@
               </a:defRPr>
             </a:defPPr>
             <a:lvl1pPr algn="l">
+              <a:buNone/>
               <a:defRPr sz="1650" b="0">
                 <a:solidFill>
                   <a:srgbClr val="566A80"/>
@@ -20646,6 +20275,7 @@
               </a:defRPr>
             </a:lvl1pPr>
             <a:lvl2pPr algn="l">
+              <a:buNone/>
               <a:defRPr sz="1650" b="0">
                 <a:solidFill>
                   <a:srgbClr val="566A80"/>
@@ -20656,6 +20286,7 @@
               </a:defRPr>
             </a:lvl2pPr>
             <a:lvl3pPr algn="l">
+              <a:buNone/>
               <a:defRPr sz="1650" b="0">
                 <a:solidFill>
                   <a:srgbClr val="566A80"/>
@@ -20666,6 +20297,7 @@
               </a:defRPr>
             </a:lvl3pPr>
             <a:lvl4pPr algn="l">
+              <a:buNone/>
               <a:defRPr sz="1650" b="0">
                 <a:solidFill>
                   <a:srgbClr val="566A80"/>
@@ -20676,6 +20308,7 @@
               </a:defRPr>
             </a:lvl4pPr>
             <a:lvl5pPr algn="l">
+              <a:buNone/>
               <a:defRPr sz="1650" b="0">
                 <a:solidFill>
                   <a:srgbClr val="566A80"/>
@@ -20686,6 +20319,7 @@
               </a:defRPr>
             </a:lvl5pPr>
             <a:lvl6pPr algn="l">
+              <a:buNone/>
               <a:defRPr sz="1650" b="0">
                 <a:solidFill>
                   <a:srgbClr val="566A80"/>
@@ -20696,6 +20330,7 @@
               </a:defRPr>
             </a:lvl6pPr>
             <a:lvl7pPr algn="l">
+              <a:buNone/>
               <a:defRPr sz="1650" b="0">
                 <a:solidFill>
                   <a:srgbClr val="566A80"/>
@@ -20706,6 +20341,7 @@
               </a:defRPr>
             </a:lvl7pPr>
             <a:lvl8pPr algn="l">
+              <a:buNone/>
               <a:defRPr sz="1650" b="0">
                 <a:solidFill>
                   <a:srgbClr val="566A80"/>
@@ -20716,6 +20352,7 @@
               </a:defRPr>
             </a:lvl8pPr>
             <a:lvl9pPr algn="l">
+              <a:buNone/>
               <a:defRPr sz="1650" b="0">
                 <a:solidFill>
                   <a:srgbClr val="566A80"/>
@@ -20728,6 +20365,7 @@
           </a:lstStyle>
           <a:p xmlns:a="http://schemas.openxmlformats.org/drawingml/2006/main">
             <a:pPr algn="l">
+              <a:buNone/>
               <a:defRPr sz="1650" b="0">
                 <a:solidFill>
                   <a:srgbClr val="566A80"/>
@@ -20794,6 +20432,7 @@
               </a:defRPr>
             </a:defPPr>
             <a:lvl1pPr algn="l">
+              <a:buNone/>
               <a:defRPr sz="8250" b="1">
                 <a:solidFill>
                   <a:srgbClr val="2B5BEB"/>
@@ -20804,6 +20443,7 @@
               </a:defRPr>
             </a:lvl1pPr>
             <a:lvl2pPr algn="l">
+              <a:buNone/>
               <a:defRPr sz="8250" b="1">
                 <a:solidFill>
                   <a:srgbClr val="2B5BEB"/>
@@ -20814,6 +20454,7 @@
               </a:defRPr>
             </a:lvl2pPr>
             <a:lvl3pPr algn="l">
+              <a:buNone/>
               <a:defRPr sz="8250" b="1">
                 <a:solidFill>
                   <a:srgbClr val="2B5BEB"/>
@@ -20824,6 +20465,7 @@
               </a:defRPr>
             </a:lvl3pPr>
             <a:lvl4pPr algn="l">
+              <a:buNone/>
               <a:defRPr sz="8250" b="1">
                 <a:solidFill>
                   <a:srgbClr val="2B5BEB"/>
@@ -20834,6 +20476,7 @@
               </a:defRPr>
             </a:lvl4pPr>
             <a:lvl5pPr algn="l">
+              <a:buNone/>
               <a:defRPr sz="8250" b="1">
                 <a:solidFill>
                   <a:srgbClr val="2B5BEB"/>
@@ -20844,6 +20487,7 @@
               </a:defRPr>
             </a:lvl5pPr>
             <a:lvl6pPr algn="l">
+              <a:buNone/>
               <a:defRPr sz="8250" b="1">
                 <a:solidFill>
                   <a:srgbClr val="2B5BEB"/>
@@ -20854,6 +20498,7 @@
               </a:defRPr>
             </a:lvl6pPr>
             <a:lvl7pPr algn="l">
+              <a:buNone/>
               <a:defRPr sz="8250" b="1">
                 <a:solidFill>
                   <a:srgbClr val="2B5BEB"/>
@@ -20864,6 +20509,7 @@
               </a:defRPr>
             </a:lvl7pPr>
             <a:lvl8pPr algn="l">
+              <a:buNone/>
               <a:defRPr sz="8250" b="1">
                 <a:solidFill>
                   <a:srgbClr val="2B5BEB"/>
@@ -20874,6 +20520,7 @@
               </a:defRPr>
             </a:lvl8pPr>
             <a:lvl9pPr algn="l">
+              <a:buNone/>
               <a:defRPr sz="8250" b="1">
                 <a:solidFill>
                   <a:srgbClr val="2B5BEB"/>
@@ -20886,6 +20533,7 @@
           </a:lstStyle>
           <a:p xmlns:a="http://schemas.openxmlformats.org/drawingml/2006/main">
             <a:pPr algn="l">
+              <a:buNone/>
               <a:defRPr sz="8250" b="1">
                 <a:solidFill>
                   <a:srgbClr val="2B5BEB"/>
@@ -20952,6 +20600,7 @@
               </a:defRPr>
             </a:defPPr>
             <a:lvl1pPr algn="l">
+              <a:buNone/>
               <a:defRPr sz="2250" b="1">
                 <a:solidFill>
                   <a:srgbClr val="122C46"/>
@@ -20962,6 +20611,7 @@
               </a:defRPr>
             </a:lvl1pPr>
             <a:lvl2pPr algn="l">
+              <a:buNone/>
               <a:defRPr sz="2250" b="1">
                 <a:solidFill>
                   <a:srgbClr val="122C46"/>
@@ -20972,6 +20622,7 @@
               </a:defRPr>
             </a:lvl2pPr>
             <a:lvl3pPr algn="l">
+              <a:buNone/>
               <a:defRPr sz="2250" b="1">
                 <a:solidFill>
                   <a:srgbClr val="122C46"/>
@@ -20982,6 +20633,7 @@
               </a:defRPr>
             </a:lvl3pPr>
             <a:lvl4pPr algn="l">
+              <a:buNone/>
               <a:defRPr sz="2250" b="1">
                 <a:solidFill>
                   <a:srgbClr val="122C46"/>
@@ -20992,6 +20644,7 @@
               </a:defRPr>
             </a:lvl4pPr>
             <a:lvl5pPr algn="l">
+              <a:buNone/>
               <a:defRPr sz="2250" b="1">
                 <a:solidFill>
                   <a:srgbClr val="122C46"/>
@@ -21002,6 +20655,7 @@
               </a:defRPr>
             </a:lvl5pPr>
             <a:lvl6pPr algn="l">
+              <a:buNone/>
               <a:defRPr sz="2250" b="1">
                 <a:solidFill>
                   <a:srgbClr val="122C46"/>
@@ -21012,6 +20666,7 @@
               </a:defRPr>
             </a:lvl6pPr>
             <a:lvl7pPr algn="l">
+              <a:buNone/>
               <a:defRPr sz="2250" b="1">
                 <a:solidFill>
                   <a:srgbClr val="122C46"/>
@@ -21022,6 +20677,7 @@
               </a:defRPr>
             </a:lvl7pPr>
             <a:lvl8pPr algn="l">
+              <a:buNone/>
               <a:defRPr sz="2250" b="1">
                 <a:solidFill>
                   <a:srgbClr val="122C46"/>
@@ -21032,6 +20688,7 @@
               </a:defRPr>
             </a:lvl8pPr>
             <a:lvl9pPr algn="l">
+              <a:buNone/>
               <a:defRPr sz="2250" b="1">
                 <a:solidFill>
                   <a:srgbClr val="122C46"/>
@@ -21044,6 +20701,7 @@
           </a:lstStyle>
           <a:p xmlns:a="http://schemas.openxmlformats.org/drawingml/2006/main">
             <a:pPr algn="l">
+              <a:buNone/>
               <a:defRPr sz="2250" b="1">
                 <a:solidFill>
                   <a:srgbClr val="122C46"/>
@@ -21110,6 +20768,7 @@
               </a:defRPr>
             </a:defPPr>
             <a:lvl1pPr algn="l">
+              <a:buNone/>
               <a:defRPr sz="8250" b="1">
                 <a:solidFill>
                   <a:srgbClr val="087F7A"/>
@@ -21120,6 +20779,7 @@
               </a:defRPr>
             </a:lvl1pPr>
             <a:lvl2pPr algn="l">
+              <a:buNone/>
               <a:defRPr sz="8250" b="1">
                 <a:solidFill>
                   <a:srgbClr val="087F7A"/>
@@ -21130,6 +20790,7 @@
               </a:defRPr>
             </a:lvl2pPr>
             <a:lvl3pPr algn="l">
+              <a:buNone/>
               <a:defRPr sz="8250" b="1">
                 <a:solidFill>
                   <a:srgbClr val="087F7A"/>
@@ -21140,6 +20801,7 @@
               </a:defRPr>
             </a:lvl3pPr>
             <a:lvl4pPr algn="l">
+              <a:buNone/>
               <a:defRPr sz="8250" b="1">
                 <a:solidFill>
                   <a:srgbClr val="087F7A"/>
@@ -21150,6 +20812,7 @@
               </a:defRPr>
             </a:lvl4pPr>
             <a:lvl5pPr algn="l">
+              <a:buNone/>
               <a:defRPr sz="8250" b="1">
                 <a:solidFill>
                   <a:srgbClr val="087F7A"/>
@@ -21160,6 +20823,7 @@
               </a:defRPr>
             </a:lvl5pPr>
             <a:lvl6pPr algn="l">
+              <a:buNone/>
               <a:defRPr sz="8250" b="1">
                 <a:solidFill>
                   <a:srgbClr val="087F7A"/>
@@ -21170,6 +20834,7 @@
               </a:defRPr>
             </a:lvl6pPr>
             <a:lvl7pPr algn="l">
+              <a:buNone/>
               <a:defRPr sz="8250" b="1">
                 <a:solidFill>
                   <a:srgbClr val="087F7A"/>
@@ -21180,6 +20845,7 @@
               </a:defRPr>
             </a:lvl7pPr>
             <a:lvl8pPr algn="l">
+              <a:buNone/>
               <a:defRPr sz="8250" b="1">
                 <a:solidFill>
                   <a:srgbClr val="087F7A"/>
@@ -21190,6 +20856,7 @@
               </a:defRPr>
             </a:lvl8pPr>
             <a:lvl9pPr algn="l">
+              <a:buNone/>
               <a:defRPr sz="8250" b="1">
                 <a:solidFill>
                   <a:srgbClr val="087F7A"/>
@@ -21202,6 +20869,7 @@
           </a:lstStyle>
           <a:p xmlns:a="http://schemas.openxmlformats.org/drawingml/2006/main">
             <a:pPr algn="l">
+              <a:buNone/>
               <a:defRPr sz="8250" b="1">
                 <a:solidFill>
                   <a:srgbClr val="087F7A"/>
@@ -21268,6 +20936,7 @@
               </a:defRPr>
             </a:defPPr>
             <a:lvl1pPr algn="l">
+              <a:buNone/>
               <a:defRPr sz="2250" b="1">
                 <a:solidFill>
                   <a:srgbClr val="122C46"/>
@@ -21278,6 +20947,7 @@
               </a:defRPr>
             </a:lvl1pPr>
             <a:lvl2pPr algn="l">
+              <a:buNone/>
               <a:defRPr sz="2250" b="1">
                 <a:solidFill>
                   <a:srgbClr val="122C46"/>
@@ -21288,6 +20958,7 @@
               </a:defRPr>
             </a:lvl2pPr>
             <a:lvl3pPr algn="l">
+              <a:buNone/>
               <a:defRPr sz="2250" b="1">
                 <a:solidFill>
                   <a:srgbClr val="122C46"/>
@@ -21298,6 +20969,7 @@
               </a:defRPr>
             </a:lvl3pPr>
             <a:lvl4pPr algn="l">
+              <a:buNone/>
               <a:defRPr sz="2250" b="1">
                 <a:solidFill>
                   <a:srgbClr val="122C46"/>
@@ -21308,6 +20980,7 @@
               </a:defRPr>
             </a:lvl4pPr>
             <a:lvl5pPr algn="l">
+              <a:buNone/>
               <a:defRPr sz="2250" b="1">
                 <a:solidFill>
                   <a:srgbClr val="122C46"/>
@@ -21318,6 +20991,7 @@
               </a:defRPr>
             </a:lvl5pPr>
             <a:lvl6pPr algn="l">
+              <a:buNone/>
               <a:defRPr sz="2250" b="1">
                 <a:solidFill>
                   <a:srgbClr val="122C46"/>
@@ -21328,6 +21002,7 @@
               </a:defRPr>
             </a:lvl6pPr>
             <a:lvl7pPr algn="l">
+              <a:buNone/>
               <a:defRPr sz="2250" b="1">
                 <a:solidFill>
                   <a:srgbClr val="122C46"/>
@@ -21338,6 +21013,7 @@
               </a:defRPr>
             </a:lvl7pPr>
             <a:lvl8pPr algn="l">
+              <a:buNone/>
               <a:defRPr sz="2250" b="1">
                 <a:solidFill>
                   <a:srgbClr val="122C46"/>
@@ -21348,6 +21024,7 @@
               </a:defRPr>
             </a:lvl8pPr>
             <a:lvl9pPr algn="l">
+              <a:buNone/>
               <a:defRPr sz="2250" b="1">
                 <a:solidFill>
                   <a:srgbClr val="122C46"/>
@@ -21360,6 +21037,7 @@
           </a:lstStyle>
           <a:p xmlns:a="http://schemas.openxmlformats.org/drawingml/2006/main">
             <a:pPr algn="l">
+              <a:buNone/>
               <a:defRPr sz="2250" b="1">
                 <a:solidFill>
                   <a:srgbClr val="122C46"/>
@@ -21426,6 +21104,7 @@
               </a:defRPr>
             </a:defPPr>
             <a:lvl1pPr algn="l">
+              <a:buNone/>
               <a:defRPr sz="8250" b="1">
                 <a:solidFill>
                   <a:srgbClr val="B66A19"/>
@@ -21436,6 +21115,7 @@
               </a:defRPr>
             </a:lvl1pPr>
             <a:lvl2pPr algn="l">
+              <a:buNone/>
               <a:defRPr sz="8250" b="1">
                 <a:solidFill>
                   <a:srgbClr val="B66A19"/>
@@ -21446,6 +21126,7 @@
               </a:defRPr>
             </a:lvl2pPr>
             <a:lvl3pPr algn="l">
+              <a:buNone/>
               <a:defRPr sz="8250" b="1">
                 <a:solidFill>
                   <a:srgbClr val="B66A19"/>
@@ -21456,6 +21137,7 @@
               </a:defRPr>
             </a:lvl3pPr>
             <a:lvl4pPr algn="l">
+              <a:buNone/>
               <a:defRPr sz="8250" b="1">
                 <a:solidFill>
                   <a:srgbClr val="B66A19"/>
@@ -21466,6 +21148,7 @@
               </a:defRPr>
             </a:lvl4pPr>
             <a:lvl5pPr algn="l">
+              <a:buNone/>
               <a:defRPr sz="8250" b="1">
                 <a:solidFill>
                   <a:srgbClr val="B66A19"/>
@@ -21476,6 +21159,7 @@
               </a:defRPr>
             </a:lvl5pPr>
             <a:lvl6pPr algn="l">
+              <a:buNone/>
               <a:defRPr sz="8250" b="1">
                 <a:solidFill>
                   <a:srgbClr val="B66A19"/>
@@ -21486,6 +21170,7 @@
               </a:defRPr>
             </a:lvl6pPr>
             <a:lvl7pPr algn="l">
+              <a:buNone/>
               <a:defRPr sz="8250" b="1">
                 <a:solidFill>
                   <a:srgbClr val="B66A19"/>
@@ -21496,6 +21181,7 @@
               </a:defRPr>
             </a:lvl7pPr>
             <a:lvl8pPr algn="l">
+              <a:buNone/>
               <a:defRPr sz="8250" b="1">
                 <a:solidFill>
                   <a:srgbClr val="B66A19"/>
@@ -21506,6 +21192,7 @@
               </a:defRPr>
             </a:lvl8pPr>
             <a:lvl9pPr algn="l">
+              <a:buNone/>
               <a:defRPr sz="8250" b="1">
                 <a:solidFill>
                   <a:srgbClr val="B66A19"/>
@@ -21518,6 +21205,7 @@
           </a:lstStyle>
           <a:p xmlns:a="http://schemas.openxmlformats.org/drawingml/2006/main">
             <a:pPr algn="l">
+              <a:buNone/>
               <a:defRPr sz="8250" b="1">
                 <a:solidFill>
                   <a:srgbClr val="B66A19"/>
@@ -21584,6 +21272,7 @@
               </a:defRPr>
             </a:defPPr>
             <a:lvl1pPr algn="l">
+              <a:buNone/>
               <a:defRPr sz="2250" b="1">
                 <a:solidFill>
                   <a:srgbClr val="122C46"/>
@@ -21594,6 +21283,7 @@
               </a:defRPr>
             </a:lvl1pPr>
             <a:lvl2pPr algn="l">
+              <a:buNone/>
               <a:defRPr sz="2250" b="1">
                 <a:solidFill>
                   <a:srgbClr val="122C46"/>
@@ -21604,6 +21294,7 @@
               </a:defRPr>
             </a:lvl2pPr>
             <a:lvl3pPr algn="l">
+              <a:buNone/>
               <a:defRPr sz="2250" b="1">
                 <a:solidFill>
                   <a:srgbClr val="122C46"/>
@@ -21614,6 +21305,7 @@
               </a:defRPr>
             </a:lvl3pPr>
             <a:lvl4pPr algn="l">
+              <a:buNone/>
               <a:defRPr sz="2250" b="1">
                 <a:solidFill>
                   <a:srgbClr val="122C46"/>
@@ -21624,6 +21316,7 @@
               </a:defRPr>
             </a:lvl4pPr>
             <a:lvl5pPr algn="l">
+              <a:buNone/>
               <a:defRPr sz="2250" b="1">
                 <a:solidFill>
                   <a:srgbClr val="122C46"/>
@@ -21634,6 +21327,7 @@
               </a:defRPr>
             </a:lvl5pPr>
             <a:lvl6pPr algn="l">
+              <a:buNone/>
               <a:defRPr sz="2250" b="1">
                 <a:solidFill>
                   <a:srgbClr val="122C46"/>
@@ -21644,6 +21338,7 @@
               </a:defRPr>
             </a:lvl6pPr>
             <a:lvl7pPr algn="l">
+              <a:buNone/>
               <a:defRPr sz="2250" b="1">
                 <a:solidFill>
                   <a:srgbClr val="122C46"/>
@@ -21654,6 +21349,7 @@
               </a:defRPr>
             </a:lvl7pPr>
             <a:lvl8pPr algn="l">
+              <a:buNone/>
               <a:defRPr sz="2250" b="1">
                 <a:solidFill>
                   <a:srgbClr val="122C46"/>
@@ -21664,6 +21360,7 @@
               </a:defRPr>
             </a:lvl8pPr>
             <a:lvl9pPr algn="l">
+              <a:buNone/>
               <a:defRPr sz="2250" b="1">
                 <a:solidFill>
                   <a:srgbClr val="122C46"/>
@@ -21676,6 +21373,7 @@
           </a:lstStyle>
           <a:p xmlns:a="http://schemas.openxmlformats.org/drawingml/2006/main">
             <a:pPr algn="l">
+              <a:buNone/>
               <a:defRPr sz="2250" b="1">
                 <a:solidFill>
                   <a:srgbClr val="122C46"/>
@@ -21704,7 +21402,7 @@
           <p:cNvPr id="14" name="metric-rule-1">
             <a:extLst xmlns:a="http://schemas.openxmlformats.org/drawingml/2006/main">
               <a:ext uri="{FF2B5EF4-FFF2-40B4-BE49-F238E27FC236}">
-                <a16:creationId xmlns:a16="http://schemas.microsoft.com/office/drawing/2014/main" id="{B087A91C-3911-4F7C-8F75-6183C37D65D1}"/>
+                <a16:creationId xmlns:a16="http://schemas.microsoft.com/office/drawing/2014/main" id="{A7734A83-955D-44A2-A64D-CAAE10A92EA2}"/>
               </a:ext>
             </a:extLst>
           </p:cNvPr>
@@ -21731,7 +21429,7 @@
           <p:cNvPr id="15" name="metric-rule-2">
             <a:extLst xmlns:a="http://schemas.openxmlformats.org/drawingml/2006/main">
               <a:ext uri="{FF2B5EF4-FFF2-40B4-BE49-F238E27FC236}">
-                <a16:creationId xmlns:a16="http://schemas.microsoft.com/office/drawing/2014/main" id="{5E2498A9-ACC4-4C5A-96A6-7BF5354A00D3}"/>
+                <a16:creationId xmlns:a16="http://schemas.microsoft.com/office/drawing/2014/main" id="{5F2FC3B1-4A30-482E-BA45-94C40B8BC49F}"/>
               </a:ext>
             </a:extLst>
           </p:cNvPr>
@@ -21796,6 +21494,7 @@
               </a:defRPr>
             </a:defPPr>
             <a:lvl1pPr algn="l">
+              <a:buNone/>
               <a:defRPr sz="1800" b="0">
                 <a:solidFill>
                   <a:srgbClr val="566A80"/>
@@ -21806,6 +21505,7 @@
               </a:defRPr>
             </a:lvl1pPr>
             <a:lvl2pPr algn="l">
+              <a:buNone/>
               <a:defRPr sz="1800" b="0">
                 <a:solidFill>
                   <a:srgbClr val="566A80"/>
@@ -21816,6 +21516,7 @@
               </a:defRPr>
             </a:lvl2pPr>
             <a:lvl3pPr algn="l">
+              <a:buNone/>
               <a:defRPr sz="1800" b="0">
                 <a:solidFill>
                   <a:srgbClr val="566A80"/>
@@ -21826,6 +21527,7 @@
               </a:defRPr>
             </a:lvl3pPr>
             <a:lvl4pPr algn="l">
+              <a:buNone/>
               <a:defRPr sz="1800" b="0">
                 <a:solidFill>
                   <a:srgbClr val="566A80"/>
@@ -21836,6 +21538,7 @@
               </a:defRPr>
             </a:lvl4pPr>
             <a:lvl5pPr algn="l">
+              <a:buNone/>
               <a:defRPr sz="1800" b="0">
                 <a:solidFill>
                   <a:srgbClr val="566A80"/>
@@ -21846,6 +21549,7 @@
               </a:defRPr>
             </a:lvl5pPr>
             <a:lvl6pPr algn="l">
+              <a:buNone/>
               <a:defRPr sz="1800" b="0">
                 <a:solidFill>
                   <a:srgbClr val="566A80"/>
@@ -21856,6 +21560,7 @@
               </a:defRPr>
             </a:lvl6pPr>
             <a:lvl7pPr algn="l">
+              <a:buNone/>
               <a:defRPr sz="1800" b="0">
                 <a:solidFill>
                   <a:srgbClr val="566A80"/>
@@ -21866,6 +21571,7 @@
               </a:defRPr>
             </a:lvl7pPr>
             <a:lvl8pPr algn="l">
+              <a:buNone/>
               <a:defRPr sz="1800" b="0">
                 <a:solidFill>
                   <a:srgbClr val="566A80"/>
@@ -21876,6 +21582,7 @@
               </a:defRPr>
             </a:lvl8pPr>
             <a:lvl9pPr algn="l">
+              <a:buNone/>
               <a:defRPr sz="1800" b="0">
                 <a:solidFill>
                   <a:srgbClr val="566A80"/>
@@ -21888,6 +21595,7 @@
           </a:lstStyle>
           <a:p xmlns:a="http://schemas.openxmlformats.org/drawingml/2006/main">
             <a:pPr algn="l">
+              <a:buNone/>
               <a:defRPr sz="1800" b="0">
                 <a:solidFill>
                   <a:srgbClr val="566A80"/>
@@ -21916,7 +21624,7 @@
           <p:cNvPr id="17" name="">
             <a:extLst xmlns:a="http://schemas.openxmlformats.org/drawingml/2006/main">
               <a:ext uri="{FF2B5EF4-FFF2-40B4-BE49-F238E27FC236}">
-                <a16:creationId xmlns:a16="http://schemas.microsoft.com/office/drawing/2014/main" id="{954D09D8-386E-4237-9A94-141552116CE6}"/>
+                <a16:creationId xmlns:a16="http://schemas.microsoft.com/office/drawing/2014/main" id="{17E9885E-50C4-4A7C-91DF-F0D33412FE45}"/>
               </a:ext>
             </a:extLst>
           </p:cNvPr>
@@ -23296,7 +23004,7 @@
           <p:cNvPr id="6" name="footer-rule">
             <a:extLst xmlns:a="http://schemas.openxmlformats.org/drawingml/2006/main">
               <a:ext uri="{FF2B5EF4-FFF2-40B4-BE49-F238E27FC236}">
-                <a16:creationId xmlns:a16="http://schemas.microsoft.com/office/drawing/2014/main" id="{4A3BCE77-133B-4F75-82AA-6CFDE3567D21}"/>
+                <a16:creationId xmlns:a16="http://schemas.microsoft.com/office/drawing/2014/main" id="{DD5A732E-67FD-476C-B9D2-13290B0F72F1}"/>
               </a:ext>
             </a:extLst>
           </p:cNvPr>
@@ -23491,7 +23199,7 @@
           <p:cNvPr id="8" name="">
             <a:extLst xmlns:a="http://schemas.openxmlformats.org/drawingml/2006/main">
               <a:ext uri="{FF2B5EF4-FFF2-40B4-BE49-F238E27FC236}">
-                <a16:creationId xmlns:a16="http://schemas.microsoft.com/office/drawing/2014/main" id="{B7314BDF-E788-4794-8670-D7049EC82A79}"/>
+                <a16:creationId xmlns:a16="http://schemas.microsoft.com/office/drawing/2014/main" id="{CA855FDE-D615-4A12-ABA2-4AC0F0987C01}"/>
               </a:ext>
             </a:extLst>
           </p:cNvPr>

</xml_diff>

<commit_message>
docs: expand presentation rationale and align 330-second speaker notes
</commit_message>
<xml_diff>
--- a/doc/presentation/운영진단_에이전트_5분발표.pptx
+++ b/doc/presentation/운영진단_에이전트_5분발표.pptx
@@ -2,31 +2,31 @@
 <file path=ppt/presentation.xml><?xml version="1.0" encoding="utf-8"?>
 <p:presentation xmlns:p="http://schemas.openxmlformats.org/presentationml/2006/main" embedTrueTypeFonts="1" saveSubsetFonts="0">
   <p:sldMasterIdLst>
-    <p:sldMasterId xmlns:r="http://schemas.openxmlformats.org/officeDocument/2006/relationships" id="2147483648" r:id="Rd9dedfffd8fd4d00"/>
+    <p:sldMasterId xmlns:r="http://schemas.openxmlformats.org/officeDocument/2006/relationships" id="2147483648" r:id="Ra0b43ebf14ec46bf"/>
   </p:sldMasterIdLst>
   <p:notesMasterIdLst>
-    <p:notesMasterId xmlns:r="http://schemas.openxmlformats.org/officeDocument/2006/relationships" r:id="R595ba1f0f5944d2c"/>
+    <p:notesMasterId xmlns:r="http://schemas.openxmlformats.org/officeDocument/2006/relationships" r:id="R7a76b4727be44b2a"/>
   </p:notesMasterIdLst>
   <p:sldIdLst>
-    <p:sldId xmlns:r="http://schemas.openxmlformats.org/officeDocument/2006/relationships" id="256" r:id="R82b5d21b194443a0"/>
-    <p:sldId xmlns:r="http://schemas.openxmlformats.org/officeDocument/2006/relationships" id="257" r:id="R975263f577ba4bb3"/>
-    <p:sldId xmlns:r="http://schemas.openxmlformats.org/officeDocument/2006/relationships" id="258" r:id="R34c628c7d239420f"/>
-    <p:sldId xmlns:r="http://schemas.openxmlformats.org/officeDocument/2006/relationships" id="259" r:id="R4dc60d0c043746cb"/>
-    <p:sldId xmlns:r="http://schemas.openxmlformats.org/officeDocument/2006/relationships" id="260" r:id="R98d9229ed5324a66"/>
-    <p:sldId xmlns:r="http://schemas.openxmlformats.org/officeDocument/2006/relationships" id="261" r:id="Rb2e8370bf9ee4349"/>
-    <p:sldId xmlns:r="http://schemas.openxmlformats.org/officeDocument/2006/relationships" id="262" r:id="Rc47859c29ecb4749"/>
-    <p:sldId xmlns:r="http://schemas.openxmlformats.org/officeDocument/2006/relationships" id="263" r:id="R81960451033846d4"/>
+    <p:sldId xmlns:r="http://schemas.openxmlformats.org/officeDocument/2006/relationships" id="256" r:id="R1c5a954697674732"/>
+    <p:sldId xmlns:r="http://schemas.openxmlformats.org/officeDocument/2006/relationships" id="257" r:id="R2cf3c04c23bf424b"/>
+    <p:sldId xmlns:r="http://schemas.openxmlformats.org/officeDocument/2006/relationships" id="258" r:id="R5bf09f3f5a364767"/>
+    <p:sldId xmlns:r="http://schemas.openxmlformats.org/officeDocument/2006/relationships" id="259" r:id="R28df0800b8ad4441"/>
+    <p:sldId xmlns:r="http://schemas.openxmlformats.org/officeDocument/2006/relationships" id="260" r:id="R64f1915ca15a4917"/>
+    <p:sldId xmlns:r="http://schemas.openxmlformats.org/officeDocument/2006/relationships" id="261" r:id="Rd5d6253ed1424f00"/>
+    <p:sldId xmlns:r="http://schemas.openxmlformats.org/officeDocument/2006/relationships" id="262" r:id="Re728900cb0194919"/>
+    <p:sldId xmlns:r="http://schemas.openxmlformats.org/officeDocument/2006/relationships" id="263" r:id="Redfd1a06607045f9"/>
   </p:sldIdLst>
   <p:sldSz cx="18288000" cy="10287000"/>
   <p:notesSz cx="6858000" cy="9144000"/>
   <p:embeddedFontLst>
     <p:embeddedFont>
       <p:font typeface="Noto Sans Bold"/>
-      <p:regular xmlns:r="http://schemas.openxmlformats.org/officeDocument/2006/relationships" r:id="Re2ec74a51a1e4a25"/>
+      <p:regular xmlns:r="http://schemas.openxmlformats.org/officeDocument/2006/relationships" r:id="Rfdb2f5ce343f4fd0"/>
     </p:embeddedFont>
     <p:embeddedFont>
       <p:font typeface="Noto Sans Kr"/>
-      <p:regular xmlns:r="http://schemas.openxmlformats.org/officeDocument/2006/relationships" r:id="R428dec6ece114b3f"/>
+      <p:regular xmlns:r="http://schemas.openxmlformats.org/officeDocument/2006/relationships" r:id="R02f490b3ca334389"/>
     </p:embeddedFont>
   </p:embeddedFontLst>
   <p:defaultTextStyle>
@@ -598,7 +598,7 @@
           </a:p>
           <a:p xmlns:a="http://schemas.openxmlformats.org/drawingml/2006/main">
             <a:r>
-              <a:t>발표 시간 15초 / 0~15초</a:t>
+              <a:t>발표 시간 15초 / 0:00~0:15</a:t>
             </a:r>
           </a:p>
           <a:p xmlns:a="http://schemas.openxmlformats.org/drawingml/2006/main">
@@ -613,7 +613,7 @@
           </a:p>
           <a:p xmlns:a="http://schemas.openxmlformats.org/drawingml/2006/main">
             <a:r>
-              <a:t>안녕하세요. SKALA 광주 2반 G066 정준용입니다. 가설 기반 운영 진단 에이전트의 개선 결과를 실제 질문과 출력 화면으로 보여드리겠습니다.</a:t>
+              <a:t>안녕하세요. SKALA 광주 2반 G066 정준용입니다. 장애 증상에서 출발해 추가 관측으로 원인을 좁히는 운영 진단 에이전트를 구현했습니다. 조사 과정과 실제 검증 결과를 중심으로 소개하겠습니다.</a:t>
             </a:r>
           </a:p>
           <a:p xmlns:a="http://schemas.openxmlformats.org/drawingml/2006/main">
@@ -628,7 +628,7 @@
           </a:p>
           <a:p xmlns:a="http://schemas.openxmlformats.org/drawingml/2006/main">
             <a:r>
-              <a:t>먼저 개선한 핵심 기능입니다.</a:t>
+              <a:t>먼저, 기존 시스템에서 개선한 문제입니다.</a:t>
             </a:r>
           </a:p>
           <a:p xmlns:a="http://schemas.openxmlformats.org/drawingml/2006/main">
@@ -643,7 +643,7 @@
           </a:p>
           <a:p xmlns:a="http://schemas.openxmlformats.org/drawingml/2006/main">
             <a:r>
-              <a:t>프로젝트명과 소속을 소개한다. 오른쪽 사진은 실제 Ollama 실행 화면이다.</a:t>
+              <a:t>프로젝트명과 소속을 소개한다. 오른쪽은 실제 Ollama 실행 화면이다.</a:t>
             </a:r>
           </a:p>
           <a:p xmlns:a="http://schemas.openxmlformats.org/drawingml/2006/main">
@@ -678,7 +678,7 @@
           </a:p>
           <a:p xmlns:a="http://schemas.openxmlformats.org/drawingml/2006/main">
             <a:r>
-              <a:t>보존된 2026-10-21 검증 결과. 관측은 교육용 합성 데이터. 계획·작성은 실제 Ollama qwen3.5:2b, 별도 Judge는 qwen3:8b. 입력 검사와 도입 전 가설 평가의 범위를 구분. 교차 지지는 인과 확정과 구분.</a:t>
+              <a:t>3·4·7번은 2026-10-21 보존 실행·평가를 사용한다. 관측은 교육용 합성 데이터이며 계획·작성은 실제 Ollama qwen3.5:2b, 별도 Judge는 qwen3:8b다. 교차 지지는 인과 확정과 구분한다.</a:t>
             </a:r>
           </a:p>
         </p:txBody>
@@ -758,7 +758,7 @@
           </a:p>
           <a:p xmlns:a="http://schemas.openxmlformats.org/drawingml/2006/main">
             <a:r>
-              <a:t>발표 시간 25초 / 15~40초</a:t>
+              <a:t>발표 시간 30초 / 0:15~0:45</a:t>
             </a:r>
           </a:p>
           <a:p xmlns:a="http://schemas.openxmlformats.org/drawingml/2006/main">
@@ -773,7 +773,7 @@
           </a:p>
           <a:p xmlns:a="http://schemas.openxmlformats.org/drawingml/2006/main">
             <a:r>
-              <a:t>핵심은 가설 기반 추가 조사와 근거 검증입니다. 초기 경고만으로 원인을 단정하지 않고 필요한 관측을 더 수집합니다. 보고서는 수치와 출처, 조치 조건을 코드로 확인하고 반복 실패하면 관측 사실만 안내합니다. 입력 검사와 부분 실패 대응은 이를 뒷받침하는 보조 기능입니다.</a:t>
+              <a:t>기존 시스템의 문제는 초기 경고만으로 원인을 추정한다는 점이었습니다. 예를 들어 CPU 상승과 중복 배치 경고가 함께 발생해도, 배치가 실제 CPU를 사용했는지는 추가 확인이 필요합니다. 그래서 경쟁 가설을 세우고, 가설을 구별할 관측을 추가하도록 개선했습니다. 또한 생성된 보고서의 수치와 출처, 조치 조건을 검사해 잘못된 내용은 다시 작성하도록 했습니다. 핵심은 원인을 조사하는 과정과 보고서를 검증하는 과정을 함께 개선한 것입니다.</a:t>
             </a:r>
           </a:p>
           <a:p xmlns:a="http://schemas.openxmlformats.org/drawingml/2006/main">
@@ -788,7 +788,7 @@
           </a:p>
           <a:p xmlns:a="http://schemas.openxmlformats.org/drawingml/2006/main">
             <a:r>
-              <a:t>같은 질문을 넣었을 때 실제 답변이 어떻게 달라지는지 보겠습니다.</a:t>
+              <a:t>같은 질문에 추가 근거가 달라지면 어떤 결과가 나오는지 보겠습니다.</a:t>
             </a:r>
           </a:p>
           <a:p xmlns:a="http://schemas.openxmlformats.org/drawingml/2006/main">
@@ -803,7 +803,7 @@
           </a:p>
           <a:p xmlns:a="http://schemas.openxmlformats.org/drawingml/2006/main">
             <a:r>
-              <a:t>표 첫 행의 가설 기반 추가 조사, 둘째 행의 근거 검증을 먼저 설명한다. 아래 보조 안정성 기능은 한 문장으로 짚는다.</a:t>
+              <a:t>두 개선 행을 차례로 짚고 초기 경고만으로 원인을 구별하기 어려운 이유를 설명한다. 보조 안정성 기능은 길게 읽지 않는다.</a:t>
             </a:r>
           </a:p>
           <a:p xmlns:a="http://schemas.openxmlformats.org/drawingml/2006/main">
@@ -848,7 +848,7 @@
           </a:p>
           <a:p xmlns:a="http://schemas.openxmlformats.org/drawingml/2006/main">
             <a:r>
-              <a:t>보존된 2026-10-21 검증 결과. 관측은 교육용 합성 데이터. 계획·작성은 실제 Ollama qwen3.5:2b, 별도 Judge는 qwen3:8b. 입력 검사와 도입 전 가설 평가의 범위를 구분. 교차 지지는 인과 확정과 구분.</a:t>
+              <a:t>3·4·7번은 2026-10-21 보존 실행·평가를 사용한다. 관측은 교육용 합성 데이터이며 계획·작성은 실제 Ollama qwen3.5:2b, 별도 Judge는 qwen3:8b다. 교차 지지는 인과 확정과 구분한다.</a:t>
             </a:r>
           </a:p>
         </p:txBody>
@@ -928,7 +928,7 @@
           </a:p>
           <a:p xmlns:a="http://schemas.openxmlformats.org/drawingml/2006/main">
             <a:r>
-              <a:t>발표 시간 45초 / 40~85초</a:t>
+              <a:t>발표 시간 45초 / 0:45~1:30</a:t>
             </a:r>
           </a:p>
           <a:p xmlns:a="http://schemas.openxmlformats.org/drawingml/2006/main">
@@ -943,7 +943,7 @@
           </a:p>
           <a:p xmlns:a="http://schemas.openxmlformats.org/drawingml/2006/main">
             <a:r>
-              <a:t>상단은 실제로 입력한 질문입니다. CPU 91%와 중복 배치 경고에서 원인을 구별해 달라고 요청했습니다. 왼쪽 실행은 배치의 CPU 기여 86%와 중복 작업이 확인돼 중복 배치를 교차 지지했습니다. 오른쪽 실행은 배치 기여가 5%여서 반증했고, 요청 처리 기여와 요청량 증가가 요청량 가설을 교차 지지했습니다. 아래는 저장된 최종 답변의 발췌입니다. 추가 조회는 각각 세 번과 두 번에서 종료했습니다. 두 실행은 실제 LLM을 사용했고 관측은 교육용 합성 데이터입니다.</a:t>
+              <a:t>두 실행에는 동일하게 CPU가 91%이고 중복 배치 경고가 있는데 실제 원인을 구별해 달라고 질문했습니다. 왼쪽에서는 배치의 CPU 기여 비중이 86%였고, 중복 작업의 실행도 겹쳤습니다. 두 관측이 배치 가설을 지지했습니다. 반면 오른쪽에서는 배치의 기여가 5%에 불과했고, 요청량이 평소의 3.2배로 증가했습니다. 따라서 배치 가설은 반증하고 요청량 가설을 지지했습니다. 같은 경고에서도 실제 관측에 따라 판단이 달라진 것입니다. 계획과 작성에는 실제 LLM을 사용했고, 관측에는 교육용 합성 데이터를 사용했습니다.</a:t>
             </a:r>
           </a:p>
           <a:p xmlns:a="http://schemas.openxmlformats.org/drawingml/2006/main">
@@ -958,7 +958,7 @@
           </a:p>
           <a:p xmlns:a="http://schemas.openxmlformats.org/drawingml/2006/main">
             <a:r>
-              <a:t>이 답변이 나오는 조사 과정을 화면으로 보겠습니다.</a:t>
+              <a:t>이제 이 판단을 만드는 조사 절차를 설명하겠습니다.</a:t>
             </a:r>
           </a:p>
           <a:p xmlns:a="http://schemas.openxmlformats.org/drawingml/2006/main">
@@ -973,7 +973,7 @@
           </a:p>
           <a:p xmlns:a="http://schemas.openxmlformats.org/drawingml/2006/main">
             <a:r>
-              <a:t>실제 질문을 읽고 두 열의 관측과 최종 원인 추정을 연결한다. 하단의 실제 추가 조회 횟수로 종료 동작을 짚는다.</a:t>
+              <a:t>위쪽 동일 질문과 왼쪽 배치·오른쪽 요청량 결과를 비교한다. 교육용 합성 관측과 실제 LLM의 범위를 구분한다.</a:t>
             </a:r>
           </a:p>
           <a:p xmlns:a="http://schemas.openxmlformats.org/drawingml/2006/main">
@@ -1013,7 +1013,7 @@
           </a:p>
           <a:p xmlns:a="http://schemas.openxmlformats.org/drawingml/2006/main">
             <a:r>
-              <a:t>보존된 2026-10-21 검증 결과. 관측은 교육용 합성 데이터. 계획·작성은 실제 Ollama qwen3.5:2b, 별도 Judge는 qwen3:8b. 입력 검사와 도입 전 가설 평가의 범위를 구분. 교차 지지는 인과 확정과 구분.</a:t>
+              <a:t>3·4·7번은 2026-10-21 보존 실행·평가를 사용한다. 관측은 교육용 합성 데이터이며 계획·작성은 실제 Ollama qwen3.5:2b, 별도 Judge는 qwen3:8b다. 교차 지지는 인과 확정과 구분한다.</a:t>
             </a:r>
           </a:p>
         </p:txBody>
@@ -1093,7 +1093,7 @@
           </a:p>
           <a:p xmlns:a="http://schemas.openxmlformats.org/drawingml/2006/main">
             <a:r>
-              <a:t>발표 시간 55초 / 85~140초</a:t>
+              <a:t>발표 시간 60초 / 1:30~2:30</a:t>
             </a:r>
           </a:p>
           <a:p xmlns:a="http://schemas.openxmlformats.org/drawingml/2006/main">
@@ -1108,7 +1108,7 @@
           </a:p>
           <a:p xmlns:a="http://schemas.openxmlformats.org/drawingml/2006/main">
             <a:r>
-              <a:t>먼저 관측을 읽기 전에 가설별 지지·반증 기준을 고정합니다. LLM이 미수행 질문을 고르고 MCP가 관측을 가져오면 코드가 조건과 대조합니다. 오른쪽은 실제 요청량 사례의 조사 화면입니다. 첫 조사에서 CPU가 어느 작업에 귀속되는지 확인하고, 다음 조사에서 평소 대비 요청량과 지속 시간을 확인했습니다. 서로 다른 관측이 교차 지지하고 경쟁 가설이 반증돼 두 번 만에 종료했습니다. 화면에는 조사 이유와 판단 전후도 남깁니다. 근거가 부족하면 최대 네 번 조사하고, 끝까지 부족하거나 상충하면 보류합니다. 보고서는 이어서 별도 근거 검증을 거칩니다.</a:t>
+              <a:t>가장 중요한 설계는 관측을 조회하기 전에 판정 조건을 정한다는 점입니다. 예를 들어 특정 작업의 CPU 기여 비중이 70% 이상이면 해당 가설을 지지하도록 기준을 먼저 고정합니다. 이후 LLM은 남은 조사 후보 중 필요한 질문을 선택합니다. MCP가 관측을 가져오면, 코드가 미리 정한 조건과 대조해 가설 상태를 갱신합니다. 질문 선택과 수치 판정의 책임을 나눈 것입니다. 오른쪽 사례에서는 CPU가 어느 작업에 사용됐는지 확인한 뒤 요청량과 지속 시간을 조사했습니다. 서로 다른 관측이 같은 가설을 지지하고 경쟁 가설의 반증도 확보돼 종료했습니다. 화면에는 조사 이유, 판정 조건, 관측 결과를 남깁니다. 추가 조회는 최대 네 번이며, 근거가 부족하거나 상충하면 원인 확정을 보류합니다.</a:t>
             </a:r>
           </a:p>
           <a:p xmlns:a="http://schemas.openxmlformats.org/drawingml/2006/main">
@@ -1123,7 +1123,7 @@
           </a:p>
           <a:p xmlns:a="http://schemas.openxmlformats.org/drawingml/2006/main">
             <a:r>
-              <a:t>전체 서비스에서는 이 흐름을 다음과 같이 연결했습니다.</a:t>
+              <a:t>이 흐름을 전체 시스템에서는 다음과 같이 연결했습니다.</a:t>
             </a:r>
           </a:p>
           <a:p xmlns:a="http://schemas.openxmlformats.org/drawingml/2006/main">
@@ -1138,7 +1138,7 @@
           </a:p>
           <a:p xmlns:a="http://schemas.openxmlformats.org/drawingml/2006/main">
             <a:r>
-              <a:t>왼쪽 절차와 오른쪽 실제 조사 화면을 연결한다. 하단의 1차·2차 조회와 종료 이유를 짚고 사례 수치는 다시 읽지 않는다.</a:t>
+              <a:t>왼쪽 사전 조건의 CPU 기여 70% 예시를 짚고 LLM 질문 선택·코드 판정·종료 역할을 구분한다. 오른쪽 실제 조회 순서와 종료 이유를 연결한다.</a:t>
             </a:r>
           </a:p>
           <a:p xmlns:a="http://schemas.openxmlformats.org/drawingml/2006/main">
@@ -1183,7 +1183,7 @@
           </a:p>
           <a:p xmlns:a="http://schemas.openxmlformats.org/drawingml/2006/main">
             <a:r>
-              <a:t>보존된 2026-10-21 검증 결과. 관측은 교육용 합성 데이터. 계획·작성은 실제 Ollama qwen3.5:2b, 별도 Judge는 qwen3:8b. 입력 검사와 도입 전 가설 평가의 범위를 구분. 교차 지지는 인과 확정과 구분.</a:t>
+              <a:t>3·4·7번은 2026-10-21 보존 실행·평가를 사용한다. 관측은 교육용 합성 데이터이며 계획·작성은 실제 Ollama qwen3.5:2b, 별도 Judge는 qwen3:8b다. 교차 지지는 인과 확정과 구분한다.</a:t>
             </a:r>
           </a:p>
         </p:txBody>
@@ -1263,7 +1263,7 @@
           </a:p>
           <a:p xmlns:a="http://schemas.openxmlformats.org/drawingml/2006/main">
             <a:r>
-              <a:t>발표 시간 45초 / 140~185초</a:t>
+              <a:t>발표 시간 55초 / 2:30~3:25</a:t>
             </a:r>
           </a:p>
           <a:p xmlns:a="http://schemas.openxmlformats.org/drawingml/2006/main">
@@ -1278,7 +1278,7 @@
           </a:p>
           <a:p xmlns:a="http://schemas.openxmlformats.org/drawingml/2006/main">
             <a:r>
-              <a:t>Vue 화면에서 질문을 보내면 FastAPI가 요청과 대상을 확인합니다. LangGraph가 전문 조회와 추가 조사, 보고서 작성을 조정합니다. LLM은 질문 선택과 작성에 사용하고, MCP는 관측 조회, RAG는 매뉴얼 검색을 담당합니다. 진행 상황은 SSE로 전달하고 완료 결과와 대화 맥락은 SQLite에 저장합니다. 평가와 추적은 별도 경로로 연결했습니다.</a:t>
+              <a:t>Vue에서 질문을 보내면 FastAPI가 입력과 조사 대상을 확인합니다. 중앙의 LangGraph는 Supervisor 역할로 전문 조회와 추가 조사, 보고서 작성을 조정합니다. 지표와 로그는 병렬로 수집하고, 런북은 수집한 관측을 반영해 검색합니다. 전문 역할을 서브그래프로 분리해 일부 조회가 실패해도 성공한 근거는 유지하도록 했습니다. MCP에서는 Tool로 관측을 조회하고, Resource로 런북 원문을 제공하며, Prompt로 공통 조사 절차를 전달합니다. 진행 상황은 SSE로 화면에 전달하고 완료 결과와 대화 맥락은 SQLite에 저장합니다. 모델과 도구 연결은 의존성 주입으로 분리해 테스트할 때 교체할 수 있도록 했습니다.</a:t>
             </a:r>
           </a:p>
           <a:p xmlns:a="http://schemas.openxmlformats.org/drawingml/2006/main">
@@ -1293,7 +1293,7 @@
           </a:p>
           <a:p xmlns:a="http://schemas.openxmlformats.org/drawingml/2006/main">
             <a:r>
-              <a:t>이 중 근거 검증이 실제로 동작한 사례를 보겠습니다.</a:t>
+              <a:t>다음은 검색한 근거가 실제 보고서 검증으로 이어진 화면입니다.</a:t>
             </a:r>
           </a:p>
           <a:p xmlns:a="http://schemas.openxmlformats.org/drawingml/2006/main">
@@ -1308,7 +1308,7 @@
           </a:p>
           <a:p xmlns:a="http://schemas.openxmlformats.org/drawingml/2006/main">
             <a:r>
-              <a:t>전체 아키텍처 한 장에서 Vue, FastAPI, LangGraph 경로와 연결된 도구·모델·기록·평가 역할을 짚는다.</a:t>
+              <a:t>Vue에서 FastAPI와 LangGraph로 이동하며 전체 구조를 짚는다. 전문 조회 병렬 수집과 관측 기반 검색, MCP·저장·평가 연결을 설명한다.</a:t>
             </a:r>
           </a:p>
           <a:p xmlns:a="http://schemas.openxmlformats.org/drawingml/2006/main">
@@ -1358,6 +1358,11 @@
           </a:p>
           <a:p xmlns:a="http://schemas.openxmlformats.org/drawingml/2006/main">
             <a:r>
+              <a:t>https://github.com/beshurl/skala-ai-mini-project/blob/main/agent/deps.py</a:t>
+            </a:r>
+          </a:p>
+          <a:p xmlns:a="http://schemas.openxmlformats.org/drawingml/2006/main">
+            <a:r>
               <a:t/>
             </a:r>
           </a:p>
@@ -1368,7 +1373,7 @@
           </a:p>
           <a:p xmlns:a="http://schemas.openxmlformats.org/drawingml/2006/main">
             <a:r>
-              <a:t>보존된 2026-10-21 검증 결과. 관측은 교육용 합성 데이터. 계획·작성은 실제 Ollama qwen3.5:2b, 별도 Judge는 qwen3:8b. 입력 검사와 도입 전 가설 평가의 범위를 구분. 교차 지지는 인과 확정과 구분.</a:t>
+              <a:t>3·4·7번은 2026-10-21 보존 실행·평가를 사용한다. 관측은 교육용 합성 데이터이며 계획·작성은 실제 Ollama qwen3.5:2b, 별도 Judge는 qwen3:8b다. 교차 지지는 인과 확정과 구분한다.</a:t>
             </a:r>
           </a:p>
         </p:txBody>
@@ -1448,7 +1453,7 @@
           </a:p>
           <a:p xmlns:a="http://schemas.openxmlformats.org/drawingml/2006/main">
             <a:r>
-              <a:t>발표 시간 45초 / 185~230초</a:t>
+              <a:t>발표 시간 50초 / 3:25~4:15</a:t>
             </a:r>
           </a:p>
           <a:p xmlns:a="http://schemas.openxmlformats.org/drawingml/2006/main">
@@ -1463,7 +1468,7 @@
           </a:p>
           <a:p xmlns:a="http://schemas.openxmlformats.org/drawingml/2006/main">
             <a:r>
-              <a:t>왼쪽은 기술별 역할이고, 오른쪽은 실제 프론트의 보고서 검증 화면입니다. RAG는 CPU 급증 대응 절차 등 관련 런북 세 종을 검색했습니다. 10월 22일 실제 Ollama로 다시 실행했을 때, 첫 초안은 확인 가능한 다음 행동이 빠져 코드 검사에서 불합격했습니다. 피드백을 반영한 두 번째 작성은 통과했고, 화면에도 작성 두 회와 재작성 한 회가 표시됩니다. 여섯 검증 항목이 확인됐으며, Judge는 이 검사와 구분한 별도 품질 평가입니다.</a:t>
+              <a:t>RAG는 매뉴얼 여섯 종을 임베딩해 의미가 가까운 문서를 검색합니다. 벡터는 SQLite에 저장하고 NumPy로 유사도를 계산했습니다. 현재 문서 규모에 맞춰 별도 검색 서버 없이 구성했습니다. 검색 결과는 MCP의 원문과 대조하고, 관측 조건에 맞는 문서를 보고서 근거로 사용합니다. 오른쪽은 실제 Ollama로 재실행한 화면입니다. 첫 초안은 확인 가능한 다음 행동이 빠져 코드 검사에서 불합격했습니다. 피드백을 반영한 두 번째 작성은 통과했습니다. 화면에서도 여섯 검증 항목과 작성 두 회, 재작성 한 회를 확인할 수 있습니다.</a:t>
             </a:r>
           </a:p>
           <a:p xmlns:a="http://schemas.openxmlformats.org/drawingml/2006/main">
@@ -1478,7 +1483,7 @@
           </a:p>
           <a:p xmlns:a="http://schemas.openxmlformats.org/drawingml/2006/main">
             <a:r>
-              <a:t>그 별도 평가와 원격 추적 결과도 확인했습니다.</a:t>
+              <a:t>코드 검사 외에, 답변의 품질과 실행 기록도 별도로 평가했습니다.</a:t>
             </a:r>
           </a:p>
           <a:p xmlns:a="http://schemas.openxmlformats.org/drawingml/2006/main">
@@ -1493,7 +1498,7 @@
           </a:p>
           <a:p xmlns:a="http://schemas.openxmlformats.org/drawingml/2006/main">
             <a:r>
-              <a:t>오른쪽 실제 프론트 화면에서 모든 검증 통과, 여섯 검증 항목, 작성 2회·재작성 1회를 짚는다. 1차 누락 사유는 저장한 실행 이벤트에서 확인한 내용이며, 이 화면 자체는 최종 검증 상태다.</a:t>
+              <a:t>왼쪽 MCP 인터페이스 역할과 RAG 벡터 저장·검색 구성을 짚고 오른쪽 실제 프론트의 검증 완료·작성 2회·재작성 1회를 확인한다. 화면은 최종 상태이며 1차 누락 사유는 저장된 이벤트 근거다.</a:t>
             </a:r>
           </a:p>
           <a:p xmlns:a="http://schemas.openxmlformats.org/drawingml/2006/main">
@@ -1553,7 +1558,7 @@
           </a:p>
           <a:p xmlns:a="http://schemas.openxmlformats.org/drawingml/2006/main">
             <a:r>
-              <a:t>6번은 2026-10-22 실제 Ollama qwen3.5:2b 재실행 화면. 관측은 교육용 합성 데이터. 이번 실행에서 Judge 재평가·원격 추적 재조회는 하지 않았으며 7번의 2026-10-21 보존 평가와 구분한다.</a:t>
+              <a:t>6번은 2026-10-22 실제 Ollama qwen3.5:2b 재실행 화면. 관측은 교육용 합성 데이터. Judge 재평가·원격 추적 재조회는 하지 않았으며 7번의 2026-10-21 보존 평가와 구분한다.</a:t>
             </a:r>
           </a:p>
         </p:txBody>
@@ -1633,7 +1638,7 @@
           </a:p>
           <a:p xmlns:a="http://schemas.openxmlformats.org/drawingml/2006/main">
             <a:r>
-              <a:t>발표 시간 40초 / 230~270초</a:t>
+              <a:t>발표 시간 45초 / 4:15~5:00</a:t>
             </a:r>
           </a:p>
           <a:p xmlns:a="http://schemas.openxmlformats.org/drawingml/2006/main">
@@ -1648,7 +1653,7 @@
           </a:p>
           <a:p xmlns:a="http://schemas.openxmlformats.org/drawingml/2006/main">
             <a:r>
-              <a:t>자동 테스트는 99개를 통과했습니다. 입력 검사 도입 전 실제 Ollama의 가설 조사 여섯 건은 기능 검사 모두 통과했고, Judge 포함 종합은 다섯 건 통과였습니다. 아래 개별 결과에서 요청량 사례는 다섯 평가 항목 모두 5점이었지만, 릴리스 사례는 Judge 근거 점수가 2점이어서 종합 미통과로 남았습니다. LangSmith 실행 여섯 건과 점수 서른 개도 재조회했습니다. 입력 검사 도입 후 거절 다섯 건은 생성 0토큰이었습니다.</a:t>
+              <a:t>보존된 검증 결과에서 코드 분기와 오류 처리를 검사하는 자동 테스트 99개가 통과했습니다. 실제 LLM을 사용한 가설 조사 여섯 사례도 기능 검사를 모두 통과했습니다. 별도 Judge는 근거 충실성, 수치 정확성, 조치 조건 등을 평가했습니다. 릴리스 사례는 기능 검사를 통과했지만 Judge 점수가 낮아 종합 결과는 여섯 건 중 다섯 건이었습니다. 이 차이를 숨기지 않고 검토 대상으로 남겼습니다. LangSmith에서는 실행 여섯 건과 평가 점수 서른 개를 재조회해 원격 저장까지 확인했습니다. 별도로 입력 거절 다섯 건에서는 생성 토큰이 0임을 검증했습니다.</a:t>
             </a:r>
           </a:p>
           <a:p xmlns:a="http://schemas.openxmlformats.org/drawingml/2006/main">
@@ -1663,7 +1668,7 @@
           </a:p>
           <a:p xmlns:a="http://schemas.openxmlformats.org/drawingml/2006/main">
             <a:r>
-              <a:t>마지막으로 이 결과의 한계와 다음 과제입니다.</a:t>
+              <a:t>마지막으로 현재 한계와 이번 구현에서 배운 점입니다.</a:t>
             </a:r>
           </a:p>
           <a:p xmlns:a="http://schemas.openxmlformats.org/drawingml/2006/main">
@@ -1678,7 +1683,7 @@
           </a:p>
           <a:p xmlns:a="http://schemas.openxmlformats.org/drawingml/2006/main">
             <a:r>
-              <a:t>상단 전체 수치와 하단 traffic·release 개별 점수를 연결한다. 원격 추적 재조회 결과와 별도 입력 거절 검증을 짧게 언급한다.</a:t>
+              <a:t>99개 자동 테스트와 실제 모델의 6/6 기능 검사·5/6 종합을 구분한다. LangSmith의 실행·평가 점수 재조회와 별도 생성 0토큰 결과를 짧게 설명한다.</a:t>
             </a:r>
           </a:p>
           <a:p xmlns:a="http://schemas.openxmlformats.org/drawingml/2006/main">
@@ -1718,7 +1723,7 @@
           </a:p>
           <a:p xmlns:a="http://schemas.openxmlformats.org/drawingml/2006/main">
             <a:r>
-              <a:t>보존된 2026-10-21 검증 결과. 관측은 교육용 합성 데이터. 계획·작성은 실제 Ollama qwen3.5:2b, 별도 Judge는 qwen3:8b. 입력 검사와 도입 전 가설 평가의 범위를 구분. 교차 지지는 인과 확정과 구분.</a:t>
+              <a:t>3·4·7번은 2026-10-21 보존 실행·평가를 사용한다. 관측은 교육용 합성 데이터이며 계획·작성은 실제 Ollama qwen3.5:2b, 별도 Judge는 qwen3:8b다. 교차 지지는 인과 확정과 구분한다.</a:t>
             </a:r>
           </a:p>
         </p:txBody>
@@ -1798,7 +1803,7 @@
           </a:p>
           <a:p xmlns:a="http://schemas.openxmlformats.org/drawingml/2006/main">
             <a:r>
-              <a:t>발표 시간 30초 / 270~300초</a:t>
+              <a:t>발표 시간 30초 / 5:00~5:30</a:t>
             </a:r>
           </a:p>
           <a:p xmlns:a="http://schemas.openxmlformats.org/drawingml/2006/main">
@@ -1813,7 +1818,7 @@
           </a:p>
           <a:p xmlns:a="http://schemas.openxmlformats.org/drawingml/2006/main">
             <a:r>
-              <a:t>현재는 CPU 세 가설과 합성 관측에 한정되고 교차 지지가 실제 원인 확정을 뜻하지는 않습니다. Judge에도 오판 가능성이 있습니다. 앞으로 실제 모니터링 연결과 다른 계열 모델·사람 평가, 전체 비용 계측을 진행하겠습니다. 이번 경험으로 판단 조건과 근거를 남겨야 설명의 변화까지 검증할 수 있다는 점을 배웠습니다. 감사합니다.</a:t>
+              <a:t>현재는 CPU 관련 세 가설과 합성 관측에 한정됩니다. 조회 한도는 비용을 통제하지만 미확인 가설을 남길 수 있고, Judge에도 오판 가능성이 있습니다. 앞으로 실제 모니터링을 연결하고, 다른 계열 모델과 사람 평가를 비교하며 전체 비용을 계측하겠습니다. 이번 프로젝트를 통해 판단 조건과 근거를 함께 남겨야, 진단이 달라진 이유까지 설명할 수 있다는 점을 배웠습니다. 감사합니다.</a:t>
             </a:r>
           </a:p>
           <a:p xmlns:a="http://schemas.openxmlformats.org/drawingml/2006/main">
@@ -1828,22 +1833,22 @@
           </a:p>
           <a:p xmlns:a="http://schemas.openxmlformats.org/drawingml/2006/main">
             <a:r>
-              <a:t>감사합니다.</a:t>
-            </a:r>
-          </a:p>
-          <a:p xmlns:a="http://schemas.openxmlformats.org/drawingml/2006/main">
-            <a:r>
               <a:t/>
             </a:r>
           </a:p>
           <a:p xmlns:a="http://schemas.openxmlformats.org/drawingml/2006/main">
             <a:r>
+              <a:t/>
+            </a:r>
+          </a:p>
+          <a:p xmlns:a="http://schemas.openxmlformats.org/drawingml/2006/main">
+            <a:r>
               <a:t>화면 진행</a:t>
             </a:r>
           </a:p>
           <a:p xmlns:a="http://schemas.openxmlformats.org/drawingml/2006/main">
             <a:r>
-              <a:t>남은 한계와 다음 개선을 연결하고 판단 조건과 근거를 기록한 경험으로 마무리한다.</a:t>
+              <a:t>CPU 범위와 조회 한도에 따른 미확인 항목, Judge 오류를 다음 개선과 연결하고 판단 조건·근거 기록의 교훈으로 마무리한다.</a:t>
             </a:r>
           </a:p>
           <a:p xmlns:a="http://schemas.openxmlformats.org/drawingml/2006/main">
@@ -1873,7 +1878,7 @@
           </a:p>
           <a:p xmlns:a="http://schemas.openxmlformats.org/drawingml/2006/main">
             <a:r>
-              <a:t>보존된 2026-10-21 검증 결과. 관측은 교육용 합성 데이터. 계획·작성은 실제 Ollama qwen3.5:2b, 별도 Judge는 qwen3:8b. 입력 검사와 도입 전 가설 평가의 범위를 구분. 교차 지지는 인과 확정과 구분.</a:t>
+              <a:t>3·4·7번은 2026-10-21 보존 실행·평가를 사용한다. 관측은 교육용 합성 데이터이며 계획·작성은 실제 Ollama qwen3.5:2b, 별도 Judge는 qwen3:8b다. 교차 지지는 인과 확정과 구분한다.</a:t>
             </a:r>
           </a:p>
         </p:txBody>
@@ -4900,17 +4905,17 @@
   </p:cSld>
   <p:clrMap bg1="lt1" tx1="dk1" bg2="lt2" tx2="dk2" accent1="accent1" accent2="accent2" accent3="accent3" accent4="accent4" accent5="accent5" accent6="accent6" hlink="hlink" folHlink="folHlink"/>
   <p:sldLayoutIdLst>
-    <p:sldLayoutId xmlns:r="http://schemas.openxmlformats.org/officeDocument/2006/relationships" id="2147483649" r:id="R28b0a815a4c342fb"/>
-    <p:sldLayoutId xmlns:r="http://schemas.openxmlformats.org/officeDocument/2006/relationships" id="2147483650" r:id="R5a2ecd8fc8784945"/>
-    <p:sldLayoutId xmlns:r="http://schemas.openxmlformats.org/officeDocument/2006/relationships" id="2147483651" r:id="R5b3f4e59573d4ca5"/>
-    <p:sldLayoutId xmlns:r="http://schemas.openxmlformats.org/officeDocument/2006/relationships" id="2147483652" r:id="R7066e5acafdd4b99"/>
-    <p:sldLayoutId xmlns:r="http://schemas.openxmlformats.org/officeDocument/2006/relationships" id="2147483653" r:id="Rf7ae56ef302a4f07"/>
-    <p:sldLayoutId xmlns:r="http://schemas.openxmlformats.org/officeDocument/2006/relationships" id="2147483654" r:id="R8d17c1fc2ace4953"/>
-    <p:sldLayoutId xmlns:r="http://schemas.openxmlformats.org/officeDocument/2006/relationships" id="2147483655" r:id="Rf5505557abd04f4f"/>
-    <p:sldLayoutId xmlns:r="http://schemas.openxmlformats.org/officeDocument/2006/relationships" id="2147483656" r:id="R6e871bae8dbf451c"/>
-    <p:sldLayoutId xmlns:r="http://schemas.openxmlformats.org/officeDocument/2006/relationships" id="2147483657" r:id="Rcdea45ce7c9b4166"/>
-    <p:sldLayoutId xmlns:r="http://schemas.openxmlformats.org/officeDocument/2006/relationships" id="2147483658" r:id="R5e46125a129645f6"/>
-    <p:sldLayoutId xmlns:r="http://schemas.openxmlformats.org/officeDocument/2006/relationships" id="2147483659" r:id="R737fa8c1497d4bdf"/>
+    <p:sldLayoutId xmlns:r="http://schemas.openxmlformats.org/officeDocument/2006/relationships" id="2147483649" r:id="R36f518b4a7974a18"/>
+    <p:sldLayoutId xmlns:r="http://schemas.openxmlformats.org/officeDocument/2006/relationships" id="2147483650" r:id="Rca7c756488dc4c5f"/>
+    <p:sldLayoutId xmlns:r="http://schemas.openxmlformats.org/officeDocument/2006/relationships" id="2147483651" r:id="Rb97f9094b1f2492e"/>
+    <p:sldLayoutId xmlns:r="http://schemas.openxmlformats.org/officeDocument/2006/relationships" id="2147483652" r:id="R3641d063d0d74a76"/>
+    <p:sldLayoutId xmlns:r="http://schemas.openxmlformats.org/officeDocument/2006/relationships" id="2147483653" r:id="R89ab868bb4a74867"/>
+    <p:sldLayoutId xmlns:r="http://schemas.openxmlformats.org/officeDocument/2006/relationships" id="2147483654" r:id="R11642e52f6624d99"/>
+    <p:sldLayoutId xmlns:r="http://schemas.openxmlformats.org/officeDocument/2006/relationships" id="2147483655" r:id="Rc755c43d5c1c4aff"/>
+    <p:sldLayoutId xmlns:r="http://schemas.openxmlformats.org/officeDocument/2006/relationships" id="2147483656" r:id="R3cf4b86ff6094ef5"/>
+    <p:sldLayoutId xmlns:r="http://schemas.openxmlformats.org/officeDocument/2006/relationships" id="2147483657" r:id="R1c4cb1db030641f1"/>
+    <p:sldLayoutId xmlns:r="http://schemas.openxmlformats.org/officeDocument/2006/relationships" id="2147483658" r:id="R5b69ddccfab74d66"/>
+    <p:sldLayoutId xmlns:r="http://schemas.openxmlformats.org/officeDocument/2006/relationships" id="2147483659" r:id="Rcc6785d0f2cd4cdb"/>
   </p:sldLayoutIdLst>
   <p:txStyles>
     <p:titleStyle>
@@ -6545,7 +6550,7 @@
           <p:cNvPr id="7" name="">
             <a:extLst xmlns:a="http://schemas.openxmlformats.org/drawingml/2006/main">
               <a:ext uri="{FF2B5EF4-FFF2-40B4-BE49-F238E27FC236}">
-                <a16:creationId xmlns:a16="http://schemas.microsoft.com/office/drawing/2014/main" id="{18B93153-3291-4BF7-AB63-22CE89147489}"/>
+                <a16:creationId xmlns:a16="http://schemas.microsoft.com/office/drawing/2014/main" id="{0ED069DC-B6FE-4382-B970-B1F400AFDDDC}"/>
               </a:ext>
             </a:extLst>
           </p:cNvPr>
@@ -6555,7 +6560,7 @@
           <p:nvPr/>
         </p:nvPicPr>
         <p:blipFill>
-          <a:blip xmlns:r="http://schemas.openxmlformats.org/officeDocument/2006/relationships" xmlns:a="http://schemas.openxmlformats.org/drawingml/2006/main" r:embed="R443a406128814aa4"/>
+          <a:blip xmlns:r="http://schemas.openxmlformats.org/officeDocument/2006/relationships" xmlns:a="http://schemas.openxmlformats.org/drawingml/2006/main" r:embed="R8f969585bcf04dcb"/>
           <a:stretch xmlns:a="http://schemas.openxmlformats.org/drawingml/2006/main"/>
         </p:blipFill>
         <p:spPr>
@@ -6741,7 +6746,7 @@
           <p:cNvPr id="9" name="cover-rule">
             <a:extLst xmlns:a="http://schemas.openxmlformats.org/drawingml/2006/main">
               <a:ext uri="{FF2B5EF4-FFF2-40B4-BE49-F238E27FC236}">
-                <a16:creationId xmlns:a16="http://schemas.microsoft.com/office/drawing/2014/main" id="{5CA45356-8639-4EBD-805C-C5116709A9B9}"/>
+                <a16:creationId xmlns:a16="http://schemas.microsoft.com/office/drawing/2014/main" id="{2A9BE19D-AA7B-4DA4-B1B5-86AADA30F929}"/>
               </a:ext>
             </a:extLst>
           </p:cNvPr>
@@ -7637,7 +7642,7 @@
           <p:cNvPr id="6" name="footer-rule">
             <a:extLst xmlns:a="http://schemas.openxmlformats.org/drawingml/2006/main">
               <a:ext uri="{FF2B5EF4-FFF2-40B4-BE49-F238E27FC236}">
-                <a16:creationId xmlns:a16="http://schemas.microsoft.com/office/drawing/2014/main" id="{6678DE10-754F-4619-8EDE-1527F50BB2A0}"/>
+                <a16:creationId xmlns:a16="http://schemas.microsoft.com/office/drawing/2014/main" id="{998944C6-A8BE-4809-82A4-96F957436524}"/>
               </a:ext>
             </a:extLst>
           </p:cNvPr>
@@ -7832,7 +7837,7 @@
           <p:cNvPr id="8" name="">
             <a:extLst xmlns:a="http://schemas.openxmlformats.org/drawingml/2006/main">
               <a:ext uri="{FF2B5EF4-FFF2-40B4-BE49-F238E27FC236}">
-                <a16:creationId xmlns:a16="http://schemas.microsoft.com/office/drawing/2014/main" id="{759A79F0-3F2D-4B3F-BBC2-CB984BE98F81}"/>
+                <a16:creationId xmlns:a16="http://schemas.microsoft.com/office/drawing/2014/main" id="{6EBE6838-E91B-47A0-90DB-EC1F8FCE7F76}"/>
               </a:ext>
             </a:extLst>
           </p:cNvPr>
@@ -9369,7 +9374,7 @@
           <p:cNvPr id="6" name="footer-rule">
             <a:extLst xmlns:a="http://schemas.openxmlformats.org/drawingml/2006/main">
               <a:ext uri="{FF2B5EF4-FFF2-40B4-BE49-F238E27FC236}">
-                <a16:creationId xmlns:a16="http://schemas.microsoft.com/office/drawing/2014/main" id="{6C825383-1D2F-4284-83D9-BA4B062CABB4}"/>
+                <a16:creationId xmlns:a16="http://schemas.microsoft.com/office/drawing/2014/main" id="{95B0F024-59D4-4D99-8A24-D8B7F8D1629E}"/>
               </a:ext>
             </a:extLst>
           </p:cNvPr>
@@ -9924,7 +9929,7 @@
           <p:cNvPr id="10" name="">
             <a:extLst xmlns:a="http://schemas.openxmlformats.org/drawingml/2006/main">
               <a:ext uri="{FF2B5EF4-FFF2-40B4-BE49-F238E27FC236}">
-                <a16:creationId xmlns:a16="http://schemas.microsoft.com/office/drawing/2014/main" id="{75644472-1036-4226-A1BF-1DC801DA8C9D}"/>
+                <a16:creationId xmlns:a16="http://schemas.microsoft.com/office/drawing/2014/main" id="{8DC5CCA0-FF37-4D95-882E-81A56BEA168E}"/>
               </a:ext>
             </a:extLst>
           </p:cNvPr>
@@ -11319,7 +11324,7 @@
           <p:cNvPr id="6" name="footer-rule">
             <a:extLst xmlns:a="http://schemas.openxmlformats.org/drawingml/2006/main">
               <a:ext uri="{FF2B5EF4-FFF2-40B4-BE49-F238E27FC236}">
-                <a16:creationId xmlns:a16="http://schemas.microsoft.com/office/drawing/2014/main" id="{3EA4BC4D-D15F-4373-94C3-BF5B934D9DD1}"/>
+                <a16:creationId xmlns:a16="http://schemas.microsoft.com/office/drawing/2014/main" id="{0E30B428-23FB-4982-8F9C-9122E68DD724}"/>
               </a:ext>
             </a:extLst>
           </p:cNvPr>
@@ -12008,7 +12013,7 @@
                 <a:ea typeface="Noto Sans Kr"/>
                 <a:cs typeface="Noto Sans Kr"/>
               </a:rPr>
-              <a:t>조회 전에 지지·반증 조건 기록</a:t>
+              <a:t>예: CPU 기여 70% 이상이면 지지</a:t>
             </a:r>
           </a:p>
         </p:txBody>
@@ -13530,7 +13535,7 @@
           <p:cNvPr id="20" name="">
             <a:extLst xmlns:a="http://schemas.openxmlformats.org/drawingml/2006/main">
               <a:ext uri="{FF2B5EF4-FFF2-40B4-BE49-F238E27FC236}">
-                <a16:creationId xmlns:a16="http://schemas.microsoft.com/office/drawing/2014/main" id="{B284B7DF-EBC1-47CE-9060-8138FD9D0D88}"/>
+                <a16:creationId xmlns:a16="http://schemas.microsoft.com/office/drawing/2014/main" id="{AB1C9F5B-A610-4571-A9D1-C42D8B0B160F}"/>
               </a:ext>
             </a:extLst>
           </p:cNvPr>
@@ -13540,7 +13545,7 @@
           <p:nvPr/>
         </p:nvPicPr>
         <p:blipFill>
-          <a:blip xmlns:r="http://schemas.openxmlformats.org/officeDocument/2006/relationships" xmlns:a="http://schemas.openxmlformats.org/drawingml/2006/main" r:embed="R6a29252292404dc2"/>
+          <a:blip xmlns:r="http://schemas.openxmlformats.org/officeDocument/2006/relationships" xmlns:a="http://schemas.openxmlformats.org/drawingml/2006/main" r:embed="R1d16bbf28cc04a69"/>
           <a:srcRect xmlns:a="http://schemas.openxmlformats.org/drawingml/2006/main" l="19000" t="41000" r="24000" b="9000"/>
           <a:stretch xmlns:a="http://schemas.openxmlformats.org/drawingml/2006/main"/>
         </p:blipFill>
@@ -14442,7 +14447,7 @@
                 <a:ea typeface="Noto Sans Kr"/>
                 <a:cs typeface="Noto Sans Kr"/>
               </a:rPr>
-              <a:t>화면·백엔드·AI의 책임을 나누고, 조회와 평가 경로를 연결했습니다.</a:t>
+              <a:t>Supervisor가 전문 조회·추가 조사를 조정하고, 진행 상황과 근거를 기록합니다.</a:t>
             </a:r>
           </a:p>
         </p:txBody>
@@ -14620,7 +14625,7 @@
           <p:cNvPr id="6" name="footer-rule">
             <a:extLst xmlns:a="http://schemas.openxmlformats.org/drawingml/2006/main">
               <a:ext uri="{FF2B5EF4-FFF2-40B4-BE49-F238E27FC236}">
-                <a16:creationId xmlns:a16="http://schemas.microsoft.com/office/drawing/2014/main" id="{46095F37-403B-4381-AA71-9AF15A742E44}"/>
+                <a16:creationId xmlns:a16="http://schemas.microsoft.com/office/drawing/2014/main" id="{341A7BD7-5CE5-4619-A922-F8022C186BDC}"/>
               </a:ext>
             </a:extLst>
           </p:cNvPr>
@@ -14815,7 +14820,7 @@
           <p:cNvPr id="8" name="architecture-link">
             <a:extLst xmlns:a="http://schemas.openxmlformats.org/drawingml/2006/main">
               <a:ext uri="{FF2B5EF4-FFF2-40B4-BE49-F238E27FC236}">
-                <a16:creationId xmlns:a16="http://schemas.microsoft.com/office/drawing/2014/main" id="{B930400F-8601-47D6-AF81-0FA94E4B8C38}"/>
+                <a16:creationId xmlns:a16="http://schemas.microsoft.com/office/drawing/2014/main" id="{C77D24FD-1CA6-4ADB-8E48-588BD1023FBC}"/>
               </a:ext>
             </a:extLst>
           </p:cNvPr>
@@ -14843,7 +14848,7 @@
           <p:cNvPr id="9" name="architecture-link">
             <a:extLst xmlns:a="http://schemas.openxmlformats.org/drawingml/2006/main">
               <a:ext uri="{FF2B5EF4-FFF2-40B4-BE49-F238E27FC236}">
-                <a16:creationId xmlns:a16="http://schemas.microsoft.com/office/drawing/2014/main" id="{29C1F7E6-292E-433F-90DA-DF58F685719B}"/>
+                <a16:creationId xmlns:a16="http://schemas.microsoft.com/office/drawing/2014/main" id="{7549AAD0-17BD-4262-A9E9-B7F5AF773F98}"/>
               </a:ext>
             </a:extLst>
           </p:cNvPr>
@@ -15207,7 +15212,7 @@
           <p:cNvPr id="12" name="architecture-link">
             <a:extLst xmlns:a="http://schemas.openxmlformats.org/drawingml/2006/main">
               <a:ext uri="{FF2B5EF4-FFF2-40B4-BE49-F238E27FC236}">
-                <a16:creationId xmlns:a16="http://schemas.microsoft.com/office/drawing/2014/main" id="{62842D1A-1D02-436B-8B54-478E4B735D2A}"/>
+                <a16:creationId xmlns:a16="http://schemas.microsoft.com/office/drawing/2014/main" id="{05D2CF16-EED3-48A3-9DD3-711E010C193F}"/>
               </a:ext>
             </a:extLst>
           </p:cNvPr>
@@ -15403,7 +15408,7 @@
           <p:cNvPr id="14" name="architecture-link">
             <a:extLst xmlns:a="http://schemas.openxmlformats.org/drawingml/2006/main">
               <a:ext uri="{FF2B5EF4-FFF2-40B4-BE49-F238E27FC236}">
-                <a16:creationId xmlns:a16="http://schemas.microsoft.com/office/drawing/2014/main" id="{60E636DA-60F8-432E-B213-7F2103F2E173}"/>
+                <a16:creationId xmlns:a16="http://schemas.microsoft.com/office/drawing/2014/main" id="{89DC51EA-D715-4184-95D4-7A1441837884}"/>
               </a:ext>
             </a:extLst>
           </p:cNvPr>
@@ -15431,7 +15436,7 @@
           <p:cNvPr id="15" name="architecture-link">
             <a:extLst xmlns:a="http://schemas.openxmlformats.org/drawingml/2006/main">
               <a:ext uri="{FF2B5EF4-FFF2-40B4-BE49-F238E27FC236}">
-                <a16:creationId xmlns:a16="http://schemas.microsoft.com/office/drawing/2014/main" id="{7F924EA7-2542-4342-AA00-6EAE1557D68E}"/>
+                <a16:creationId xmlns:a16="http://schemas.microsoft.com/office/drawing/2014/main" id="{F63722EE-32BA-4E89-BC4A-5BCF7DA19893}"/>
               </a:ext>
             </a:extLst>
           </p:cNvPr>
@@ -15460,7 +15465,7 @@
           <p:cNvPr id="16" name="architecture-link">
             <a:extLst xmlns:a="http://schemas.openxmlformats.org/drawingml/2006/main">
               <a:ext uri="{FF2B5EF4-FFF2-40B4-BE49-F238E27FC236}">
-                <a16:creationId xmlns:a16="http://schemas.microsoft.com/office/drawing/2014/main" id="{B16CD55B-C360-4498-96B8-1B4719D831D3}"/>
+                <a16:creationId xmlns:a16="http://schemas.microsoft.com/office/drawing/2014/main" id="{701D1B79-AB05-47AA-8BA1-D02F6CCFF53E}"/>
               </a:ext>
             </a:extLst>
           </p:cNvPr>
@@ -15488,7 +15493,7 @@
           <p:cNvPr id="17" name="architecture-link">
             <a:extLst xmlns:a="http://schemas.openxmlformats.org/drawingml/2006/main">
               <a:ext uri="{FF2B5EF4-FFF2-40B4-BE49-F238E27FC236}">
-                <a16:creationId xmlns:a16="http://schemas.microsoft.com/office/drawing/2014/main" id="{A45969A9-A596-4218-B7A6-565090793DCA}"/>
+                <a16:creationId xmlns:a16="http://schemas.microsoft.com/office/drawing/2014/main" id="{037237E9-9A34-49FB-9510-8F11FEEFAA49}"/>
               </a:ext>
             </a:extLst>
           </p:cNvPr>
@@ -15516,7 +15521,7 @@
           <p:cNvPr id="18" name="architecture-link">
             <a:extLst xmlns:a="http://schemas.openxmlformats.org/drawingml/2006/main">
               <a:ext uri="{FF2B5EF4-FFF2-40B4-BE49-F238E27FC236}">
-                <a16:creationId xmlns:a16="http://schemas.microsoft.com/office/drawing/2014/main" id="{FE9369FD-BD85-4454-B231-52CCF380BC0C}"/>
+                <a16:creationId xmlns:a16="http://schemas.microsoft.com/office/drawing/2014/main" id="{D5AFD136-7DE4-414C-9C6E-F2757E03D3E5}"/>
               </a:ext>
             </a:extLst>
           </p:cNvPr>
@@ -16137,7 +16142,7 @@
                 <a:ea typeface="Noto Sans Kr"/>
                 <a:cs typeface="Noto Sans Kr"/>
               </a:rPr>
-              <a:t>근거 수집·가설 조사</a:t>
+              <a:t>Supervisor · 전문 조회 조정</a:t>
             </a:r>
             <a:br>
               <a:rPr sz="2250">
@@ -16158,7 +16163,7 @@
                 <a:ea typeface="Noto Sans Kr"/>
                 <a:cs typeface="Noto Sans Kr"/>
               </a:rPr>
-              <a:t>사실·조치 조건 검증</a:t>
+              <a:t>가설 조사·보고서 근거 검증</a:t>
             </a:r>
           </a:p>
         </p:txBody>
@@ -18234,7 +18239,7 @@
           <p:cNvPr id="6" name="footer-rule">
             <a:extLst xmlns:a="http://schemas.openxmlformats.org/drawingml/2006/main">
               <a:ext uri="{FF2B5EF4-FFF2-40B4-BE49-F238E27FC236}">
-                <a16:creationId xmlns:a16="http://schemas.microsoft.com/office/drawing/2014/main" id="{F3FF57B9-869B-4749-BB7A-8D2B35D65914}"/>
+                <a16:creationId xmlns:a16="http://schemas.microsoft.com/office/drawing/2014/main" id="{9CCC09CB-DC45-471E-9C8E-ECC598C9800D}"/>
               </a:ext>
             </a:extLst>
           </p:cNvPr>
@@ -18424,12 +18429,377 @@
           </a:p>
         </p:txBody>
       </p:sp>
+      <p:sp>
+        <p:nvSpPr>
+          <p:cNvPr id="9" name="technical-quality">
+            <a:extLst xmlns:a="http://schemas.openxmlformats.org/drawingml/2006/main">
+              <a:ext uri="{FF2B5EF4-FFF2-40B4-BE49-F238E27FC236}">
+                <a16:creationId xmlns:a16="http://schemas.microsoft.com/office/drawing/2014/main" id="{233A2D13-2563-433B-A267-034CA4FF9420}"/>
+              </a:ext>
+            </a:extLst>
+          </p:cNvPr>
+          <p:cNvSpPr>
+            <a:spLocks xmlns:a="http://schemas.openxmlformats.org/drawingml/2006/main" noGrp="1"/>
+          </p:cNvSpPr>
+          <p:nvPr/>
+        </p:nvSpPr>
+        <p:spPr>
+          <a:xfrm xmlns:a="http://schemas.openxmlformats.org/drawingml/2006/main">
+            <a:off x="1143000" y="8286750"/>
+            <a:ext cx="7429500" cy="400050"/>
+          </a:xfrm>
+          <a:prstGeom xmlns:a="http://schemas.openxmlformats.org/drawingml/2006/main" prst="rect">
+            <a:avLst/>
+          </a:prstGeom>
+          <a:noFill xmlns:a="http://schemas.openxmlformats.org/drawingml/2006/main"/>
+          <a:ln xmlns:a="http://schemas.openxmlformats.org/drawingml/2006/main" w="0">
+            <a:noFill/>
+          </a:ln>
+        </p:spPr>
+        <p:txBody>
+          <a:bodyPr xmlns:a="http://schemas.openxmlformats.org/drawingml/2006/main" wrap="none" lIns="0" tIns="0" rIns="0" bIns="0" anchor="t">
+            <a:noAutofit/>
+          </a:bodyPr>
+          <a:lstStyle xmlns:a="http://schemas.openxmlformats.org/drawingml/2006/main">
+            <a:defPPr algn="l">
+              <a:defRPr sz="1950" b="0">
+                <a:solidFill>
+                  <a:srgbClr val="566A80"/>
+                </a:solidFill>
+                <a:latin typeface="Noto Sans Kr"/>
+                <a:ea typeface="Noto Sans Kr"/>
+                <a:cs typeface="Noto Sans Kr"/>
+              </a:defRPr>
+            </a:defPPr>
+            <a:lvl1pPr algn="l">
+              <a:buNone/>
+              <a:defRPr sz="1950" b="0">
+                <a:solidFill>
+                  <a:srgbClr val="566A80"/>
+                </a:solidFill>
+                <a:latin typeface="Noto Sans Kr"/>
+                <a:ea typeface="Noto Sans Kr"/>
+                <a:cs typeface="Noto Sans Kr"/>
+              </a:defRPr>
+            </a:lvl1pPr>
+            <a:lvl2pPr algn="l">
+              <a:buNone/>
+              <a:defRPr sz="1950" b="0">
+                <a:solidFill>
+                  <a:srgbClr val="566A80"/>
+                </a:solidFill>
+                <a:latin typeface="Noto Sans Kr"/>
+                <a:ea typeface="Noto Sans Kr"/>
+                <a:cs typeface="Noto Sans Kr"/>
+              </a:defRPr>
+            </a:lvl2pPr>
+            <a:lvl3pPr algn="l">
+              <a:buNone/>
+              <a:defRPr sz="1950" b="0">
+                <a:solidFill>
+                  <a:srgbClr val="566A80"/>
+                </a:solidFill>
+                <a:latin typeface="Noto Sans Kr"/>
+                <a:ea typeface="Noto Sans Kr"/>
+                <a:cs typeface="Noto Sans Kr"/>
+              </a:defRPr>
+            </a:lvl3pPr>
+            <a:lvl4pPr algn="l">
+              <a:buNone/>
+              <a:defRPr sz="1950" b="0">
+                <a:solidFill>
+                  <a:srgbClr val="566A80"/>
+                </a:solidFill>
+                <a:latin typeface="Noto Sans Kr"/>
+                <a:ea typeface="Noto Sans Kr"/>
+                <a:cs typeface="Noto Sans Kr"/>
+              </a:defRPr>
+            </a:lvl4pPr>
+            <a:lvl5pPr algn="l">
+              <a:buNone/>
+              <a:defRPr sz="1950" b="0">
+                <a:solidFill>
+                  <a:srgbClr val="566A80"/>
+                </a:solidFill>
+                <a:latin typeface="Noto Sans Kr"/>
+                <a:ea typeface="Noto Sans Kr"/>
+                <a:cs typeface="Noto Sans Kr"/>
+              </a:defRPr>
+            </a:lvl5pPr>
+            <a:lvl6pPr algn="l">
+              <a:buNone/>
+              <a:defRPr sz="1950" b="0">
+                <a:solidFill>
+                  <a:srgbClr val="566A80"/>
+                </a:solidFill>
+                <a:latin typeface="Noto Sans Kr"/>
+                <a:ea typeface="Noto Sans Kr"/>
+                <a:cs typeface="Noto Sans Kr"/>
+              </a:defRPr>
+            </a:lvl6pPr>
+            <a:lvl7pPr algn="l">
+              <a:buNone/>
+              <a:defRPr sz="1950" b="0">
+                <a:solidFill>
+                  <a:srgbClr val="566A80"/>
+                </a:solidFill>
+                <a:latin typeface="Noto Sans Kr"/>
+                <a:ea typeface="Noto Sans Kr"/>
+                <a:cs typeface="Noto Sans Kr"/>
+              </a:defRPr>
+            </a:lvl7pPr>
+            <a:lvl8pPr algn="l">
+              <a:buNone/>
+              <a:defRPr sz="1950" b="0">
+                <a:solidFill>
+                  <a:srgbClr val="566A80"/>
+                </a:solidFill>
+                <a:latin typeface="Noto Sans Kr"/>
+                <a:ea typeface="Noto Sans Kr"/>
+                <a:cs typeface="Noto Sans Kr"/>
+              </a:defRPr>
+            </a:lvl8pPr>
+            <a:lvl9pPr algn="l">
+              <a:buNone/>
+              <a:defRPr sz="1950" b="0">
+                <a:solidFill>
+                  <a:srgbClr val="566A80"/>
+                </a:solidFill>
+                <a:latin typeface="Noto Sans Kr"/>
+                <a:ea typeface="Noto Sans Kr"/>
+                <a:cs typeface="Noto Sans Kr"/>
+              </a:defRPr>
+            </a:lvl9pPr>
+          </a:lstStyle>
+          <a:p xmlns:a="http://schemas.openxmlformats.org/drawingml/2006/main">
+            <a:pPr algn="l">
+              <a:buNone/>
+              <a:defRPr sz="1950" b="0">
+                <a:solidFill>
+                  <a:srgbClr val="566A80"/>
+                </a:solidFill>
+                <a:latin typeface="Noto Sans Kr"/>
+                <a:ea typeface="Noto Sans Kr"/>
+                <a:cs typeface="Noto Sans Kr"/>
+              </a:defRPr>
+            </a:pPr>
+            <a:r>
+              <a:rPr sz="1950" b="0">
+                <a:solidFill>
+                  <a:srgbClr val="566A80"/>
+                </a:solidFill>
+                <a:latin typeface="Noto Sans Kr"/>
+                <a:ea typeface="Noto Sans Kr"/>
+                <a:cs typeface="Noto Sans Kr"/>
+              </a:rPr>
+              <a:t>모듈 분리·의존성 주입으로 외부 연결 교체</a:t>
+            </a:r>
+          </a:p>
+        </p:txBody>
+      </p:sp>
+      <p:sp>
+        <p:nvSpPr>
+          <p:cNvPr id="15" name="validation-screenshot-title">
+            <a:extLst xmlns:a="http://schemas.openxmlformats.org/drawingml/2006/main">
+              <a:ext uri="{FF2B5EF4-FFF2-40B4-BE49-F238E27FC236}">
+                <a16:creationId xmlns:a16="http://schemas.microsoft.com/office/drawing/2014/main" id="{5E1A6FDE-0EF8-4165-B20C-1F4680E3AA50}"/>
+              </a:ext>
+            </a:extLst>
+          </p:cNvPr>
+          <p:cNvSpPr>
+            <a:spLocks xmlns:a="http://schemas.openxmlformats.org/drawingml/2006/main" noGrp="1"/>
+          </p:cNvSpPr>
+          <p:nvPr/>
+        </p:nvSpPr>
+        <p:spPr>
+          <a:xfrm xmlns:a="http://schemas.openxmlformats.org/drawingml/2006/main">
+            <a:off x="9144000" y="3333750"/>
+            <a:ext cx="8001000" cy="476250"/>
+          </a:xfrm>
+          <a:prstGeom xmlns:a="http://schemas.openxmlformats.org/drawingml/2006/main" prst="rect">
+            <a:avLst/>
+          </a:prstGeom>
+          <a:noFill xmlns:a="http://schemas.openxmlformats.org/drawingml/2006/main"/>
+          <a:ln xmlns:a="http://schemas.openxmlformats.org/drawingml/2006/main" w="0">
+            <a:noFill/>
+          </a:ln>
+        </p:spPr>
+        <p:txBody>
+          <a:bodyPr xmlns:a="http://schemas.openxmlformats.org/drawingml/2006/main" wrap="none" lIns="0" tIns="0" rIns="0" bIns="0" anchor="t">
+            <a:noAutofit/>
+          </a:bodyPr>
+          <a:lstStyle xmlns:a="http://schemas.openxmlformats.org/drawingml/2006/main">
+            <a:defPPr>
+              <a:defRPr sz="2550" b="1">
+                <a:solidFill>
+                  <a:srgbClr val="2B5BEB"/>
+                </a:solidFill>
+                <a:latin typeface="Noto Sans Bold"/>
+                <a:ea typeface="Noto Sans Bold"/>
+                <a:cs typeface="Noto Sans Bold"/>
+              </a:defRPr>
+            </a:defPPr>
+            <a:lvl1pPr>
+              <a:buNone/>
+              <a:defRPr sz="2550" b="1">
+                <a:solidFill>
+                  <a:srgbClr val="2B5BEB"/>
+                </a:solidFill>
+                <a:latin typeface="Noto Sans Bold"/>
+                <a:ea typeface="Noto Sans Bold"/>
+                <a:cs typeface="Noto Sans Bold"/>
+              </a:defRPr>
+            </a:lvl1pPr>
+            <a:lvl2pPr>
+              <a:buNone/>
+              <a:defRPr sz="2550" b="1">
+                <a:solidFill>
+                  <a:srgbClr val="2B5BEB"/>
+                </a:solidFill>
+                <a:latin typeface="Noto Sans Bold"/>
+                <a:ea typeface="Noto Sans Bold"/>
+                <a:cs typeface="Noto Sans Bold"/>
+              </a:defRPr>
+            </a:lvl2pPr>
+            <a:lvl3pPr>
+              <a:buNone/>
+              <a:defRPr sz="2550" b="1">
+                <a:solidFill>
+                  <a:srgbClr val="2B5BEB"/>
+                </a:solidFill>
+                <a:latin typeface="Noto Sans Bold"/>
+                <a:ea typeface="Noto Sans Bold"/>
+                <a:cs typeface="Noto Sans Bold"/>
+              </a:defRPr>
+            </a:lvl3pPr>
+            <a:lvl4pPr>
+              <a:buNone/>
+              <a:defRPr sz="2550" b="1">
+                <a:solidFill>
+                  <a:srgbClr val="2B5BEB"/>
+                </a:solidFill>
+                <a:latin typeface="Noto Sans Bold"/>
+                <a:ea typeface="Noto Sans Bold"/>
+                <a:cs typeface="Noto Sans Bold"/>
+              </a:defRPr>
+            </a:lvl4pPr>
+            <a:lvl5pPr>
+              <a:buNone/>
+              <a:defRPr sz="2550" b="1">
+                <a:solidFill>
+                  <a:srgbClr val="2B5BEB"/>
+                </a:solidFill>
+                <a:latin typeface="Noto Sans Bold"/>
+                <a:ea typeface="Noto Sans Bold"/>
+                <a:cs typeface="Noto Sans Bold"/>
+              </a:defRPr>
+            </a:lvl5pPr>
+            <a:lvl6pPr>
+              <a:buNone/>
+              <a:defRPr sz="2550" b="1">
+                <a:solidFill>
+                  <a:srgbClr val="2B5BEB"/>
+                </a:solidFill>
+                <a:latin typeface="Noto Sans Bold"/>
+                <a:ea typeface="Noto Sans Bold"/>
+                <a:cs typeface="Noto Sans Bold"/>
+              </a:defRPr>
+            </a:lvl6pPr>
+            <a:lvl7pPr>
+              <a:buNone/>
+              <a:defRPr sz="2550" b="1">
+                <a:solidFill>
+                  <a:srgbClr val="2B5BEB"/>
+                </a:solidFill>
+                <a:latin typeface="Noto Sans Bold"/>
+                <a:ea typeface="Noto Sans Bold"/>
+                <a:cs typeface="Noto Sans Bold"/>
+              </a:defRPr>
+            </a:lvl7pPr>
+            <a:lvl8pPr>
+              <a:buNone/>
+              <a:defRPr sz="2550" b="1">
+                <a:solidFill>
+                  <a:srgbClr val="2B5BEB"/>
+                </a:solidFill>
+                <a:latin typeface="Noto Sans Bold"/>
+                <a:ea typeface="Noto Sans Bold"/>
+                <a:cs typeface="Noto Sans Bold"/>
+              </a:defRPr>
+            </a:lvl8pPr>
+            <a:lvl9pPr>
+              <a:buNone/>
+              <a:defRPr sz="2550" b="1">
+                <a:solidFill>
+                  <a:srgbClr val="2B5BEB"/>
+                </a:solidFill>
+                <a:latin typeface="Noto Sans Bold"/>
+                <a:ea typeface="Noto Sans Bold"/>
+                <a:cs typeface="Noto Sans Bold"/>
+              </a:defRPr>
+            </a:lvl9pPr>
+          </a:lstStyle>
+          <a:p xmlns:a="http://schemas.openxmlformats.org/drawingml/2006/main">
+            <a:pPr>
+              <a:buNone/>
+              <a:defRPr sz="2550" b="1">
+                <a:solidFill>
+                  <a:srgbClr val="2B5BEB"/>
+                </a:solidFill>
+                <a:latin typeface="Noto Sans Bold"/>
+                <a:ea typeface="Noto Sans Bold"/>
+                <a:cs typeface="Noto Sans Bold"/>
+              </a:defRPr>
+            </a:pPr>
+            <a:r>
+              <a:rPr sz="2550" b="1">
+                <a:solidFill>
+                  <a:srgbClr val="2B5BEB"/>
+                </a:solidFill>
+                <a:latin typeface="Noto Sans Bold"/>
+                <a:ea typeface="Noto Sans Bold"/>
+                <a:cs typeface="Noto Sans Bold"/>
+              </a:rPr>
+              <a:t>실제 프론트의 최종 검증 결과</a:t>
+            </a:r>
+          </a:p>
+        </p:txBody>
+      </p:sp>
+      <p:pic>
+        <p:nvPicPr>
+          <p:cNvPr id="16" name="">
+            <a:extLst xmlns:a="http://schemas.openxmlformats.org/drawingml/2006/main">
+              <a:ext uri="{FF2B5EF4-FFF2-40B4-BE49-F238E27FC236}">
+                <a16:creationId xmlns:a16="http://schemas.microsoft.com/office/drawing/2014/main" id="{D2312597-6485-468B-ADD5-119840B2B82E}"/>
+              </a:ext>
+            </a:extLst>
+          </p:cNvPr>
+          <p:cNvPicPr>
+            <a:picLocks xmlns:a="http://schemas.openxmlformats.org/drawingml/2006/main" noChangeAspect="1"/>
+          </p:cNvPicPr>
+          <p:nvPr/>
+        </p:nvPicPr>
+        <p:blipFill>
+          <a:blip xmlns:r="http://schemas.openxmlformats.org/officeDocument/2006/relationships" xmlns:a="http://schemas.openxmlformats.org/drawingml/2006/main" r:embed="R1e3ecdbd7ec8439f"/>
+          <a:srcRect xmlns:a="http://schemas.openxmlformats.org/drawingml/2006/main" l="78516" t="35833" r="1953" b="41944"/>
+          <a:stretch xmlns:a="http://schemas.openxmlformats.org/drawingml/2006/main"/>
+        </p:blipFill>
+        <p:spPr>
+          <a:xfrm xmlns:a="http://schemas.openxmlformats.org/drawingml/2006/main">
+            <a:off x="9334500" y="3905250"/>
+            <a:ext cx="7239000" cy="4632960"/>
+          </a:xfrm>
+          <a:prstGeom xmlns:a="http://schemas.openxmlformats.org/drawingml/2006/main" prst="rect">
+            <a:avLst/>
+          </a:prstGeom>
+        </p:spPr>
+      </p:pic>
       <p:graphicFrame>
         <p:nvGraphicFramePr>
-          <p:cNvPr id="8" name="">
+          <p:cNvPr id="17" name="">
             <a:extLst xmlns:a="http://schemas.openxmlformats.org/drawingml/2006/main">
               <a:ext uri="{FF2B5EF4-FFF2-40B4-BE49-F238E27FC236}">
-                <a16:creationId xmlns:a16="http://schemas.microsoft.com/office/drawing/2014/main" id="{94B40EA3-C170-4F4E-9BA2-1C635349DB3E}"/>
+                <a16:creationId xmlns:a16="http://schemas.microsoft.com/office/drawing/2014/main" id="{CC718DF8-AFD2-451E-94A0-C564B5F4277A}"/>
               </a:ext>
             </a:extLst>
           </p:cNvPr>
@@ -18438,7 +18808,7 @@
         </p:nvGraphicFramePr>
         <p:xfrm>
           <a:off xmlns:a="http://schemas.openxmlformats.org/drawingml/2006/main" x="1143000" y="3333750"/>
-          <a:ext xmlns:a="http://schemas.openxmlformats.org/drawingml/2006/main" cx="7239000" cy="4724400"/>
+          <a:ext xmlns:a="http://schemas.openxmlformats.org/drawingml/2006/main" cx="7239000" cy="4552950"/>
         </p:xfrm>
         <a:graphic xmlns:a="http://schemas.openxmlformats.org/drawingml/2006/main">
           <a:graphicData uri="http://schemas.openxmlformats.org/drawingml/2006/table">
@@ -18511,7 +18881,7 @@
                           <a:ea typeface="Noto Sans Bold"/>
                           <a:cs typeface="Noto Sans Bold"/>
                         </a:rPr>
-                        <a:t>역할·실행 결과</a:t>
+                        <a:t>역할과 선택 이유</a:t>
                       </a:r>
                     </a:p>
                   </a:txBody>
@@ -18597,7 +18967,7 @@
                           <a:ea typeface="Noto Sans Kr"/>
                           <a:cs typeface="Noto Sans Kr"/>
                         </a:rPr>
-                        <a:t>전문 조회 병렬 실행</a:t>
+                        <a:t>전문 역할 분리·조건부 반복</a:t>
                       </a:r>
                     </a:p>
                     <a:p>
@@ -18610,7 +18980,7 @@
                           <a:ea typeface="Noto Sans Kr"/>
                           <a:cs typeface="Noto Sans Kr"/>
                         </a:rPr>
-                        <a:t>조건부 조사 조정</a:t>
+                        <a:t>지표·로그 병렬 조회</a:t>
                       </a:r>
                     </a:p>
                   </a:txBody>
@@ -18633,7 +19003,7 @@
                   </a:tcPr>
                 </a:tc>
               </a:tr>
-              <a:tr h="704850">
+              <a:tr h="1200150">
                 <a:tc>
                   <a:txBody>
                     <a:bodyPr/>
@@ -18690,7 +19060,33 @@
                           <a:ea typeface="Noto Sans Kr"/>
                           <a:cs typeface="Noto Sans Kr"/>
                         </a:rPr>
-                        <a:t>Tool · Resource · Prompt</a:t>
+                        <a:t>Tool: 관측 조회</a:t>
+                      </a:r>
+                    </a:p>
+                    <a:p>
+                      <a:r>
+                        <a:rPr sz="2100">
+                          <a:solidFill>
+                            <a:srgbClr val="122C46"/>
+                          </a:solidFill>
+                          <a:latin typeface="Noto Sans Kr"/>
+                          <a:ea typeface="Noto Sans Kr"/>
+                          <a:cs typeface="Noto Sans Kr"/>
+                        </a:rPr>
+                        <a:t>Resource: 런북 원문</a:t>
+                      </a:r>
+                    </a:p>
+                    <a:p>
+                      <a:r>
+                        <a:rPr sz="2100">
+                          <a:solidFill>
+                            <a:srgbClr val="122C46"/>
+                          </a:solidFill>
+                          <a:latin typeface="Noto Sans Kr"/>
+                          <a:ea typeface="Noto Sans Kr"/>
+                          <a:cs typeface="Noto Sans Kr"/>
+                        </a:rPr>
+                        <a:t>Prompt: 공통 조사 절차</a:t>
                       </a:r>
                     </a:p>
                   </a:txBody>
@@ -18713,7 +19109,7 @@
                   </a:tcPr>
                 </a:tc>
               </a:tr>
-              <a:tr h="1047750">
+              <a:tr h="1200150">
                 <a:tc>
                   <a:txBody>
                     <a:bodyPr/>
@@ -18770,7 +19166,7 @@
                           <a:ea typeface="Noto Sans Kr"/>
                           <a:cs typeface="Noto Sans Kr"/>
                         </a:rPr>
-                        <a:t>CPU 급증 대응 절차 등</a:t>
+                        <a:t>매뉴얼 6종·최대 3종 검색</a:t>
                       </a:r>
                     </a:p>
                     <a:p>
@@ -18783,7 +19179,20 @@
                           <a:ea typeface="Noto Sans Kr"/>
                           <a:cs typeface="Noto Sans Kr"/>
                         </a:rPr>
-                        <a:t>관련 런북 3종 검색</a:t>
+                        <a:t>SQLite 벡터 저장</a:t>
+                      </a:r>
+                    </a:p>
+                    <a:p>
+                      <a:r>
+                        <a:rPr sz="2100">
+                          <a:solidFill>
+                            <a:srgbClr val="122C46"/>
+                          </a:solidFill>
+                          <a:latin typeface="Noto Sans Kr"/>
+                          <a:ea typeface="Noto Sans Kr"/>
+                          <a:cs typeface="Noto Sans Kr"/>
+                        </a:rPr>
+                        <a:t>NumPy 유사도 계산</a:t>
                       </a:r>
                     </a:p>
                   </a:txBody>
@@ -18863,87 +19272,7 @@
                           <a:ea typeface="Noto Sans Kr"/>
                           <a:cs typeface="Noto Sans Kr"/>
                         </a:rPr>
-                        <a:t>보고서 후보 작성·파싱</a:t>
-                      </a:r>
-                    </a:p>
-                  </a:txBody>
-                  <a:tcPr marL="266700" marR="228600" marT="114300" marB="114300" anchor="ctr">
-                    <a:lnR w="9525">
-                      <a:solidFill>
-                        <a:srgbClr val="DDE5EE"/>
-                      </a:solidFill>
-                      <a:prstDash val="solid"/>
-                    </a:lnR>
-                    <a:lnB w="9525">
-                      <a:solidFill>
-                        <a:srgbClr val="DDE5EE"/>
-                      </a:solidFill>
-                      <a:prstDash val="solid"/>
-                    </a:lnB>
-                    <a:solidFill>
-                      <a:srgbClr val="FFFFFF"/>
-                    </a:solidFill>
-                  </a:tcPr>
-                </a:tc>
-              </a:tr>
-              <a:tr h="819150">
-                <a:tc>
-                  <a:txBody>
-                    <a:bodyPr/>
-                    <a:lstStyle/>
-                    <a:p>
-                      <a:r>
-                        <a:rPr sz="2100">
-                          <a:solidFill>
-                            <a:srgbClr val="122C46"/>
-                          </a:solidFill>
-                          <a:latin typeface="Noto Sans Kr"/>
-                          <a:ea typeface="Noto Sans Kr"/>
-                          <a:cs typeface="Noto Sans Kr"/>
-                        </a:rPr>
-                        <a:t>평가·추적</a:t>
-                      </a:r>
-                    </a:p>
-                  </a:txBody>
-                  <a:tcPr marL="266700" marR="228600" marT="114300" marB="114300" anchor="ctr">
-                    <a:lnL w="9525">
-                      <a:solidFill>
-                        <a:srgbClr val="DDE5EE"/>
-                      </a:solidFill>
-                      <a:prstDash val="solid"/>
-                    </a:lnL>
-                    <a:lnR w="9525">
-                      <a:solidFill>
-                        <a:srgbClr val="DDE5EE"/>
-                      </a:solidFill>
-                      <a:prstDash val="solid"/>
-                    </a:lnR>
-                    <a:lnB w="9525">
-                      <a:solidFill>
-                        <a:srgbClr val="DDE5EE"/>
-                      </a:solidFill>
-                      <a:prstDash val="solid"/>
-                    </a:lnB>
-                    <a:solidFill>
-                      <a:srgbClr val="FFFFFF"/>
-                    </a:solidFill>
-                  </a:tcPr>
-                </a:tc>
-                <a:tc>
-                  <a:txBody>
-                    <a:bodyPr/>
-                    <a:lstStyle/>
-                    <a:p>
-                      <a:r>
-                        <a:rPr sz="2100">
-                          <a:solidFill>
-                            <a:srgbClr val="122C46"/>
-                          </a:solidFill>
-                          <a:latin typeface="Noto Sans Kr"/>
-                          <a:ea typeface="Noto Sans Kr"/>
-                          <a:cs typeface="Noto Sans Kr"/>
-                        </a:rPr>
-                        <a:t>Judge · LangSmith</a:t>
+                        <a:t>프롬프트·모델·파서 연결</a:t>
                       </a:r>
                     </a:p>
                   </a:txBody>
@@ -18970,361 +19299,6 @@
           </a:graphicData>
         </a:graphic>
       </p:graphicFrame>
-      <p:sp>
-        <p:nvSpPr>
-          <p:cNvPr id="9" name="technical-quality">
-            <a:extLst xmlns:a="http://schemas.openxmlformats.org/drawingml/2006/main">
-              <a:ext uri="{FF2B5EF4-FFF2-40B4-BE49-F238E27FC236}">
-                <a16:creationId xmlns:a16="http://schemas.microsoft.com/office/drawing/2014/main" id="{233A2D13-2563-433B-A267-034CA4FF9420}"/>
-              </a:ext>
-            </a:extLst>
-          </p:cNvPr>
-          <p:cNvSpPr>
-            <a:spLocks xmlns:a="http://schemas.openxmlformats.org/drawingml/2006/main" noGrp="1"/>
-          </p:cNvSpPr>
-          <p:nvPr/>
-        </p:nvSpPr>
-        <p:spPr>
-          <a:xfrm xmlns:a="http://schemas.openxmlformats.org/drawingml/2006/main">
-            <a:off x="1143000" y="8286750"/>
-            <a:ext cx="7429500" cy="400050"/>
-          </a:xfrm>
-          <a:prstGeom xmlns:a="http://schemas.openxmlformats.org/drawingml/2006/main" prst="rect">
-            <a:avLst/>
-          </a:prstGeom>
-          <a:noFill xmlns:a="http://schemas.openxmlformats.org/drawingml/2006/main"/>
-          <a:ln xmlns:a="http://schemas.openxmlformats.org/drawingml/2006/main" w="0">
-            <a:noFill/>
-          </a:ln>
-        </p:spPr>
-        <p:txBody>
-          <a:bodyPr xmlns:a="http://schemas.openxmlformats.org/drawingml/2006/main" wrap="none" lIns="0" tIns="0" rIns="0" bIns="0" anchor="t">
-            <a:noAutofit/>
-          </a:bodyPr>
-          <a:lstStyle xmlns:a="http://schemas.openxmlformats.org/drawingml/2006/main">
-            <a:defPPr algn="l">
-              <a:defRPr sz="1950" b="0">
-                <a:solidFill>
-                  <a:srgbClr val="566A80"/>
-                </a:solidFill>
-                <a:latin typeface="Noto Sans Kr"/>
-                <a:ea typeface="Noto Sans Kr"/>
-                <a:cs typeface="Noto Sans Kr"/>
-              </a:defRPr>
-            </a:defPPr>
-            <a:lvl1pPr algn="l">
-              <a:buNone/>
-              <a:defRPr sz="1950" b="0">
-                <a:solidFill>
-                  <a:srgbClr val="566A80"/>
-                </a:solidFill>
-                <a:latin typeface="Noto Sans Kr"/>
-                <a:ea typeface="Noto Sans Kr"/>
-                <a:cs typeface="Noto Sans Kr"/>
-              </a:defRPr>
-            </a:lvl1pPr>
-            <a:lvl2pPr algn="l">
-              <a:buNone/>
-              <a:defRPr sz="1950" b="0">
-                <a:solidFill>
-                  <a:srgbClr val="566A80"/>
-                </a:solidFill>
-                <a:latin typeface="Noto Sans Kr"/>
-                <a:ea typeface="Noto Sans Kr"/>
-                <a:cs typeface="Noto Sans Kr"/>
-              </a:defRPr>
-            </a:lvl2pPr>
-            <a:lvl3pPr algn="l">
-              <a:buNone/>
-              <a:defRPr sz="1950" b="0">
-                <a:solidFill>
-                  <a:srgbClr val="566A80"/>
-                </a:solidFill>
-                <a:latin typeface="Noto Sans Kr"/>
-                <a:ea typeface="Noto Sans Kr"/>
-                <a:cs typeface="Noto Sans Kr"/>
-              </a:defRPr>
-            </a:lvl3pPr>
-            <a:lvl4pPr algn="l">
-              <a:buNone/>
-              <a:defRPr sz="1950" b="0">
-                <a:solidFill>
-                  <a:srgbClr val="566A80"/>
-                </a:solidFill>
-                <a:latin typeface="Noto Sans Kr"/>
-                <a:ea typeface="Noto Sans Kr"/>
-                <a:cs typeface="Noto Sans Kr"/>
-              </a:defRPr>
-            </a:lvl4pPr>
-            <a:lvl5pPr algn="l">
-              <a:buNone/>
-              <a:defRPr sz="1950" b="0">
-                <a:solidFill>
-                  <a:srgbClr val="566A80"/>
-                </a:solidFill>
-                <a:latin typeface="Noto Sans Kr"/>
-                <a:ea typeface="Noto Sans Kr"/>
-                <a:cs typeface="Noto Sans Kr"/>
-              </a:defRPr>
-            </a:lvl5pPr>
-            <a:lvl6pPr algn="l">
-              <a:buNone/>
-              <a:defRPr sz="1950" b="0">
-                <a:solidFill>
-                  <a:srgbClr val="566A80"/>
-                </a:solidFill>
-                <a:latin typeface="Noto Sans Kr"/>
-                <a:ea typeface="Noto Sans Kr"/>
-                <a:cs typeface="Noto Sans Kr"/>
-              </a:defRPr>
-            </a:lvl6pPr>
-            <a:lvl7pPr algn="l">
-              <a:buNone/>
-              <a:defRPr sz="1950" b="0">
-                <a:solidFill>
-                  <a:srgbClr val="566A80"/>
-                </a:solidFill>
-                <a:latin typeface="Noto Sans Kr"/>
-                <a:ea typeface="Noto Sans Kr"/>
-                <a:cs typeface="Noto Sans Kr"/>
-              </a:defRPr>
-            </a:lvl7pPr>
-            <a:lvl8pPr algn="l">
-              <a:buNone/>
-              <a:defRPr sz="1950" b="0">
-                <a:solidFill>
-                  <a:srgbClr val="566A80"/>
-                </a:solidFill>
-                <a:latin typeface="Noto Sans Kr"/>
-                <a:ea typeface="Noto Sans Kr"/>
-                <a:cs typeface="Noto Sans Kr"/>
-              </a:defRPr>
-            </a:lvl8pPr>
-            <a:lvl9pPr algn="l">
-              <a:buNone/>
-              <a:defRPr sz="1950" b="0">
-                <a:solidFill>
-                  <a:srgbClr val="566A80"/>
-                </a:solidFill>
-                <a:latin typeface="Noto Sans Kr"/>
-                <a:ea typeface="Noto Sans Kr"/>
-                <a:cs typeface="Noto Sans Kr"/>
-              </a:defRPr>
-            </a:lvl9pPr>
-          </a:lstStyle>
-          <a:p xmlns:a="http://schemas.openxmlformats.org/drawingml/2006/main">
-            <a:pPr algn="l">
-              <a:buNone/>
-              <a:defRPr sz="1950" b="0">
-                <a:solidFill>
-                  <a:srgbClr val="566A80"/>
-                </a:solidFill>
-                <a:latin typeface="Noto Sans Kr"/>
-                <a:ea typeface="Noto Sans Kr"/>
-                <a:cs typeface="Noto Sans Kr"/>
-              </a:defRPr>
-            </a:pPr>
-            <a:r>
-              <a:rPr sz="1950" b="0">
-                <a:solidFill>
-                  <a:srgbClr val="566A80"/>
-                </a:solidFill>
-                <a:latin typeface="Noto Sans Kr"/>
-                <a:ea typeface="Noto Sans Kr"/>
-                <a:cs typeface="Noto Sans Kr"/>
-              </a:rPr>
-              <a:t>모듈화·의존성 주입·단위/API 테스트</a:t>
-            </a:r>
-          </a:p>
-        </p:txBody>
-      </p:sp>
-      <p:sp>
-        <p:nvSpPr>
-          <p:cNvPr id="15" name="validation-screenshot-title">
-            <a:extLst xmlns:a="http://schemas.openxmlformats.org/drawingml/2006/main">
-              <a:ext uri="{FF2B5EF4-FFF2-40B4-BE49-F238E27FC236}">
-                <a16:creationId xmlns:a16="http://schemas.microsoft.com/office/drawing/2014/main" id="{5E1A6FDE-0EF8-4165-B20C-1F4680E3AA50}"/>
-              </a:ext>
-            </a:extLst>
-          </p:cNvPr>
-          <p:cNvSpPr>
-            <a:spLocks xmlns:a="http://schemas.openxmlformats.org/drawingml/2006/main" noGrp="1"/>
-          </p:cNvSpPr>
-          <p:nvPr/>
-        </p:nvSpPr>
-        <p:spPr>
-          <a:xfrm xmlns:a="http://schemas.openxmlformats.org/drawingml/2006/main">
-            <a:off x="9144000" y="3333750"/>
-            <a:ext cx="8001000" cy="476250"/>
-          </a:xfrm>
-          <a:prstGeom xmlns:a="http://schemas.openxmlformats.org/drawingml/2006/main" prst="rect">
-            <a:avLst/>
-          </a:prstGeom>
-          <a:noFill xmlns:a="http://schemas.openxmlformats.org/drawingml/2006/main"/>
-          <a:ln xmlns:a="http://schemas.openxmlformats.org/drawingml/2006/main" w="0">
-            <a:noFill/>
-          </a:ln>
-        </p:spPr>
-        <p:txBody>
-          <a:bodyPr xmlns:a="http://schemas.openxmlformats.org/drawingml/2006/main" wrap="none" lIns="0" tIns="0" rIns="0" bIns="0" anchor="t">
-            <a:noAutofit/>
-          </a:bodyPr>
-          <a:lstStyle xmlns:a="http://schemas.openxmlformats.org/drawingml/2006/main">
-            <a:defPPr>
-              <a:defRPr sz="2550" b="1">
-                <a:solidFill>
-                  <a:srgbClr val="2B5BEB"/>
-                </a:solidFill>
-                <a:latin typeface="Noto Sans Bold"/>
-                <a:ea typeface="Noto Sans Bold"/>
-                <a:cs typeface="Noto Sans Bold"/>
-              </a:defRPr>
-            </a:defPPr>
-            <a:lvl1pPr>
-              <a:defRPr sz="2550" b="1">
-                <a:solidFill>
-                  <a:srgbClr val="2B5BEB"/>
-                </a:solidFill>
-                <a:latin typeface="Noto Sans Bold"/>
-                <a:ea typeface="Noto Sans Bold"/>
-                <a:cs typeface="Noto Sans Bold"/>
-              </a:defRPr>
-            </a:lvl1pPr>
-            <a:lvl2pPr>
-              <a:defRPr sz="2550" b="1">
-                <a:solidFill>
-                  <a:srgbClr val="2B5BEB"/>
-                </a:solidFill>
-                <a:latin typeface="Noto Sans Bold"/>
-                <a:ea typeface="Noto Sans Bold"/>
-                <a:cs typeface="Noto Sans Bold"/>
-              </a:defRPr>
-            </a:lvl2pPr>
-            <a:lvl3pPr>
-              <a:defRPr sz="2550" b="1">
-                <a:solidFill>
-                  <a:srgbClr val="2B5BEB"/>
-                </a:solidFill>
-                <a:latin typeface="Noto Sans Bold"/>
-                <a:ea typeface="Noto Sans Bold"/>
-                <a:cs typeface="Noto Sans Bold"/>
-              </a:defRPr>
-            </a:lvl3pPr>
-            <a:lvl4pPr>
-              <a:defRPr sz="2550" b="1">
-                <a:solidFill>
-                  <a:srgbClr val="2B5BEB"/>
-                </a:solidFill>
-                <a:latin typeface="Noto Sans Bold"/>
-                <a:ea typeface="Noto Sans Bold"/>
-                <a:cs typeface="Noto Sans Bold"/>
-              </a:defRPr>
-            </a:lvl4pPr>
-            <a:lvl5pPr>
-              <a:defRPr sz="2550" b="1">
-                <a:solidFill>
-                  <a:srgbClr val="2B5BEB"/>
-                </a:solidFill>
-                <a:latin typeface="Noto Sans Bold"/>
-                <a:ea typeface="Noto Sans Bold"/>
-                <a:cs typeface="Noto Sans Bold"/>
-              </a:defRPr>
-            </a:lvl5pPr>
-            <a:lvl6pPr>
-              <a:defRPr sz="2550" b="1">
-                <a:solidFill>
-                  <a:srgbClr val="2B5BEB"/>
-                </a:solidFill>
-                <a:latin typeface="Noto Sans Bold"/>
-                <a:ea typeface="Noto Sans Bold"/>
-                <a:cs typeface="Noto Sans Bold"/>
-              </a:defRPr>
-            </a:lvl6pPr>
-            <a:lvl7pPr>
-              <a:defRPr sz="2550" b="1">
-                <a:solidFill>
-                  <a:srgbClr val="2B5BEB"/>
-                </a:solidFill>
-                <a:latin typeface="Noto Sans Bold"/>
-                <a:ea typeface="Noto Sans Bold"/>
-                <a:cs typeface="Noto Sans Bold"/>
-              </a:defRPr>
-            </a:lvl7pPr>
-            <a:lvl8pPr>
-              <a:defRPr sz="2550" b="1">
-                <a:solidFill>
-                  <a:srgbClr val="2B5BEB"/>
-                </a:solidFill>
-                <a:latin typeface="Noto Sans Bold"/>
-                <a:ea typeface="Noto Sans Bold"/>
-                <a:cs typeface="Noto Sans Bold"/>
-              </a:defRPr>
-            </a:lvl8pPr>
-            <a:lvl9pPr>
-              <a:defRPr sz="2550" b="1">
-                <a:solidFill>
-                  <a:srgbClr val="2B5BEB"/>
-                </a:solidFill>
-                <a:latin typeface="Noto Sans Bold"/>
-                <a:ea typeface="Noto Sans Bold"/>
-                <a:cs typeface="Noto Sans Bold"/>
-              </a:defRPr>
-            </a:lvl9pPr>
-          </a:lstStyle>
-          <a:p xmlns:a="http://schemas.openxmlformats.org/drawingml/2006/main">
-            <a:pPr>
-              <a:defRPr sz="2550" b="1">
-                <a:solidFill>
-                  <a:srgbClr val="2B5BEB"/>
-                </a:solidFill>
-                <a:latin typeface="Noto Sans Bold"/>
-                <a:ea typeface="Noto Sans Bold"/>
-                <a:cs typeface="Noto Sans Bold"/>
-              </a:defRPr>
-            </a:pPr>
-            <a:r>
-              <a:rPr sz="2550" b="1">
-                <a:solidFill>
-                  <a:srgbClr val="2B5BEB"/>
-                </a:solidFill>
-                <a:latin typeface="Noto Sans Bold"/>
-                <a:ea typeface="Noto Sans Bold"/>
-                <a:cs typeface="Noto Sans Bold"/>
-              </a:rPr>
-              <a:t>실제 프론트의 최종 검증 결과</a:t>
-            </a:r>
-          </a:p>
-        </p:txBody>
-      </p:sp>
-      <p:pic>
-        <p:nvPicPr>
-          <p:cNvPr id="16" name="">
-            <a:extLst xmlns:a="http://schemas.openxmlformats.org/drawingml/2006/main">
-              <a:ext uri="{FF2B5EF4-FFF2-40B4-BE49-F238E27FC236}">
-                <a16:creationId xmlns:a16="http://schemas.microsoft.com/office/drawing/2014/main" id="{83CDB313-DA00-4E1B-B1AF-7B732EF55B14}"/>
-              </a:ext>
-            </a:extLst>
-          </p:cNvPr>
-          <p:cNvPicPr>
-            <a:picLocks xmlns:a="http://schemas.openxmlformats.org/drawingml/2006/main" noChangeAspect="1"/>
-          </p:cNvPicPr>
-          <p:nvPr/>
-        </p:nvPicPr>
-        <p:blipFill>
-          <a:blip xmlns:r="http://schemas.openxmlformats.org/officeDocument/2006/relationships" xmlns:a="http://schemas.openxmlformats.org/drawingml/2006/main" r:embed="Ra8663917e0584216"/>
-          <a:srcRect xmlns:a="http://schemas.openxmlformats.org/drawingml/2006/main" l="78516" t="35833" r="1953" b="41944"/>
-          <a:stretch xmlns:a="http://schemas.openxmlformats.org/drawingml/2006/main"/>
-        </p:blipFill>
-        <p:spPr>
-          <a:xfrm xmlns:a="http://schemas.openxmlformats.org/drawingml/2006/main">
-            <a:off x="9334500" y="3905250"/>
-            <a:ext cx="7239000" cy="4632960"/>
-          </a:xfrm>
-          <a:prstGeom xmlns:a="http://schemas.openxmlformats.org/drawingml/2006/main" prst="rect">
-            <a:avLst/>
-          </a:prstGeom>
-        </p:spPr>
-      </p:pic>
     </p:spTree>
     <p:extLst>
       <p:ext uri="{BB962C8B-B14F-4D97-AF65-F5344CB8AC3E}">
@@ -20021,7 +19995,7 @@
                 <a:ea typeface="Noto Sans Kr"/>
                 <a:cs typeface="Noto Sans Kr"/>
               </a:rPr>
-              <a:t>전체 통과 수치와 개별 평가 결과를 함께 확인했습니다.</a:t>
+              <a:t>기능 검사와 별도 Judge 평가를 구분하고, 원격 저장까지 확인했습니다.</a:t>
             </a:r>
           </a:p>
         </p:txBody>
@@ -20199,7 +20173,7 @@
           <p:cNvPr id="6" name="footer-rule">
             <a:extLst xmlns:a="http://schemas.openxmlformats.org/drawingml/2006/main">
               <a:ext uri="{FF2B5EF4-FFF2-40B4-BE49-F238E27FC236}">
-                <a16:creationId xmlns:a16="http://schemas.microsoft.com/office/drawing/2014/main" id="{A9070377-A011-4917-B281-EFBA2D17500F}"/>
+                <a16:creationId xmlns:a16="http://schemas.microsoft.com/office/drawing/2014/main" id="{55930782-AA21-4769-BE6D-858D195FABC0}"/>
               </a:ext>
             </a:extLst>
           </p:cNvPr>
@@ -20720,7 +20694,7 @@
                 <a:ea typeface="Noto Sans Bold"/>
                 <a:cs typeface="Noto Sans Bold"/>
               </a:rPr>
-              <a:t>자동 테스트 통과</a:t>
+              <a:t>분기·오류 처리 테스트</a:t>
             </a:r>
           </a:p>
         </p:txBody>
@@ -21402,7 +21376,7 @@
           <p:cNvPr id="14" name="metric-rule-1">
             <a:extLst xmlns:a="http://schemas.openxmlformats.org/drawingml/2006/main">
               <a:ext uri="{FF2B5EF4-FFF2-40B4-BE49-F238E27FC236}">
-                <a16:creationId xmlns:a16="http://schemas.microsoft.com/office/drawing/2014/main" id="{A7734A83-955D-44A2-A64D-CAAE10A92EA2}"/>
+                <a16:creationId xmlns:a16="http://schemas.microsoft.com/office/drawing/2014/main" id="{D3367E63-81FF-4874-8FB2-F0941A08905F}"/>
               </a:ext>
             </a:extLst>
           </p:cNvPr>
@@ -21429,7 +21403,7 @@
           <p:cNvPr id="15" name="metric-rule-2">
             <a:extLst xmlns:a="http://schemas.openxmlformats.org/drawingml/2006/main">
               <a:ext uri="{FF2B5EF4-FFF2-40B4-BE49-F238E27FC236}">
-                <a16:creationId xmlns:a16="http://schemas.microsoft.com/office/drawing/2014/main" id="{5F2FC3B1-4A30-482E-BA45-94C40B8BC49F}"/>
+                <a16:creationId xmlns:a16="http://schemas.microsoft.com/office/drawing/2014/main" id="{3BC0B764-BE30-4CF4-BA26-B4BB15428989}"/>
               </a:ext>
             </a:extLst>
           </p:cNvPr>
@@ -21624,7 +21598,7 @@
           <p:cNvPr id="17" name="">
             <a:extLst xmlns:a="http://schemas.openxmlformats.org/drawingml/2006/main">
               <a:ext uri="{FF2B5EF4-FFF2-40B4-BE49-F238E27FC236}">
-                <a16:creationId xmlns:a16="http://schemas.microsoft.com/office/drawing/2014/main" id="{17E9885E-50C4-4A7C-91DF-F0D33412FE45}"/>
+                <a16:creationId xmlns:a16="http://schemas.microsoft.com/office/drawing/2014/main" id="{527787AD-4052-46C7-9164-7AA3A844C4C8}"/>
               </a:ext>
             </a:extLst>
           </p:cNvPr>
@@ -22994,7 +22968,7 @@
                 <a:ea typeface="Noto Sans Kr"/>
                 <a:cs typeface="Noto Sans Kr"/>
               </a:rPr>
-              <a:t>교차 지지도 인과 확정과 구분합니다.</a:t>
+              <a:t>교차 지지도 인과 확정과 구분합니다. 전체 비용 절감률은 미측정입니다.</a:t>
             </a:r>
           </a:p>
         </p:txBody>
@@ -23004,7 +22978,7 @@
           <p:cNvPr id="6" name="footer-rule">
             <a:extLst xmlns:a="http://schemas.openxmlformats.org/drawingml/2006/main">
               <a:ext uri="{FF2B5EF4-FFF2-40B4-BE49-F238E27FC236}">
-                <a16:creationId xmlns:a16="http://schemas.microsoft.com/office/drawing/2014/main" id="{DD5A732E-67FD-476C-B9D2-13290B0F72F1}"/>
+                <a16:creationId xmlns:a16="http://schemas.microsoft.com/office/drawing/2014/main" id="{22533769-5E50-4BAF-A100-9BB5A800D89C}"/>
               </a:ext>
             </a:extLst>
           </p:cNvPr>
@@ -23199,7 +23173,7 @@
           <p:cNvPr id="8" name="">
             <a:extLst xmlns:a="http://schemas.openxmlformats.org/drawingml/2006/main">
               <a:ext uri="{FF2B5EF4-FFF2-40B4-BE49-F238E27FC236}">
-                <a16:creationId xmlns:a16="http://schemas.microsoft.com/office/drawing/2014/main" id="{CA855FDE-D615-4A12-ABA2-4AC0F0987C01}"/>
+                <a16:creationId xmlns:a16="http://schemas.microsoft.com/office/drawing/2014/main" id="{5ECDF77E-7EA2-4B8B-8B1D-528FB008D77B}"/>
               </a:ext>
             </a:extLst>
           </p:cNvPr>
@@ -23325,87 +23299,7 @@
                           <a:ea typeface="Noto Sans Kr"/>
                           <a:cs typeface="Noto Sans Kr"/>
                         </a:rPr>
-                        <a:t>규칙 필터의 오탐·미탐</a:t>
-                      </a:r>
-                    </a:p>
-                  </a:txBody>
-                  <a:tcPr marL="266700" marR="228600" marT="114300" marB="114300" anchor="ctr">
-                    <a:lnL w="9525">
-                      <a:solidFill>
-                        <a:srgbClr val="DDE5EE"/>
-                      </a:solidFill>
-                      <a:prstDash val="solid"/>
-                    </a:lnL>
-                    <a:lnR w="9525">
-                      <a:solidFill>
-                        <a:srgbClr val="DDE5EE"/>
-                      </a:solidFill>
-                      <a:prstDash val="solid"/>
-                    </a:lnR>
-                    <a:lnB w="9525">
-                      <a:solidFill>
-                        <a:srgbClr val="DDE5EE"/>
-                      </a:solidFill>
-                      <a:prstDash val="solid"/>
-                    </a:lnB>
-                    <a:solidFill>
-                      <a:srgbClr val="FFFFFF"/>
-                    </a:solidFill>
-                  </a:tcPr>
-                </a:tc>
-                <a:tc>
-                  <a:txBody>
-                    <a:bodyPr/>
-                    <a:lstStyle/>
-                    <a:p>
-                      <a:r>
-                        <a:rPr sz="2400">
-                          <a:solidFill>
-                            <a:srgbClr val="122C46"/>
-                          </a:solidFill>
-                          <a:latin typeface="Noto Sans Kr"/>
-                          <a:ea typeface="Noto Sans Kr"/>
-                          <a:cs typeface="Noto Sans Kr"/>
-                        </a:rPr>
-                        <a:t>사람 라벨로 입력 정확도 측정</a:t>
-                      </a:r>
-                    </a:p>
-                  </a:txBody>
-                  <a:tcPr marL="266700" marR="228600" marT="114300" marB="114300" anchor="ctr">
-                    <a:lnR w="9525">
-                      <a:solidFill>
-                        <a:srgbClr val="DDE5EE"/>
-                      </a:solidFill>
-                      <a:prstDash val="solid"/>
-                    </a:lnR>
-                    <a:lnB w="9525">
-                      <a:solidFill>
-                        <a:srgbClr val="DDE5EE"/>
-                      </a:solidFill>
-                      <a:prstDash val="solid"/>
-                    </a:lnB>
-                    <a:solidFill>
-                      <a:srgbClr val="FFFFFF"/>
-                    </a:solidFill>
-                  </a:tcPr>
-                </a:tc>
-              </a:tr>
-              <a:tr h="1028700">
-                <a:tc>
-                  <a:txBody>
-                    <a:bodyPr/>
-                    <a:lstStyle/>
-                    <a:p>
-                      <a:r>
-                        <a:rPr sz="2400">
-                          <a:solidFill>
-                            <a:srgbClr val="122C46"/>
-                          </a:solidFill>
-                          <a:latin typeface="Noto Sans Kr"/>
-                          <a:ea typeface="Noto Sans Kr"/>
-                          <a:cs typeface="Noto Sans Kr"/>
-                        </a:rPr>
-                        <a:t>CPU 세 가설·합성 관측·최대 4회</a:t>
+                        <a:t>CPU 세 가설·합성 관측</a:t>
                       </a:r>
                     </a:p>
                   </a:txBody>
@@ -23485,7 +23379,7 @@
                           <a:ea typeface="Noto Sans Kr"/>
                           <a:cs typeface="Noto Sans Kr"/>
                         </a:rPr>
-                        <a:t>Judge 편향·전체 비용 효과 미측정</a:t>
+                        <a:t>조회 한도로 미확인 가설 잔존</a:t>
                       </a:r>
                     </a:p>
                   </a:txBody>
@@ -23527,7 +23421,87 @@
                           <a:ea typeface="Noto Sans Kr"/>
                           <a:cs typeface="Noto Sans Kr"/>
                         </a:rPr>
-                        <a:t>다른 계열·사람 평가와 비용 계측</a:t>
+                        <a:t>조사 우선순위와 호출 비용 계측</a:t>
+                      </a:r>
+                    </a:p>
+                  </a:txBody>
+                  <a:tcPr marL="266700" marR="228600" marT="114300" marB="114300" anchor="ctr">
+                    <a:lnR w="9525">
+                      <a:solidFill>
+                        <a:srgbClr val="DDE5EE"/>
+                      </a:solidFill>
+                      <a:prstDash val="solid"/>
+                    </a:lnR>
+                    <a:lnB w="9525">
+                      <a:solidFill>
+                        <a:srgbClr val="DDE5EE"/>
+                      </a:solidFill>
+                      <a:prstDash val="solid"/>
+                    </a:lnB>
+                    <a:solidFill>
+                      <a:srgbClr val="FFFFFF"/>
+                    </a:solidFill>
+                  </a:tcPr>
+                </a:tc>
+              </a:tr>
+              <a:tr h="1028700">
+                <a:tc>
+                  <a:txBody>
+                    <a:bodyPr/>
+                    <a:lstStyle/>
+                    <a:p>
+                      <a:r>
+                        <a:rPr sz="2400">
+                          <a:solidFill>
+                            <a:srgbClr val="122C46"/>
+                          </a:solidFill>
+                          <a:latin typeface="Noto Sans Kr"/>
+                          <a:ea typeface="Noto Sans Kr"/>
+                          <a:cs typeface="Noto Sans Kr"/>
+                        </a:rPr>
+                        <a:t>Judge 편향·입력 필터 오탐·미탐</a:t>
+                      </a:r>
+                    </a:p>
+                  </a:txBody>
+                  <a:tcPr marL="266700" marR="228600" marT="114300" marB="114300" anchor="ctr">
+                    <a:lnL w="9525">
+                      <a:solidFill>
+                        <a:srgbClr val="DDE5EE"/>
+                      </a:solidFill>
+                      <a:prstDash val="solid"/>
+                    </a:lnL>
+                    <a:lnR w="9525">
+                      <a:solidFill>
+                        <a:srgbClr val="DDE5EE"/>
+                      </a:solidFill>
+                      <a:prstDash val="solid"/>
+                    </a:lnR>
+                    <a:lnB w="9525">
+                      <a:solidFill>
+                        <a:srgbClr val="DDE5EE"/>
+                      </a:solidFill>
+                      <a:prstDash val="solid"/>
+                    </a:lnB>
+                    <a:solidFill>
+                      <a:srgbClr val="FFFFFF"/>
+                    </a:solidFill>
+                  </a:tcPr>
+                </a:tc>
+                <a:tc>
+                  <a:txBody>
+                    <a:bodyPr/>
+                    <a:lstStyle/>
+                    <a:p>
+                      <a:r>
+                        <a:rPr sz="2400">
+                          <a:solidFill>
+                            <a:srgbClr val="122C46"/>
+                          </a:solidFill>
+                          <a:latin typeface="Noto Sans Kr"/>
+                          <a:ea typeface="Noto Sans Kr"/>
+                          <a:cs typeface="Noto Sans Kr"/>
+                        </a:rPr>
+                        <a:t>다른 계열·사람 평가로 검증 보완</a:t>
                       </a:r>
                     </a:p>
                   </a:txBody>

</xml_diff>

<commit_message>
docs: focus twelve-slide deck on implemented changes and evidence
</commit_message>
<xml_diff>
--- a/doc/presentation/운영진단_에이전트_5분발표.pptx
+++ b/doc/presentation/운영진단_에이전트_5분발표.pptx
@@ -2,35 +2,35 @@
 <file path=ppt/presentation.xml><?xml version="1.0" encoding="utf-8"?>
 <p:presentation xmlns:p="http://schemas.openxmlformats.org/presentationml/2006/main" embedTrueTypeFonts="1" saveSubsetFonts="0">
   <p:sldMasterIdLst>
-    <p:sldMasterId xmlns:r="http://schemas.openxmlformats.org/officeDocument/2006/relationships" id="2147483648" r:id="Rfbdf0c155cbd4622"/>
+    <p:sldMasterId xmlns:r="http://schemas.openxmlformats.org/officeDocument/2006/relationships" id="2147483648" r:id="Ree748136dbc542dd"/>
   </p:sldMasterIdLst>
   <p:notesMasterIdLst>
-    <p:notesMasterId xmlns:r="http://schemas.openxmlformats.org/officeDocument/2006/relationships" r:id="R7c836189435e4c16"/>
+    <p:notesMasterId xmlns:r="http://schemas.openxmlformats.org/officeDocument/2006/relationships" r:id="Rad5ab9595b5b4978"/>
   </p:notesMasterIdLst>
   <p:sldIdLst>
-    <p:sldId xmlns:r="http://schemas.openxmlformats.org/officeDocument/2006/relationships" id="256" r:id="R31c5885c9cca46eb"/>
-    <p:sldId xmlns:r="http://schemas.openxmlformats.org/officeDocument/2006/relationships" id="257" r:id="R7c4a7465408f44e4"/>
-    <p:sldId xmlns:r="http://schemas.openxmlformats.org/officeDocument/2006/relationships" id="258" r:id="Ra83f3ba577df4491"/>
-    <p:sldId xmlns:r="http://schemas.openxmlformats.org/officeDocument/2006/relationships" id="259" r:id="R26c36871b9ec4003"/>
-    <p:sldId xmlns:r="http://schemas.openxmlformats.org/officeDocument/2006/relationships" id="260" r:id="R9ab8929305fa4eeb"/>
-    <p:sldId xmlns:r="http://schemas.openxmlformats.org/officeDocument/2006/relationships" id="261" r:id="R942b4eda912b4d25"/>
-    <p:sldId xmlns:r="http://schemas.openxmlformats.org/officeDocument/2006/relationships" id="262" r:id="R68da46c8e7cb4851"/>
-    <p:sldId xmlns:r="http://schemas.openxmlformats.org/officeDocument/2006/relationships" id="263" r:id="Rcc13a91fdf29402a"/>
-    <p:sldId xmlns:r="http://schemas.openxmlformats.org/officeDocument/2006/relationships" id="264" r:id="Rb6425017f11a4373"/>
-    <p:sldId xmlns:r="http://schemas.openxmlformats.org/officeDocument/2006/relationships" id="265" r:id="R1bc61571b5d94dce"/>
-    <p:sldId xmlns:r="http://schemas.openxmlformats.org/officeDocument/2006/relationships" id="266" r:id="Rfd9c868139fa4dca"/>
-    <p:sldId xmlns:r="http://schemas.openxmlformats.org/officeDocument/2006/relationships" id="267" r:id="R725d743444b54865"/>
+    <p:sldId xmlns:r="http://schemas.openxmlformats.org/officeDocument/2006/relationships" id="256" r:id="R579eb0695298432b"/>
+    <p:sldId xmlns:r="http://schemas.openxmlformats.org/officeDocument/2006/relationships" id="257" r:id="Rb3d3ababfb7e400f"/>
+    <p:sldId xmlns:r="http://schemas.openxmlformats.org/officeDocument/2006/relationships" id="258" r:id="Rb42d677145a14e93"/>
+    <p:sldId xmlns:r="http://schemas.openxmlformats.org/officeDocument/2006/relationships" id="259" r:id="Rc3ecda0fc7f84796"/>
+    <p:sldId xmlns:r="http://schemas.openxmlformats.org/officeDocument/2006/relationships" id="260" r:id="R3e5331e47f0a44a9"/>
+    <p:sldId xmlns:r="http://schemas.openxmlformats.org/officeDocument/2006/relationships" id="261" r:id="R74a24b683ed543ef"/>
+    <p:sldId xmlns:r="http://schemas.openxmlformats.org/officeDocument/2006/relationships" id="262" r:id="R99ecc2d70665418a"/>
+    <p:sldId xmlns:r="http://schemas.openxmlformats.org/officeDocument/2006/relationships" id="263" r:id="R87cc5dae3ce44cdd"/>
+    <p:sldId xmlns:r="http://schemas.openxmlformats.org/officeDocument/2006/relationships" id="264" r:id="R98516a782ede485d"/>
+    <p:sldId xmlns:r="http://schemas.openxmlformats.org/officeDocument/2006/relationships" id="265" r:id="R9db38388a75647a4"/>
+    <p:sldId xmlns:r="http://schemas.openxmlformats.org/officeDocument/2006/relationships" id="266" r:id="Rdc458e252beb4105"/>
+    <p:sldId xmlns:r="http://schemas.openxmlformats.org/officeDocument/2006/relationships" id="267" r:id="R91a1f3165dc34edf"/>
   </p:sldIdLst>
   <p:sldSz cx="18288000" cy="10287000"/>
   <p:notesSz cx="6858000" cy="9144000"/>
   <p:embeddedFontLst>
     <p:embeddedFont>
       <p:font typeface="Noto Sans Bold"/>
-      <p:regular xmlns:r="http://schemas.openxmlformats.org/officeDocument/2006/relationships" r:id="R36d834c7d7bf4418"/>
+      <p:regular xmlns:r="http://schemas.openxmlformats.org/officeDocument/2006/relationships" r:id="R5a2a5b2141d643c4"/>
     </p:embeddedFont>
     <p:embeddedFont>
       <p:font typeface="Noto Sans Kr"/>
-      <p:regular xmlns:r="http://schemas.openxmlformats.org/officeDocument/2006/relationships" r:id="Rca3862052ccb423b"/>
+      <p:regular xmlns:r="http://schemas.openxmlformats.org/officeDocument/2006/relationships" r:id="Rf52a6e0b57364374"/>
     </p:embeddedFont>
   </p:embeddedFontLst>
   <p:defaultTextStyle>
@@ -617,7 +617,7 @@
           </a:p>
           <a:p xmlns:a="http://schemas.openxmlformats.org/drawingml/2006/main">
             <a:r>
-              <a:t>안녕하세요. SKALA 광주 2반 G066 정준용입니다. 장애 증상에서 추가 관측으로 원인을 좁히는 운영 진단 에이전트를 구현했습니다. 실제 조사와 검증 결과를 중심으로 소개하겠습니다.</a:t>
+              <a:t>안녕하세요. SKALA 광주 2반 G066 정준용입니다. 기존 진단 흐름에 추가 조사와 근거 검증을 구현했습니다. 이번에 바꾼 기능과 실제 실행 결과를 중심으로 소개하겠습니다.</a:t>
             </a:r>
           </a:p>
           <a:p xmlns:a="http://schemas.openxmlformats.org/drawingml/2006/main">
@@ -632,7 +632,7 @@
           </a:p>
           <a:p xmlns:a="http://schemas.openxmlformats.org/drawingml/2006/main">
             <a:r>
-              <a:t>먼저 개선한 문제입니다.</a:t>
+              <a:t>먼저 기존 방식과 달라진 점입니다.</a:t>
             </a:r>
           </a:p>
           <a:p xmlns:a="http://schemas.openxmlformats.org/drawingml/2006/main">
@@ -752,7 +752,7 @@
           <a:lstStyle xmlns:a="http://schemas.openxmlformats.org/drawingml/2006/main"/>
           <a:p xmlns:a="http://schemas.openxmlformats.org/drawingml/2006/main">
             <a:r>
-              <a:t>기능 검사와 Judge 평가</a:t>
+              <a:t>기능 검사에 Judge 평가 추가</a:t>
             </a:r>
           </a:p>
           <a:p xmlns:a="http://schemas.openxmlformats.org/drawingml/2006/main">
@@ -777,7 +777,7 @@
           </a:p>
           <a:p xmlns:a="http://schemas.openxmlformats.org/drawingml/2006/main">
             <a:r>
-              <a:t>실제 LLM의 가설 조사 여섯 사례는 기능 검사를 모두 통과했습니다. 별도 Judge는 근거 충실성과 수치 정확성 등 다섯 항목을 평가했고, 종합 결과는 여섯 건 중 다섯 건이었습니다. 릴리스 사례는 기능 조건을 충족했지만 Judge 점수가 낮아 검토 대상으로 남겼습니다. 코드 분기와 오류 처리를 검사한 자동 테스트 99개 통과 기록도 보존했습니다.</a:t>
+              <a:t>기능 동작과 답변 품질을 분리해 평가했습니다. 실제 LLM 여섯 사례는 보류와 실패 대응을 포함한 기능 검사를 모두 통과했습니다. 별도 Judge의 다섯 항목까지 포함하면 다섯 건 통과입니다. 릴리스 사례는 주장 대조 단계의 Judge 오판을 검토 중이며 미통과를 그대로 보존했습니다. 자동 테스트 99개와 실제 모델 여섯 건 평가도 구분했습니다.</a:t>
             </a:r>
           </a:p>
           <a:p xmlns:a="http://schemas.openxmlformats.org/drawingml/2006/main">
@@ -792,7 +792,7 @@
           </a:p>
           <a:p xmlns:a="http://schemas.openxmlformats.org/drawingml/2006/main">
             <a:r>
-              <a:t>실행 과정과 평가 점수가 실제로 저장됐는지도 확인했습니다.</a:t>
+              <a:t>이 평가가 원격에 저장됐는지도 직접 확인했습니다.</a:t>
             </a:r>
           </a:p>
           <a:p xmlns:a="http://schemas.openxmlformats.org/drawingml/2006/main">
@@ -807,7 +807,7 @@
           </a:p>
           <a:p xmlns:a="http://schemas.openxmlformats.org/drawingml/2006/main">
             <a:r>
-              <a:t>6/6 기능 검사와 5/6 종합을 비교한다. 99개 자동 테스트와 실제 모델 6건 평가를 구분한다.</a:t>
+              <a:t>기능 6/6과 Judge 포함 5/6, release 최종 근거 점수 2/5를 비교한다. Judge 오류는 원점수와 주장 대조 결과를 보존한 검토 사항이다.</a:t>
             </a:r>
           </a:p>
           <a:p xmlns:a="http://schemas.openxmlformats.org/drawingml/2006/main">
@@ -917,7 +917,7 @@
           <a:lstStyle xmlns:a="http://schemas.openxmlformats.org/drawingml/2006/main"/>
           <a:p xmlns:a="http://schemas.openxmlformats.org/drawingml/2006/main">
             <a:r>
-              <a:t>LangSmith 추적과 저장 확인</a:t>
+              <a:t>실행 기록과 비용 통제 추가</a:t>
             </a:r>
           </a:p>
           <a:p xmlns:a="http://schemas.openxmlformats.org/drawingml/2006/main">
@@ -942,7 +942,7 @@
           </a:p>
           <a:p xmlns:a="http://schemas.openxmlformats.org/drawingml/2006/main">
             <a:r>
-              <a:t>LangSmith에 저장한 실행 여섯 건과 평가 점수 서른 개를 다시 조회해 원격 저장을 확인했습니다. 별도의 입력 검사에서는 거절 다섯 건의 LLM·MCP 호출과 생성 토큰이 0임을 검증했습니다.</a:t>
+              <a:t>LangSmith에 저장한 실행 여섯 건과 점수 서른 개를 다시 조회했습니다. 별도로 모델 호출 전 입력 검사도 추가해 거절 다섯 건의 LLM·MCP 호출과 생성 토큰이 0임을 확인했습니다. 이는 거절 요청의 결과이며 전체 비용 절감률은 아직 측정하지 않았습니다.</a:t>
             </a:r>
           </a:p>
           <a:p xmlns:a="http://schemas.openxmlformats.org/drawingml/2006/main">
@@ -957,7 +957,7 @@
           </a:p>
           <a:p xmlns:a="http://schemas.openxmlformats.org/drawingml/2006/main">
             <a:r>
-              <a:t>마지막으로 현재 한계와 배운 점입니다.</a:t>
+              <a:t>마지막으로 개선의 한계와 다음 과제입니다.</a:t>
             </a:r>
           </a:p>
           <a:p xmlns:a="http://schemas.openxmlformats.org/drawingml/2006/main">
@@ -972,7 +972,7 @@
           </a:p>
           <a:p xmlns:a="http://schemas.openxmlformats.org/drawingml/2006/main">
             <a:r>
-              <a:t>원격 실행 6건과 평가 점수 30개를 짚고 입력 검사는 보조 비용 통제로 짧게 언급한다.</a:t>
+              <a:t>6건·30개 재조회와 별도 입력 거절 0토큰만 짚는다. 두 검증 시점을 구분한다.</a:t>
             </a:r>
           </a:p>
           <a:p xmlns:a="http://schemas.openxmlformats.org/drawingml/2006/main">
@@ -1082,7 +1082,7 @@
           <a:lstStyle xmlns:a="http://schemas.openxmlformats.org/drawingml/2006/main"/>
           <a:p xmlns:a="http://schemas.openxmlformats.org/drawingml/2006/main">
             <a:r>
-              <a:t>한계와 다음 개선, 배운 점</a:t>
+              <a:t>개선 효과와 남은 과제</a:t>
             </a:r>
           </a:p>
           <a:p xmlns:a="http://schemas.openxmlformats.org/drawingml/2006/main">
@@ -1107,7 +1107,7 @@
           </a:p>
           <a:p xmlns:a="http://schemas.openxmlformats.org/drawingml/2006/main">
             <a:r>
-              <a:t>현재는 CPU 세 가설과 합성 관측에 한정됩니다. 조회 한도는 비용을 통제하지만 미확인 가설을 남길 수 있고, Judge에도 오판 가능성이 있습니다. 앞으로 실제 모니터링과 다른 계열 모델·사람 평가를 연결하고 전체 비용을 계측하겠습니다. 판단 조건과 근거를 함께 남겨야 진단이 달라진 이유까지 설명할 수 있다는 점을 배웠습니다. 감사합니다.</a:t>
+              <a:t>현재는 CPU 세 가설과 합성 관측에 한정됩니다. 조회 한도는 비용을 통제하지만 미확인 가설을 남길 수 있고, Judge도 오판할 수 있습니다. 다음에는 실제 모니터링과 다른 계열 모델·사람 평가를 연결하겠습니다. 이번 작업을 통해 결론뿐 아니라 판단 조건과 근거를 함께 남겨야 진단이 달라진 이유까지 설명할 수 있다는 점을 배웠습니다. 감사합니다.</a:t>
             </a:r>
           </a:p>
           <a:p xmlns:a="http://schemas.openxmlformats.org/drawingml/2006/main">
@@ -1137,7 +1137,7 @@
           </a:p>
           <a:p xmlns:a="http://schemas.openxmlformats.org/drawingml/2006/main">
             <a:r>
-              <a:t>조회 범위와 비용·품질의 트레이드오프를 다음 개선과 연결하고 교훈으로 마무리한다.</a:t>
+              <a:t>실제 데이터 연결, 질문 우선순위, 다른 Judge·사람 평가를 한계와 연결한다.</a:t>
             </a:r>
           </a:p>
           <a:p xmlns:a="http://schemas.openxmlformats.org/drawingml/2006/main">
@@ -1237,7 +1237,7 @@
           <a:lstStyle xmlns:a="http://schemas.openxmlformats.org/drawingml/2006/main"/>
           <a:p xmlns:a="http://schemas.openxmlformats.org/drawingml/2006/main">
             <a:r>
-              <a:t>개선한 두 가지 문제</a:t>
+              <a:t>이번에 바꾼 세 가지 흐름</a:t>
             </a:r>
           </a:p>
           <a:p xmlns:a="http://schemas.openxmlformats.org/drawingml/2006/main">
@@ -1262,7 +1262,7 @@
           </a:p>
           <a:p xmlns:a="http://schemas.openxmlformats.org/drawingml/2006/main">
             <a:r>
-              <a:t>초기 경고만으로는 여러 원인 중 무엇이 문제인지 구별하기 어렵습니다. 그래서 경쟁 가설을 세우고, 가설을 구별할 관측을 추가했습니다. 생성된 답변도 조회 수치와 출처, 조치 조건을 검사해 문제가 있으면 다시 작성하도록 했습니다. 조사 과정과 보고서의 신뢰성을 함께 개선한 것입니다.</a:t>
+              <a:t>기존에는 초기 경고를 원인으로 연결하기 쉽고, 답변 검사는 길이와 번호 형식에 머물렀습니다. 이번에는 경쟁 가설을 추가 관측으로 비교하고, 수치와 출처·조치 조건을 코드로 검사하도록 바꿨습니다. 최종 답변만 보여주던 화면에도 조사 이유와 판단 이력을 추가했습니다.</a:t>
             </a:r>
           </a:p>
           <a:p xmlns:a="http://schemas.openxmlformats.org/drawingml/2006/main">
@@ -1277,7 +1277,7 @@
           </a:p>
           <a:p xmlns:a="http://schemas.openxmlformats.org/drawingml/2006/main">
             <a:r>
-              <a:t>전체 시스템에서 각 역할을 어떻게 나눴는지 보겠습니다.</a:t>
+              <a:t>이 세 변화를 전체 구조에서 짚어보겠습니다.</a:t>
             </a:r>
           </a:p>
           <a:p xmlns:a="http://schemas.openxmlformats.org/drawingml/2006/main">
@@ -1292,7 +1292,7 @@
           </a:p>
           <a:p xmlns:a="http://schemas.openxmlformats.org/drawingml/2006/main">
             <a:r>
-              <a:t>원인 구별과 보고서 검증 두 개선만 설명하고 보조 기능은 길게 읽지 않는다.</a:t>
+              <a:t>기존과 개선 열을 가로로 비교한다. 검증 수치의 전후 향상률을 측정한 표가 아니라 구현 동작 비교다.</a:t>
             </a:r>
           </a:p>
           <a:p xmlns:a="http://schemas.openxmlformats.org/drawingml/2006/main">
@@ -1323,6 +1323,11 @@
           <a:p xmlns:a="http://schemas.openxmlformats.org/drawingml/2006/main">
             <a:r>
               <a:t>https://github.com/beshurl/skala-ai-mini-project/blob/main/agent/reporting.py</a:t>
+            </a:r>
+          </a:p>
+          <a:p xmlns:a="http://schemas.openxmlformats.org/drawingml/2006/main">
+            <a:r>
+              <a:t>https://github.com/beshurl/skala-ai-mini-project/blob/main/artifacts/baseline/graph_v2.py</a:t>
             </a:r>
           </a:p>
           <a:p xmlns:a="http://schemas.openxmlformats.org/drawingml/2006/main">
@@ -1407,7 +1412,7 @@
           <a:lstStyle xmlns:a="http://schemas.openxmlformats.org/drawingml/2006/main"/>
           <a:p xmlns:a="http://schemas.openxmlformats.org/drawingml/2006/main">
             <a:r>
-              <a:t>전체 아키텍처</a:t>
+              <a:t>개선 기능을 연결한 전체 구조</a:t>
             </a:r>
           </a:p>
           <a:p xmlns:a="http://schemas.openxmlformats.org/drawingml/2006/main">
@@ -1417,7 +1422,7 @@
           </a:p>
           <a:p xmlns:a="http://schemas.openxmlformats.org/drawingml/2006/main">
             <a:r>
-              <a:t>발표 시간 30초 / 0:40~1:10</a:t>
+              <a:t>발표 시간 20초 / 0:40~1:00</a:t>
             </a:r>
           </a:p>
           <a:p xmlns:a="http://schemas.openxmlformats.org/drawingml/2006/main">
@@ -1432,7 +1437,7 @@
           </a:p>
           <a:p xmlns:a="http://schemas.openxmlformats.org/drawingml/2006/main">
             <a:r>
-              <a:t>Vue에서 질문하면 FastAPI가 입력과 대상을 확인합니다. LangGraph는 Supervisor 역할로 전문 조회와 추가 조사, 보고서 작성을 조정합니다. 지표와 로그는 병렬로 수집하고 관측을 반영해 런북을 검색합니다. 진행 상황은 SSE로 전달하고 완료 결과와 대화 맥락은 SQLite에 저장합니다.</a:t>
+              <a:t>전체 구조에서는 바꾼 부분만 보겠습니다. LangGraph에 추가 조사와 검증 반복을 연결하고, MCP에는 추가 관측 도구를 연결했습니다. 화면에는 판단 이력을, 저장과 평가에는 근거 기록을 추가했습니다. 모델·도구·검색기는 의존성 주입으로 분리했습니다.</a:t>
             </a:r>
           </a:p>
           <a:p xmlns:a="http://schemas.openxmlformats.org/drawingml/2006/main">
@@ -1447,7 +1452,7 @@
           </a:p>
           <a:p xmlns:a="http://schemas.openxmlformats.org/drawingml/2006/main">
             <a:r>
-              <a:t>중앙의 가설 조사는 다음 규칙으로 동작합니다.</a:t>
+              <a:t>가장 핵심인 추가 조사부터 설명하겠습니다.</a:t>
             </a:r>
           </a:p>
           <a:p xmlns:a="http://schemas.openxmlformats.org/drawingml/2006/main">
@@ -1462,7 +1467,7 @@
           </a:p>
           <a:p xmlns:a="http://schemas.openxmlformats.org/drawingml/2006/main">
             <a:r>
-              <a:t>전체 아키텍처 한 장에서 Vue·FastAPI·LangGraph와 MCP·RAG·저장·평가 경로를 짚는다.</a:t>
+              <a:t>중앙의 추가 조사·검증, 왼쪽 판단 이력, 아래 관측·검색, 위 평가만 짚는다. Vue·FastAPI·MCP 자체를 새로 만든 기술이라고 설명하지 않는다.</a:t>
             </a:r>
           </a:p>
           <a:p xmlns:a="http://schemas.openxmlformats.org/drawingml/2006/main">
@@ -1597,7 +1602,7 @@
           <a:lstStyle xmlns:a="http://schemas.openxmlformats.org/drawingml/2006/main"/>
           <a:p xmlns:a="http://schemas.openxmlformats.org/drawingml/2006/main">
             <a:r>
-              <a:t>가설을 구별하는 조사 규칙</a:t>
+              <a:t>원인 추정에 반증 절차 추가</a:t>
             </a:r>
           </a:p>
           <a:p xmlns:a="http://schemas.openxmlformats.org/drawingml/2006/main">
@@ -1607,7 +1612,7 @@
           </a:p>
           <a:p xmlns:a="http://schemas.openxmlformats.org/drawingml/2006/main">
             <a:r>
-              <a:t>발표 시간 35초 / 1:10~1:45</a:t>
+              <a:t>발표 시간 35초 / 1:00~1:35</a:t>
             </a:r>
           </a:p>
           <a:p xmlns:a="http://schemas.openxmlformats.org/drawingml/2006/main">
@@ -1622,7 +1627,7 @@
           </a:p>
           <a:p xmlns:a="http://schemas.openxmlformats.org/drawingml/2006/main">
             <a:r>
-              <a:t>먼저 관측을 조회하기 전에 지지·반증 조건을 정합니다. 예를 들어 작업의 CPU 기여 비중이 70% 이상이면 해당 가설을 지지합니다. LLM이 남은 질문 중 필요한 조사를 선택하면 MCP가 관측을 가져오고, 코드가 조건과 대조합니다. 충분한 근거가 모이면 종료하고, 최대 네 번을 조사해도 부족하거나 상충하면 판단을 보류합니다.</a:t>
+              <a:t>중복 배치 경고가 있어도 실제 CPU를 쓰는 작업은 다를 수 있습니다. 그래서 조회 전에 지지·반증 조건을 고정했습니다. 예를 들어 작업군의 CPU 기여 70% 이상은 지지, 15% 이하는 반증입니다. LLM은 남은 질문을 고르고 코드는 관측을 판정합니다. 두 관측의 교차 지지와 경쟁 가설의 반증을 확보하면 종료하고, 최대 네 번 뒤에도 불충분하면 판단을 보류합니다.</a:t>
             </a:r>
           </a:p>
           <a:p xmlns:a="http://schemas.openxmlformats.org/drawingml/2006/main">
@@ -1637,7 +1642,7 @@
           </a:p>
           <a:p xmlns:a="http://schemas.openxmlformats.org/drawingml/2006/main">
             <a:r>
-              <a:t>실제 화면에서는 조사 이유와 판단 변화를 함께 볼 수 있습니다.</a:t>
+              <a:t>이 조사 과정도 화면에서 확인할 수 있게 했습니다.</a:t>
             </a:r>
           </a:p>
           <a:p xmlns:a="http://schemas.openxmlformats.org/drawingml/2006/main">
@@ -1652,7 +1657,7 @@
           </a:p>
           <a:p xmlns:a="http://schemas.openxmlformats.org/drawingml/2006/main">
             <a:r>
-              <a:t>사전 조건, LLM 질문 선택, 코드 판정의 역할을 순서대로 짚는다.</a:t>
+              <a:t>사전 조건, 질문 선택, 코드 판정 순으로 설명한다. 70%는 실험용 작업군 기여 기준이며 전체 CPU 경고 임계값과 구분한다.</a:t>
             </a:r>
           </a:p>
           <a:p xmlns:a="http://schemas.openxmlformats.org/drawingml/2006/main">
@@ -1767,7 +1772,7 @@
           <a:lstStyle xmlns:a="http://schemas.openxmlformats.org/drawingml/2006/main"/>
           <a:p xmlns:a="http://schemas.openxmlformats.org/drawingml/2006/main">
             <a:r>
-              <a:t>실제 추가 조사 화면</a:t>
+              <a:t>조사 이유와 판단 변화 표시</a:t>
             </a:r>
           </a:p>
           <a:p xmlns:a="http://schemas.openxmlformats.org/drawingml/2006/main">
@@ -1777,7 +1782,7 @@
           </a:p>
           <a:p xmlns:a="http://schemas.openxmlformats.org/drawingml/2006/main">
             <a:r>
-              <a:t>발표 시간 30초 / 1:45~2:15</a:t>
+              <a:t>발표 시간 30초 / 1:35~2:05</a:t>
             </a:r>
           </a:p>
           <a:p xmlns:a="http://schemas.openxmlformats.org/drawingml/2006/main">
@@ -1792,7 +1797,7 @@
           </a:p>
           <a:p xmlns:a="http://schemas.openxmlformats.org/drawingml/2006/main">
             <a:r>
-              <a:t>요청량 사례의 저장된 실행 화면입니다. 첫 조사에서는 CPU가 어느 작업에 사용됐는지 확인했습니다. 배치 기여는 낮았고 요청 처리 기여는 높았습니다. 다음으로 요청량 증가와 지속 시간을 확인했습니다. 서로 다른 두 관측이 요청량 가설을 지지하고 경쟁 가설의 반증도 확보돼 두 번 만에 종료했습니다.</a:t>
+              <a:t>결과만 보는 대신 왜 조사했고 무엇이 바뀌었는지 확인하도록 화면을 추가했습니다. 실제 실행의 결과 영역입니다. 배치 가설은 반증됐고 요청량 가설은 교차 지지로 바뀌었습니다. 과정 패널에는 조회 이유와 사전 조건, 관측과 종료 이유도 남깁니다. 사용자가 결론의 근거를 직접 따라갈 수 있게 한 변화입니다.</a:t>
             </a:r>
           </a:p>
           <a:p xmlns:a="http://schemas.openxmlformats.org/drawingml/2006/main">
@@ -1807,7 +1812,7 @@
           </a:p>
           <a:p xmlns:a="http://schemas.openxmlformats.org/drawingml/2006/main">
             <a:r>
-              <a:t>추가 관측이 달라지면 같은 경고에서도 판단이 달라집니다.</a:t>
+              <a:t>관측을 바꿨을 때 실제 판단도 달라지는지 비교했습니다.</a:t>
             </a:r>
           </a:p>
           <a:p xmlns:a="http://schemas.openxmlformats.org/drawingml/2006/main">
@@ -1822,7 +1827,7 @@
           </a:p>
           <a:p xmlns:a="http://schemas.openxmlformats.org/drawingml/2006/main">
             <a:r>
-              <a:t>이미지의 배치 반증과 요청량 교차 지지를 짚고 실제 조회 순서와 종료 이유를 설명한다.</a:t>
+              <a:t>화면의 반증·교차 지지와 근거 ID를 짚는다. 발췌 영역 밖의 조사 이유·사전 조건은 원본 전체 화면과 저장 이력에서 확인한다.</a:t>
             </a:r>
           </a:p>
           <a:p xmlns:a="http://schemas.openxmlformats.org/drawingml/2006/main">
@@ -1947,7 +1952,7 @@
           </a:p>
           <a:p xmlns:a="http://schemas.openxmlformats.org/drawingml/2006/main">
             <a:r>
-              <a:t>발표 시간 35초 / 2:15~2:50</a:t>
+              <a:t>발표 시간 35초 / 2:05~2:40</a:t>
             </a:r>
           </a:p>
           <a:p xmlns:a="http://schemas.openxmlformats.org/drawingml/2006/main">
@@ -1962,7 +1967,7 @@
           </a:p>
           <a:p xmlns:a="http://schemas.openxmlformats.org/drawingml/2006/main">
             <a:r>
-              <a:t>두 실행은 최초 CPU 91%와 중복 배치 경고가 같습니다. 왼쪽은 배치의 CPU 기여 86%와 중복 작업의 겹침이 확인돼 배치 가설을 지지했습니다. 오른쪽은 배치 기여가 5%였고 요청량이 3.2배로 증가해 요청량 가설을 지지했습니다. 실제 LLM을 사용한 두 실행이며 관측은 교육용 합성 데이터입니다.</a:t>
+              <a:t>두 사례는 최초 CPU 91%와 중복 배치 경고가 같습니다. 왼쪽은 배치 CPU 기여 86%와 작업 중첩이 확인돼 배치 가설을 지지했습니다. 오른쪽은 배치 기여 5%와 요청량 3.2배 증가를 확인해 요청량 가설을 지지했습니다. 둘 다 개선 버전의 실행이며, 이전 버전과의 성능 비교는 아닙니다. 실제 LLM을 사용했고 관측은 합성 데이터입니다.</a:t>
             </a:r>
           </a:p>
           <a:p xmlns:a="http://schemas.openxmlformats.org/drawingml/2006/main">
@@ -1977,7 +1982,7 @@
           </a:p>
           <a:p xmlns:a="http://schemas.openxmlformats.org/drawingml/2006/main">
             <a:r>
-              <a:t>이때 필요한 관측과 문서는 MCP로 연결했습니다.</a:t>
+              <a:t>추가 조회에 실패했을 때도 결과를 지키도록 바꿨습니다.</a:t>
             </a:r>
           </a:p>
           <a:p xmlns:a="http://schemas.openxmlformats.org/drawingml/2006/main">
@@ -1992,7 +1997,7 @@
           </a:p>
           <a:p xmlns:a="http://schemas.openxmlformats.org/drawingml/2006/main">
             <a:r>
-              <a:t>최초 조건이 같다는 점과 추가 관측·최종 판단의 차이를 비교한다. 교차 지지를 인과 확정으로 설명하지 않는다.</a:t>
+              <a:t>추가 관측과 판단의 차이를 짚는다. 두 개선 실행 사례를 버전 전후 측정이나 운영 장애 정답률로 설명하지 않는다.</a:t>
             </a:r>
           </a:p>
           <a:p xmlns:a="http://schemas.openxmlformats.org/drawingml/2006/main">
@@ -2102,7 +2107,7 @@
           <a:lstStyle xmlns:a="http://schemas.openxmlformats.org/drawingml/2006/main"/>
           <a:p xmlns:a="http://schemas.openxmlformats.org/drawingml/2006/main">
             <a:r>
-              <a:t>MCP로 연결한 조회와 문서</a:t>
+              <a:t>추가 관측과 부분 실패 대응</a:t>
             </a:r>
           </a:p>
           <a:p xmlns:a="http://schemas.openxmlformats.org/drawingml/2006/main">
@@ -2112,7 +2117,7 @@
           </a:p>
           <a:p xmlns:a="http://schemas.openxmlformats.org/drawingml/2006/main">
             <a:r>
-              <a:t>발표 시간 20초 / 2:50~3:10</a:t>
+              <a:t>발표 시간 30초 / 2:40~3:10</a:t>
             </a:r>
           </a:p>
           <a:p xmlns:a="http://schemas.openxmlformats.org/drawingml/2006/main">
@@ -2127,7 +2132,7 @@
           </a:p>
           <a:p xmlns:a="http://schemas.openxmlformats.org/drawingml/2006/main">
             <a:r>
-              <a:t>MCP의 Tool은 지표와 로그, 추가 관측을 조회합니다. Resource는 런북 원문을 제공하고, Prompt는 대상과 증상을 포함한 공통 조사 절차를 전달합니다. 모든 도구는 읽기 전용입니다.</a:t>
+              <a:t>기존 조회 흐름에 가설별 추가 관측 도구를 연결했습니다. 동시에 일부 도구가 실패하면 성공한 근거까지 잃지 않도록 실패를 항목별로 격리했습니다. 실제 LLM 평가에서는 CPU 귀속 도구의 타임아웃을 주입했습니다. 다른 관측은 유지했고, 원인 확정에 필요한 근거가 없으므로 판단을 보류했습니다. 실패를 숨기지 않고 진단 한계를 남기는 것이 목표입니다.</a:t>
             </a:r>
           </a:p>
           <a:p xmlns:a="http://schemas.openxmlformats.org/drawingml/2006/main">
@@ -2142,7 +2147,7 @@
           </a:p>
           <a:p xmlns:a="http://schemas.openxmlformats.org/drawingml/2006/main">
             <a:r>
-              <a:t>여러 런북 중 관련 문서를 찾는 역할은 RAG가 담당합니다.</a:t>
+              <a:t>문서 검색도 수집한 관측을 활용하도록 바꿨습니다.</a:t>
             </a:r>
           </a:p>
           <a:p xmlns:a="http://schemas.openxmlformats.org/drawingml/2006/main">
@@ -2157,7 +2162,7 @@
           </a:p>
           <a:p xmlns:a="http://schemas.openxmlformats.org/drawingml/2006/main">
             <a:r>
-              <a:t>Tool·Resource·Prompt의 역할을 한 번씩 짚는다.</a:t>
+              <a:t>추가 관측 도구와 부분 실패 처리를 설명하고 타임아웃 주입 사례의 성공 근거 유지·판단 보류를 짚는다.</a:t>
             </a:r>
           </a:p>
           <a:p xmlns:a="http://schemas.openxmlformats.org/drawingml/2006/main">
@@ -2172,42 +2177,32 @@
           </a:p>
           <a:p xmlns:a="http://schemas.openxmlformats.org/drawingml/2006/main">
             <a:r>
-              <a:t>https://github.com/beshurl/skala-ai-mini-project/blob/main/agent/graph.py</a:t>
-            </a:r>
-          </a:p>
-          <a:p xmlns:a="http://schemas.openxmlformats.org/drawingml/2006/main">
-            <a:r>
-              <a:t>https://github.com/beshurl/skala-ai-mini-project/blob/main/agent/specialists.py</a:t>
-            </a:r>
-          </a:p>
-          <a:p xmlns:a="http://schemas.openxmlformats.org/drawingml/2006/main">
-            <a:r>
               <a:t>https://github.com/beshurl/skala-ai-mini-project/blob/main/mcp_server.py</a:t>
             </a:r>
           </a:p>
           <a:p xmlns:a="http://schemas.openxmlformats.org/drawingml/2006/main">
             <a:r>
-              <a:t>https://github.com/beshurl/skala-ai-mini-project/blob/main/agent/retrieval.py</a:t>
-            </a:r>
-          </a:p>
-          <a:p xmlns:a="http://schemas.openxmlformats.org/drawingml/2006/main">
-            <a:r>
-              <a:t>https://github.com/beshurl/skala-ai-mini-project/blob/main/agent/session_store.py</a:t>
-            </a:r>
-          </a:p>
-          <a:p xmlns:a="http://schemas.openxmlformats.org/drawingml/2006/main">
-            <a:r>
-              <a:t>https://github.com/beshurl/skala-ai-mini-project/blob/main/agent/judge.py</a:t>
-            </a:r>
-          </a:p>
-          <a:p xmlns:a="http://schemas.openxmlformats.org/drawingml/2006/main">
-            <a:r>
-              <a:t>https://github.com/beshurl/skala-ai-mini-project/blob/main/agent/observability.py</a:t>
+              <a:t>https://github.com/beshurl/skala-ai-mini-project/blob/main/agent/mcp_client.py</a:t>
+            </a:r>
+          </a:p>
+          <a:p xmlns:a="http://schemas.openxmlformats.org/drawingml/2006/main">
+            <a:r>
+              <a:t>https://github.com/beshurl/skala-ai-mini-project/blob/main/agent/investigation.py</a:t>
+            </a:r>
+          </a:p>
+          <a:p xmlns:a="http://schemas.openxmlformats.org/drawingml/2006/main">
+            <a:r>
+              <a:t>https://github.com/beshurl/skala-ai-mini-project/blob/main/agent/contracts.py</a:t>
             </a:r>
           </a:p>
           <a:p xmlns:a="http://schemas.openxmlformats.org/drawingml/2006/main">
             <a:r>
               <a:t>https://github.com/beshurl/skala-ai-mini-project/blob/main/agent/deps.py</a:t>
+            </a:r>
+          </a:p>
+          <a:p xmlns:a="http://schemas.openxmlformats.org/drawingml/2006/main">
+            <a:r>
+              <a:t>https://github.com/beshurl/skala-ai-mini-project/blob/main/artifacts/investigation_evaluation.json</a:t>
             </a:r>
           </a:p>
           <a:p xmlns:a="http://schemas.openxmlformats.org/drawingml/2006/main">
@@ -2292,7 +2287,7 @@
           <a:lstStyle xmlns:a="http://schemas.openxmlformats.org/drawingml/2006/main"/>
           <a:p xmlns:a="http://schemas.openxmlformats.org/drawingml/2006/main">
             <a:r>
-              <a:t>관측을 반영하는 RAG 검색</a:t>
+              <a:t>단일 런북 선택에서 다중 검색으로</a:t>
             </a:r>
           </a:p>
           <a:p xmlns:a="http://schemas.openxmlformats.org/drawingml/2006/main">
@@ -2317,7 +2312,7 @@
           </a:p>
           <a:p xmlns:a="http://schemas.openxmlformats.org/drawingml/2006/main">
             <a:r>
-              <a:t>RAG는 질문에 지표와 알림을 더해 검색합니다. 매뉴얼 여섯 종을 임베딩하고 최대 세 문서를 선택한 뒤 MCP 원문과 대조합니다. 벡터는 SQLite에 저장하고 NumPy로 유사도를 계산했습니다. 현재 문서 규모에 맞춘 로컬 구성입니다. 모델과 도구 연결은 모듈과 의존성 주입으로 분리했습니다.</a:t>
+              <a:t>기존 키워드 분류로 한 런북을 고르던 흐름을 의미 검색으로 바꿨습니다. 질문에 지표와 알림을 더해 매뉴얼 여섯 종에서 최대 세 종을 찾습니다. SQLite에 벡터를 저장하고 NumPy로 유사도를 계산합니다. 검색 후보는 MCP 원문과 대조하며, 실제 조치는 관측 조건에 맞는 근거만 사용합니다.</a:t>
             </a:r>
           </a:p>
           <a:p xmlns:a="http://schemas.openxmlformats.org/drawingml/2006/main">
@@ -2332,7 +2327,7 @@
           </a:p>
           <a:p xmlns:a="http://schemas.openxmlformats.org/drawingml/2006/main">
             <a:r>
-              <a:t>검색한 근거가 실제 보고서 검증으로 이어진 결과입니다.</a:t>
+              <a:t>이 근거가 보고서에 올바르게 쓰였는지도 검사합니다.</a:t>
             </a:r>
           </a:p>
           <a:p xmlns:a="http://schemas.openxmlformats.org/drawingml/2006/main">
@@ -2347,7 +2342,7 @@
           </a:p>
           <a:p xmlns:a="http://schemas.openxmlformats.org/drawingml/2006/main">
             <a:r>
-              <a:t>질의 구성·벡터 검색·원문 대조를 따라 설명하고 저장·검색 구현을 한 문장으로 소개한다.</a:t>
+              <a:t>기존 단일 선택과 개선 다중 검색의 동작을 비교한다. 검색 정확도 향상률은 제시하지 않는다.</a:t>
             </a:r>
           </a:p>
           <a:p xmlns:a="http://schemas.openxmlformats.org/drawingml/2006/main">
@@ -2393,6 +2388,16 @@
           <a:p xmlns:a="http://schemas.openxmlformats.org/drawingml/2006/main">
             <a:r>
               <a:t>https://github.com/beshurl/skala-ai-mini-project/blob/main/doc/presentation/assets/live-validation-20261022.json</a:t>
+            </a:r>
+          </a:p>
+          <a:p xmlns:a="http://schemas.openxmlformats.org/drawingml/2006/main">
+            <a:r>
+              <a:t>https://github.com/beshurl/skala-ai-mini-project/blob/main/artifacts/baseline/graph_v2.py</a:t>
+            </a:r>
+          </a:p>
+          <a:p xmlns:a="http://schemas.openxmlformats.org/drawingml/2006/main">
+            <a:r>
+              <a:t>https://github.com/beshurl/skala-ai-mini-project/blob/main/agent/specialists.py</a:t>
             </a:r>
           </a:p>
           <a:p xmlns:a="http://schemas.openxmlformats.org/drawingml/2006/main">
@@ -2477,7 +2482,7 @@
           <a:lstStyle xmlns:a="http://schemas.openxmlformats.org/drawingml/2006/main"/>
           <a:p xmlns:a="http://schemas.openxmlformats.org/drawingml/2006/main">
             <a:r>
-              <a:t>실제 보고서 검증 화면</a:t>
+              <a:t>형식 검사에서 사실 검증으로</a:t>
             </a:r>
           </a:p>
           <a:p xmlns:a="http://schemas.openxmlformats.org/drawingml/2006/main">
@@ -2502,7 +2507,7 @@
           </a:p>
           <a:p xmlns:a="http://schemas.openxmlformats.org/drawingml/2006/main">
             <a:r>
-              <a:t>보고서 후보는 프롬프트·모델·파서를 연결해 작성합니다. 오른쪽은 실제 Ollama로 재실행한 프론트 화면입니다. 첫 초안은 다음 행동이 빠져 코드 검사에서 불합격했습니다. 피드백을 반영한 두 번째 작성은 통과했고, 화면에도 작성 두 회와 재작성 한 회가 표시됩니다.</a:t>
+              <a:t>기존 길이·번호 검사를 시스템명, 수치, 근거와 조치 조건까지 확장했습니다. 오른쪽은 실제 Ollama 재실행 결과입니다. 첫 초안은 다음 행동이 누락돼 불합격했고 두 번째 작성에서 보완해 통과했습니다. 화면에도 작성 두 회와 재작성 한 회가 남습니다. 최대 세 번 뒤에도 실패하면 검증 미통과를 알리고 관측 사실만 안내합니다.</a:t>
             </a:r>
           </a:p>
           <a:p xmlns:a="http://schemas.openxmlformats.org/drawingml/2006/main">
@@ -2517,7 +2522,7 @@
           </a:p>
           <a:p xmlns:a="http://schemas.openxmlformats.org/drawingml/2006/main">
             <a:r>
-              <a:t>이 코드 검사와 별도로 답변 품질도 평가했습니다.</a:t>
+              <a:t>실행 중 검사와 별도로 답변 품질 평가도 추가했습니다.</a:t>
             </a:r>
           </a:p>
           <a:p xmlns:a="http://schemas.openxmlformats.org/drawingml/2006/main">
@@ -2532,7 +2537,7 @@
           </a:p>
           <a:p xmlns:a="http://schemas.openxmlformats.org/drawingml/2006/main">
             <a:r>
-              <a:t>왼쪽 1차 불합격·2차 통과와 오른쪽 실제 최종 검증 상태를 연결한다. 불합격 사유는 저장된 실행 이벤트 근거다.</a:t>
+              <a:t>여섯 검사 항목과 작성 2회·재작성 1회를 짚는다. 1차 누락은 저장 이벤트 근거이며 화면은 최종 통과 상태다.</a:t>
             </a:r>
           </a:p>
           <a:p xmlns:a="http://schemas.openxmlformats.org/drawingml/2006/main">
@@ -2578,6 +2583,11 @@
           <a:p xmlns:a="http://schemas.openxmlformats.org/drawingml/2006/main">
             <a:r>
               <a:t>https://github.com/beshurl/skala-ai-mini-project/blob/main/doc/presentation/assets/live-validation-20261022.json</a:t>
+            </a:r>
+          </a:p>
+          <a:p xmlns:a="http://schemas.openxmlformats.org/drawingml/2006/main">
+            <a:r>
+              <a:t>https://github.com/beshurl/skala-ai-mini-project/blob/main/artifacts/baseline/graph_v2.py</a:t>
             </a:r>
           </a:p>
           <a:p xmlns:a="http://schemas.openxmlformats.org/drawingml/2006/main">
@@ -5619,17 +5629,17 @@
   </p:cSld>
   <p:clrMap bg1="lt1" tx1="dk1" bg2="lt2" tx2="dk2" accent1="accent1" accent2="accent2" accent3="accent3" accent4="accent4" accent5="accent5" accent6="accent6" hlink="hlink" folHlink="folHlink"/>
   <p:sldLayoutIdLst>
-    <p:sldLayoutId xmlns:r="http://schemas.openxmlformats.org/officeDocument/2006/relationships" id="2147483649" r:id="Raa845eba3b144d66"/>
-    <p:sldLayoutId xmlns:r="http://schemas.openxmlformats.org/officeDocument/2006/relationships" id="2147483650" r:id="R121a2a04a15a4b28"/>
-    <p:sldLayoutId xmlns:r="http://schemas.openxmlformats.org/officeDocument/2006/relationships" id="2147483651" r:id="R9c63dd5362804774"/>
-    <p:sldLayoutId xmlns:r="http://schemas.openxmlformats.org/officeDocument/2006/relationships" id="2147483652" r:id="R9c53c7831d4a4a46"/>
-    <p:sldLayoutId xmlns:r="http://schemas.openxmlformats.org/officeDocument/2006/relationships" id="2147483653" r:id="R3c177a63f19a4efd"/>
-    <p:sldLayoutId xmlns:r="http://schemas.openxmlformats.org/officeDocument/2006/relationships" id="2147483654" r:id="R6236205844c84652"/>
-    <p:sldLayoutId xmlns:r="http://schemas.openxmlformats.org/officeDocument/2006/relationships" id="2147483655" r:id="Rd76cc01c49a749de"/>
-    <p:sldLayoutId xmlns:r="http://schemas.openxmlformats.org/officeDocument/2006/relationships" id="2147483656" r:id="Rd7eca860b7ae489b"/>
-    <p:sldLayoutId xmlns:r="http://schemas.openxmlformats.org/officeDocument/2006/relationships" id="2147483657" r:id="R31ee84114ac74b88"/>
-    <p:sldLayoutId xmlns:r="http://schemas.openxmlformats.org/officeDocument/2006/relationships" id="2147483658" r:id="Re9c3b5a76d7e45b4"/>
-    <p:sldLayoutId xmlns:r="http://schemas.openxmlformats.org/officeDocument/2006/relationships" id="2147483659" r:id="Rc1c8efa066d64e99"/>
+    <p:sldLayoutId xmlns:r="http://schemas.openxmlformats.org/officeDocument/2006/relationships" id="2147483649" r:id="R7b30c8219b964b63"/>
+    <p:sldLayoutId xmlns:r="http://schemas.openxmlformats.org/officeDocument/2006/relationships" id="2147483650" r:id="Rd3a284d4085a4644"/>
+    <p:sldLayoutId xmlns:r="http://schemas.openxmlformats.org/officeDocument/2006/relationships" id="2147483651" r:id="R61c6339f4f0a456b"/>
+    <p:sldLayoutId xmlns:r="http://schemas.openxmlformats.org/officeDocument/2006/relationships" id="2147483652" r:id="Raab13c5df016460c"/>
+    <p:sldLayoutId xmlns:r="http://schemas.openxmlformats.org/officeDocument/2006/relationships" id="2147483653" r:id="R14b168a885bf4e5d"/>
+    <p:sldLayoutId xmlns:r="http://schemas.openxmlformats.org/officeDocument/2006/relationships" id="2147483654" r:id="R197fb9b9e4a14247"/>
+    <p:sldLayoutId xmlns:r="http://schemas.openxmlformats.org/officeDocument/2006/relationships" id="2147483655" r:id="Rccafafcf2f9f4171"/>
+    <p:sldLayoutId xmlns:r="http://schemas.openxmlformats.org/officeDocument/2006/relationships" id="2147483656" r:id="R25a7240c9a9247e5"/>
+    <p:sldLayoutId xmlns:r="http://schemas.openxmlformats.org/officeDocument/2006/relationships" id="2147483657" r:id="R140f700728c94e84"/>
+    <p:sldLayoutId xmlns:r="http://schemas.openxmlformats.org/officeDocument/2006/relationships" id="2147483658" r:id="Ra9fff2f56fa84ad9"/>
+    <p:sldLayoutId xmlns:r="http://schemas.openxmlformats.org/officeDocument/2006/relationships" id="2147483659" r:id="Rc5f1beb17f6b498a"/>
   </p:sldLayoutIdLst>
   <p:txStyles>
     <p:titleStyle>
@@ -7264,7 +7274,7 @@
           <p:cNvPr id="7" name="">
             <a:extLst xmlns:a="http://schemas.openxmlformats.org/drawingml/2006/main">
               <a:ext uri="{FF2B5EF4-FFF2-40B4-BE49-F238E27FC236}">
-                <a16:creationId xmlns:a16="http://schemas.microsoft.com/office/drawing/2014/main" id="{CD254716-2825-4393-A036-29E4F266B2FD}"/>
+                <a16:creationId xmlns:a16="http://schemas.microsoft.com/office/drawing/2014/main" id="{AA7AAAC9-DC5E-4A4E-B9DE-93AD7635EF59}"/>
               </a:ext>
             </a:extLst>
           </p:cNvPr>
@@ -7274,7 +7284,7 @@
           <p:nvPr/>
         </p:nvPicPr>
         <p:blipFill>
-          <a:blip xmlns:r="http://schemas.openxmlformats.org/officeDocument/2006/relationships" xmlns:a="http://schemas.openxmlformats.org/drawingml/2006/main" r:embed="R74fe838e3eb94793"/>
+          <a:blip xmlns:r="http://schemas.openxmlformats.org/officeDocument/2006/relationships" xmlns:a="http://schemas.openxmlformats.org/drawingml/2006/main" r:embed="R7bbd89e9b8344720"/>
           <a:stretch xmlns:a="http://schemas.openxmlformats.org/drawingml/2006/main"/>
         </p:blipFill>
         <p:spPr>
@@ -7460,7 +7470,7 @@
           <p:cNvPr id="9" name="cover-rule">
             <a:extLst xmlns:a="http://schemas.openxmlformats.org/drawingml/2006/main">
               <a:ext uri="{FF2B5EF4-FFF2-40B4-BE49-F238E27FC236}">
-                <a16:creationId xmlns:a16="http://schemas.microsoft.com/office/drawing/2014/main" id="{FCC7B2F8-3657-46B6-80D4-28722F929AF2}"/>
+                <a16:creationId xmlns:a16="http://schemas.microsoft.com/office/drawing/2014/main" id="{C2E015AA-4AAA-43A0-9A47-CF9BCAEF14CE}"/>
               </a:ext>
             </a:extLst>
           </p:cNvPr>
@@ -7516,7 +7526,7 @@
           <p:cNvPr id="13" name="section-label">
             <a:extLst xmlns:a="http://schemas.openxmlformats.org/drawingml/2006/main">
               <a:ext uri="{FF2B5EF4-FFF2-40B4-BE49-F238E27FC236}">
-                <a16:creationId xmlns:a16="http://schemas.microsoft.com/office/drawing/2014/main" id="{C8E51EB3-BCAF-49CE-804C-6892DD76068D}"/>
+                <a16:creationId xmlns:a16="http://schemas.microsoft.com/office/drawing/2014/main" id="{AB4345CC-128A-4CF2-96FC-6F7911ABD540}"/>
               </a:ext>
             </a:extLst>
           </p:cNvPr>
@@ -7664,7 +7674,7 @@
                 <a:ea typeface="Noto Sans Bold"/>
                 <a:cs typeface="Noto Sans Bold"/>
               </a:rPr>
-              <a:t>구현 결과: 품질 평가</a:t>
+              <a:t>검증 2: 기능과 품질의 분리</a:t>
             </a:r>
           </a:p>
         </p:txBody>
@@ -7674,7 +7684,7 @@
           <p:cNvPr id="2" name="page-number">
             <a:extLst xmlns:a="http://schemas.openxmlformats.org/drawingml/2006/main">
               <a:ext uri="{FF2B5EF4-FFF2-40B4-BE49-F238E27FC236}">
-                <a16:creationId xmlns:a16="http://schemas.microsoft.com/office/drawing/2014/main" id="{F124DD70-FE2D-49A2-B338-7133D464CD43}"/>
+                <a16:creationId xmlns:a16="http://schemas.microsoft.com/office/drawing/2014/main" id="{C2B5E7C0-3563-4E25-8CF8-BAE487AAF2E1}"/>
               </a:ext>
             </a:extLst>
           </p:cNvPr>
@@ -7832,7 +7842,7 @@
           <p:cNvPr id="3" name="slide-title">
             <a:extLst xmlns:a="http://schemas.openxmlformats.org/drawingml/2006/main">
               <a:ext uri="{FF2B5EF4-FFF2-40B4-BE49-F238E27FC236}">
-                <a16:creationId xmlns:a16="http://schemas.microsoft.com/office/drawing/2014/main" id="{F5F3761C-985F-4EF8-A0CB-6FC7E4D82C05}"/>
+                <a16:creationId xmlns:a16="http://schemas.microsoft.com/office/drawing/2014/main" id="{5E7C11DE-C4F7-4139-A3D9-AAA9E82F384D}"/>
               </a:ext>
             </a:extLst>
           </p:cNvPr>
@@ -7980,7 +7990,7 @@
                 <a:ea typeface="Noto Sans Bold"/>
                 <a:cs typeface="Noto Sans Bold"/>
               </a:rPr>
-              <a:t>기능 검사와 Judge 평가</a:t>
+              <a:t>기능 검사에 Judge 평가 추가</a:t>
             </a:r>
           </a:p>
         </p:txBody>
@@ -7990,7 +8000,7 @@
           <p:cNvPr id="4" name="slide-subtitle">
             <a:extLst xmlns:a="http://schemas.openxmlformats.org/drawingml/2006/main">
               <a:ext uri="{FF2B5EF4-FFF2-40B4-BE49-F238E27FC236}">
-                <a16:creationId xmlns:a16="http://schemas.microsoft.com/office/drawing/2014/main" id="{909A0315-72A8-42AC-959C-4AFCD11AB485}"/>
+                <a16:creationId xmlns:a16="http://schemas.microsoft.com/office/drawing/2014/main" id="{D82ACD94-BA2D-4AA5-89EE-5C8F8D1E3A37}"/>
               </a:ext>
             </a:extLst>
           </p:cNvPr>
@@ -8138,7 +8148,7 @@
                 <a:ea typeface="Noto Sans Kr"/>
                 <a:cs typeface="Noto Sans Kr"/>
               </a:rPr>
-              <a:t>기능 동작과 근거 충실성 등 5개 품질 항목을 별도로 평가합니다.</a:t>
+              <a:t>동작 조건과 답변 품질을 나눠 평가하고 미통과 결과도 보존합니다.</a:t>
             </a:r>
           </a:p>
         </p:txBody>
@@ -8148,7 +8158,7 @@
           <p:cNvPr id="5" name="scope-note">
             <a:extLst xmlns:a="http://schemas.openxmlformats.org/drawingml/2006/main">
               <a:ext uri="{FF2B5EF4-FFF2-40B4-BE49-F238E27FC236}">
-                <a16:creationId xmlns:a16="http://schemas.microsoft.com/office/drawing/2014/main" id="{865D1558-A922-4E36-B396-8E362C8C6DB1}"/>
+                <a16:creationId xmlns:a16="http://schemas.microsoft.com/office/drawing/2014/main" id="{3692519A-B9A6-49F8-B49F-627E68742DA3}"/>
               </a:ext>
             </a:extLst>
           </p:cNvPr>
@@ -8306,7 +8316,7 @@
           <p:cNvPr id="6" name="footer-rule">
             <a:extLst xmlns:a="http://schemas.openxmlformats.org/drawingml/2006/main">
               <a:ext uri="{FF2B5EF4-FFF2-40B4-BE49-F238E27FC236}">
-                <a16:creationId xmlns:a16="http://schemas.microsoft.com/office/drawing/2014/main" id="{BA0F36BF-ADEA-4587-9D27-B9BBF7FD6ADB}"/>
+                <a16:creationId xmlns:a16="http://schemas.microsoft.com/office/drawing/2014/main" id="{EFE108F1-48E5-46BC-A9B3-68921DB16018}"/>
               </a:ext>
             </a:extLst>
           </p:cNvPr>
@@ -8333,7 +8343,7 @@
           <p:cNvPr id="7" name="footer">
             <a:extLst xmlns:a="http://schemas.openxmlformats.org/drawingml/2006/main">
               <a:ext uri="{FF2B5EF4-FFF2-40B4-BE49-F238E27FC236}">
-                <a16:creationId xmlns:a16="http://schemas.microsoft.com/office/drawing/2014/main" id="{6FFB8263-0188-4BE3-B763-E6CBDD7E8932}"/>
+                <a16:creationId xmlns:a16="http://schemas.microsoft.com/office/drawing/2014/main" id="{95FBC4FD-A281-42E6-BD1A-4DE192042E56}"/>
               </a:ext>
             </a:extLst>
           </p:cNvPr>
@@ -8491,7 +8501,7 @@
           <p:cNvPr id="8" name="evaluation-metric-0">
             <a:extLst xmlns:a="http://schemas.openxmlformats.org/drawingml/2006/main">
               <a:ext uri="{FF2B5EF4-FFF2-40B4-BE49-F238E27FC236}">
-                <a16:creationId xmlns:a16="http://schemas.microsoft.com/office/drawing/2014/main" id="{0DD427A1-3782-45DB-AF76-6D8E6535E97F}"/>
+                <a16:creationId xmlns:a16="http://schemas.microsoft.com/office/drawing/2014/main" id="{E09D34A4-7707-41AB-A620-D843B7E6A596}"/>
               </a:ext>
             </a:extLst>
           </p:cNvPr>
@@ -8649,7 +8659,7 @@
           <p:cNvPr id="9" name="evaluation-label-0">
             <a:extLst xmlns:a="http://schemas.openxmlformats.org/drawingml/2006/main">
               <a:ext uri="{FF2B5EF4-FFF2-40B4-BE49-F238E27FC236}">
-                <a16:creationId xmlns:a16="http://schemas.microsoft.com/office/drawing/2014/main" id="{0BDA8FFC-5EBC-4D42-B60E-17283EA1DADC}"/>
+                <a16:creationId xmlns:a16="http://schemas.microsoft.com/office/drawing/2014/main" id="{DE4401CC-1DE1-45A6-9579-FC608CF72194}"/>
               </a:ext>
             </a:extLst>
           </p:cNvPr>
@@ -8807,7 +8817,7 @@
           <p:cNvPr id="10" name="evaluation-metric-1">
             <a:extLst xmlns:a="http://schemas.openxmlformats.org/drawingml/2006/main">
               <a:ext uri="{FF2B5EF4-FFF2-40B4-BE49-F238E27FC236}">
-                <a16:creationId xmlns:a16="http://schemas.microsoft.com/office/drawing/2014/main" id="{7B5B3FB0-14FD-45A1-8AFA-EE826CD1DE52}"/>
+                <a16:creationId xmlns:a16="http://schemas.microsoft.com/office/drawing/2014/main" id="{1D12CA1C-E141-4200-8DD8-0A114FBA1DF2}"/>
               </a:ext>
             </a:extLst>
           </p:cNvPr>
@@ -8965,7 +8975,7 @@
           <p:cNvPr id="11" name="evaluation-label-1">
             <a:extLst xmlns:a="http://schemas.openxmlformats.org/drawingml/2006/main">
               <a:ext uri="{FF2B5EF4-FFF2-40B4-BE49-F238E27FC236}">
-                <a16:creationId xmlns:a16="http://schemas.microsoft.com/office/drawing/2014/main" id="{1CCCA570-4F21-459B-A14F-422440A26576}"/>
+                <a16:creationId xmlns:a16="http://schemas.microsoft.com/office/drawing/2014/main" id="{32008445-1C04-4326-B89E-E89C6F22457D}"/>
               </a:ext>
             </a:extLst>
           </p:cNvPr>
@@ -9123,7 +9133,7 @@
           <p:cNvPr id="12" name="">
             <a:extLst xmlns:a="http://schemas.openxmlformats.org/drawingml/2006/main">
               <a:ext uri="{FF2B5EF4-FFF2-40B4-BE49-F238E27FC236}">
-                <a16:creationId xmlns:a16="http://schemas.microsoft.com/office/drawing/2014/main" id="{396E96E1-923A-4754-BD98-132FEFA6DB0E}"/>
+                <a16:creationId xmlns:a16="http://schemas.microsoft.com/office/drawing/2014/main" id="{DD5C0AFE-1E71-467C-83B2-B6C392D78736}"/>
               </a:ext>
             </a:extLst>
           </p:cNvPr>
@@ -9516,7 +9526,7 @@
     </p:spTree>
     <p:extLst>
       <p:ext uri="{BB962C8B-B14F-4D97-AF65-F5344CB8AC3E}">
-        <p14:creationId xmlns:p14="http://schemas.microsoft.com/office/powerpoint/2010/main" val="1136494305"/>
+        <p14:creationId xmlns:p14="http://schemas.microsoft.com/office/powerpoint/2010/main" val="1440662576"/>
       </p:ext>
     </p:extLst>
   </p:cSld>
@@ -9547,7 +9557,7 @@
           <p:cNvPr id="14" name="section-label">
             <a:extLst xmlns:a="http://schemas.openxmlformats.org/drawingml/2006/main">
               <a:ext uri="{FF2B5EF4-FFF2-40B4-BE49-F238E27FC236}">
-                <a16:creationId xmlns:a16="http://schemas.microsoft.com/office/drawing/2014/main" id="{1C83868C-45FD-4E0E-85A2-1CDB4D4D11B8}"/>
+                <a16:creationId xmlns:a16="http://schemas.microsoft.com/office/drawing/2014/main" id="{597A4355-B485-4D9D-840C-BB5EC747B4E0}"/>
               </a:ext>
             </a:extLst>
           </p:cNvPr>
@@ -9695,7 +9705,7 @@
                 <a:ea typeface="Noto Sans Bold"/>
                 <a:cs typeface="Noto Sans Bold"/>
               </a:rPr>
-              <a:t>구현 결과: 관측 가능성</a:t>
+              <a:t>검증 3: 추적과 호출 통제</a:t>
             </a:r>
           </a:p>
         </p:txBody>
@@ -9705,7 +9715,7 @@
           <p:cNvPr id="2" name="page-number">
             <a:extLst xmlns:a="http://schemas.openxmlformats.org/drawingml/2006/main">
               <a:ext uri="{FF2B5EF4-FFF2-40B4-BE49-F238E27FC236}">
-                <a16:creationId xmlns:a16="http://schemas.microsoft.com/office/drawing/2014/main" id="{334977EB-C72F-4F76-84A6-E903D73FB5B7}"/>
+                <a16:creationId xmlns:a16="http://schemas.microsoft.com/office/drawing/2014/main" id="{6EDFBC9B-929B-435E-944F-9B34322BFDE1}"/>
               </a:ext>
             </a:extLst>
           </p:cNvPr>
@@ -9863,7 +9873,7 @@
           <p:cNvPr id="3" name="slide-title">
             <a:extLst xmlns:a="http://schemas.openxmlformats.org/drawingml/2006/main">
               <a:ext uri="{FF2B5EF4-FFF2-40B4-BE49-F238E27FC236}">
-                <a16:creationId xmlns:a16="http://schemas.microsoft.com/office/drawing/2014/main" id="{C237A8A9-07AD-435A-B4CD-59B644C50716}"/>
+                <a16:creationId xmlns:a16="http://schemas.microsoft.com/office/drawing/2014/main" id="{9072B2CB-188A-4BB6-9C8E-9F1CAA0ECBC3}"/>
               </a:ext>
             </a:extLst>
           </p:cNvPr>
@@ -10011,7 +10021,7 @@
                 <a:ea typeface="Noto Sans Bold"/>
                 <a:cs typeface="Noto Sans Bold"/>
               </a:rPr>
-              <a:t>LangSmith 추적과 저장 확인</a:t>
+              <a:t>실행 기록과 비용 통제 추가</a:t>
             </a:r>
           </a:p>
         </p:txBody>
@@ -10021,7 +10031,7 @@
           <p:cNvPr id="4" name="slide-subtitle">
             <a:extLst xmlns:a="http://schemas.openxmlformats.org/drawingml/2006/main">
               <a:ext uri="{FF2B5EF4-FFF2-40B4-BE49-F238E27FC236}">
-                <a16:creationId xmlns:a16="http://schemas.microsoft.com/office/drawing/2014/main" id="{BD453378-6DA9-475D-B1AA-1EE149FA4121}"/>
+                <a16:creationId xmlns:a16="http://schemas.microsoft.com/office/drawing/2014/main" id="{E35642A1-08FB-48FB-88C5-A9EE95993354}"/>
               </a:ext>
             </a:extLst>
           </p:cNvPr>
@@ -10169,7 +10179,7 @@
                 <a:ea typeface="Noto Sans Kr"/>
                 <a:cs typeface="Noto Sans Kr"/>
               </a:rPr>
-              <a:t>저장한 실행과 평가 점수를 다시 조회해 원격 저장을 확인했습니다.</a:t>
+              <a:t>추적 기록을 재조회하고, 불필요한 요청은 호출 전에 거절합니다.</a:t>
             </a:r>
           </a:p>
         </p:txBody>
@@ -10179,7 +10189,7 @@
           <p:cNvPr id="5" name="scope-note">
             <a:extLst xmlns:a="http://schemas.openxmlformats.org/drawingml/2006/main">
               <a:ext uri="{FF2B5EF4-FFF2-40B4-BE49-F238E27FC236}">
-                <a16:creationId xmlns:a16="http://schemas.microsoft.com/office/drawing/2014/main" id="{1E814A4B-6ED6-41DE-8C8A-6BBC23A7C6F2}"/>
+                <a16:creationId xmlns:a16="http://schemas.microsoft.com/office/drawing/2014/main" id="{1477B288-059F-4C5A-A25E-491DEC572FDC}"/>
               </a:ext>
             </a:extLst>
           </p:cNvPr>
@@ -10337,7 +10347,7 @@
           <p:cNvPr id="6" name="footer-rule">
             <a:extLst xmlns:a="http://schemas.openxmlformats.org/drawingml/2006/main">
               <a:ext uri="{FF2B5EF4-FFF2-40B4-BE49-F238E27FC236}">
-                <a16:creationId xmlns:a16="http://schemas.microsoft.com/office/drawing/2014/main" id="{D2C226ED-C716-46C8-A06D-0641A234106C}"/>
+                <a16:creationId xmlns:a16="http://schemas.microsoft.com/office/drawing/2014/main" id="{43D37F9A-A39B-4382-A4AC-360BAFF2BF80}"/>
               </a:ext>
             </a:extLst>
           </p:cNvPr>
@@ -10364,7 +10374,7 @@
           <p:cNvPr id="7" name="footer">
             <a:extLst xmlns:a="http://schemas.openxmlformats.org/drawingml/2006/main">
               <a:ext uri="{FF2B5EF4-FFF2-40B4-BE49-F238E27FC236}">
-                <a16:creationId xmlns:a16="http://schemas.microsoft.com/office/drawing/2014/main" id="{B0349454-AE37-47E6-A053-1BAE118E52F9}"/>
+                <a16:creationId xmlns:a16="http://schemas.microsoft.com/office/drawing/2014/main" id="{FC057C0F-C247-4937-B8DD-3D169318CA5B}"/>
               </a:ext>
             </a:extLst>
           </p:cNvPr>
@@ -10522,7 +10532,7 @@
           <p:cNvPr id="8" name="trace-runs">
             <a:extLst xmlns:a="http://schemas.openxmlformats.org/drawingml/2006/main">
               <a:ext uri="{FF2B5EF4-FFF2-40B4-BE49-F238E27FC236}">
-                <a16:creationId xmlns:a16="http://schemas.microsoft.com/office/drawing/2014/main" id="{162C9507-311D-427B-B361-BDE3BA245D15}"/>
+                <a16:creationId xmlns:a16="http://schemas.microsoft.com/office/drawing/2014/main" id="{A58D546E-A73B-4C1E-A510-F5F29C27601C}"/>
               </a:ext>
             </a:extLst>
           </p:cNvPr>
@@ -10680,7 +10690,7 @@
           <p:cNvPr id="9" name="trace-runs-label">
             <a:extLst xmlns:a="http://schemas.openxmlformats.org/drawingml/2006/main">
               <a:ext uri="{FF2B5EF4-FFF2-40B4-BE49-F238E27FC236}">
-                <a16:creationId xmlns:a16="http://schemas.microsoft.com/office/drawing/2014/main" id="{204645B5-259E-4FBE-A367-AF79F1C46CD0}"/>
+                <a16:creationId xmlns:a16="http://schemas.microsoft.com/office/drawing/2014/main" id="{2BF63357-4375-4506-9D72-685A5576B7E4}"/>
               </a:ext>
             </a:extLst>
           </p:cNvPr>
@@ -10838,7 +10848,7 @@
           <p:cNvPr id="10" name="trace-feedback">
             <a:extLst xmlns:a="http://schemas.openxmlformats.org/drawingml/2006/main">
               <a:ext uri="{FF2B5EF4-FFF2-40B4-BE49-F238E27FC236}">
-                <a16:creationId xmlns:a16="http://schemas.microsoft.com/office/drawing/2014/main" id="{A8AC38AA-9B8F-4F83-8DA6-1E5475ACEBDD}"/>
+                <a16:creationId xmlns:a16="http://schemas.microsoft.com/office/drawing/2014/main" id="{D04993E2-7827-4D20-B6FA-D0A1F8573721}"/>
               </a:ext>
             </a:extLst>
           </p:cNvPr>
@@ -10996,7 +11006,7 @@
           <p:cNvPr id="11" name="trace-feedback-label">
             <a:extLst xmlns:a="http://schemas.openxmlformats.org/drawingml/2006/main">
               <a:ext uri="{FF2B5EF4-FFF2-40B4-BE49-F238E27FC236}">
-                <a16:creationId xmlns:a16="http://schemas.microsoft.com/office/drawing/2014/main" id="{FB6323BA-2D99-42B0-92D2-31B7C7D7E326}"/>
+                <a16:creationId xmlns:a16="http://schemas.microsoft.com/office/drawing/2014/main" id="{3D20A057-ECBF-4ABD-8637-5FE01B912E39}"/>
               </a:ext>
             </a:extLst>
           </p:cNvPr>
@@ -11154,7 +11164,7 @@
           <p:cNvPr id="12" name="cost-label">
             <a:extLst xmlns:a="http://schemas.openxmlformats.org/drawingml/2006/main">
               <a:ext uri="{FF2B5EF4-FFF2-40B4-BE49-F238E27FC236}">
-                <a16:creationId xmlns:a16="http://schemas.microsoft.com/office/drawing/2014/main" id="{A42ECF87-133E-4FB3-A839-6A23A0384DDB}"/>
+                <a16:creationId xmlns:a16="http://schemas.microsoft.com/office/drawing/2014/main" id="{76177031-58BB-4F52-BA1E-010638665516}"/>
               </a:ext>
             </a:extLst>
           </p:cNvPr>
@@ -11312,7 +11322,7 @@
           <p:cNvPr id="13" name="cost-result">
             <a:extLst xmlns:a="http://schemas.openxmlformats.org/drawingml/2006/main">
               <a:ext uri="{FF2B5EF4-FFF2-40B4-BE49-F238E27FC236}">
-                <a16:creationId xmlns:a16="http://schemas.microsoft.com/office/drawing/2014/main" id="{B1BFB576-9D39-406B-BA28-CE58137083EC}"/>
+                <a16:creationId xmlns:a16="http://schemas.microsoft.com/office/drawing/2014/main" id="{B99B5271-51EE-4001-BBBF-52258986444A}"/>
               </a:ext>
             </a:extLst>
           </p:cNvPr>
@@ -11468,7 +11478,7 @@
     </p:spTree>
     <p:extLst>
       <p:ext uri="{BB962C8B-B14F-4D97-AF65-F5344CB8AC3E}">
-        <p14:creationId xmlns:p14="http://schemas.microsoft.com/office/powerpoint/2010/main" val="844065862"/>
+        <p14:creationId xmlns:p14="http://schemas.microsoft.com/office/powerpoint/2010/main" val="1913040406"/>
       </p:ext>
     </p:extLst>
   </p:cSld>
@@ -11499,7 +11509,7 @@
           <p:cNvPr id="10" name="section-label">
             <a:extLst xmlns:a="http://schemas.openxmlformats.org/drawingml/2006/main">
               <a:ext uri="{FF2B5EF4-FFF2-40B4-BE49-F238E27FC236}">
-                <a16:creationId xmlns:a16="http://schemas.microsoft.com/office/drawing/2014/main" id="{1AEEE8F0-B58F-474C-B7E1-75EE927784ED}"/>
+                <a16:creationId xmlns:a16="http://schemas.microsoft.com/office/drawing/2014/main" id="{E65509F0-3928-452C-ACC1-10CCD7F3D507}"/>
               </a:ext>
             </a:extLst>
           </p:cNvPr>
@@ -11647,7 +11657,7 @@
                 <a:ea typeface="Noto Sans Bold"/>
                 <a:cs typeface="Noto Sans Bold"/>
               </a:rPr>
-              <a:t>교훈</a:t>
+              <a:t>교훈과 향후 개선</a:t>
             </a:r>
           </a:p>
         </p:txBody>
@@ -11657,7 +11667,7 @@
           <p:cNvPr id="2" name="page-number">
             <a:extLst xmlns:a="http://schemas.openxmlformats.org/drawingml/2006/main">
               <a:ext uri="{FF2B5EF4-FFF2-40B4-BE49-F238E27FC236}">
-                <a16:creationId xmlns:a16="http://schemas.microsoft.com/office/drawing/2014/main" id="{5DDFDCC2-8950-4992-8D93-1356BA85AE97}"/>
+                <a16:creationId xmlns:a16="http://schemas.microsoft.com/office/drawing/2014/main" id="{9779A887-05B3-444F-A762-914C8A2BB2B4}"/>
               </a:ext>
             </a:extLst>
           </p:cNvPr>
@@ -11815,7 +11825,7 @@
           <p:cNvPr id="3" name="slide-title">
             <a:extLst xmlns:a="http://schemas.openxmlformats.org/drawingml/2006/main">
               <a:ext uri="{FF2B5EF4-FFF2-40B4-BE49-F238E27FC236}">
-                <a16:creationId xmlns:a16="http://schemas.microsoft.com/office/drawing/2014/main" id="{286F3AC1-E0FA-4FB9-B86D-F6472FA03535}"/>
+                <a16:creationId xmlns:a16="http://schemas.microsoft.com/office/drawing/2014/main" id="{4FF1D1F4-9E8E-4F90-946D-BD015A6F2263}"/>
               </a:ext>
             </a:extLst>
           </p:cNvPr>
@@ -11963,7 +11973,7 @@
                 <a:ea typeface="Noto Sans Bold"/>
                 <a:cs typeface="Noto Sans Bold"/>
               </a:rPr>
-              <a:t>한계와 다음 개선, 배운 점</a:t>
+              <a:t>개선 효과와 남은 과제</a:t>
             </a:r>
           </a:p>
         </p:txBody>
@@ -11973,7 +11983,7 @@
           <p:cNvPr id="4" name="slide-subtitle">
             <a:extLst xmlns:a="http://schemas.openxmlformats.org/drawingml/2006/main">
               <a:ext uri="{FF2B5EF4-FFF2-40B4-BE49-F238E27FC236}">
-                <a16:creationId xmlns:a16="http://schemas.microsoft.com/office/drawing/2014/main" id="{CF6DE93A-B18B-449D-8011-9AF7678C8CE2}"/>
+                <a16:creationId xmlns:a16="http://schemas.microsoft.com/office/drawing/2014/main" id="{DC65B6D5-E73E-4632-9910-AAE56423108E}"/>
               </a:ext>
             </a:extLst>
           </p:cNvPr>
@@ -12131,7 +12141,7 @@
           <p:cNvPr id="5" name="scope-note">
             <a:extLst xmlns:a="http://schemas.openxmlformats.org/drawingml/2006/main">
               <a:ext uri="{FF2B5EF4-FFF2-40B4-BE49-F238E27FC236}">
-                <a16:creationId xmlns:a16="http://schemas.microsoft.com/office/drawing/2014/main" id="{50A7A52A-433E-4A01-A171-11283E94C4C5}"/>
+                <a16:creationId xmlns:a16="http://schemas.microsoft.com/office/drawing/2014/main" id="{19D67460-25D7-4780-A2E6-025E93856E31}"/>
               </a:ext>
             </a:extLst>
           </p:cNvPr>
@@ -12289,7 +12299,7 @@
           <p:cNvPr id="6" name="footer-rule">
             <a:extLst xmlns:a="http://schemas.openxmlformats.org/drawingml/2006/main">
               <a:ext uri="{FF2B5EF4-FFF2-40B4-BE49-F238E27FC236}">
-                <a16:creationId xmlns:a16="http://schemas.microsoft.com/office/drawing/2014/main" id="{913629A2-3F33-47CA-B980-2D701EE5E29C}"/>
+                <a16:creationId xmlns:a16="http://schemas.microsoft.com/office/drawing/2014/main" id="{3F65B6F2-E351-4163-A31F-BD13F3F454E2}"/>
               </a:ext>
             </a:extLst>
           </p:cNvPr>
@@ -12316,7 +12326,7 @@
           <p:cNvPr id="7" name="footer">
             <a:extLst xmlns:a="http://schemas.openxmlformats.org/drawingml/2006/main">
               <a:ext uri="{FF2B5EF4-FFF2-40B4-BE49-F238E27FC236}">
-                <a16:creationId xmlns:a16="http://schemas.microsoft.com/office/drawing/2014/main" id="{A5B215BC-9707-4B72-8CA1-9F6E24016780}"/>
+                <a16:creationId xmlns:a16="http://schemas.microsoft.com/office/drawing/2014/main" id="{9A20C94E-2A02-4896-9B1F-9346CB67CE4D}"/>
               </a:ext>
             </a:extLst>
           </p:cNvPr>
@@ -12474,7 +12484,7 @@
           <p:cNvPr id="8" name="">
             <a:extLst xmlns:a="http://schemas.openxmlformats.org/drawingml/2006/main">
               <a:ext uri="{FF2B5EF4-FFF2-40B4-BE49-F238E27FC236}">
-                <a16:creationId xmlns:a16="http://schemas.microsoft.com/office/drawing/2014/main" id="{FC9EA10A-6F0E-40B1-9B35-3325B3D15F30}"/>
+                <a16:creationId xmlns:a16="http://schemas.microsoft.com/office/drawing/2014/main" id="{ACFFD016-0244-47ED-A7CF-257BFCA2ED0B}"/>
               </a:ext>
             </a:extLst>
           </p:cNvPr>
@@ -12754,7 +12764,7 @@
           <p:cNvPr id="9" name="reflection">
             <a:extLst xmlns:a="http://schemas.openxmlformats.org/drawingml/2006/main">
               <a:ext uri="{FF2B5EF4-FFF2-40B4-BE49-F238E27FC236}">
-                <a16:creationId xmlns:a16="http://schemas.microsoft.com/office/drawing/2014/main" id="{81B56973-F350-469F-A581-4B99D6EDD399}"/>
+                <a16:creationId xmlns:a16="http://schemas.microsoft.com/office/drawing/2014/main" id="{0DCBEB5F-27F7-43F3-8F23-C3C338B6678C}"/>
               </a:ext>
             </a:extLst>
           </p:cNvPr>
@@ -12933,7 +12943,7 @@
     </p:spTree>
     <p:extLst>
       <p:ext uri="{BB962C8B-B14F-4D97-AF65-F5344CB8AC3E}">
-        <p14:creationId xmlns:p14="http://schemas.microsoft.com/office/powerpoint/2010/main" val="1449944142"/>
+        <p14:creationId xmlns:p14="http://schemas.microsoft.com/office/powerpoint/2010/main" val="1086900173"/>
       </p:ext>
     </p:extLst>
   </p:cSld>
@@ -12964,7 +12974,7 @@
           <p:cNvPr id="10" name="section-label">
             <a:extLst xmlns:a="http://schemas.openxmlformats.org/drawingml/2006/main">
               <a:ext uri="{FF2B5EF4-FFF2-40B4-BE49-F238E27FC236}">
-                <a16:creationId xmlns:a16="http://schemas.microsoft.com/office/drawing/2014/main" id="{39DB3D09-FB4A-49FA-86B4-090A0447CB41}"/>
+                <a16:creationId xmlns:a16="http://schemas.microsoft.com/office/drawing/2014/main" id="{E0C55A08-8C94-49AB-9A7B-26FB6BEEDE50}"/>
               </a:ext>
             </a:extLst>
           </p:cNvPr>
@@ -13112,7 +13122,7 @@
                 <a:ea typeface="Noto Sans Bold"/>
                 <a:cs typeface="Noto Sans Bold"/>
               </a:rPr>
-              <a:t>문제와 핵심 개선</a:t>
+              <a:t>문제와 개선 전후</a:t>
             </a:r>
           </a:p>
         </p:txBody>
@@ -13122,7 +13132,7 @@
           <p:cNvPr id="2" name="page-number">
             <a:extLst xmlns:a="http://schemas.openxmlformats.org/drawingml/2006/main">
               <a:ext uri="{FF2B5EF4-FFF2-40B4-BE49-F238E27FC236}">
-                <a16:creationId xmlns:a16="http://schemas.microsoft.com/office/drawing/2014/main" id="{700D1A25-54EF-4B56-B52D-2FA2663A3BB4}"/>
+                <a16:creationId xmlns:a16="http://schemas.microsoft.com/office/drawing/2014/main" id="{AD15BFE0-72BA-4D24-9BEF-790ED6EC6F65}"/>
               </a:ext>
             </a:extLst>
           </p:cNvPr>
@@ -13280,7 +13290,7 @@
           <p:cNvPr id="3" name="slide-title">
             <a:extLst xmlns:a="http://schemas.openxmlformats.org/drawingml/2006/main">
               <a:ext uri="{FF2B5EF4-FFF2-40B4-BE49-F238E27FC236}">
-                <a16:creationId xmlns:a16="http://schemas.microsoft.com/office/drawing/2014/main" id="{91A8BC6B-33EA-40AE-A9EC-6B0E3981FC76}"/>
+                <a16:creationId xmlns:a16="http://schemas.microsoft.com/office/drawing/2014/main" id="{66BC7D28-3E11-4EAE-860D-C2F3097D6F6B}"/>
               </a:ext>
             </a:extLst>
           </p:cNvPr>
@@ -13428,7 +13438,7 @@
                 <a:ea typeface="Noto Sans Bold"/>
                 <a:cs typeface="Noto Sans Bold"/>
               </a:rPr>
-              <a:t>개선한 두 가지 문제</a:t>
+              <a:t>이번에 바꾼 세 가지 흐름</a:t>
             </a:r>
           </a:p>
         </p:txBody>
@@ -13438,7 +13448,7 @@
           <p:cNvPr id="4" name="slide-subtitle">
             <a:extLst xmlns:a="http://schemas.openxmlformats.org/drawingml/2006/main">
               <a:ext uri="{FF2B5EF4-FFF2-40B4-BE49-F238E27FC236}">
-                <a16:creationId xmlns:a16="http://schemas.microsoft.com/office/drawing/2014/main" id="{580BE431-D059-415C-AE9E-0F8D7739D3E8}"/>
+                <a16:creationId xmlns:a16="http://schemas.microsoft.com/office/drawing/2014/main" id="{25299185-174B-445A-A9E8-C71D31F36A27}"/>
               </a:ext>
             </a:extLst>
           </p:cNvPr>
@@ -13586,7 +13596,7 @@
                 <a:ea typeface="Noto Sans Kr"/>
                 <a:cs typeface="Noto Sans Kr"/>
               </a:rPr>
-              <a:t>원인을 구별하는 조사와, 보고서의 근거 검증을 개선했습니다.</a:t>
+              <a:t>기존 동작과 이번 변경을 세 가지 흐름으로 비교합니다.</a:t>
             </a:r>
           </a:p>
         </p:txBody>
@@ -13596,7 +13606,7 @@
           <p:cNvPr id="5" name="scope-note">
             <a:extLst xmlns:a="http://schemas.openxmlformats.org/drawingml/2006/main">
               <a:ext uri="{FF2B5EF4-FFF2-40B4-BE49-F238E27FC236}">
-                <a16:creationId xmlns:a16="http://schemas.microsoft.com/office/drawing/2014/main" id="{E6BA759E-D6F8-4CDE-8C63-30C41EC92D61}"/>
+                <a16:creationId xmlns:a16="http://schemas.microsoft.com/office/drawing/2014/main" id="{5288473C-36A5-423B-849D-15ECE173AC38}"/>
               </a:ext>
             </a:extLst>
           </p:cNvPr>
@@ -13744,7 +13754,7 @@
                 <a:ea typeface="Noto Sans Kr"/>
                 <a:cs typeface="Noto Sans Kr"/>
               </a:rPr>
-              <a:t>보조 안정성: 대상 확인·입력 검사·부분 실패 격리·기록 복원</a:t>
+              <a:t>입력 검사·대상 확인·비용 통제는 보조 개선으로 정리</a:t>
             </a:r>
           </a:p>
         </p:txBody>
@@ -13754,7 +13764,7 @@
           <p:cNvPr id="6" name="footer-rule">
             <a:extLst xmlns:a="http://schemas.openxmlformats.org/drawingml/2006/main">
               <a:ext uri="{FF2B5EF4-FFF2-40B4-BE49-F238E27FC236}">
-                <a16:creationId xmlns:a16="http://schemas.microsoft.com/office/drawing/2014/main" id="{5D658461-BB9F-4C7C-9C7F-1FC3D33E99B9}"/>
+                <a16:creationId xmlns:a16="http://schemas.microsoft.com/office/drawing/2014/main" id="{80CB5695-DC11-4A3A-91C7-5273EEA5CC73}"/>
               </a:ext>
             </a:extLst>
           </p:cNvPr>
@@ -13781,7 +13791,7 @@
           <p:cNvPr id="7" name="footer">
             <a:extLst xmlns:a="http://schemas.openxmlformats.org/drawingml/2006/main">
               <a:ext uri="{FF2B5EF4-FFF2-40B4-BE49-F238E27FC236}">
-                <a16:creationId xmlns:a16="http://schemas.microsoft.com/office/drawing/2014/main" id="{552035BF-536B-464F-95C7-3022FEC1E002}"/>
+                <a16:creationId xmlns:a16="http://schemas.microsoft.com/office/drawing/2014/main" id="{456C7039-F2A4-4C7A-8888-55BBA3318490}"/>
               </a:ext>
             </a:extLst>
           </p:cNvPr>
@@ -13939,7 +13949,7 @@
           <p:cNvPr id="8" name="">
             <a:extLst xmlns:a="http://schemas.openxmlformats.org/drawingml/2006/main">
               <a:ext uri="{FF2B5EF4-FFF2-40B4-BE49-F238E27FC236}">
-                <a16:creationId xmlns:a16="http://schemas.microsoft.com/office/drawing/2014/main" id="{3B891466-EE1A-4E29-885B-6DA3CB0C0545}"/>
+                <a16:creationId xmlns:a16="http://schemas.microsoft.com/office/drawing/2014/main" id="{72A6ADF0-BE53-429D-AB5D-4F0615C37385}"/>
               </a:ext>
             </a:extLst>
           </p:cNvPr>
@@ -13947,8 +13957,8 @@
           <p:nvPr/>
         </p:nvGraphicFramePr>
         <p:xfrm>
-          <a:off xmlns:a="http://schemas.openxmlformats.org/drawingml/2006/main" x="1143000" y="3810000"/>
-          <a:ext xmlns:a="http://schemas.openxmlformats.org/drawingml/2006/main" cx="16002000" cy="3448050"/>
+          <a:off xmlns:a="http://schemas.openxmlformats.org/drawingml/2006/main" x="1143000" y="3619500"/>
+          <a:ext xmlns:a="http://schemas.openxmlformats.org/drawingml/2006/main" cx="16002000" cy="4114800"/>
         </p:xfrm>
         <a:graphic xmlns:a="http://schemas.openxmlformats.org/drawingml/2006/main">
           <a:graphicData uri="http://schemas.openxmlformats.org/drawingml/2006/table">
@@ -13965,7 +13975,7 @@
                     <a:lstStyle/>
                     <a:p>
                       <a:r>
-                        <a:rPr sz="2400" b="1">
+                        <a:rPr sz="2550" b="1">
                           <a:solidFill>
                             <a:srgbClr val="FFFFFF"/>
                           </a:solidFill>
@@ -13973,7 +13983,7 @@
                           <a:ea typeface="Noto Sans Bold"/>
                           <a:cs typeface="Noto Sans Bold"/>
                         </a:rPr>
-                        <a:t>기존 한계</a:t>
+                        <a:t>개선 전</a:t>
                       </a:r>
                     </a:p>
                   </a:txBody>
@@ -14013,7 +14023,7 @@
                     <a:lstStyle/>
                     <a:p>
                       <a:r>
-                        <a:rPr sz="2400" b="1">
+                        <a:rPr sz="2550" b="1">
                           <a:solidFill>
                             <a:srgbClr val="FFFFFF"/>
                           </a:solidFill>
@@ -14021,7 +14031,7 @@
                           <a:ea typeface="Noto Sans Bold"/>
                           <a:cs typeface="Noto Sans Bold"/>
                         </a:rPr>
-                        <a:t>핵심 개선</a:t>
+                        <a:t>이번 변경</a:t>
                       </a:r>
                     </a:p>
                   </a:txBody>
@@ -14050,7 +14060,7 @@
                   </a:tcPr>
                 </a:tc>
               </a:tr>
-              <a:tr h="1381125">
+              <a:tr h="1143000">
                 <a:tc>
                   <a:txBody>
                     <a:bodyPr/>
@@ -14065,7 +14075,7 @@
                           <a:ea typeface="Noto Sans Kr"/>
                           <a:cs typeface="Noto Sans Kr"/>
                         </a:rPr>
-                        <a:t>초기 경고만으로 원인 추정</a:t>
+                        <a:t>초기 경고를 원인으로 연결</a:t>
                       </a:r>
                     </a:p>
                   </a:txBody>
@@ -14107,7 +14117,7 @@
                           <a:ea typeface="Noto Sans Kr"/>
                           <a:cs typeface="Noto Sans Kr"/>
                         </a:rPr>
-                        <a:t>경쟁 가설을 구별할 추가 관측</a:t>
+                        <a:t>추가 관측으로 경쟁 가설 비교</a:t>
                       </a:r>
                     </a:p>
                   </a:txBody>
@@ -14130,7 +14140,7 @@
                   </a:tcPr>
                 </a:tc>
               </a:tr>
-              <a:tr h="1381125">
+              <a:tr h="1143000">
                 <a:tc>
                   <a:txBody>
                     <a:bodyPr/>
@@ -14145,7 +14155,7 @@
                           <a:ea typeface="Noto Sans Kr"/>
                           <a:cs typeface="Noto Sans Kr"/>
                         </a:rPr>
-                        <a:t>답변의 수치·출처 확인이 어려움</a:t>
+                        <a:t>길이·번호 중심 답변 검사</a:t>
                       </a:r>
                     </a:p>
                   </a:txBody>
@@ -14187,7 +14197,87 @@
                           <a:ea typeface="Noto Sans Kr"/>
                           <a:cs typeface="Noto Sans Kr"/>
                         </a:rPr>
-                        <a:t>코드 검증 후 재작성·사실 안내</a:t>
+                        <a:t>수치·출처·조치 조건 검증</a:t>
+                      </a:r>
+                    </a:p>
+                  </a:txBody>
+                  <a:tcPr marL="285750" marR="228600" marT="152400" marB="152400" anchor="ctr">
+                    <a:lnR w="9525">
+                      <a:solidFill>
+                        <a:srgbClr val="DDE5EE"/>
+                      </a:solidFill>
+                      <a:prstDash val="solid"/>
+                    </a:lnR>
+                    <a:lnB w="9525">
+                      <a:solidFill>
+                        <a:srgbClr val="DDE5EE"/>
+                      </a:solidFill>
+                      <a:prstDash val="solid"/>
+                    </a:lnB>
+                    <a:solidFill>
+                      <a:srgbClr val="FFFFFF"/>
+                    </a:solidFill>
+                  </a:tcPr>
+                </a:tc>
+              </a:tr>
+              <a:tr h="1143000">
+                <a:tc>
+                  <a:txBody>
+                    <a:bodyPr/>
+                    <a:lstStyle/>
+                    <a:p>
+                      <a:r>
+                        <a:rPr sz="2700">
+                          <a:solidFill>
+                            <a:srgbClr val="122C46"/>
+                          </a:solidFill>
+                          <a:latin typeface="Noto Sans Kr"/>
+                          <a:ea typeface="Noto Sans Kr"/>
+                          <a:cs typeface="Noto Sans Kr"/>
+                        </a:rPr>
+                        <a:t>최종 답변 위주 결과 표시</a:t>
+                      </a:r>
+                    </a:p>
+                  </a:txBody>
+                  <a:tcPr marL="285750" marR="228600" marT="152400" marB="152400" anchor="ctr">
+                    <a:lnL w="9525">
+                      <a:solidFill>
+                        <a:srgbClr val="DDE5EE"/>
+                      </a:solidFill>
+                      <a:prstDash val="solid"/>
+                    </a:lnL>
+                    <a:lnR w="9525">
+                      <a:solidFill>
+                        <a:srgbClr val="DDE5EE"/>
+                      </a:solidFill>
+                      <a:prstDash val="solid"/>
+                    </a:lnR>
+                    <a:lnB w="9525">
+                      <a:solidFill>
+                        <a:srgbClr val="DDE5EE"/>
+                      </a:solidFill>
+                      <a:prstDash val="solid"/>
+                    </a:lnB>
+                    <a:solidFill>
+                      <a:srgbClr val="FFFFFF"/>
+                    </a:solidFill>
+                  </a:tcPr>
+                </a:tc>
+                <a:tc>
+                  <a:txBody>
+                    <a:bodyPr/>
+                    <a:lstStyle/>
+                    <a:p>
+                      <a:r>
+                        <a:rPr sz="2700">
+                          <a:solidFill>
+                            <a:srgbClr val="122C46"/>
+                          </a:solidFill>
+                          <a:latin typeface="Noto Sans Kr"/>
+                          <a:ea typeface="Noto Sans Kr"/>
+                          <a:cs typeface="Noto Sans Kr"/>
+                        </a:rPr>
+                        <a:t>조사 이유·판단 변화 기록</a:t>
                       </a:r>
                     </a:p>
                   </a:txBody>
@@ -14219,7 +14309,7 @@
           <p:cNvPr id="9" name="improvement-message">
             <a:extLst xmlns:a="http://schemas.openxmlformats.org/drawingml/2006/main">
               <a:ext uri="{FF2B5EF4-FFF2-40B4-BE49-F238E27FC236}">
-                <a16:creationId xmlns:a16="http://schemas.microsoft.com/office/drawing/2014/main" id="{D1EA6FDC-5779-4DA7-99AB-45C336266110}"/>
+                <a16:creationId xmlns:a16="http://schemas.microsoft.com/office/drawing/2014/main" id="{A498C95C-6227-4D84-9EAA-8E1731B9675C}"/>
               </a:ext>
             </a:extLst>
           </p:cNvPr>
@@ -14230,7 +14320,7 @@
         </p:nvSpPr>
         <p:spPr>
           <a:xfrm xmlns:a="http://schemas.openxmlformats.org/drawingml/2006/main">
-            <a:off x="1143000" y="7858125"/>
+            <a:off x="1143000" y="8143875"/>
             <a:ext cx="16002000" cy="571500"/>
           </a:xfrm>
           <a:prstGeom xmlns:a="http://schemas.openxmlformats.org/drawingml/2006/main" prst="rect">
@@ -14247,7 +14337,7 @@
           </a:bodyPr>
           <a:lstStyle xmlns:a="http://schemas.openxmlformats.org/drawingml/2006/main">
             <a:defPPr algn="l">
-              <a:defRPr sz="3150" b="1">
+              <a:defRPr sz="3000" b="1">
                 <a:solidFill>
                   <a:srgbClr val="2B5BEB"/>
                 </a:solidFill>
@@ -14257,7 +14347,7 @@
               </a:defRPr>
             </a:defPPr>
             <a:lvl1pPr algn="l">
-              <a:defRPr sz="3150" b="1">
+              <a:defRPr sz="3000" b="1">
                 <a:solidFill>
                   <a:srgbClr val="2B5BEB"/>
                 </a:solidFill>
@@ -14267,7 +14357,7 @@
               </a:defRPr>
             </a:lvl1pPr>
             <a:lvl2pPr algn="l">
-              <a:defRPr sz="3150" b="1">
+              <a:defRPr sz="3000" b="1">
                 <a:solidFill>
                   <a:srgbClr val="2B5BEB"/>
                 </a:solidFill>
@@ -14277,7 +14367,7 @@
               </a:defRPr>
             </a:lvl2pPr>
             <a:lvl3pPr algn="l">
-              <a:defRPr sz="3150" b="1">
+              <a:defRPr sz="3000" b="1">
                 <a:solidFill>
                   <a:srgbClr val="2B5BEB"/>
                 </a:solidFill>
@@ -14287,7 +14377,7 @@
               </a:defRPr>
             </a:lvl3pPr>
             <a:lvl4pPr algn="l">
-              <a:defRPr sz="3150" b="1">
+              <a:defRPr sz="3000" b="1">
                 <a:solidFill>
                   <a:srgbClr val="2B5BEB"/>
                 </a:solidFill>
@@ -14297,7 +14387,7 @@
               </a:defRPr>
             </a:lvl4pPr>
             <a:lvl5pPr algn="l">
-              <a:defRPr sz="3150" b="1">
+              <a:defRPr sz="3000" b="1">
                 <a:solidFill>
                   <a:srgbClr val="2B5BEB"/>
                 </a:solidFill>
@@ -14307,7 +14397,7 @@
               </a:defRPr>
             </a:lvl5pPr>
             <a:lvl6pPr algn="l">
-              <a:defRPr sz="3150" b="1">
+              <a:defRPr sz="3000" b="1">
                 <a:solidFill>
                   <a:srgbClr val="2B5BEB"/>
                 </a:solidFill>
@@ -14317,7 +14407,7 @@
               </a:defRPr>
             </a:lvl6pPr>
             <a:lvl7pPr algn="l">
-              <a:defRPr sz="3150" b="1">
+              <a:defRPr sz="3000" b="1">
                 <a:solidFill>
                   <a:srgbClr val="2B5BEB"/>
                 </a:solidFill>
@@ -14327,7 +14417,7 @@
               </a:defRPr>
             </a:lvl7pPr>
             <a:lvl8pPr algn="l">
-              <a:defRPr sz="3150" b="1">
+              <a:defRPr sz="3000" b="1">
                 <a:solidFill>
                   <a:srgbClr val="2B5BEB"/>
                 </a:solidFill>
@@ -14337,7 +14427,7 @@
               </a:defRPr>
             </a:lvl8pPr>
             <a:lvl9pPr algn="l">
-              <a:defRPr sz="3150" b="1">
+              <a:defRPr sz="3000" b="1">
                 <a:solidFill>
                   <a:srgbClr val="2B5BEB"/>
                 </a:solidFill>
@@ -14349,7 +14439,7 @@
           </a:lstStyle>
           <a:p xmlns:a="http://schemas.openxmlformats.org/drawingml/2006/main">
             <a:pPr algn="l">
-              <a:defRPr sz="3150" b="1">
+              <a:defRPr sz="3000" b="1">
                 <a:solidFill>
                   <a:srgbClr val="2B5BEB"/>
                 </a:solidFill>
@@ -14359,7 +14449,7 @@
               </a:defRPr>
             </a:pPr>
             <a:r>
-              <a:rPr sz="3150" b="1">
+              <a:rPr sz="3000" b="1">
                 <a:solidFill>
                   <a:srgbClr val="2B5BEB"/>
                 </a:solidFill>
@@ -14367,7 +14457,7 @@
                 <a:ea typeface="Noto Sans Bold"/>
                 <a:cs typeface="Noto Sans Bold"/>
               </a:rPr>
-              <a:t>조사 과정과 보고서의 신뢰성을 함께 확인</a:t>
+              <a:t>판단 과정과 보고서 근거를 확인할 수 있게 개선</a:t>
             </a:r>
           </a:p>
         </p:txBody>
@@ -14375,7 +14465,7 @@
     </p:spTree>
     <p:extLst>
       <p:ext uri="{BB962C8B-B14F-4D97-AF65-F5344CB8AC3E}">
-        <p14:creationId xmlns:p14="http://schemas.microsoft.com/office/powerpoint/2010/main" val="571331820"/>
+        <p14:creationId xmlns:p14="http://schemas.microsoft.com/office/powerpoint/2010/main" val="30926151"/>
       </p:ext>
     </p:extLst>
   </p:cSld>
@@ -14564,7 +14654,7 @@
                 <a:ea typeface="Noto Sans Bold"/>
                 <a:cs typeface="Noto Sans Bold"/>
               </a:rPr>
-              <a:t>시스템 구조</a:t>
+              <a:t>개선 기능의 연결 위치</a:t>
             </a:r>
           </a:p>
         </p:txBody>
@@ -14900,7 +14990,7 @@
                 <a:ea typeface="Noto Sans Bold"/>
                 <a:cs typeface="Noto Sans Bold"/>
               </a:rPr>
-              <a:t>전체 아키텍처</a:t>
+              <a:t>개선 기능을 연결한 전체 구조</a:t>
             </a:r>
           </a:p>
         </p:txBody>
@@ -15068,7 +15158,7 @@
                 <a:ea typeface="Noto Sans Kr"/>
                 <a:cs typeface="Noto Sans Kr"/>
               </a:rPr>
-              <a:t>Supervisor가 전문 조회·추가 조사를 조정하고, 진행 상황과 근거를 기록합니다.</a:t>
+              <a:t>중앙의 조사·검증과 화면·관측·평가 연결을 개선했습니다.</a:t>
             </a:r>
           </a:p>
         </p:txBody>
@@ -15236,7 +15326,7 @@
                 <a:ea typeface="Noto Sans Kr"/>
                 <a:cs typeface="Noto Sans Kr"/>
               </a:rPr>
-              <a:t>실제 LLM 연결 / 지표·로그·추가 관측은 교육용 합성 데이터</a:t>
+              <a:t>개선한 연결: 조사·검증 반복, 판단 이력, 추가 관측·검색·평가 기록</a:t>
             </a:r>
           </a:p>
         </p:txBody>
@@ -15246,7 +15336,7 @@
           <p:cNvPr id="6" name="footer-rule">
             <a:extLst xmlns:a="http://schemas.openxmlformats.org/drawingml/2006/main">
               <a:ext uri="{FF2B5EF4-FFF2-40B4-BE49-F238E27FC236}">
-                <a16:creationId xmlns:a16="http://schemas.microsoft.com/office/drawing/2014/main" id="{C40E4B04-F7F6-48FD-B467-2C44B54114F2}"/>
+                <a16:creationId xmlns:a16="http://schemas.microsoft.com/office/drawing/2014/main" id="{19714E56-98A8-4954-ABAF-1D4BC7C2F12C}"/>
               </a:ext>
             </a:extLst>
           </p:cNvPr>
@@ -15441,7 +15531,7 @@
           <p:cNvPr id="8" name="architecture-link">
             <a:extLst xmlns:a="http://schemas.openxmlformats.org/drawingml/2006/main">
               <a:ext uri="{FF2B5EF4-FFF2-40B4-BE49-F238E27FC236}">
-                <a16:creationId xmlns:a16="http://schemas.microsoft.com/office/drawing/2014/main" id="{C07D86C2-1E6A-4CF1-B436-B02FAE0C1029}"/>
+                <a16:creationId xmlns:a16="http://schemas.microsoft.com/office/drawing/2014/main" id="{1B017F22-9872-472D-BCAC-F4360437674E}"/>
               </a:ext>
             </a:extLst>
           </p:cNvPr>
@@ -15469,7 +15559,7 @@
           <p:cNvPr id="9" name="architecture-link">
             <a:extLst xmlns:a="http://schemas.openxmlformats.org/drawingml/2006/main">
               <a:ext uri="{FF2B5EF4-FFF2-40B4-BE49-F238E27FC236}">
-                <a16:creationId xmlns:a16="http://schemas.microsoft.com/office/drawing/2014/main" id="{004CFB26-78C1-4222-A848-E596155E15B5}"/>
+                <a16:creationId xmlns:a16="http://schemas.microsoft.com/office/drawing/2014/main" id="{95C3C867-7675-4290-8D99-5A0132DD4D13}"/>
               </a:ext>
             </a:extLst>
           </p:cNvPr>
@@ -15833,7 +15923,7 @@
           <p:cNvPr id="12" name="architecture-link">
             <a:extLst xmlns:a="http://schemas.openxmlformats.org/drawingml/2006/main">
               <a:ext uri="{FF2B5EF4-FFF2-40B4-BE49-F238E27FC236}">
-                <a16:creationId xmlns:a16="http://schemas.microsoft.com/office/drawing/2014/main" id="{D190D733-EDE6-4857-86B7-D9BC68548D6F}"/>
+                <a16:creationId xmlns:a16="http://schemas.microsoft.com/office/drawing/2014/main" id="{B477EC1A-DEE1-4EA4-9DEC-19404A00680E}"/>
               </a:ext>
             </a:extLst>
           </p:cNvPr>
@@ -16029,7 +16119,7 @@
           <p:cNvPr id="14" name="architecture-link">
             <a:extLst xmlns:a="http://schemas.openxmlformats.org/drawingml/2006/main">
               <a:ext uri="{FF2B5EF4-FFF2-40B4-BE49-F238E27FC236}">
-                <a16:creationId xmlns:a16="http://schemas.microsoft.com/office/drawing/2014/main" id="{CC6C85DB-99EA-4185-988C-D7300BF8583C}"/>
+                <a16:creationId xmlns:a16="http://schemas.microsoft.com/office/drawing/2014/main" id="{08006701-4C2A-416B-BE5D-77A2F806C5CC}"/>
               </a:ext>
             </a:extLst>
           </p:cNvPr>
@@ -16057,7 +16147,7 @@
           <p:cNvPr id="15" name="architecture-link">
             <a:extLst xmlns:a="http://schemas.openxmlformats.org/drawingml/2006/main">
               <a:ext uri="{FF2B5EF4-FFF2-40B4-BE49-F238E27FC236}">
-                <a16:creationId xmlns:a16="http://schemas.microsoft.com/office/drawing/2014/main" id="{F7DF0B71-2D70-4627-AC0B-7A7BFE4E60C9}"/>
+                <a16:creationId xmlns:a16="http://schemas.microsoft.com/office/drawing/2014/main" id="{6B689C45-E5E3-4FC3-9E54-001F8A7B80F4}"/>
               </a:ext>
             </a:extLst>
           </p:cNvPr>
@@ -16086,7 +16176,7 @@
           <p:cNvPr id="16" name="architecture-link">
             <a:extLst xmlns:a="http://schemas.openxmlformats.org/drawingml/2006/main">
               <a:ext uri="{FF2B5EF4-FFF2-40B4-BE49-F238E27FC236}">
-                <a16:creationId xmlns:a16="http://schemas.microsoft.com/office/drawing/2014/main" id="{2BFC9E38-E04B-49C0-B3C9-88D84B6D4C9D}"/>
+                <a16:creationId xmlns:a16="http://schemas.microsoft.com/office/drawing/2014/main" id="{2A1423BF-07BA-479B-8749-9209150EC151}"/>
               </a:ext>
             </a:extLst>
           </p:cNvPr>
@@ -16114,7 +16204,7 @@
           <p:cNvPr id="17" name="architecture-link">
             <a:extLst xmlns:a="http://schemas.openxmlformats.org/drawingml/2006/main">
               <a:ext uri="{FF2B5EF4-FFF2-40B4-BE49-F238E27FC236}">
-                <a16:creationId xmlns:a16="http://schemas.microsoft.com/office/drawing/2014/main" id="{E1128387-FCC2-4621-AD42-28AF06F98536}"/>
+                <a16:creationId xmlns:a16="http://schemas.microsoft.com/office/drawing/2014/main" id="{95E33ADB-F836-4673-85AC-08A6C2206626}"/>
               </a:ext>
             </a:extLst>
           </p:cNvPr>
@@ -16142,7 +16232,7 @@
           <p:cNvPr id="18" name="architecture-link">
             <a:extLst xmlns:a="http://schemas.openxmlformats.org/drawingml/2006/main">
               <a:ext uri="{FF2B5EF4-FFF2-40B4-BE49-F238E27FC236}">
-                <a16:creationId xmlns:a16="http://schemas.microsoft.com/office/drawing/2014/main" id="{18BE9324-C01A-4F91-8324-82E252C75C7E}"/>
+                <a16:creationId xmlns:a16="http://schemas.microsoft.com/office/drawing/2014/main" id="{F07720DC-3EB0-4A61-9D32-2D313526457B}"/>
               </a:ext>
             </a:extLst>
           </p:cNvPr>
@@ -16361,7 +16451,7 @@
                 <a:ea typeface="Noto Sans Kr"/>
                 <a:cs typeface="Noto Sans Kr"/>
               </a:rPr>
-              <a:t>채팅·조사 과정</a:t>
+              <a:t>조사 이유·판단 이력</a:t>
             </a:r>
           </a:p>
         </p:txBody>
@@ -16763,7 +16853,7 @@
                 <a:ea typeface="Noto Sans Kr"/>
                 <a:cs typeface="Noto Sans Kr"/>
               </a:rPr>
-              <a:t>Supervisor · 전문 조회 조정</a:t>
+              <a:t>Supervisor · 조회 조정</a:t>
             </a:r>
             <a:br>
               <a:rPr sz="2250">
@@ -16784,7 +16874,7 @@
                 <a:ea typeface="Noto Sans Kr"/>
                 <a:cs typeface="Noto Sans Kr"/>
               </a:rPr>
-              <a:t>가설 조사·보고서 근거 검증</a:t>
+              <a:t>추가 조사·검증 반복</a:t>
             </a:r>
           </a:p>
         </p:txBody>
@@ -17387,7 +17477,7 @@
                 <a:ea typeface="Noto Sans Kr"/>
                 <a:cs typeface="Noto Sans Kr"/>
               </a:rPr>
-              <a:t>결과·근거·대화</a:t>
+              <a:t>가설·근거·맥락</a:t>
             </a:r>
           </a:p>
         </p:txBody>
@@ -17588,7 +17678,7 @@
                 <a:ea typeface="Noto Sans Kr"/>
                 <a:cs typeface="Noto Sans Kr"/>
               </a:rPr>
-              <a:t>읽기 전용 관측</a:t>
+              <a:t>관측·실패 격리</a:t>
             </a:r>
           </a:p>
         </p:txBody>
@@ -17789,7 +17879,7 @@
                 <a:ea typeface="Noto Sans Kr"/>
                 <a:cs typeface="Noto Sans Kr"/>
               </a:rPr>
-              <a:t>매뉴얼 검색</a:t>
+              <a:t>관측 반영 검색</a:t>
             </a:r>
           </a:p>
         </p:txBody>
@@ -18020,7 +18110,7 @@
           <p:cNvPr id="18" name="section-label">
             <a:extLst xmlns:a="http://schemas.openxmlformats.org/drawingml/2006/main">
               <a:ext uri="{FF2B5EF4-FFF2-40B4-BE49-F238E27FC236}">
-                <a16:creationId xmlns:a16="http://schemas.microsoft.com/office/drawing/2014/main" id="{10EED478-3352-40FC-8C4B-2B8C69FF5B74}"/>
+                <a16:creationId xmlns:a16="http://schemas.microsoft.com/office/drawing/2014/main" id="{45395C77-27E2-47D8-9F49-3436341221FC}"/>
               </a:ext>
             </a:extLst>
           </p:cNvPr>
@@ -18168,7 +18258,7 @@
                 <a:ea typeface="Noto Sans Bold"/>
                 <a:cs typeface="Noto Sans Bold"/>
               </a:rPr>
-              <a:t>핵심 기능: 조사 원리</a:t>
+              <a:t>개선 1: 가설 기반 추가 조사</a:t>
             </a:r>
           </a:p>
         </p:txBody>
@@ -18178,7 +18268,7 @@
           <p:cNvPr id="2" name="page-number">
             <a:extLst xmlns:a="http://schemas.openxmlformats.org/drawingml/2006/main">
               <a:ext uri="{FF2B5EF4-FFF2-40B4-BE49-F238E27FC236}">
-                <a16:creationId xmlns:a16="http://schemas.microsoft.com/office/drawing/2014/main" id="{5FB67FDA-676D-4638-9B58-62D509033B54}"/>
+                <a16:creationId xmlns:a16="http://schemas.microsoft.com/office/drawing/2014/main" id="{C9E7556D-9AA7-43E4-971F-B05BB536E60B}"/>
               </a:ext>
             </a:extLst>
           </p:cNvPr>
@@ -18336,7 +18426,7 @@
           <p:cNvPr id="3" name="slide-title">
             <a:extLst xmlns:a="http://schemas.openxmlformats.org/drawingml/2006/main">
               <a:ext uri="{FF2B5EF4-FFF2-40B4-BE49-F238E27FC236}">
-                <a16:creationId xmlns:a16="http://schemas.microsoft.com/office/drawing/2014/main" id="{EC1FD576-3B66-484E-9C69-28C2B30A773B}"/>
+                <a16:creationId xmlns:a16="http://schemas.microsoft.com/office/drawing/2014/main" id="{3E0E90FD-78E6-4E2B-983A-B50C87D76F6C}"/>
               </a:ext>
             </a:extLst>
           </p:cNvPr>
@@ -18484,7 +18574,7 @@
                 <a:ea typeface="Noto Sans Bold"/>
                 <a:cs typeface="Noto Sans Bold"/>
               </a:rPr>
-              <a:t>가설을 구별하는 조사 규칙</a:t>
+              <a:t>원인 추정에 반증 절차 추가</a:t>
             </a:r>
           </a:p>
         </p:txBody>
@@ -18494,7 +18584,7 @@
           <p:cNvPr id="4" name="slide-subtitle">
             <a:extLst xmlns:a="http://schemas.openxmlformats.org/drawingml/2006/main">
               <a:ext uri="{FF2B5EF4-FFF2-40B4-BE49-F238E27FC236}">
-                <a16:creationId xmlns:a16="http://schemas.microsoft.com/office/drawing/2014/main" id="{1EC78954-8C70-490E-9AB1-6A578DAFEDAB}"/>
+                <a16:creationId xmlns:a16="http://schemas.microsoft.com/office/drawing/2014/main" id="{C2C5D57C-4706-45CE-83C7-90102FA9F350}"/>
               </a:ext>
             </a:extLst>
           </p:cNvPr>
@@ -18642,7 +18732,7 @@
                 <a:ea typeface="Noto Sans Kr"/>
                 <a:cs typeface="Noto Sans Kr"/>
               </a:rPr>
-              <a:t>관측을 읽기 전에 지지·반증 조건을 고정합니다.</a:t>
+              <a:t>경고로 추정하던 원인을, 구별 가능한 관측으로 확인합니다.</a:t>
             </a:r>
           </a:p>
         </p:txBody>
@@ -18652,7 +18742,7 @@
           <p:cNvPr id="5" name="scope-note">
             <a:extLst xmlns:a="http://schemas.openxmlformats.org/drawingml/2006/main">
               <a:ext uri="{FF2B5EF4-FFF2-40B4-BE49-F238E27FC236}">
-                <a16:creationId xmlns:a16="http://schemas.microsoft.com/office/drawing/2014/main" id="{6FD3E9EB-E475-46AF-9173-29A1900B3EDE}"/>
+                <a16:creationId xmlns:a16="http://schemas.microsoft.com/office/drawing/2014/main" id="{F2B07607-4263-4279-8E54-33E9F077E9D3}"/>
               </a:ext>
             </a:extLst>
           </p:cNvPr>
@@ -18810,7 +18900,7 @@
           <p:cNvPr id="6" name="footer-rule">
             <a:extLst xmlns:a="http://schemas.openxmlformats.org/drawingml/2006/main">
               <a:ext uri="{FF2B5EF4-FFF2-40B4-BE49-F238E27FC236}">
-                <a16:creationId xmlns:a16="http://schemas.microsoft.com/office/drawing/2014/main" id="{856A2643-8624-4980-9489-3AF1C540A0B5}"/>
+                <a16:creationId xmlns:a16="http://schemas.microsoft.com/office/drawing/2014/main" id="{7AD0C466-2F97-47E1-AA01-130F0E59A1B7}"/>
               </a:ext>
             </a:extLst>
           </p:cNvPr>
@@ -18837,7 +18927,7 @@
           <p:cNvPr id="7" name="footer">
             <a:extLst xmlns:a="http://schemas.openxmlformats.org/drawingml/2006/main">
               <a:ext uri="{FF2B5EF4-FFF2-40B4-BE49-F238E27FC236}">
-                <a16:creationId xmlns:a16="http://schemas.microsoft.com/office/drawing/2014/main" id="{E43C2D18-E063-4B19-BFBB-75E16FA26AD8}"/>
+                <a16:creationId xmlns:a16="http://schemas.microsoft.com/office/drawing/2014/main" id="{1F857575-30F9-4C97-92DF-5B3C5EFDFB55}"/>
               </a:ext>
             </a:extLst>
           </p:cNvPr>
@@ -18995,7 +19085,7 @@
           <p:cNvPr id="8" name="rule-number-0">
             <a:extLst xmlns:a="http://schemas.openxmlformats.org/drawingml/2006/main">
               <a:ext uri="{FF2B5EF4-FFF2-40B4-BE49-F238E27FC236}">
-                <a16:creationId xmlns:a16="http://schemas.microsoft.com/office/drawing/2014/main" id="{7819BE29-39F5-4C0C-89D7-4D2CE587E862}"/>
+                <a16:creationId xmlns:a16="http://schemas.microsoft.com/office/drawing/2014/main" id="{627C7213-DD33-4DC8-964B-0B52BB2332DF}"/>
               </a:ext>
             </a:extLst>
           </p:cNvPr>
@@ -19153,7 +19243,7 @@
           <p:cNvPr id="9" name="rule-title-0">
             <a:extLst xmlns:a="http://schemas.openxmlformats.org/drawingml/2006/main">
               <a:ext uri="{FF2B5EF4-FFF2-40B4-BE49-F238E27FC236}">
-                <a16:creationId xmlns:a16="http://schemas.microsoft.com/office/drawing/2014/main" id="{1DA88FFC-5460-45F9-BBE8-53FFD31811BE}"/>
+                <a16:creationId xmlns:a16="http://schemas.microsoft.com/office/drawing/2014/main" id="{F314AD56-C2F2-44B0-90D8-2EA1792C594D}"/>
               </a:ext>
             </a:extLst>
           </p:cNvPr>
@@ -19301,7 +19391,7 @@
                 <a:ea typeface="Noto Sans Bold"/>
                 <a:cs typeface="Noto Sans Bold"/>
               </a:rPr>
-              <a:t>사전 조건 고정</a:t>
+              <a:t>조건 먼저 고정</a:t>
             </a:r>
           </a:p>
         </p:txBody>
@@ -19311,7 +19401,7 @@
           <p:cNvPr id="10" name="rule-body-0">
             <a:extLst xmlns:a="http://schemas.openxmlformats.org/drawingml/2006/main">
               <a:ext uri="{FF2B5EF4-FFF2-40B4-BE49-F238E27FC236}">
-                <a16:creationId xmlns:a16="http://schemas.microsoft.com/office/drawing/2014/main" id="{6A7D3AC1-4C44-414C-BF7E-424B48A37E5D}"/>
+                <a16:creationId xmlns:a16="http://schemas.microsoft.com/office/drawing/2014/main" id="{DD6283DB-0A3D-43C1-8F5B-FF15B1DC8DE7}"/>
               </a:ext>
             </a:extLst>
           </p:cNvPr>
@@ -19459,7 +19549,7 @@
                 <a:ea typeface="Noto Sans Kr"/>
                 <a:cs typeface="Noto Sans Kr"/>
               </a:rPr>
-              <a:t>예: 작업 CPU 기여 70% 이상이면 지지</a:t>
+              <a:t>작업 CPU 기여 70% 이상 지지·15% 이하 반증</a:t>
             </a:r>
           </a:p>
         </p:txBody>
@@ -19469,7 +19559,7 @@
           <p:cNvPr id="11" name="rule-number-1">
             <a:extLst xmlns:a="http://schemas.openxmlformats.org/drawingml/2006/main">
               <a:ext uri="{FF2B5EF4-FFF2-40B4-BE49-F238E27FC236}">
-                <a16:creationId xmlns:a16="http://schemas.microsoft.com/office/drawing/2014/main" id="{A074F22B-F98D-4C3F-9FDE-C52281504FCC}"/>
+                <a16:creationId xmlns:a16="http://schemas.microsoft.com/office/drawing/2014/main" id="{2D5B71FC-331D-4787-A64D-AEFE491787DB}"/>
               </a:ext>
             </a:extLst>
           </p:cNvPr>
@@ -19627,7 +19717,7 @@
           <p:cNvPr id="12" name="rule-title-1">
             <a:extLst xmlns:a="http://schemas.openxmlformats.org/drawingml/2006/main">
               <a:ext uri="{FF2B5EF4-FFF2-40B4-BE49-F238E27FC236}">
-                <a16:creationId xmlns:a16="http://schemas.microsoft.com/office/drawing/2014/main" id="{4AE73513-EABA-4B72-908B-46E4ECB6C8BD}"/>
+                <a16:creationId xmlns:a16="http://schemas.microsoft.com/office/drawing/2014/main" id="{9391035A-2EE1-4F00-BDEC-FBEDE7E8B3A9}"/>
               </a:ext>
             </a:extLst>
           </p:cNvPr>
@@ -19775,7 +19865,7 @@
                 <a:ea typeface="Noto Sans Bold"/>
                 <a:cs typeface="Noto Sans Bold"/>
               </a:rPr>
-              <a:t>LLM의 질문 선택</a:t>
+              <a:t>남은 질문 선택</a:t>
             </a:r>
           </a:p>
         </p:txBody>
@@ -19785,7 +19875,7 @@
           <p:cNvPr id="13" name="rule-body-1">
             <a:extLst xmlns:a="http://schemas.openxmlformats.org/drawingml/2006/main">
               <a:ext uri="{FF2B5EF4-FFF2-40B4-BE49-F238E27FC236}">
-                <a16:creationId xmlns:a16="http://schemas.microsoft.com/office/drawing/2014/main" id="{875151A5-C5C6-4A05-A025-6DCB6E354E51}"/>
+                <a16:creationId xmlns:a16="http://schemas.microsoft.com/office/drawing/2014/main" id="{B734B0FC-5E79-4A2E-A42F-1C9A599A256E}"/>
               </a:ext>
             </a:extLst>
           </p:cNvPr>
@@ -19933,7 +20023,7 @@
                 <a:ea typeface="Noto Sans Kr"/>
                 <a:cs typeface="Noto Sans Kr"/>
               </a:rPr>
-              <a:t>허용된 미수행 질문 중 다음 조사 선택</a:t>
+              <a:t>LLM이 허용된 미수행 관측을 선택</a:t>
             </a:r>
           </a:p>
         </p:txBody>
@@ -19943,7 +20033,7 @@
           <p:cNvPr id="14" name="rule-number-2">
             <a:extLst xmlns:a="http://schemas.openxmlformats.org/drawingml/2006/main">
               <a:ext uri="{FF2B5EF4-FFF2-40B4-BE49-F238E27FC236}">
-                <a16:creationId xmlns:a16="http://schemas.microsoft.com/office/drawing/2014/main" id="{E1939D0C-800A-404E-BEA0-64251C3AF20F}"/>
+                <a16:creationId xmlns:a16="http://schemas.microsoft.com/office/drawing/2014/main" id="{8C8E0150-F14F-4C3A-8CB0-BAB6D5A6DA78}"/>
               </a:ext>
             </a:extLst>
           </p:cNvPr>
@@ -20101,7 +20191,7 @@
           <p:cNvPr id="15" name="rule-title-2">
             <a:extLst xmlns:a="http://schemas.openxmlformats.org/drawingml/2006/main">
               <a:ext uri="{FF2B5EF4-FFF2-40B4-BE49-F238E27FC236}">
-                <a16:creationId xmlns:a16="http://schemas.microsoft.com/office/drawing/2014/main" id="{364C5610-1E05-4059-9E0F-83AB3BE841FA}"/>
+                <a16:creationId xmlns:a16="http://schemas.microsoft.com/office/drawing/2014/main" id="{425E6A12-419B-442B-9B38-C2488324627C}"/>
               </a:ext>
             </a:extLst>
           </p:cNvPr>
@@ -20249,7 +20339,7 @@
                 <a:ea typeface="Noto Sans Bold"/>
                 <a:cs typeface="Noto Sans Bold"/>
               </a:rPr>
-              <a:t>코드의 판정·종료</a:t>
+              <a:t>판정·다음 단계</a:t>
             </a:r>
           </a:p>
         </p:txBody>
@@ -20259,7 +20349,7 @@
           <p:cNvPr id="16" name="rule-body-2">
             <a:extLst xmlns:a="http://schemas.openxmlformats.org/drawingml/2006/main">
               <a:ext uri="{FF2B5EF4-FFF2-40B4-BE49-F238E27FC236}">
-                <a16:creationId xmlns:a16="http://schemas.microsoft.com/office/drawing/2014/main" id="{5F9A023E-FF9C-4604-B017-2CB92B6008A9}"/>
+                <a16:creationId xmlns:a16="http://schemas.microsoft.com/office/drawing/2014/main" id="{D9A76086-138B-4290-9164-38EEB91F233D}"/>
               </a:ext>
             </a:extLst>
           </p:cNvPr>
@@ -20407,7 +20497,7 @@
                 <a:ea typeface="Noto Sans Kr"/>
                 <a:cs typeface="Noto Sans Kr"/>
               </a:rPr>
-              <a:t>관측 대조 후 반복·종료·판단 보류</a:t>
+              <a:t>코드가 관측을 대조해 반복·종료·보류</a:t>
             </a:r>
           </a:p>
         </p:txBody>
@@ -20417,7 +20507,7 @@
           <p:cNvPr id="17" name="investigation-stop-policy">
             <a:extLst xmlns:a="http://schemas.openxmlformats.org/drawingml/2006/main">
               <a:ext uri="{FF2B5EF4-FFF2-40B4-BE49-F238E27FC236}">
-                <a16:creationId xmlns:a16="http://schemas.microsoft.com/office/drawing/2014/main" id="{21DB25F7-3662-4426-8844-FF58592EAFB2}"/>
+                <a16:creationId xmlns:a16="http://schemas.microsoft.com/office/drawing/2014/main" id="{708F12F9-22D2-4CA5-842B-B25DFFA86360}"/>
               </a:ext>
             </a:extLst>
           </p:cNvPr>
@@ -20565,7 +20655,7 @@
                 <a:ea typeface="Noto Sans Bold"/>
                 <a:cs typeface="Noto Sans Bold"/>
               </a:rPr>
-              <a:t>충분한 구별 근거가 확보되면 한도 전에 종료</a:t>
+              <a:t>교차 지지와 경쟁 가설의 반증 확보 시 조기 종료</a:t>
             </a:r>
           </a:p>
         </p:txBody>
@@ -20573,7 +20663,7 @@
     </p:spTree>
     <p:extLst>
       <p:ext uri="{BB962C8B-B14F-4D97-AF65-F5344CB8AC3E}">
-        <p14:creationId xmlns:p14="http://schemas.microsoft.com/office/powerpoint/2010/main" val="2119773544"/>
+        <p14:creationId xmlns:p14="http://schemas.microsoft.com/office/powerpoint/2010/main" val="1768256028"/>
       </p:ext>
     </p:extLst>
   </p:cSld>
@@ -20604,7 +20694,7 @@
           <p:cNvPr id="10" name="section-label">
             <a:extLst xmlns:a="http://schemas.openxmlformats.org/drawingml/2006/main">
               <a:ext uri="{FF2B5EF4-FFF2-40B4-BE49-F238E27FC236}">
-                <a16:creationId xmlns:a16="http://schemas.microsoft.com/office/drawing/2014/main" id="{423DF070-77A4-47AA-983A-D306DAF3CA75}"/>
+                <a16:creationId xmlns:a16="http://schemas.microsoft.com/office/drawing/2014/main" id="{B9A0E8AB-FC9B-4298-ACCE-5E5D727D9A83}"/>
               </a:ext>
             </a:extLst>
           </p:cNvPr>
@@ -20752,7 +20842,7 @@
                 <a:ea typeface="Noto Sans Bold"/>
                 <a:cs typeface="Noto Sans Bold"/>
               </a:rPr>
-              <a:t>실행 결과: 조사 과정</a:t>
+              <a:t>개선 2: 조사 과정을 보는 화면</a:t>
             </a:r>
           </a:p>
         </p:txBody>
@@ -20762,7 +20852,7 @@
           <p:cNvPr id="2" name="page-number">
             <a:extLst xmlns:a="http://schemas.openxmlformats.org/drawingml/2006/main">
               <a:ext uri="{FF2B5EF4-FFF2-40B4-BE49-F238E27FC236}">
-                <a16:creationId xmlns:a16="http://schemas.microsoft.com/office/drawing/2014/main" id="{60E569DE-9EEE-438E-9A78-A454EE61F4A9}"/>
+                <a16:creationId xmlns:a16="http://schemas.microsoft.com/office/drawing/2014/main" id="{6300F2BE-9234-46E1-8F9E-31BA94A56E01}"/>
               </a:ext>
             </a:extLst>
           </p:cNvPr>
@@ -20920,7 +21010,7 @@
           <p:cNvPr id="3" name="slide-title">
             <a:extLst xmlns:a="http://schemas.openxmlformats.org/drawingml/2006/main">
               <a:ext uri="{FF2B5EF4-FFF2-40B4-BE49-F238E27FC236}">
-                <a16:creationId xmlns:a16="http://schemas.microsoft.com/office/drawing/2014/main" id="{03BD915F-2267-47A2-8197-218937985EFD}"/>
+                <a16:creationId xmlns:a16="http://schemas.microsoft.com/office/drawing/2014/main" id="{E1370542-E7B1-477A-9FB1-21899773B4BF}"/>
               </a:ext>
             </a:extLst>
           </p:cNvPr>
@@ -21068,7 +21158,7 @@
                 <a:ea typeface="Noto Sans Bold"/>
                 <a:cs typeface="Noto Sans Bold"/>
               </a:rPr>
-              <a:t>실제 추가 조사 화면</a:t>
+              <a:t>조사 이유와 판단 변화 표시</a:t>
             </a:r>
           </a:p>
         </p:txBody>
@@ -21078,7 +21168,7 @@
           <p:cNvPr id="4" name="slide-subtitle">
             <a:extLst xmlns:a="http://schemas.openxmlformats.org/drawingml/2006/main">
               <a:ext uri="{FF2B5EF4-FFF2-40B4-BE49-F238E27FC236}">
-                <a16:creationId xmlns:a16="http://schemas.microsoft.com/office/drawing/2014/main" id="{C3E494CC-268A-4996-9194-B873CE8E2DBC}"/>
+                <a16:creationId xmlns:a16="http://schemas.microsoft.com/office/drawing/2014/main" id="{CBD0337E-DE0C-4C55-9B95-F632782315DB}"/>
               </a:ext>
             </a:extLst>
           </p:cNvPr>
@@ -21226,7 +21316,7 @@
                 <a:ea typeface="Noto Sans Kr"/>
                 <a:cs typeface="Noto Sans Kr"/>
               </a:rPr>
-              <a:t>CPU 귀속을 확인하고, 요청량 관측으로 교차 확인했습니다.</a:t>
+              <a:t>최종 답변에 더해, 관측과 가설 상태가 바뀐 이력을 보여줍니다.</a:t>
             </a:r>
           </a:p>
         </p:txBody>
@@ -21236,7 +21326,7 @@
           <p:cNvPr id="5" name="scope-note">
             <a:extLst xmlns:a="http://schemas.openxmlformats.org/drawingml/2006/main">
               <a:ext uri="{FF2B5EF4-FFF2-40B4-BE49-F238E27FC236}">
-                <a16:creationId xmlns:a16="http://schemas.microsoft.com/office/drawing/2014/main" id="{41C033BB-804F-4ED8-93C3-AA9EFBA78AD5}"/>
+                <a16:creationId xmlns:a16="http://schemas.microsoft.com/office/drawing/2014/main" id="{3A9C67E0-E852-4A80-8C84-82D7DB57ADDB}"/>
               </a:ext>
             </a:extLst>
           </p:cNvPr>
@@ -21394,7 +21484,7 @@
           <p:cNvPr id="6" name="footer-rule">
             <a:extLst xmlns:a="http://schemas.openxmlformats.org/drawingml/2006/main">
               <a:ext uri="{FF2B5EF4-FFF2-40B4-BE49-F238E27FC236}">
-                <a16:creationId xmlns:a16="http://schemas.microsoft.com/office/drawing/2014/main" id="{971AEEBD-1B2D-4EF9-A609-EEE3DCD78591}"/>
+                <a16:creationId xmlns:a16="http://schemas.microsoft.com/office/drawing/2014/main" id="{CE3BB639-3FCF-4A15-B4E4-D04E0BA18566}"/>
               </a:ext>
             </a:extLst>
           </p:cNvPr>
@@ -21421,7 +21511,7 @@
           <p:cNvPr id="7" name="footer">
             <a:extLst xmlns:a="http://schemas.openxmlformats.org/drawingml/2006/main">
               <a:ext uri="{FF2B5EF4-FFF2-40B4-BE49-F238E27FC236}">
-                <a16:creationId xmlns:a16="http://schemas.microsoft.com/office/drawing/2014/main" id="{789BC838-A1A3-481C-9C36-74A84E464C6F}"/>
+                <a16:creationId xmlns:a16="http://schemas.microsoft.com/office/drawing/2014/main" id="{96B0FF06-8B05-4F71-953D-97D3D1C91D92}"/>
               </a:ext>
             </a:extLst>
           </p:cNvPr>
@@ -21579,7 +21669,7 @@
           <p:cNvPr id="8" name="">
             <a:extLst xmlns:a="http://schemas.openxmlformats.org/drawingml/2006/main">
               <a:ext uri="{FF2B5EF4-FFF2-40B4-BE49-F238E27FC236}">
-                <a16:creationId xmlns:a16="http://schemas.microsoft.com/office/drawing/2014/main" id="{86E47AD2-9D87-48D6-8770-FE6E75C5B819}"/>
+                <a16:creationId xmlns:a16="http://schemas.microsoft.com/office/drawing/2014/main" id="{8170004C-EA63-4957-B338-32B01560B469}"/>
               </a:ext>
             </a:extLst>
           </p:cNvPr>
@@ -21589,7 +21679,7 @@
           <p:nvPr/>
         </p:nvPicPr>
         <p:blipFill>
-          <a:blip xmlns:r="http://schemas.openxmlformats.org/officeDocument/2006/relationships" xmlns:a="http://schemas.openxmlformats.org/drawingml/2006/main" r:embed="R671e6c0e6ce743b3"/>
+          <a:blip xmlns:r="http://schemas.openxmlformats.org/officeDocument/2006/relationships" xmlns:a="http://schemas.openxmlformats.org/drawingml/2006/main" r:embed="Rbd55dbfe958e4e7d"/>
           <a:srcRect xmlns:a="http://schemas.openxmlformats.org/drawingml/2006/main" l="19531" t="55833" r="25781" b="13611"/>
           <a:stretch xmlns:a="http://schemas.openxmlformats.org/drawingml/2006/main"/>
         </p:blipFill>
@@ -21608,7 +21698,7 @@
           <p:cNvPr id="9" name="actual-stop-reason">
             <a:extLst xmlns:a="http://schemas.openxmlformats.org/drawingml/2006/main">
               <a:ext uri="{FF2B5EF4-FFF2-40B4-BE49-F238E27FC236}">
-                <a16:creationId xmlns:a16="http://schemas.microsoft.com/office/drawing/2014/main" id="{2B9F6A61-154B-48CB-B80C-42BB09735B37}"/>
+                <a16:creationId xmlns:a16="http://schemas.microsoft.com/office/drawing/2014/main" id="{4BD22A07-7E17-4B5F-AFE0-7EDEA71322F3}"/>
               </a:ext>
             </a:extLst>
           </p:cNvPr>
@@ -21756,7 +21846,7 @@
                 <a:ea typeface="Noto Sans Bold"/>
                 <a:cs typeface="Noto Sans Bold"/>
               </a:rPr>
-              <a:t>두 종류 관측의 교차 지지와 경쟁 가설 반증 확보 후 종료</a:t>
+              <a:t>새 과정 화면: 조사 이유·사전 조건·관측·판단 변화 기록</a:t>
             </a:r>
           </a:p>
         </p:txBody>
@@ -21764,7 +21854,7 @@
     </p:spTree>
     <p:extLst>
       <p:ext uri="{BB962C8B-B14F-4D97-AF65-F5344CB8AC3E}">
-        <p14:creationId xmlns:p14="http://schemas.microsoft.com/office/powerpoint/2010/main" val="1849582691"/>
+        <p14:creationId xmlns:p14="http://schemas.microsoft.com/office/powerpoint/2010/main" val="393505279"/>
       </p:ext>
     </p:extLst>
   </p:cSld>
@@ -21795,7 +21885,7 @@
           <p:cNvPr id="10" name="section-label">
             <a:extLst xmlns:a="http://schemas.openxmlformats.org/drawingml/2006/main">
               <a:ext uri="{FF2B5EF4-FFF2-40B4-BE49-F238E27FC236}">
-                <a16:creationId xmlns:a16="http://schemas.microsoft.com/office/drawing/2014/main" id="{9072E988-5ECC-4A1A-91F1-3D526CA6D9A1}"/>
+                <a16:creationId xmlns:a16="http://schemas.microsoft.com/office/drawing/2014/main" id="{0543FF7B-99A3-4F12-9F62-EE186D046DFB}"/>
               </a:ext>
             </a:extLst>
           </p:cNvPr>
@@ -21943,7 +22033,7 @@
                 <a:ea typeface="Noto Sans Bold"/>
                 <a:cs typeface="Noto Sans Bold"/>
               </a:rPr>
-              <a:t>실행 결과: 가설 비교</a:t>
+              <a:t>검증 1: 추가 관측의 효과</a:t>
             </a:r>
           </a:p>
         </p:txBody>
@@ -21953,7 +22043,7 @@
           <p:cNvPr id="2" name="page-number">
             <a:extLst xmlns:a="http://schemas.openxmlformats.org/drawingml/2006/main">
               <a:ext uri="{FF2B5EF4-FFF2-40B4-BE49-F238E27FC236}">
-                <a16:creationId xmlns:a16="http://schemas.microsoft.com/office/drawing/2014/main" id="{CCEFB3D4-65BE-4C1D-BDB4-85B01D78AE97}"/>
+                <a16:creationId xmlns:a16="http://schemas.microsoft.com/office/drawing/2014/main" id="{CCDBA930-E664-4FE6-94E5-3235A91FB463}"/>
               </a:ext>
             </a:extLst>
           </p:cNvPr>
@@ -22111,7 +22201,7 @@
           <p:cNvPr id="3" name="slide-title">
             <a:extLst xmlns:a="http://schemas.openxmlformats.org/drawingml/2006/main">
               <a:ext uri="{FF2B5EF4-FFF2-40B4-BE49-F238E27FC236}">
-                <a16:creationId xmlns:a16="http://schemas.microsoft.com/office/drawing/2014/main" id="{12D3B2E8-207E-467A-9A6A-26E3E26CF308}"/>
+                <a16:creationId xmlns:a16="http://schemas.microsoft.com/office/drawing/2014/main" id="{CA79D985-AEFD-4A78-BAA7-E3F539CB18E6}"/>
               </a:ext>
             </a:extLst>
           </p:cNvPr>
@@ -22269,7 +22359,7 @@
           <p:cNvPr id="4" name="slide-subtitle">
             <a:extLst xmlns:a="http://schemas.openxmlformats.org/drawingml/2006/main">
               <a:ext uri="{FF2B5EF4-FFF2-40B4-BE49-F238E27FC236}">
-                <a16:creationId xmlns:a16="http://schemas.microsoft.com/office/drawing/2014/main" id="{F61D6165-5B3B-42DE-B993-C8153BD0EE31}"/>
+                <a16:creationId xmlns:a16="http://schemas.microsoft.com/office/drawing/2014/main" id="{7ED609F2-23F0-4E43-A6F7-42B29B5649B5}"/>
               </a:ext>
             </a:extLst>
           </p:cNvPr>
@@ -22427,7 +22517,7 @@
           <p:cNvPr id="5" name="scope-note">
             <a:extLst xmlns:a="http://schemas.openxmlformats.org/drawingml/2006/main">
               <a:ext uri="{FF2B5EF4-FFF2-40B4-BE49-F238E27FC236}">
-                <a16:creationId xmlns:a16="http://schemas.microsoft.com/office/drawing/2014/main" id="{6C48287C-AF43-4072-8B27-4709332514F7}"/>
+                <a16:creationId xmlns:a16="http://schemas.microsoft.com/office/drawing/2014/main" id="{4450DCC5-9ACD-428B-8B8A-72F4F6287997}"/>
               </a:ext>
             </a:extLst>
           </p:cNvPr>
@@ -22575,7 +22665,7 @@
                 <a:ea typeface="Noto Sans Kr"/>
                 <a:cs typeface="Noto Sans Kr"/>
               </a:rPr>
-              <a:t>2026-10-21 실제 LLM 실행 발췌 / 교육용 합성 관측 / 교차 지지는 인과 확정과 구분</a:t>
+              <a:t>2026-10-21 실제 LLM 실행 발췌 / 합성 관측 / 개선 버전 내 두 사례 비교·버전 전후 성능 비교와 구분</a:t>
             </a:r>
           </a:p>
         </p:txBody>
@@ -22585,7 +22675,7 @@
           <p:cNvPr id="6" name="footer-rule">
             <a:extLst xmlns:a="http://schemas.openxmlformats.org/drawingml/2006/main">
               <a:ext uri="{FF2B5EF4-FFF2-40B4-BE49-F238E27FC236}">
-                <a16:creationId xmlns:a16="http://schemas.microsoft.com/office/drawing/2014/main" id="{71EF6EE3-1145-4B46-889A-92D081FCA99D}"/>
+                <a16:creationId xmlns:a16="http://schemas.microsoft.com/office/drawing/2014/main" id="{350DA20F-3625-43E8-867B-F6CE65FE8593}"/>
               </a:ext>
             </a:extLst>
           </p:cNvPr>
@@ -22612,7 +22702,7 @@
           <p:cNvPr id="7" name="footer">
             <a:extLst xmlns:a="http://schemas.openxmlformats.org/drawingml/2006/main">
               <a:ext uri="{FF2B5EF4-FFF2-40B4-BE49-F238E27FC236}">
-                <a16:creationId xmlns:a16="http://schemas.microsoft.com/office/drawing/2014/main" id="{162589DA-5560-463C-AD0F-8149283C1590}"/>
+                <a16:creationId xmlns:a16="http://schemas.microsoft.com/office/drawing/2014/main" id="{E5CCF5B4-B82F-4B43-847F-91EF67322010}"/>
               </a:ext>
             </a:extLst>
           </p:cNvPr>
@@ -22770,7 +22860,7 @@
           <p:cNvPr id="8" name="">
             <a:extLst xmlns:a="http://schemas.openxmlformats.org/drawingml/2006/main">
               <a:ext uri="{FF2B5EF4-FFF2-40B4-BE49-F238E27FC236}">
-                <a16:creationId xmlns:a16="http://schemas.microsoft.com/office/drawing/2014/main" id="{2742E36E-9375-491E-8A68-D149CB2598FC}"/>
+                <a16:creationId xmlns:a16="http://schemas.microsoft.com/office/drawing/2014/main" id="{6FB4ABF1-6252-4E10-945A-14E0DF148169}"/>
               </a:ext>
             </a:extLst>
           </p:cNvPr>
@@ -23102,7 +23192,7 @@
           <p:cNvPr id="9" name="comparison-message">
             <a:extLst xmlns:a="http://schemas.openxmlformats.org/drawingml/2006/main">
               <a:ext uri="{FF2B5EF4-FFF2-40B4-BE49-F238E27FC236}">
-                <a16:creationId xmlns:a16="http://schemas.microsoft.com/office/drawing/2014/main" id="{498E2CF4-2A38-4DAD-A88F-FA8FD2BB9B94}"/>
+                <a16:creationId xmlns:a16="http://schemas.microsoft.com/office/drawing/2014/main" id="{23C69D6B-C083-4118-BA33-2CDD874D4C6A}"/>
               </a:ext>
             </a:extLst>
           </p:cNvPr>
@@ -23250,7 +23340,7 @@
                 <a:ea typeface="Noto Sans Bold"/>
                 <a:cs typeface="Noto Sans Bold"/>
               </a:rPr>
-              <a:t>추가 관측이 최종 판단을 바꿉니다</a:t>
+              <a:t>같은 초기 경고여도 추가 관측에 따라 판단 변경</a:t>
             </a:r>
           </a:p>
         </p:txBody>
@@ -23258,7 +23348,7 @@
     </p:spTree>
     <p:extLst>
       <p:ext uri="{BB962C8B-B14F-4D97-AF65-F5344CB8AC3E}">
-        <p14:creationId xmlns:p14="http://schemas.microsoft.com/office/powerpoint/2010/main" val="126919471"/>
+        <p14:creationId xmlns:p14="http://schemas.microsoft.com/office/powerpoint/2010/main" val="1361508445"/>
       </p:ext>
     </p:extLst>
   </p:cSld>
@@ -23286,10 +23376,10 @@
       </p:grpSpPr>
       <p:sp>
         <p:nvSpPr>
-          <p:cNvPr id="10" name="section-label">
+          <p:cNvPr id="11" name="section-label">
             <a:extLst xmlns:a="http://schemas.openxmlformats.org/drawingml/2006/main">
               <a:ext uri="{FF2B5EF4-FFF2-40B4-BE49-F238E27FC236}">
-                <a16:creationId xmlns:a16="http://schemas.microsoft.com/office/drawing/2014/main" id="{04D2D927-6F4D-46BC-A6EC-594CA75BB447}"/>
+                <a16:creationId xmlns:a16="http://schemas.microsoft.com/office/drawing/2014/main" id="{CB177889-D216-4BF2-878A-053651CA0F9C}"/>
               </a:ext>
             </a:extLst>
           </p:cNvPr>
@@ -23437,7 +23527,7 @@
                 <a:ea typeface="Noto Sans Bold"/>
                 <a:cs typeface="Noto Sans Bold"/>
               </a:rPr>
-              <a:t>적용 기술: 표준 인터페이스</a:t>
+              <a:t>개선 3: 조회 흐름의 안정성</a:t>
             </a:r>
           </a:p>
         </p:txBody>
@@ -23447,7 +23537,7 @@
           <p:cNvPr id="2" name="page-number">
             <a:extLst xmlns:a="http://schemas.openxmlformats.org/drawingml/2006/main">
               <a:ext uri="{FF2B5EF4-FFF2-40B4-BE49-F238E27FC236}">
-                <a16:creationId xmlns:a16="http://schemas.microsoft.com/office/drawing/2014/main" id="{1EC50B37-4F57-47AF-A7EE-1FEFFE59C2A5}"/>
+                <a16:creationId xmlns:a16="http://schemas.microsoft.com/office/drawing/2014/main" id="{C27E26DF-3889-4541-B12A-78D135EC55B1}"/>
               </a:ext>
             </a:extLst>
           </p:cNvPr>
@@ -23605,7 +23695,7 @@
           <p:cNvPr id="3" name="slide-title">
             <a:extLst xmlns:a="http://schemas.openxmlformats.org/drawingml/2006/main">
               <a:ext uri="{FF2B5EF4-FFF2-40B4-BE49-F238E27FC236}">
-                <a16:creationId xmlns:a16="http://schemas.microsoft.com/office/drawing/2014/main" id="{0BAA5C63-2427-47B3-B4AB-B23A34670492}"/>
+                <a16:creationId xmlns:a16="http://schemas.microsoft.com/office/drawing/2014/main" id="{B50D33A8-4FE3-44B5-B07E-CAC31A056A6F}"/>
               </a:ext>
             </a:extLst>
           </p:cNvPr>
@@ -23753,7 +23843,7 @@
                 <a:ea typeface="Noto Sans Bold"/>
                 <a:cs typeface="Noto Sans Bold"/>
               </a:rPr>
-              <a:t>MCP로 연결한 조회와 문서</a:t>
+              <a:t>추가 관측과 부분 실패 대응</a:t>
             </a:r>
           </a:p>
         </p:txBody>
@@ -23763,7 +23853,7 @@
           <p:cNvPr id="4" name="slide-subtitle">
             <a:extLst xmlns:a="http://schemas.openxmlformats.org/drawingml/2006/main">
               <a:ext uri="{FF2B5EF4-FFF2-40B4-BE49-F238E27FC236}">
-                <a16:creationId xmlns:a16="http://schemas.microsoft.com/office/drawing/2014/main" id="{E6A6788F-48E8-4C8A-99B6-B926F0FF9444}"/>
+                <a16:creationId xmlns:a16="http://schemas.microsoft.com/office/drawing/2014/main" id="{6BAA227B-03DE-439C-ABED-B83795CFA997}"/>
               </a:ext>
             </a:extLst>
           </p:cNvPr>
@@ -23911,7 +24001,7 @@
                 <a:ea typeface="Noto Sans Kr"/>
                 <a:cs typeface="Noto Sans Kr"/>
               </a:rPr>
-              <a:t>관측·문서·조사 절차를 표준 인터페이스로 연결했습니다.</a:t>
+              <a:t>가설별 관측 도구를 연결하고 실패 항목을 따로 남깁니다.</a:t>
             </a:r>
           </a:p>
         </p:txBody>
@@ -23921,7 +24011,7 @@
           <p:cNvPr id="5" name="scope-note">
             <a:extLst xmlns:a="http://schemas.openxmlformats.org/drawingml/2006/main">
               <a:ext uri="{FF2B5EF4-FFF2-40B4-BE49-F238E27FC236}">
-                <a16:creationId xmlns:a16="http://schemas.microsoft.com/office/drawing/2014/main" id="{CDFB69EF-A47C-4B7B-A690-37F7AF792CD7}"/>
+                <a16:creationId xmlns:a16="http://schemas.microsoft.com/office/drawing/2014/main" id="{BA2E780F-B7DA-45E2-A787-1D894A416891}"/>
               </a:ext>
             </a:extLst>
           </p:cNvPr>
@@ -24069,7 +24159,7 @@
                 <a:ea typeface="Noto Sans Kr"/>
                 <a:cs typeface="Noto Sans Kr"/>
               </a:rPr>
-              <a:t>모든 도구는 읽기 전용 / 시스템 재시작·배포·설정 변경은 실행하지 않음</a:t>
+              <a:t>MCP Resource·Prompt는 공통 근거·절차에 활용 / 모든 도구는 읽기 전용</a:t>
             </a:r>
           </a:p>
         </p:txBody>
@@ -24079,7 +24169,7 @@
           <p:cNvPr id="6" name="footer-rule">
             <a:extLst xmlns:a="http://schemas.openxmlformats.org/drawingml/2006/main">
               <a:ext uri="{FF2B5EF4-FFF2-40B4-BE49-F238E27FC236}">
-                <a16:creationId xmlns:a16="http://schemas.microsoft.com/office/drawing/2014/main" id="{BCBCBFAF-093C-433B-967D-A1B25E5450C4}"/>
+                <a16:creationId xmlns:a16="http://schemas.microsoft.com/office/drawing/2014/main" id="{6A0D56D2-903E-4843-9A2B-12D6F13F7259}"/>
               </a:ext>
             </a:extLst>
           </p:cNvPr>
@@ -24106,7 +24196,7 @@
           <p:cNvPr id="7" name="footer">
             <a:extLst xmlns:a="http://schemas.openxmlformats.org/drawingml/2006/main">
               <a:ext uri="{FF2B5EF4-FFF2-40B4-BE49-F238E27FC236}">
-                <a16:creationId xmlns:a16="http://schemas.microsoft.com/office/drawing/2014/main" id="{152C6484-4584-4199-B48E-9614075E0D8A}"/>
+                <a16:creationId xmlns:a16="http://schemas.microsoft.com/office/drawing/2014/main" id="{FE3D9236-AB58-4329-B71A-54920EF8F131}"/>
               </a:ext>
             </a:extLst>
           </p:cNvPr>
@@ -24264,7 +24354,7 @@
           <p:cNvPr id="8" name="">
             <a:extLst xmlns:a="http://schemas.openxmlformats.org/drawingml/2006/main">
               <a:ext uri="{FF2B5EF4-FFF2-40B4-BE49-F238E27FC236}">
-                <a16:creationId xmlns:a16="http://schemas.microsoft.com/office/drawing/2014/main" id="{953970A7-5E17-4B72-A3D0-FB18C433A019}"/>
+                <a16:creationId xmlns:a16="http://schemas.microsoft.com/office/drawing/2014/main" id="{5DB620E3-80C9-4413-BF11-C7E252DE5A4C}"/>
               </a:ext>
             </a:extLst>
           </p:cNvPr>
@@ -24272,26 +24362,25 @@
           <p:nvPr/>
         </p:nvGraphicFramePr>
         <p:xfrm>
-          <a:off xmlns:a="http://schemas.openxmlformats.org/drawingml/2006/main" x="1143000" y="4048125"/>
-          <a:ext xmlns:a="http://schemas.openxmlformats.org/drawingml/2006/main" cx="16002000" cy="2667000"/>
+          <a:off xmlns:a="http://schemas.openxmlformats.org/drawingml/2006/main" x="1143000" y="3714750"/>
+          <a:ext xmlns:a="http://schemas.openxmlformats.org/drawingml/2006/main" cx="16002000" cy="3257550"/>
         </p:xfrm>
         <a:graphic xmlns:a="http://schemas.openxmlformats.org/drawingml/2006/main">
           <a:graphicData uri="http://schemas.openxmlformats.org/drawingml/2006/table">
             <a:tbl>
               <a:tblPr firstRow="0" bandRow="0"/>
               <a:tblGrid>
-                <a:gridCol w="5334000"/>
-                <a:gridCol w="5334000"/>
-                <a:gridCol w="5334000"/>
+                <a:gridCol w="8001000"/>
+                <a:gridCol w="8001000"/>
               </a:tblGrid>
-              <a:tr h="857250">
+              <a:tr h="685800">
                 <a:tc>
                   <a:txBody>
                     <a:bodyPr/>
                     <a:lstStyle/>
                     <a:p>
                       <a:r>
-                        <a:rPr sz="3150" b="1">
+                        <a:rPr sz="2550" b="1">
                           <a:solidFill>
                             <a:srgbClr val="FFFFFF"/>
                           </a:solidFill>
@@ -24299,7 +24388,7 @@
                           <a:ea typeface="Noto Sans Bold"/>
                           <a:cs typeface="Noto Sans Bold"/>
                         </a:rPr>
-                        <a:t>Tool</a:t>
+                        <a:t>개선 전</a:t>
                       </a:r>
                     </a:p>
                   </a:txBody>
@@ -24339,7 +24428,7 @@
                     <a:lstStyle/>
                     <a:p>
                       <a:r>
-                        <a:rPr sz="3150" b="1">
+                        <a:rPr sz="2550" b="1">
                           <a:solidFill>
                             <a:srgbClr val="FFFFFF"/>
                           </a:solidFill>
@@ -24347,49 +24436,7 @@
                           <a:ea typeface="Noto Sans Bold"/>
                           <a:cs typeface="Noto Sans Bold"/>
                         </a:rPr>
-                        <a:t>Resource</a:t>
-                      </a:r>
-                    </a:p>
-                  </a:txBody>
-                  <a:tcPr marL="285750" marR="228600" marT="152400" marB="152400" anchor="ctr">
-                    <a:lnR w="9525">
-                      <a:solidFill>
-                        <a:srgbClr val="DDE5EE"/>
-                      </a:solidFill>
-                      <a:prstDash val="solid"/>
-                    </a:lnR>
-                    <a:lnT w="9525">
-                      <a:solidFill>
-                        <a:srgbClr val="DDE5EE"/>
-                      </a:solidFill>
-                      <a:prstDash val="solid"/>
-                    </a:lnT>
-                    <a:lnB w="9525">
-                      <a:solidFill>
-                        <a:srgbClr val="DDE5EE"/>
-                      </a:solidFill>
-                      <a:prstDash val="solid"/>
-                    </a:lnB>
-                    <a:solidFill>
-                      <a:srgbClr val="112840"/>
-                    </a:solidFill>
-                  </a:tcPr>
-                </a:tc>
-                <a:tc>
-                  <a:txBody>
-                    <a:bodyPr/>
-                    <a:lstStyle/>
-                    <a:p>
-                      <a:r>
-                        <a:rPr sz="3150" b="1">
-                          <a:solidFill>
-                            <a:srgbClr val="FFFFFF"/>
-                          </a:solidFill>
-                          <a:latin typeface="Noto Sans Bold"/>
-                          <a:ea typeface="Noto Sans Bold"/>
-                          <a:cs typeface="Noto Sans Bold"/>
-                        </a:rPr>
-                        <a:t>Prompt</a:t>
+                        <a:t>이번 변경</a:t>
                       </a:r>
                     </a:p>
                   </a:txBody>
@@ -24418,7 +24465,7 @@
                   </a:tcPr>
                 </a:tc>
               </a:tr>
-              <a:tr h="1809750">
+              <a:tr h="1285875">
                 <a:tc>
                   <a:txBody>
                     <a:bodyPr/>
@@ -24433,7 +24480,7 @@
                           <a:ea typeface="Noto Sans Kr"/>
                           <a:cs typeface="Noto Sans Kr"/>
                         </a:rPr>
-                        <a:t>지표·로그·추가 관측 조회</a:t>
+                        <a:t>초기 지표·로그 중심 조회</a:t>
                       </a:r>
                     </a:p>
                   </a:txBody>
@@ -24475,11 +24522,55 @@
                           <a:ea typeface="Noto Sans Kr"/>
                           <a:cs typeface="Noto Sans Kr"/>
                         </a:rPr>
-                        <a:t>런북 원문 제공</a:t>
+                        <a:t>가설별 추가 관측 도구 연결</a:t>
                       </a:r>
                     </a:p>
                   </a:txBody>
                   <a:tcPr marL="285750" marR="228600" marT="152400" marB="152400" anchor="ctr">
+                    <a:lnR w="9525">
+                      <a:solidFill>
+                        <a:srgbClr val="DDE5EE"/>
+                      </a:solidFill>
+                      <a:prstDash val="solid"/>
+                    </a:lnR>
+                    <a:lnB w="9525">
+                      <a:solidFill>
+                        <a:srgbClr val="DDE5EE"/>
+                      </a:solidFill>
+                      <a:prstDash val="solid"/>
+                    </a:lnB>
+                    <a:solidFill>
+                      <a:srgbClr val="FFFFFF"/>
+                    </a:solidFill>
+                  </a:tcPr>
+                </a:tc>
+              </a:tr>
+              <a:tr h="1285875">
+                <a:tc>
+                  <a:txBody>
+                    <a:bodyPr/>
+                    <a:lstStyle/>
+                    <a:p>
+                      <a:r>
+                        <a:rPr sz="2700">
+                          <a:solidFill>
+                            <a:srgbClr val="122C46"/>
+                          </a:solidFill>
+                          <a:latin typeface="Noto Sans Kr"/>
+                          <a:ea typeface="Noto Sans Kr"/>
+                          <a:cs typeface="Noto Sans Kr"/>
+                        </a:rPr>
+                        <a:t>일부 조회 실패 시 전체 오류</a:t>
+                      </a:r>
+                    </a:p>
+                  </a:txBody>
+                  <a:tcPr marL="285750" marR="228600" marT="152400" marB="152400" anchor="ctr">
+                    <a:lnL w="9525">
+                      <a:solidFill>
+                        <a:srgbClr val="DDE5EE"/>
+                      </a:solidFill>
+                      <a:prstDash val="solid"/>
+                    </a:lnL>
                     <a:lnR w="9525">
                       <a:solidFill>
                         <a:srgbClr val="DDE5EE"/>
@@ -24511,20 +24602,7 @@
                           <a:ea typeface="Noto Sans Kr"/>
                           <a:cs typeface="Noto Sans Kr"/>
                         </a:rPr>
-                        <a:t>대상·증상을 포함한</a:t>
-                      </a:r>
-                    </a:p>
-                    <a:p>
-                      <a:r>
-                        <a:rPr sz="2700">
-                          <a:solidFill>
-                            <a:srgbClr val="122C46"/>
-                          </a:solidFill>
-                          <a:latin typeface="Noto Sans Kr"/>
-                          <a:ea typeface="Noto Sans Kr"/>
-                          <a:cs typeface="Noto Sans Kr"/>
-                        </a:rPr>
-                        <a:t>공통 조사 절차</a:t>
+                        <a:t>실패 격리·성공 근거 보존</a:t>
                       </a:r>
                     </a:p>
                   </a:txBody>
@@ -24553,10 +24631,10 @@
       </p:graphicFrame>
       <p:sp>
         <p:nvSpPr>
-          <p:cNvPr id="9" name="mcp-message">
+          <p:cNvPr id="9" name="failure-test">
             <a:extLst xmlns:a="http://schemas.openxmlformats.org/drawingml/2006/main">
               <a:ext uri="{FF2B5EF4-FFF2-40B4-BE49-F238E27FC236}">
-                <a16:creationId xmlns:a16="http://schemas.microsoft.com/office/drawing/2014/main" id="{A25FB5D7-E8B8-42C7-80EB-71C3B193BA41}"/>
+                <a16:creationId xmlns:a16="http://schemas.microsoft.com/office/drawing/2014/main" id="{AD521175-19E1-4902-BC35-AA9E5D45319F}"/>
               </a:ext>
             </a:extLst>
           </p:cNvPr>
@@ -24567,7 +24645,7 @@
         </p:nvSpPr>
         <p:spPr>
           <a:xfrm xmlns:a="http://schemas.openxmlformats.org/drawingml/2006/main">
-            <a:off x="1143000" y="7858125"/>
+            <a:off x="1143000" y="7572375"/>
             <a:ext cx="16002000" cy="571500"/>
           </a:xfrm>
           <a:prstGeom xmlns:a="http://schemas.openxmlformats.org/drawingml/2006/main" prst="rect">
@@ -24584,7 +24662,7 @@
           </a:bodyPr>
           <a:lstStyle xmlns:a="http://schemas.openxmlformats.org/drawingml/2006/main">
             <a:defPPr algn="l">
-              <a:defRPr sz="3150" b="1">
+              <a:defRPr sz="3000" b="1">
                 <a:solidFill>
                   <a:srgbClr val="2B5BEB"/>
                 </a:solidFill>
@@ -24594,7 +24672,7 @@
               </a:defRPr>
             </a:defPPr>
             <a:lvl1pPr algn="l">
-              <a:defRPr sz="3150" b="1">
+              <a:defRPr sz="3000" b="1">
                 <a:solidFill>
                   <a:srgbClr val="2B5BEB"/>
                 </a:solidFill>
@@ -24604,7 +24682,7 @@
               </a:defRPr>
             </a:lvl1pPr>
             <a:lvl2pPr algn="l">
-              <a:defRPr sz="3150" b="1">
+              <a:defRPr sz="3000" b="1">
                 <a:solidFill>
                   <a:srgbClr val="2B5BEB"/>
                 </a:solidFill>
@@ -24614,7 +24692,7 @@
               </a:defRPr>
             </a:lvl2pPr>
             <a:lvl3pPr algn="l">
-              <a:defRPr sz="3150" b="1">
+              <a:defRPr sz="3000" b="1">
                 <a:solidFill>
                   <a:srgbClr val="2B5BEB"/>
                 </a:solidFill>
@@ -24624,7 +24702,7 @@
               </a:defRPr>
             </a:lvl3pPr>
             <a:lvl4pPr algn="l">
-              <a:defRPr sz="3150" b="1">
+              <a:defRPr sz="3000" b="1">
                 <a:solidFill>
                   <a:srgbClr val="2B5BEB"/>
                 </a:solidFill>
@@ -24634,7 +24712,7 @@
               </a:defRPr>
             </a:lvl4pPr>
             <a:lvl5pPr algn="l">
-              <a:defRPr sz="3150" b="1">
+              <a:defRPr sz="3000" b="1">
                 <a:solidFill>
                   <a:srgbClr val="2B5BEB"/>
                 </a:solidFill>
@@ -24644,7 +24722,7 @@
               </a:defRPr>
             </a:lvl5pPr>
             <a:lvl6pPr algn="l">
-              <a:defRPr sz="3150" b="1">
+              <a:defRPr sz="3000" b="1">
                 <a:solidFill>
                   <a:srgbClr val="2B5BEB"/>
                 </a:solidFill>
@@ -24654,7 +24732,7 @@
               </a:defRPr>
             </a:lvl6pPr>
             <a:lvl7pPr algn="l">
-              <a:defRPr sz="3150" b="1">
+              <a:defRPr sz="3000" b="1">
                 <a:solidFill>
                   <a:srgbClr val="2B5BEB"/>
                 </a:solidFill>
@@ -24664,7 +24742,7 @@
               </a:defRPr>
             </a:lvl7pPr>
             <a:lvl8pPr algn="l">
-              <a:defRPr sz="3150" b="1">
+              <a:defRPr sz="3000" b="1">
                 <a:solidFill>
                   <a:srgbClr val="2B5BEB"/>
                 </a:solidFill>
@@ -24674,7 +24752,7 @@
               </a:defRPr>
             </a:lvl8pPr>
             <a:lvl9pPr algn="l">
-              <a:defRPr sz="3150" b="1">
+              <a:defRPr sz="3000" b="1">
                 <a:solidFill>
                   <a:srgbClr val="2B5BEB"/>
                 </a:solidFill>
@@ -24686,7 +24764,7 @@
           </a:lstStyle>
           <a:p xmlns:a="http://schemas.openxmlformats.org/drawingml/2006/main">
             <a:pPr algn="l">
-              <a:defRPr sz="3150" b="1">
+              <a:defRPr sz="3000" b="1">
                 <a:solidFill>
                   <a:srgbClr val="2B5BEB"/>
                 </a:solidFill>
@@ -24696,7 +24774,7 @@
               </a:defRPr>
             </a:pPr>
             <a:r>
-              <a:rPr sz="3150" b="1">
+              <a:rPr sz="3000" b="1">
                 <a:solidFill>
                   <a:srgbClr val="2B5BEB"/>
                 </a:solidFill>
@@ -24704,7 +24782,165 @@
                 <a:ea typeface="Noto Sans Bold"/>
                 <a:cs typeface="Noto Sans Bold"/>
               </a:rPr>
-              <a:t>조회와 문서의 출처를 같은 흐름에서 확인</a:t>
+              <a:t>실제 검증: CPU 귀속 도구 타임아웃 주입</a:t>
+            </a:r>
+          </a:p>
+        </p:txBody>
+      </p:sp>
+      <p:sp>
+        <p:nvSpPr>
+          <p:cNvPr id="10" name="failure-outcome">
+            <a:extLst xmlns:a="http://schemas.openxmlformats.org/drawingml/2006/main">
+              <a:ext uri="{FF2B5EF4-FFF2-40B4-BE49-F238E27FC236}">
+                <a16:creationId xmlns:a16="http://schemas.microsoft.com/office/drawing/2014/main" id="{E10D2E0C-7931-4309-B538-74A4080F68A3}"/>
+              </a:ext>
+            </a:extLst>
+          </p:cNvPr>
+          <p:cNvSpPr>
+            <a:spLocks xmlns:a="http://schemas.openxmlformats.org/drawingml/2006/main" noGrp="1"/>
+          </p:cNvSpPr>
+          <p:nvPr/>
+        </p:nvSpPr>
+        <p:spPr>
+          <a:xfrm xmlns:a="http://schemas.openxmlformats.org/drawingml/2006/main">
+            <a:off x="1143000" y="8239125"/>
+            <a:ext cx="16002000" cy="476250"/>
+          </a:xfrm>
+          <a:prstGeom xmlns:a="http://schemas.openxmlformats.org/drawingml/2006/main" prst="rect">
+            <a:avLst/>
+          </a:prstGeom>
+          <a:noFill xmlns:a="http://schemas.openxmlformats.org/drawingml/2006/main"/>
+          <a:ln xmlns:a="http://schemas.openxmlformats.org/drawingml/2006/main" w="0">
+            <a:noFill/>
+          </a:ln>
+        </p:spPr>
+        <p:txBody>
+          <a:bodyPr xmlns:a="http://schemas.openxmlformats.org/drawingml/2006/main" wrap="none" lIns="0" tIns="0" rIns="0" bIns="0" anchor="t">
+            <a:noAutofit/>
+          </a:bodyPr>
+          <a:lstStyle xmlns:a="http://schemas.openxmlformats.org/drawingml/2006/main">
+            <a:defPPr algn="l">
+              <a:defRPr sz="2700" b="1">
+                <a:solidFill>
+                  <a:srgbClr val="087F7A"/>
+                </a:solidFill>
+                <a:latin typeface="Noto Sans Bold"/>
+                <a:ea typeface="Noto Sans Bold"/>
+                <a:cs typeface="Noto Sans Bold"/>
+              </a:defRPr>
+            </a:defPPr>
+            <a:lvl1pPr algn="l">
+              <a:defRPr sz="2700" b="1">
+                <a:solidFill>
+                  <a:srgbClr val="087F7A"/>
+                </a:solidFill>
+                <a:latin typeface="Noto Sans Bold"/>
+                <a:ea typeface="Noto Sans Bold"/>
+                <a:cs typeface="Noto Sans Bold"/>
+              </a:defRPr>
+            </a:lvl1pPr>
+            <a:lvl2pPr algn="l">
+              <a:defRPr sz="2700" b="1">
+                <a:solidFill>
+                  <a:srgbClr val="087F7A"/>
+                </a:solidFill>
+                <a:latin typeface="Noto Sans Bold"/>
+                <a:ea typeface="Noto Sans Bold"/>
+                <a:cs typeface="Noto Sans Bold"/>
+              </a:defRPr>
+            </a:lvl2pPr>
+            <a:lvl3pPr algn="l">
+              <a:defRPr sz="2700" b="1">
+                <a:solidFill>
+                  <a:srgbClr val="087F7A"/>
+                </a:solidFill>
+                <a:latin typeface="Noto Sans Bold"/>
+                <a:ea typeface="Noto Sans Bold"/>
+                <a:cs typeface="Noto Sans Bold"/>
+              </a:defRPr>
+            </a:lvl3pPr>
+            <a:lvl4pPr algn="l">
+              <a:defRPr sz="2700" b="1">
+                <a:solidFill>
+                  <a:srgbClr val="087F7A"/>
+                </a:solidFill>
+                <a:latin typeface="Noto Sans Bold"/>
+                <a:ea typeface="Noto Sans Bold"/>
+                <a:cs typeface="Noto Sans Bold"/>
+              </a:defRPr>
+            </a:lvl4pPr>
+            <a:lvl5pPr algn="l">
+              <a:defRPr sz="2700" b="1">
+                <a:solidFill>
+                  <a:srgbClr val="087F7A"/>
+                </a:solidFill>
+                <a:latin typeface="Noto Sans Bold"/>
+                <a:ea typeface="Noto Sans Bold"/>
+                <a:cs typeface="Noto Sans Bold"/>
+              </a:defRPr>
+            </a:lvl5pPr>
+            <a:lvl6pPr algn="l">
+              <a:defRPr sz="2700" b="1">
+                <a:solidFill>
+                  <a:srgbClr val="087F7A"/>
+                </a:solidFill>
+                <a:latin typeface="Noto Sans Bold"/>
+                <a:ea typeface="Noto Sans Bold"/>
+                <a:cs typeface="Noto Sans Bold"/>
+              </a:defRPr>
+            </a:lvl6pPr>
+            <a:lvl7pPr algn="l">
+              <a:defRPr sz="2700" b="1">
+                <a:solidFill>
+                  <a:srgbClr val="087F7A"/>
+                </a:solidFill>
+                <a:latin typeface="Noto Sans Bold"/>
+                <a:ea typeface="Noto Sans Bold"/>
+                <a:cs typeface="Noto Sans Bold"/>
+              </a:defRPr>
+            </a:lvl7pPr>
+            <a:lvl8pPr algn="l">
+              <a:defRPr sz="2700" b="1">
+                <a:solidFill>
+                  <a:srgbClr val="087F7A"/>
+                </a:solidFill>
+                <a:latin typeface="Noto Sans Bold"/>
+                <a:ea typeface="Noto Sans Bold"/>
+                <a:cs typeface="Noto Sans Bold"/>
+              </a:defRPr>
+            </a:lvl8pPr>
+            <a:lvl9pPr algn="l">
+              <a:defRPr sz="2700" b="1">
+                <a:solidFill>
+                  <a:srgbClr val="087F7A"/>
+                </a:solidFill>
+                <a:latin typeface="Noto Sans Bold"/>
+                <a:ea typeface="Noto Sans Bold"/>
+                <a:cs typeface="Noto Sans Bold"/>
+              </a:defRPr>
+            </a:lvl9pPr>
+          </a:lstStyle>
+          <a:p xmlns:a="http://schemas.openxmlformats.org/drawingml/2006/main">
+            <a:pPr algn="l">
+              <a:defRPr sz="2700" b="1">
+                <a:solidFill>
+                  <a:srgbClr val="087F7A"/>
+                </a:solidFill>
+                <a:latin typeface="Noto Sans Bold"/>
+                <a:ea typeface="Noto Sans Bold"/>
+                <a:cs typeface="Noto Sans Bold"/>
+              </a:defRPr>
+            </a:pPr>
+            <a:r>
+              <a:rPr sz="2700" b="1">
+                <a:solidFill>
+                  <a:srgbClr val="087F7A"/>
+                </a:solidFill>
+                <a:latin typeface="Noto Sans Bold"/>
+                <a:ea typeface="Noto Sans Bold"/>
+                <a:cs typeface="Noto Sans Bold"/>
+              </a:rPr>
+              <a:t>성공한 관측 유지·원인 판단 보류</a:t>
             </a:r>
           </a:p>
         </p:txBody>
@@ -24712,7 +24948,7 @@
     </p:spTree>
     <p:extLst>
       <p:ext uri="{BB962C8B-B14F-4D97-AF65-F5344CB8AC3E}">
-        <p14:creationId xmlns:p14="http://schemas.microsoft.com/office/powerpoint/2010/main" val="1313214799"/>
+        <p14:creationId xmlns:p14="http://schemas.microsoft.com/office/powerpoint/2010/main" val="944012539"/>
       </p:ext>
     </p:extLst>
   </p:cSld>
@@ -24740,10 +24976,10 @@
       </p:grpSpPr>
       <p:sp>
         <p:nvSpPr>
-          <p:cNvPr id="18" name="section-label">
+          <p:cNvPr id="11" name="section-label">
             <a:extLst xmlns:a="http://schemas.openxmlformats.org/drawingml/2006/main">
               <a:ext uri="{FF2B5EF4-FFF2-40B4-BE49-F238E27FC236}">
-                <a16:creationId xmlns:a16="http://schemas.microsoft.com/office/drawing/2014/main" id="{2D64C0F0-6B35-4386-8725-F93C6178EFC0}"/>
+                <a16:creationId xmlns:a16="http://schemas.microsoft.com/office/drawing/2014/main" id="{BD3C7942-4614-4A54-BC58-E125C305E455}"/>
               </a:ext>
             </a:extLst>
           </p:cNvPr>
@@ -24891,7 +25127,7 @@
                 <a:ea typeface="Noto Sans Bold"/>
                 <a:cs typeface="Noto Sans Bold"/>
               </a:rPr>
-              <a:t>적용 기술: 의미 검색</a:t>
+              <a:t>개선 4: 관측을 반영한 RAG</a:t>
             </a:r>
           </a:p>
         </p:txBody>
@@ -24901,7 +25137,7 @@
           <p:cNvPr id="2" name="page-number">
             <a:extLst xmlns:a="http://schemas.openxmlformats.org/drawingml/2006/main">
               <a:ext uri="{FF2B5EF4-FFF2-40B4-BE49-F238E27FC236}">
-                <a16:creationId xmlns:a16="http://schemas.microsoft.com/office/drawing/2014/main" id="{2521C8CF-83B7-4305-93E7-B134A6CF10E2}"/>
+                <a16:creationId xmlns:a16="http://schemas.microsoft.com/office/drawing/2014/main" id="{F10D9F89-5A40-4F85-9714-1AAB281522D1}"/>
               </a:ext>
             </a:extLst>
           </p:cNvPr>
@@ -25059,7 +25295,7 @@
           <p:cNvPr id="3" name="slide-title">
             <a:extLst xmlns:a="http://schemas.openxmlformats.org/drawingml/2006/main">
               <a:ext uri="{FF2B5EF4-FFF2-40B4-BE49-F238E27FC236}">
-                <a16:creationId xmlns:a16="http://schemas.microsoft.com/office/drawing/2014/main" id="{A2E07FBA-B118-474F-9E33-2050AB51FA4A}"/>
+                <a16:creationId xmlns:a16="http://schemas.microsoft.com/office/drawing/2014/main" id="{D104193A-DC56-4574-8512-6F705C8D83C8}"/>
               </a:ext>
             </a:extLst>
           </p:cNvPr>
@@ -25207,7 +25443,7 @@
                 <a:ea typeface="Noto Sans Bold"/>
                 <a:cs typeface="Noto Sans Bold"/>
               </a:rPr>
-              <a:t>관측을 반영하는 RAG 검색</a:t>
+              <a:t>단일 런북 선택에서 다중 검색으로</a:t>
             </a:r>
           </a:p>
         </p:txBody>
@@ -25217,7 +25453,7 @@
           <p:cNvPr id="4" name="slide-subtitle">
             <a:extLst xmlns:a="http://schemas.openxmlformats.org/drawingml/2006/main">
               <a:ext uri="{FF2B5EF4-FFF2-40B4-BE49-F238E27FC236}">
-                <a16:creationId xmlns:a16="http://schemas.microsoft.com/office/drawing/2014/main" id="{FA6A1CC9-410D-41CE-B9BA-3F1D00F4FEE3}"/>
+                <a16:creationId xmlns:a16="http://schemas.microsoft.com/office/drawing/2014/main" id="{C946B498-52B9-4B89-8508-EE07460F87F4}"/>
               </a:ext>
             </a:extLst>
           </p:cNvPr>
@@ -25365,7 +25601,7 @@
                 <a:ea typeface="Noto Sans Kr"/>
                 <a:cs typeface="Noto Sans Kr"/>
               </a:rPr>
-              <a:t>사용자 질문에 실제 조회한 지표·알림을 더해 검색합니다.</a:t>
+              <a:t>복합 증상을 설명할 수 있도록 검색 입력과 문서 범위를 넓혔습니다.</a:t>
             </a:r>
           </a:p>
         </p:txBody>
@@ -25375,7 +25611,7 @@
           <p:cNvPr id="5" name="scope-note">
             <a:extLst xmlns:a="http://schemas.openxmlformats.org/drawingml/2006/main">
               <a:ext uri="{FF2B5EF4-FFF2-40B4-BE49-F238E27FC236}">
-                <a16:creationId xmlns:a16="http://schemas.microsoft.com/office/drawing/2014/main" id="{98700258-3786-43AB-999C-181111AA64F4}"/>
+                <a16:creationId xmlns:a16="http://schemas.microsoft.com/office/drawing/2014/main" id="{3A57106D-A5AD-46F5-A39C-8062B2B2D1D4}"/>
               </a:ext>
             </a:extLst>
           </p:cNvPr>
@@ -25523,7 +25759,7 @@
                 <a:ea typeface="Noto Sans Kr"/>
                 <a:cs typeface="Noto Sans Kr"/>
               </a:rPr>
-              <a:t>모듈 분리·의존성 주입으로 모델·도구·검색기 교체 / 관련 원문이 없으면 정보 부족 표시</a:t>
+              <a:t>SQLite 벡터 저장·NumPy 유사도 / 검색 후보와 실제 조치 근거를 구분</a:t>
             </a:r>
           </a:p>
         </p:txBody>
@@ -25533,7 +25769,7 @@
           <p:cNvPr id="6" name="footer-rule">
             <a:extLst xmlns:a="http://schemas.openxmlformats.org/drawingml/2006/main">
               <a:ext uri="{FF2B5EF4-FFF2-40B4-BE49-F238E27FC236}">
-                <a16:creationId xmlns:a16="http://schemas.microsoft.com/office/drawing/2014/main" id="{4C07647D-D549-45EB-AD81-A1931D6B2E4A}"/>
+                <a16:creationId xmlns:a16="http://schemas.microsoft.com/office/drawing/2014/main" id="{6D0861F2-4053-4A2B-B09F-CE3DAF746737}"/>
               </a:ext>
             </a:extLst>
           </p:cNvPr>
@@ -25560,7 +25796,7 @@
           <p:cNvPr id="7" name="footer">
             <a:extLst xmlns:a="http://schemas.openxmlformats.org/drawingml/2006/main">
               <a:ext uri="{FF2B5EF4-FFF2-40B4-BE49-F238E27FC236}">
-                <a16:creationId xmlns:a16="http://schemas.microsoft.com/office/drawing/2014/main" id="{ABD06849-BFF3-4120-9793-B2EDCAB4272D}"/>
+                <a16:creationId xmlns:a16="http://schemas.microsoft.com/office/drawing/2014/main" id="{083DABB2-8B7B-4095-A519-B6EB35818C56}"/>
               </a:ext>
             </a:extLst>
           </p:cNvPr>
@@ -25713,12 +25949,292 @@
           </a:p>
         </p:txBody>
       </p:sp>
+      <p:graphicFrame>
+        <p:nvGraphicFramePr>
+          <p:cNvPr id="8" name="">
+            <a:extLst xmlns:a="http://schemas.openxmlformats.org/drawingml/2006/main">
+              <a:ext uri="{FF2B5EF4-FFF2-40B4-BE49-F238E27FC236}">
+                <a16:creationId xmlns:a16="http://schemas.microsoft.com/office/drawing/2014/main" id="{06F86666-D539-4BC1-BB46-ABA981D4F2A0}"/>
+              </a:ext>
+            </a:extLst>
+          </p:cNvPr>
+          <p:cNvGraphicFramePr/>
+          <p:nvPr/>
+        </p:nvGraphicFramePr>
+        <p:xfrm>
+          <a:off xmlns:a="http://schemas.openxmlformats.org/drawingml/2006/main" x="1143000" y="3714750"/>
+          <a:ext xmlns:a="http://schemas.openxmlformats.org/drawingml/2006/main" cx="16002000" cy="3257550"/>
+        </p:xfrm>
+        <a:graphic xmlns:a="http://schemas.openxmlformats.org/drawingml/2006/main">
+          <a:graphicData uri="http://schemas.openxmlformats.org/drawingml/2006/table">
+            <a:tbl>
+              <a:tblPr firstRow="0" bandRow="0"/>
+              <a:tblGrid>
+                <a:gridCol w="8001000"/>
+                <a:gridCol w="8001000"/>
+              </a:tblGrid>
+              <a:tr h="685800">
+                <a:tc>
+                  <a:txBody>
+                    <a:bodyPr/>
+                    <a:lstStyle/>
+                    <a:p>
+                      <a:r>
+                        <a:rPr sz="2550" b="1">
+                          <a:solidFill>
+                            <a:srgbClr val="FFFFFF"/>
+                          </a:solidFill>
+                          <a:latin typeface="Noto Sans Bold"/>
+                          <a:ea typeface="Noto Sans Bold"/>
+                          <a:cs typeface="Noto Sans Bold"/>
+                        </a:rPr>
+                        <a:t>개선 전</a:t>
+                      </a:r>
+                    </a:p>
+                  </a:txBody>
+                  <a:tcPr marL="285750" marR="228600" marT="152400" marB="152400" anchor="ctr">
+                    <a:lnL w="9525">
+                      <a:solidFill>
+                        <a:srgbClr val="DDE5EE"/>
+                      </a:solidFill>
+                      <a:prstDash val="solid"/>
+                    </a:lnL>
+                    <a:lnR w="9525">
+                      <a:solidFill>
+                        <a:srgbClr val="DDE5EE"/>
+                      </a:solidFill>
+                      <a:prstDash val="solid"/>
+                    </a:lnR>
+                    <a:lnT w="9525">
+                      <a:solidFill>
+                        <a:srgbClr val="DDE5EE"/>
+                      </a:solidFill>
+                      <a:prstDash val="solid"/>
+                    </a:lnT>
+                    <a:lnB w="9525">
+                      <a:solidFill>
+                        <a:srgbClr val="DDE5EE"/>
+                      </a:solidFill>
+                      <a:prstDash val="solid"/>
+                    </a:lnB>
+                    <a:solidFill>
+                      <a:srgbClr val="112840"/>
+                    </a:solidFill>
+                  </a:tcPr>
+                </a:tc>
+                <a:tc>
+                  <a:txBody>
+                    <a:bodyPr/>
+                    <a:lstStyle/>
+                    <a:p>
+                      <a:r>
+                        <a:rPr sz="2550" b="1">
+                          <a:solidFill>
+                            <a:srgbClr val="FFFFFF"/>
+                          </a:solidFill>
+                          <a:latin typeface="Noto Sans Bold"/>
+                          <a:ea typeface="Noto Sans Bold"/>
+                          <a:cs typeface="Noto Sans Bold"/>
+                        </a:rPr>
+                        <a:t>이번 변경</a:t>
+                      </a:r>
+                    </a:p>
+                  </a:txBody>
+                  <a:tcPr marL="285750" marR="228600" marT="152400" marB="152400" anchor="ctr">
+                    <a:lnR w="9525">
+                      <a:solidFill>
+                        <a:srgbClr val="DDE5EE"/>
+                      </a:solidFill>
+                      <a:prstDash val="solid"/>
+                    </a:lnR>
+                    <a:lnT w="9525">
+                      <a:solidFill>
+                        <a:srgbClr val="DDE5EE"/>
+                      </a:solidFill>
+                      <a:prstDash val="solid"/>
+                    </a:lnT>
+                    <a:lnB w="9525">
+                      <a:solidFill>
+                        <a:srgbClr val="DDE5EE"/>
+                      </a:solidFill>
+                      <a:prstDash val="solid"/>
+                    </a:lnB>
+                    <a:solidFill>
+                      <a:srgbClr val="112840"/>
+                    </a:solidFill>
+                  </a:tcPr>
+                </a:tc>
+              </a:tr>
+              <a:tr h="1285875">
+                <a:tc>
+                  <a:txBody>
+                    <a:bodyPr/>
+                    <a:lstStyle/>
+                    <a:p>
+                      <a:r>
+                        <a:rPr sz="2700">
+                          <a:solidFill>
+                            <a:srgbClr val="122C46"/>
+                          </a:solidFill>
+                          <a:latin typeface="Noto Sans Kr"/>
+                          <a:ea typeface="Noto Sans Kr"/>
+                          <a:cs typeface="Noto Sans Kr"/>
+                        </a:rPr>
+                        <a:t>키워드로 장애 유형 분류</a:t>
+                      </a:r>
+                    </a:p>
+                  </a:txBody>
+                  <a:tcPr marL="285750" marR="228600" marT="152400" marB="152400" anchor="ctr">
+                    <a:lnL w="9525">
+                      <a:solidFill>
+                        <a:srgbClr val="DDE5EE"/>
+                      </a:solidFill>
+                      <a:prstDash val="solid"/>
+                    </a:lnL>
+                    <a:lnR w="9525">
+                      <a:solidFill>
+                        <a:srgbClr val="DDE5EE"/>
+                      </a:solidFill>
+                      <a:prstDash val="solid"/>
+                    </a:lnR>
+                    <a:lnB w="9525">
+                      <a:solidFill>
+                        <a:srgbClr val="DDE5EE"/>
+                      </a:solidFill>
+                      <a:prstDash val="solid"/>
+                    </a:lnB>
+                    <a:solidFill>
+                      <a:srgbClr val="FFFFFF"/>
+                    </a:solidFill>
+                  </a:tcPr>
+                </a:tc>
+                <a:tc>
+                  <a:txBody>
+                    <a:bodyPr/>
+                    <a:lstStyle/>
+                    <a:p>
+                      <a:r>
+                        <a:rPr sz="2700">
+                          <a:solidFill>
+                            <a:srgbClr val="122C46"/>
+                          </a:solidFill>
+                          <a:latin typeface="Noto Sans Kr"/>
+                          <a:ea typeface="Noto Sans Kr"/>
+                          <a:cs typeface="Noto Sans Kr"/>
+                        </a:rPr>
+                        <a:t>증상·지표·알림으로 의미 검색</a:t>
+                      </a:r>
+                    </a:p>
+                  </a:txBody>
+                  <a:tcPr marL="285750" marR="228600" marT="152400" marB="152400" anchor="ctr">
+                    <a:lnR w="9525">
+                      <a:solidFill>
+                        <a:srgbClr val="DDE5EE"/>
+                      </a:solidFill>
+                      <a:prstDash val="solid"/>
+                    </a:lnR>
+                    <a:lnB w="9525">
+                      <a:solidFill>
+                        <a:srgbClr val="DDE5EE"/>
+                      </a:solidFill>
+                      <a:prstDash val="solid"/>
+                    </a:lnB>
+                    <a:solidFill>
+                      <a:srgbClr val="FFFFFF"/>
+                    </a:solidFill>
+                  </a:tcPr>
+                </a:tc>
+              </a:tr>
+              <a:tr h="1285875">
+                <a:tc>
+                  <a:txBody>
+                    <a:bodyPr/>
+                    <a:lstStyle/>
+                    <a:p>
+                      <a:r>
+                        <a:rPr sz="2700">
+                          <a:solidFill>
+                            <a:srgbClr val="122C46"/>
+                          </a:solidFill>
+                          <a:latin typeface="Noto Sans Kr"/>
+                          <a:ea typeface="Noto Sans Kr"/>
+                          <a:cs typeface="Noto Sans Kr"/>
+                        </a:rPr>
+                        <a:t>런북 한 종 선택</a:t>
+                      </a:r>
+                    </a:p>
+                  </a:txBody>
+                  <a:tcPr marL="285750" marR="228600" marT="152400" marB="152400" anchor="ctr">
+                    <a:lnL w="9525">
+                      <a:solidFill>
+                        <a:srgbClr val="DDE5EE"/>
+                      </a:solidFill>
+                      <a:prstDash val="solid"/>
+                    </a:lnL>
+                    <a:lnR w="9525">
+                      <a:solidFill>
+                        <a:srgbClr val="DDE5EE"/>
+                      </a:solidFill>
+                      <a:prstDash val="solid"/>
+                    </a:lnR>
+                    <a:lnB w="9525">
+                      <a:solidFill>
+                        <a:srgbClr val="DDE5EE"/>
+                      </a:solidFill>
+                      <a:prstDash val="solid"/>
+                    </a:lnB>
+                    <a:solidFill>
+                      <a:srgbClr val="FFFFFF"/>
+                    </a:solidFill>
+                  </a:tcPr>
+                </a:tc>
+                <a:tc>
+                  <a:txBody>
+                    <a:bodyPr/>
+                    <a:lstStyle/>
+                    <a:p>
+                      <a:r>
+                        <a:rPr sz="2700">
+                          <a:solidFill>
+                            <a:srgbClr val="122C46"/>
+                          </a:solidFill>
+                          <a:latin typeface="Noto Sans Kr"/>
+                          <a:ea typeface="Noto Sans Kr"/>
+                          <a:cs typeface="Noto Sans Kr"/>
+                        </a:rPr>
+                        <a:t>6종 임베딩에서 최대 3종 선택</a:t>
+                      </a:r>
+                    </a:p>
+                  </a:txBody>
+                  <a:tcPr marL="285750" marR="228600" marT="152400" marB="152400" anchor="ctr">
+                    <a:lnR w="9525">
+                      <a:solidFill>
+                        <a:srgbClr val="DDE5EE"/>
+                      </a:solidFill>
+                      <a:prstDash val="solid"/>
+                    </a:lnR>
+                    <a:lnB w="9525">
+                      <a:solidFill>
+                        <a:srgbClr val="DDE5EE"/>
+                      </a:solidFill>
+                      <a:prstDash val="solid"/>
+                    </a:lnB>
+                    <a:solidFill>
+                      <a:srgbClr val="FFFFFF"/>
+                    </a:solidFill>
+                  </a:tcPr>
+                </a:tc>
+              </a:tr>
+            </a:tbl>
+          </a:graphicData>
+        </a:graphic>
+      </p:graphicFrame>
       <p:sp>
         <p:nvSpPr>
-          <p:cNvPr id="8" name="rag-number-0">
+          <p:cNvPr id="9" name="rag-evidence-label">
             <a:extLst xmlns:a="http://schemas.openxmlformats.org/drawingml/2006/main">
               <a:ext uri="{FF2B5EF4-FFF2-40B4-BE49-F238E27FC236}">
-                <a16:creationId xmlns:a16="http://schemas.microsoft.com/office/drawing/2014/main" id="{E7CB5A35-C4BB-461F-93A7-04FDB74804E6}"/>
+                <a16:creationId xmlns:a16="http://schemas.microsoft.com/office/drawing/2014/main" id="{B4EBCBBB-68AE-47B3-80BD-01058406B997}"/>
               </a:ext>
             </a:extLst>
           </p:cNvPr>
@@ -25729,8 +26245,8 @@
         </p:nvSpPr>
         <p:spPr>
           <a:xfrm xmlns:a="http://schemas.openxmlformats.org/drawingml/2006/main">
-            <a:off x="1143000" y="3476625"/>
-            <a:ext cx="904875" cy="619125"/>
+            <a:off x="1143000" y="7572375"/>
+            <a:ext cx="16002000" cy="523875"/>
           </a:xfrm>
           <a:prstGeom xmlns:a="http://schemas.openxmlformats.org/drawingml/2006/main" prst="rect">
             <a:avLst/>
@@ -25746,7 +26262,7 @@
           </a:bodyPr>
           <a:lstStyle xmlns:a="http://schemas.openxmlformats.org/drawingml/2006/main">
             <a:defPPr algn="l">
-              <a:defRPr sz="3300" b="1">
+              <a:defRPr sz="2400" b="1">
                 <a:solidFill>
                   <a:srgbClr val="2B5BEB"/>
                 </a:solidFill>
@@ -25756,7 +26272,7 @@
               </a:defRPr>
             </a:defPPr>
             <a:lvl1pPr algn="l">
-              <a:defRPr sz="3300" b="1">
+              <a:defRPr sz="2400" b="1">
                 <a:solidFill>
                   <a:srgbClr val="2B5BEB"/>
                 </a:solidFill>
@@ -25766,7 +26282,7 @@
               </a:defRPr>
             </a:lvl1pPr>
             <a:lvl2pPr algn="l">
-              <a:defRPr sz="3300" b="1">
+              <a:defRPr sz="2400" b="1">
                 <a:solidFill>
                   <a:srgbClr val="2B5BEB"/>
                 </a:solidFill>
@@ -25776,7 +26292,7 @@
               </a:defRPr>
             </a:lvl2pPr>
             <a:lvl3pPr algn="l">
-              <a:defRPr sz="3300" b="1">
+              <a:defRPr sz="2400" b="1">
                 <a:solidFill>
                   <a:srgbClr val="2B5BEB"/>
                 </a:solidFill>
@@ -25786,7 +26302,7 @@
               </a:defRPr>
             </a:lvl3pPr>
             <a:lvl4pPr algn="l">
-              <a:defRPr sz="3300" b="1">
+              <a:defRPr sz="2400" b="1">
                 <a:solidFill>
                   <a:srgbClr val="2B5BEB"/>
                 </a:solidFill>
@@ -25796,7 +26312,7 @@
               </a:defRPr>
             </a:lvl4pPr>
             <a:lvl5pPr algn="l">
-              <a:defRPr sz="3300" b="1">
+              <a:defRPr sz="2400" b="1">
                 <a:solidFill>
                   <a:srgbClr val="2B5BEB"/>
                 </a:solidFill>
@@ -25806,7 +26322,7 @@
               </a:defRPr>
             </a:lvl5pPr>
             <a:lvl6pPr algn="l">
-              <a:defRPr sz="3300" b="1">
+              <a:defRPr sz="2400" b="1">
                 <a:solidFill>
                   <a:srgbClr val="2B5BEB"/>
                 </a:solidFill>
@@ -25816,7 +26332,7 @@
               </a:defRPr>
             </a:lvl6pPr>
             <a:lvl7pPr algn="l">
-              <a:defRPr sz="3300" b="1">
+              <a:defRPr sz="2400" b="1">
                 <a:solidFill>
                   <a:srgbClr val="2B5BEB"/>
                 </a:solidFill>
@@ -25826,7 +26342,7 @@
               </a:defRPr>
             </a:lvl7pPr>
             <a:lvl8pPr algn="l">
-              <a:defRPr sz="3300" b="1">
+              <a:defRPr sz="2400" b="1">
                 <a:solidFill>
                   <a:srgbClr val="2B5BEB"/>
                 </a:solidFill>
@@ -25836,7 +26352,7 @@
               </a:defRPr>
             </a:lvl8pPr>
             <a:lvl9pPr algn="l">
-              <a:defRPr sz="3300" b="1">
+              <a:defRPr sz="2400" b="1">
                 <a:solidFill>
                   <a:srgbClr val="2B5BEB"/>
                 </a:solidFill>
@@ -25848,7 +26364,7 @@
           </a:lstStyle>
           <a:p xmlns:a="http://schemas.openxmlformats.org/drawingml/2006/main">
             <a:pPr algn="l">
-              <a:defRPr sz="3300" b="1">
+              <a:defRPr sz="2400" b="1">
                 <a:solidFill>
                   <a:srgbClr val="2B5BEB"/>
                 </a:solidFill>
@@ -25858,7 +26374,7 @@
               </a:defRPr>
             </a:pPr>
             <a:r>
-              <a:rPr sz="3300" b="1">
+              <a:rPr sz="2400" b="1">
                 <a:solidFill>
                   <a:srgbClr val="2B5BEB"/>
                 </a:solidFill>
@@ -25866,17 +26382,17 @@
                 <a:ea typeface="Noto Sans Bold"/>
                 <a:cs typeface="Noto Sans Bold"/>
               </a:rPr>
-              <a:t>01</a:t>
+              <a:t>추가한 근거 확인</a:t>
             </a:r>
           </a:p>
         </p:txBody>
       </p:sp>
       <p:sp>
         <p:nvSpPr>
-          <p:cNvPr id="9" name="rag-title-0">
+          <p:cNvPr id="10" name="rag-evidence">
             <a:extLst xmlns:a="http://schemas.openxmlformats.org/drawingml/2006/main">
               <a:ext uri="{FF2B5EF4-FFF2-40B4-BE49-F238E27FC236}">
-                <a16:creationId xmlns:a16="http://schemas.microsoft.com/office/drawing/2014/main" id="{A415DCB1-9A52-4853-9E35-2BFE5A459268}"/>
+                <a16:creationId xmlns:a16="http://schemas.microsoft.com/office/drawing/2014/main" id="{63706CE9-820D-438D-84CB-7C60CAC3DB90}"/>
               </a:ext>
             </a:extLst>
           </p:cNvPr>
@@ -25887,1271 +26403,7 @@
         </p:nvSpPr>
         <p:spPr>
           <a:xfrm xmlns:a="http://schemas.openxmlformats.org/drawingml/2006/main">
-            <a:off x="2381250" y="3476625"/>
-            <a:ext cx="5238750" cy="619125"/>
-          </a:xfrm>
-          <a:prstGeom xmlns:a="http://schemas.openxmlformats.org/drawingml/2006/main" prst="rect">
-            <a:avLst/>
-          </a:prstGeom>
-          <a:noFill xmlns:a="http://schemas.openxmlformats.org/drawingml/2006/main"/>
-          <a:ln xmlns:a="http://schemas.openxmlformats.org/drawingml/2006/main" w="0">
-            <a:noFill/>
-          </a:ln>
-        </p:spPr>
-        <p:txBody>
-          <a:bodyPr xmlns:a="http://schemas.openxmlformats.org/drawingml/2006/main" wrap="none" lIns="0" tIns="0" rIns="0" bIns="0" anchor="t">
-            <a:noAutofit/>
-          </a:bodyPr>
-          <a:lstStyle xmlns:a="http://schemas.openxmlformats.org/drawingml/2006/main">
-            <a:defPPr algn="l">
-              <a:defRPr sz="3300" b="1">
-                <a:solidFill>
-                  <a:srgbClr val="122C46"/>
-                </a:solidFill>
-                <a:latin typeface="Noto Sans Bold"/>
-                <a:ea typeface="Noto Sans Bold"/>
-                <a:cs typeface="Noto Sans Bold"/>
-              </a:defRPr>
-            </a:defPPr>
-            <a:lvl1pPr algn="l">
-              <a:defRPr sz="3300" b="1">
-                <a:solidFill>
-                  <a:srgbClr val="122C46"/>
-                </a:solidFill>
-                <a:latin typeface="Noto Sans Bold"/>
-                <a:ea typeface="Noto Sans Bold"/>
-                <a:cs typeface="Noto Sans Bold"/>
-              </a:defRPr>
-            </a:lvl1pPr>
-            <a:lvl2pPr algn="l">
-              <a:defRPr sz="3300" b="1">
-                <a:solidFill>
-                  <a:srgbClr val="122C46"/>
-                </a:solidFill>
-                <a:latin typeface="Noto Sans Bold"/>
-                <a:ea typeface="Noto Sans Bold"/>
-                <a:cs typeface="Noto Sans Bold"/>
-              </a:defRPr>
-            </a:lvl2pPr>
-            <a:lvl3pPr algn="l">
-              <a:defRPr sz="3300" b="1">
-                <a:solidFill>
-                  <a:srgbClr val="122C46"/>
-                </a:solidFill>
-                <a:latin typeface="Noto Sans Bold"/>
-                <a:ea typeface="Noto Sans Bold"/>
-                <a:cs typeface="Noto Sans Bold"/>
-              </a:defRPr>
-            </a:lvl3pPr>
-            <a:lvl4pPr algn="l">
-              <a:defRPr sz="3300" b="1">
-                <a:solidFill>
-                  <a:srgbClr val="122C46"/>
-                </a:solidFill>
-                <a:latin typeface="Noto Sans Bold"/>
-                <a:ea typeface="Noto Sans Bold"/>
-                <a:cs typeface="Noto Sans Bold"/>
-              </a:defRPr>
-            </a:lvl4pPr>
-            <a:lvl5pPr algn="l">
-              <a:defRPr sz="3300" b="1">
-                <a:solidFill>
-                  <a:srgbClr val="122C46"/>
-                </a:solidFill>
-                <a:latin typeface="Noto Sans Bold"/>
-                <a:ea typeface="Noto Sans Bold"/>
-                <a:cs typeface="Noto Sans Bold"/>
-              </a:defRPr>
-            </a:lvl5pPr>
-            <a:lvl6pPr algn="l">
-              <a:defRPr sz="3300" b="1">
-                <a:solidFill>
-                  <a:srgbClr val="122C46"/>
-                </a:solidFill>
-                <a:latin typeface="Noto Sans Bold"/>
-                <a:ea typeface="Noto Sans Bold"/>
-                <a:cs typeface="Noto Sans Bold"/>
-              </a:defRPr>
-            </a:lvl6pPr>
-            <a:lvl7pPr algn="l">
-              <a:defRPr sz="3300" b="1">
-                <a:solidFill>
-                  <a:srgbClr val="122C46"/>
-                </a:solidFill>
-                <a:latin typeface="Noto Sans Bold"/>
-                <a:ea typeface="Noto Sans Bold"/>
-                <a:cs typeface="Noto Sans Bold"/>
-              </a:defRPr>
-            </a:lvl7pPr>
-            <a:lvl8pPr algn="l">
-              <a:defRPr sz="3300" b="1">
-                <a:solidFill>
-                  <a:srgbClr val="122C46"/>
-                </a:solidFill>
-                <a:latin typeface="Noto Sans Bold"/>
-                <a:ea typeface="Noto Sans Bold"/>
-                <a:cs typeface="Noto Sans Bold"/>
-              </a:defRPr>
-            </a:lvl8pPr>
-            <a:lvl9pPr algn="l">
-              <a:defRPr sz="3300" b="1">
-                <a:solidFill>
-                  <a:srgbClr val="122C46"/>
-                </a:solidFill>
-                <a:latin typeface="Noto Sans Bold"/>
-                <a:ea typeface="Noto Sans Bold"/>
-                <a:cs typeface="Noto Sans Bold"/>
-              </a:defRPr>
-            </a:lvl9pPr>
-          </a:lstStyle>
-          <a:p xmlns:a="http://schemas.openxmlformats.org/drawingml/2006/main">
-            <a:pPr algn="l">
-              <a:defRPr sz="3300" b="1">
-                <a:solidFill>
-                  <a:srgbClr val="122C46"/>
-                </a:solidFill>
-                <a:latin typeface="Noto Sans Bold"/>
-                <a:ea typeface="Noto Sans Bold"/>
-                <a:cs typeface="Noto Sans Bold"/>
-              </a:defRPr>
-            </a:pPr>
-            <a:r>
-              <a:rPr sz="3300" b="1">
-                <a:solidFill>
-                  <a:srgbClr val="122C46"/>
-                </a:solidFill>
-                <a:latin typeface="Noto Sans Bold"/>
-                <a:ea typeface="Noto Sans Bold"/>
-                <a:cs typeface="Noto Sans Bold"/>
-              </a:rPr>
-              <a:t>질의 구성</a:t>
-            </a:r>
-          </a:p>
-        </p:txBody>
-      </p:sp>
-      <p:sp>
-        <p:nvSpPr>
-          <p:cNvPr id="10" name="rag-body-0">
-            <a:extLst xmlns:a="http://schemas.openxmlformats.org/drawingml/2006/main">
-              <a:ext uri="{FF2B5EF4-FFF2-40B4-BE49-F238E27FC236}">
-                <a16:creationId xmlns:a16="http://schemas.microsoft.com/office/drawing/2014/main" id="{8651A37B-90D8-41BC-933F-F2E34770F39C}"/>
-              </a:ext>
-            </a:extLst>
-          </p:cNvPr>
-          <p:cNvSpPr>
-            <a:spLocks xmlns:a="http://schemas.openxmlformats.org/drawingml/2006/main" noGrp="1"/>
-          </p:cNvSpPr>
-          <p:nvPr/>
-        </p:nvSpPr>
-        <p:spPr>
-          <a:xfrm xmlns:a="http://schemas.openxmlformats.org/drawingml/2006/main">
-            <a:off x="8096250" y="3533775"/>
-            <a:ext cx="9048750" cy="619125"/>
-          </a:xfrm>
-          <a:prstGeom xmlns:a="http://schemas.openxmlformats.org/drawingml/2006/main" prst="rect">
-            <a:avLst/>
-          </a:prstGeom>
-          <a:noFill xmlns:a="http://schemas.openxmlformats.org/drawingml/2006/main"/>
-          <a:ln xmlns:a="http://schemas.openxmlformats.org/drawingml/2006/main" w="0">
-            <a:noFill/>
-          </a:ln>
-        </p:spPr>
-        <p:txBody>
-          <a:bodyPr xmlns:a="http://schemas.openxmlformats.org/drawingml/2006/main" wrap="none" lIns="0" tIns="0" rIns="0" bIns="0" anchor="t">
-            <a:noAutofit/>
-          </a:bodyPr>
-          <a:lstStyle xmlns:a="http://schemas.openxmlformats.org/drawingml/2006/main">
-            <a:defPPr algn="l">
-              <a:defRPr sz="2700" b="0">
-                <a:solidFill>
-                  <a:srgbClr val="566A80"/>
-                </a:solidFill>
-                <a:latin typeface="Noto Sans Kr"/>
-                <a:ea typeface="Noto Sans Kr"/>
-                <a:cs typeface="Noto Sans Kr"/>
-              </a:defRPr>
-            </a:defPPr>
-            <a:lvl1pPr algn="l">
-              <a:defRPr sz="2700" b="0">
-                <a:solidFill>
-                  <a:srgbClr val="566A80"/>
-                </a:solidFill>
-                <a:latin typeface="Noto Sans Kr"/>
-                <a:ea typeface="Noto Sans Kr"/>
-                <a:cs typeface="Noto Sans Kr"/>
-              </a:defRPr>
-            </a:lvl1pPr>
-            <a:lvl2pPr algn="l">
-              <a:defRPr sz="2700" b="0">
-                <a:solidFill>
-                  <a:srgbClr val="566A80"/>
-                </a:solidFill>
-                <a:latin typeface="Noto Sans Kr"/>
-                <a:ea typeface="Noto Sans Kr"/>
-                <a:cs typeface="Noto Sans Kr"/>
-              </a:defRPr>
-            </a:lvl2pPr>
-            <a:lvl3pPr algn="l">
-              <a:defRPr sz="2700" b="0">
-                <a:solidFill>
-                  <a:srgbClr val="566A80"/>
-                </a:solidFill>
-                <a:latin typeface="Noto Sans Kr"/>
-                <a:ea typeface="Noto Sans Kr"/>
-                <a:cs typeface="Noto Sans Kr"/>
-              </a:defRPr>
-            </a:lvl3pPr>
-            <a:lvl4pPr algn="l">
-              <a:defRPr sz="2700" b="0">
-                <a:solidFill>
-                  <a:srgbClr val="566A80"/>
-                </a:solidFill>
-                <a:latin typeface="Noto Sans Kr"/>
-                <a:ea typeface="Noto Sans Kr"/>
-                <a:cs typeface="Noto Sans Kr"/>
-              </a:defRPr>
-            </a:lvl4pPr>
-            <a:lvl5pPr algn="l">
-              <a:defRPr sz="2700" b="0">
-                <a:solidFill>
-                  <a:srgbClr val="566A80"/>
-                </a:solidFill>
-                <a:latin typeface="Noto Sans Kr"/>
-                <a:ea typeface="Noto Sans Kr"/>
-                <a:cs typeface="Noto Sans Kr"/>
-              </a:defRPr>
-            </a:lvl5pPr>
-            <a:lvl6pPr algn="l">
-              <a:defRPr sz="2700" b="0">
-                <a:solidFill>
-                  <a:srgbClr val="566A80"/>
-                </a:solidFill>
-                <a:latin typeface="Noto Sans Kr"/>
-                <a:ea typeface="Noto Sans Kr"/>
-                <a:cs typeface="Noto Sans Kr"/>
-              </a:defRPr>
-            </a:lvl6pPr>
-            <a:lvl7pPr algn="l">
-              <a:defRPr sz="2700" b="0">
-                <a:solidFill>
-                  <a:srgbClr val="566A80"/>
-                </a:solidFill>
-                <a:latin typeface="Noto Sans Kr"/>
-                <a:ea typeface="Noto Sans Kr"/>
-                <a:cs typeface="Noto Sans Kr"/>
-              </a:defRPr>
-            </a:lvl7pPr>
-            <a:lvl8pPr algn="l">
-              <a:defRPr sz="2700" b="0">
-                <a:solidFill>
-                  <a:srgbClr val="566A80"/>
-                </a:solidFill>
-                <a:latin typeface="Noto Sans Kr"/>
-                <a:ea typeface="Noto Sans Kr"/>
-                <a:cs typeface="Noto Sans Kr"/>
-              </a:defRPr>
-            </a:lvl8pPr>
-            <a:lvl9pPr algn="l">
-              <a:defRPr sz="2700" b="0">
-                <a:solidFill>
-                  <a:srgbClr val="566A80"/>
-                </a:solidFill>
-                <a:latin typeface="Noto Sans Kr"/>
-                <a:ea typeface="Noto Sans Kr"/>
-                <a:cs typeface="Noto Sans Kr"/>
-              </a:defRPr>
-            </a:lvl9pPr>
-          </a:lstStyle>
-          <a:p xmlns:a="http://schemas.openxmlformats.org/drawingml/2006/main">
-            <a:pPr algn="l">
-              <a:defRPr sz="2700" b="0">
-                <a:solidFill>
-                  <a:srgbClr val="566A80"/>
-                </a:solidFill>
-                <a:latin typeface="Noto Sans Kr"/>
-                <a:ea typeface="Noto Sans Kr"/>
-                <a:cs typeface="Noto Sans Kr"/>
-              </a:defRPr>
-            </a:pPr>
-            <a:r>
-              <a:rPr sz="2700" b="0">
-                <a:solidFill>
-                  <a:srgbClr val="566A80"/>
-                </a:solidFill>
-                <a:latin typeface="Noto Sans Kr"/>
-                <a:ea typeface="Noto Sans Kr"/>
-                <a:cs typeface="Noto Sans Kr"/>
-              </a:rPr>
-              <a:t>증상과 지표·알림을 함께 사용</a:t>
-            </a:r>
-          </a:p>
-        </p:txBody>
-      </p:sp>
-      <p:sp>
-        <p:nvSpPr>
-          <p:cNvPr id="11" name="rag-number-1">
-            <a:extLst xmlns:a="http://schemas.openxmlformats.org/drawingml/2006/main">
-              <a:ext uri="{FF2B5EF4-FFF2-40B4-BE49-F238E27FC236}">
-                <a16:creationId xmlns:a16="http://schemas.microsoft.com/office/drawing/2014/main" id="{3F5FE370-4E11-4C0A-B689-BD662E04D016}"/>
-              </a:ext>
-            </a:extLst>
-          </p:cNvPr>
-          <p:cNvSpPr>
-            <a:spLocks xmlns:a="http://schemas.openxmlformats.org/drawingml/2006/main" noGrp="1"/>
-          </p:cNvSpPr>
-          <p:nvPr/>
-        </p:nvSpPr>
-        <p:spPr>
-          <a:xfrm xmlns:a="http://schemas.openxmlformats.org/drawingml/2006/main">
-            <a:off x="1143000" y="4905375"/>
-            <a:ext cx="904875" cy="619125"/>
-          </a:xfrm>
-          <a:prstGeom xmlns:a="http://schemas.openxmlformats.org/drawingml/2006/main" prst="rect">
-            <a:avLst/>
-          </a:prstGeom>
-          <a:noFill xmlns:a="http://schemas.openxmlformats.org/drawingml/2006/main"/>
-          <a:ln xmlns:a="http://schemas.openxmlformats.org/drawingml/2006/main" w="0">
-            <a:noFill/>
-          </a:ln>
-        </p:spPr>
-        <p:txBody>
-          <a:bodyPr xmlns:a="http://schemas.openxmlformats.org/drawingml/2006/main" wrap="none" lIns="0" tIns="0" rIns="0" bIns="0" anchor="t">
-            <a:noAutofit/>
-          </a:bodyPr>
-          <a:lstStyle xmlns:a="http://schemas.openxmlformats.org/drawingml/2006/main">
-            <a:defPPr algn="l">
-              <a:defRPr sz="3300" b="1">
-                <a:solidFill>
-                  <a:srgbClr val="2B5BEB"/>
-                </a:solidFill>
-                <a:latin typeface="Noto Sans Bold"/>
-                <a:ea typeface="Noto Sans Bold"/>
-                <a:cs typeface="Noto Sans Bold"/>
-              </a:defRPr>
-            </a:defPPr>
-            <a:lvl1pPr algn="l">
-              <a:defRPr sz="3300" b="1">
-                <a:solidFill>
-                  <a:srgbClr val="2B5BEB"/>
-                </a:solidFill>
-                <a:latin typeface="Noto Sans Bold"/>
-                <a:ea typeface="Noto Sans Bold"/>
-                <a:cs typeface="Noto Sans Bold"/>
-              </a:defRPr>
-            </a:lvl1pPr>
-            <a:lvl2pPr algn="l">
-              <a:defRPr sz="3300" b="1">
-                <a:solidFill>
-                  <a:srgbClr val="2B5BEB"/>
-                </a:solidFill>
-                <a:latin typeface="Noto Sans Bold"/>
-                <a:ea typeface="Noto Sans Bold"/>
-                <a:cs typeface="Noto Sans Bold"/>
-              </a:defRPr>
-            </a:lvl2pPr>
-            <a:lvl3pPr algn="l">
-              <a:defRPr sz="3300" b="1">
-                <a:solidFill>
-                  <a:srgbClr val="2B5BEB"/>
-                </a:solidFill>
-                <a:latin typeface="Noto Sans Bold"/>
-                <a:ea typeface="Noto Sans Bold"/>
-                <a:cs typeface="Noto Sans Bold"/>
-              </a:defRPr>
-            </a:lvl3pPr>
-            <a:lvl4pPr algn="l">
-              <a:defRPr sz="3300" b="1">
-                <a:solidFill>
-                  <a:srgbClr val="2B5BEB"/>
-                </a:solidFill>
-                <a:latin typeface="Noto Sans Bold"/>
-                <a:ea typeface="Noto Sans Bold"/>
-                <a:cs typeface="Noto Sans Bold"/>
-              </a:defRPr>
-            </a:lvl4pPr>
-            <a:lvl5pPr algn="l">
-              <a:defRPr sz="3300" b="1">
-                <a:solidFill>
-                  <a:srgbClr val="2B5BEB"/>
-                </a:solidFill>
-                <a:latin typeface="Noto Sans Bold"/>
-                <a:ea typeface="Noto Sans Bold"/>
-                <a:cs typeface="Noto Sans Bold"/>
-              </a:defRPr>
-            </a:lvl5pPr>
-            <a:lvl6pPr algn="l">
-              <a:defRPr sz="3300" b="1">
-                <a:solidFill>
-                  <a:srgbClr val="2B5BEB"/>
-                </a:solidFill>
-                <a:latin typeface="Noto Sans Bold"/>
-                <a:ea typeface="Noto Sans Bold"/>
-                <a:cs typeface="Noto Sans Bold"/>
-              </a:defRPr>
-            </a:lvl6pPr>
-            <a:lvl7pPr algn="l">
-              <a:defRPr sz="3300" b="1">
-                <a:solidFill>
-                  <a:srgbClr val="2B5BEB"/>
-                </a:solidFill>
-                <a:latin typeface="Noto Sans Bold"/>
-                <a:ea typeface="Noto Sans Bold"/>
-                <a:cs typeface="Noto Sans Bold"/>
-              </a:defRPr>
-            </a:lvl7pPr>
-            <a:lvl8pPr algn="l">
-              <a:defRPr sz="3300" b="1">
-                <a:solidFill>
-                  <a:srgbClr val="2B5BEB"/>
-                </a:solidFill>
-                <a:latin typeface="Noto Sans Bold"/>
-                <a:ea typeface="Noto Sans Bold"/>
-                <a:cs typeface="Noto Sans Bold"/>
-              </a:defRPr>
-            </a:lvl8pPr>
-            <a:lvl9pPr algn="l">
-              <a:defRPr sz="3300" b="1">
-                <a:solidFill>
-                  <a:srgbClr val="2B5BEB"/>
-                </a:solidFill>
-                <a:latin typeface="Noto Sans Bold"/>
-                <a:ea typeface="Noto Sans Bold"/>
-                <a:cs typeface="Noto Sans Bold"/>
-              </a:defRPr>
-            </a:lvl9pPr>
-          </a:lstStyle>
-          <a:p xmlns:a="http://schemas.openxmlformats.org/drawingml/2006/main">
-            <a:pPr algn="l">
-              <a:defRPr sz="3300" b="1">
-                <a:solidFill>
-                  <a:srgbClr val="2B5BEB"/>
-                </a:solidFill>
-                <a:latin typeface="Noto Sans Bold"/>
-                <a:ea typeface="Noto Sans Bold"/>
-                <a:cs typeface="Noto Sans Bold"/>
-              </a:defRPr>
-            </a:pPr>
-            <a:r>
-              <a:rPr sz="3300" b="1">
-                <a:solidFill>
-                  <a:srgbClr val="2B5BEB"/>
-                </a:solidFill>
-                <a:latin typeface="Noto Sans Bold"/>
-                <a:ea typeface="Noto Sans Bold"/>
-                <a:cs typeface="Noto Sans Bold"/>
-              </a:rPr>
-              <a:t>02</a:t>
-            </a:r>
-          </a:p>
-        </p:txBody>
-      </p:sp>
-      <p:sp>
-        <p:nvSpPr>
-          <p:cNvPr id="12" name="rag-title-1">
-            <a:extLst xmlns:a="http://schemas.openxmlformats.org/drawingml/2006/main">
-              <a:ext uri="{FF2B5EF4-FFF2-40B4-BE49-F238E27FC236}">
-                <a16:creationId xmlns:a16="http://schemas.microsoft.com/office/drawing/2014/main" id="{CA0EA46B-9134-4F42-8DA5-D1043E0CAB40}"/>
-              </a:ext>
-            </a:extLst>
-          </p:cNvPr>
-          <p:cNvSpPr>
-            <a:spLocks xmlns:a="http://schemas.openxmlformats.org/drawingml/2006/main" noGrp="1"/>
-          </p:cNvSpPr>
-          <p:nvPr/>
-        </p:nvSpPr>
-        <p:spPr>
-          <a:xfrm xmlns:a="http://schemas.openxmlformats.org/drawingml/2006/main">
-            <a:off x="2381250" y="4905375"/>
-            <a:ext cx="5238750" cy="619125"/>
-          </a:xfrm>
-          <a:prstGeom xmlns:a="http://schemas.openxmlformats.org/drawingml/2006/main" prst="rect">
-            <a:avLst/>
-          </a:prstGeom>
-          <a:noFill xmlns:a="http://schemas.openxmlformats.org/drawingml/2006/main"/>
-          <a:ln xmlns:a="http://schemas.openxmlformats.org/drawingml/2006/main" w="0">
-            <a:noFill/>
-          </a:ln>
-        </p:spPr>
-        <p:txBody>
-          <a:bodyPr xmlns:a="http://schemas.openxmlformats.org/drawingml/2006/main" wrap="none" lIns="0" tIns="0" rIns="0" bIns="0" anchor="t">
-            <a:noAutofit/>
-          </a:bodyPr>
-          <a:lstStyle xmlns:a="http://schemas.openxmlformats.org/drawingml/2006/main">
-            <a:defPPr algn="l">
-              <a:defRPr sz="3300" b="1">
-                <a:solidFill>
-                  <a:srgbClr val="122C46"/>
-                </a:solidFill>
-                <a:latin typeface="Noto Sans Bold"/>
-                <a:ea typeface="Noto Sans Bold"/>
-                <a:cs typeface="Noto Sans Bold"/>
-              </a:defRPr>
-            </a:defPPr>
-            <a:lvl1pPr algn="l">
-              <a:defRPr sz="3300" b="1">
-                <a:solidFill>
-                  <a:srgbClr val="122C46"/>
-                </a:solidFill>
-                <a:latin typeface="Noto Sans Bold"/>
-                <a:ea typeface="Noto Sans Bold"/>
-                <a:cs typeface="Noto Sans Bold"/>
-              </a:defRPr>
-            </a:lvl1pPr>
-            <a:lvl2pPr algn="l">
-              <a:defRPr sz="3300" b="1">
-                <a:solidFill>
-                  <a:srgbClr val="122C46"/>
-                </a:solidFill>
-                <a:latin typeface="Noto Sans Bold"/>
-                <a:ea typeface="Noto Sans Bold"/>
-                <a:cs typeface="Noto Sans Bold"/>
-              </a:defRPr>
-            </a:lvl2pPr>
-            <a:lvl3pPr algn="l">
-              <a:defRPr sz="3300" b="1">
-                <a:solidFill>
-                  <a:srgbClr val="122C46"/>
-                </a:solidFill>
-                <a:latin typeface="Noto Sans Bold"/>
-                <a:ea typeface="Noto Sans Bold"/>
-                <a:cs typeface="Noto Sans Bold"/>
-              </a:defRPr>
-            </a:lvl3pPr>
-            <a:lvl4pPr algn="l">
-              <a:defRPr sz="3300" b="1">
-                <a:solidFill>
-                  <a:srgbClr val="122C46"/>
-                </a:solidFill>
-                <a:latin typeface="Noto Sans Bold"/>
-                <a:ea typeface="Noto Sans Bold"/>
-                <a:cs typeface="Noto Sans Bold"/>
-              </a:defRPr>
-            </a:lvl4pPr>
-            <a:lvl5pPr algn="l">
-              <a:defRPr sz="3300" b="1">
-                <a:solidFill>
-                  <a:srgbClr val="122C46"/>
-                </a:solidFill>
-                <a:latin typeface="Noto Sans Bold"/>
-                <a:ea typeface="Noto Sans Bold"/>
-                <a:cs typeface="Noto Sans Bold"/>
-              </a:defRPr>
-            </a:lvl5pPr>
-            <a:lvl6pPr algn="l">
-              <a:defRPr sz="3300" b="1">
-                <a:solidFill>
-                  <a:srgbClr val="122C46"/>
-                </a:solidFill>
-                <a:latin typeface="Noto Sans Bold"/>
-                <a:ea typeface="Noto Sans Bold"/>
-                <a:cs typeface="Noto Sans Bold"/>
-              </a:defRPr>
-            </a:lvl6pPr>
-            <a:lvl7pPr algn="l">
-              <a:defRPr sz="3300" b="1">
-                <a:solidFill>
-                  <a:srgbClr val="122C46"/>
-                </a:solidFill>
-                <a:latin typeface="Noto Sans Bold"/>
-                <a:ea typeface="Noto Sans Bold"/>
-                <a:cs typeface="Noto Sans Bold"/>
-              </a:defRPr>
-            </a:lvl7pPr>
-            <a:lvl8pPr algn="l">
-              <a:defRPr sz="3300" b="1">
-                <a:solidFill>
-                  <a:srgbClr val="122C46"/>
-                </a:solidFill>
-                <a:latin typeface="Noto Sans Bold"/>
-                <a:ea typeface="Noto Sans Bold"/>
-                <a:cs typeface="Noto Sans Bold"/>
-              </a:defRPr>
-            </a:lvl8pPr>
-            <a:lvl9pPr algn="l">
-              <a:defRPr sz="3300" b="1">
-                <a:solidFill>
-                  <a:srgbClr val="122C46"/>
-                </a:solidFill>
-                <a:latin typeface="Noto Sans Bold"/>
-                <a:ea typeface="Noto Sans Bold"/>
-                <a:cs typeface="Noto Sans Bold"/>
-              </a:defRPr>
-            </a:lvl9pPr>
-          </a:lstStyle>
-          <a:p xmlns:a="http://schemas.openxmlformats.org/drawingml/2006/main">
-            <a:pPr algn="l">
-              <a:defRPr sz="3300" b="1">
-                <a:solidFill>
-                  <a:srgbClr val="122C46"/>
-                </a:solidFill>
-                <a:latin typeface="Noto Sans Bold"/>
-                <a:ea typeface="Noto Sans Bold"/>
-                <a:cs typeface="Noto Sans Bold"/>
-              </a:defRPr>
-            </a:pPr>
-            <a:r>
-              <a:rPr sz="3300" b="1">
-                <a:solidFill>
-                  <a:srgbClr val="122C46"/>
-                </a:solidFill>
-                <a:latin typeface="Noto Sans Bold"/>
-                <a:ea typeface="Noto Sans Bold"/>
-                <a:cs typeface="Noto Sans Bold"/>
-              </a:rPr>
-              <a:t>벡터 의미 검색</a:t>
-            </a:r>
-          </a:p>
-        </p:txBody>
-      </p:sp>
-      <p:sp>
-        <p:nvSpPr>
-          <p:cNvPr id="13" name="rag-body-1">
-            <a:extLst xmlns:a="http://schemas.openxmlformats.org/drawingml/2006/main">
-              <a:ext uri="{FF2B5EF4-FFF2-40B4-BE49-F238E27FC236}">
-                <a16:creationId xmlns:a16="http://schemas.microsoft.com/office/drawing/2014/main" id="{730A1F29-7816-46C7-86E8-B08925672EC5}"/>
-              </a:ext>
-            </a:extLst>
-          </p:cNvPr>
-          <p:cNvSpPr>
-            <a:spLocks xmlns:a="http://schemas.openxmlformats.org/drawingml/2006/main" noGrp="1"/>
-          </p:cNvSpPr>
-          <p:nvPr/>
-        </p:nvSpPr>
-        <p:spPr>
-          <a:xfrm xmlns:a="http://schemas.openxmlformats.org/drawingml/2006/main">
-            <a:off x="8096250" y="4962525"/>
-            <a:ext cx="9048750" cy="619125"/>
-          </a:xfrm>
-          <a:prstGeom xmlns:a="http://schemas.openxmlformats.org/drawingml/2006/main" prst="rect">
-            <a:avLst/>
-          </a:prstGeom>
-          <a:noFill xmlns:a="http://schemas.openxmlformats.org/drawingml/2006/main"/>
-          <a:ln xmlns:a="http://schemas.openxmlformats.org/drawingml/2006/main" w="0">
-            <a:noFill/>
-          </a:ln>
-        </p:spPr>
-        <p:txBody>
-          <a:bodyPr xmlns:a="http://schemas.openxmlformats.org/drawingml/2006/main" wrap="none" lIns="0" tIns="0" rIns="0" bIns="0" anchor="t">
-            <a:noAutofit/>
-          </a:bodyPr>
-          <a:lstStyle xmlns:a="http://schemas.openxmlformats.org/drawingml/2006/main">
-            <a:defPPr algn="l">
-              <a:defRPr sz="2700" b="0">
-                <a:solidFill>
-                  <a:srgbClr val="566A80"/>
-                </a:solidFill>
-                <a:latin typeface="Noto Sans Kr"/>
-                <a:ea typeface="Noto Sans Kr"/>
-                <a:cs typeface="Noto Sans Kr"/>
-              </a:defRPr>
-            </a:defPPr>
-            <a:lvl1pPr algn="l">
-              <a:defRPr sz="2700" b="0">
-                <a:solidFill>
-                  <a:srgbClr val="566A80"/>
-                </a:solidFill>
-                <a:latin typeface="Noto Sans Kr"/>
-                <a:ea typeface="Noto Sans Kr"/>
-                <a:cs typeface="Noto Sans Kr"/>
-              </a:defRPr>
-            </a:lvl1pPr>
-            <a:lvl2pPr algn="l">
-              <a:defRPr sz="2700" b="0">
-                <a:solidFill>
-                  <a:srgbClr val="566A80"/>
-                </a:solidFill>
-                <a:latin typeface="Noto Sans Kr"/>
-                <a:ea typeface="Noto Sans Kr"/>
-                <a:cs typeface="Noto Sans Kr"/>
-              </a:defRPr>
-            </a:lvl2pPr>
-            <a:lvl3pPr algn="l">
-              <a:defRPr sz="2700" b="0">
-                <a:solidFill>
-                  <a:srgbClr val="566A80"/>
-                </a:solidFill>
-                <a:latin typeface="Noto Sans Kr"/>
-                <a:ea typeface="Noto Sans Kr"/>
-                <a:cs typeface="Noto Sans Kr"/>
-              </a:defRPr>
-            </a:lvl3pPr>
-            <a:lvl4pPr algn="l">
-              <a:defRPr sz="2700" b="0">
-                <a:solidFill>
-                  <a:srgbClr val="566A80"/>
-                </a:solidFill>
-                <a:latin typeface="Noto Sans Kr"/>
-                <a:ea typeface="Noto Sans Kr"/>
-                <a:cs typeface="Noto Sans Kr"/>
-              </a:defRPr>
-            </a:lvl4pPr>
-            <a:lvl5pPr algn="l">
-              <a:defRPr sz="2700" b="0">
-                <a:solidFill>
-                  <a:srgbClr val="566A80"/>
-                </a:solidFill>
-                <a:latin typeface="Noto Sans Kr"/>
-                <a:ea typeface="Noto Sans Kr"/>
-                <a:cs typeface="Noto Sans Kr"/>
-              </a:defRPr>
-            </a:lvl5pPr>
-            <a:lvl6pPr algn="l">
-              <a:defRPr sz="2700" b="0">
-                <a:solidFill>
-                  <a:srgbClr val="566A80"/>
-                </a:solidFill>
-                <a:latin typeface="Noto Sans Kr"/>
-                <a:ea typeface="Noto Sans Kr"/>
-                <a:cs typeface="Noto Sans Kr"/>
-              </a:defRPr>
-            </a:lvl6pPr>
-            <a:lvl7pPr algn="l">
-              <a:defRPr sz="2700" b="0">
-                <a:solidFill>
-                  <a:srgbClr val="566A80"/>
-                </a:solidFill>
-                <a:latin typeface="Noto Sans Kr"/>
-                <a:ea typeface="Noto Sans Kr"/>
-                <a:cs typeface="Noto Sans Kr"/>
-              </a:defRPr>
-            </a:lvl7pPr>
-            <a:lvl8pPr algn="l">
-              <a:defRPr sz="2700" b="0">
-                <a:solidFill>
-                  <a:srgbClr val="566A80"/>
-                </a:solidFill>
-                <a:latin typeface="Noto Sans Kr"/>
-                <a:ea typeface="Noto Sans Kr"/>
-                <a:cs typeface="Noto Sans Kr"/>
-              </a:defRPr>
-            </a:lvl8pPr>
-            <a:lvl9pPr algn="l">
-              <a:defRPr sz="2700" b="0">
-                <a:solidFill>
-                  <a:srgbClr val="566A80"/>
-                </a:solidFill>
-                <a:latin typeface="Noto Sans Kr"/>
-                <a:ea typeface="Noto Sans Kr"/>
-                <a:cs typeface="Noto Sans Kr"/>
-              </a:defRPr>
-            </a:lvl9pPr>
-          </a:lstStyle>
-          <a:p xmlns:a="http://schemas.openxmlformats.org/drawingml/2006/main">
-            <a:pPr algn="l">
-              <a:defRPr sz="2700" b="0">
-                <a:solidFill>
-                  <a:srgbClr val="566A80"/>
-                </a:solidFill>
-                <a:latin typeface="Noto Sans Kr"/>
-                <a:ea typeface="Noto Sans Kr"/>
-                <a:cs typeface="Noto Sans Kr"/>
-              </a:defRPr>
-            </a:pPr>
-            <a:r>
-              <a:rPr sz="2700" b="0">
-                <a:solidFill>
-                  <a:srgbClr val="566A80"/>
-                </a:solidFill>
-                <a:latin typeface="Noto Sans Kr"/>
-                <a:ea typeface="Noto Sans Kr"/>
-                <a:cs typeface="Noto Sans Kr"/>
-              </a:rPr>
-              <a:t>매뉴얼 6종 임베딩·최대 3종 선택</a:t>
-            </a:r>
-          </a:p>
-        </p:txBody>
-      </p:sp>
-      <p:sp>
-        <p:nvSpPr>
-          <p:cNvPr id="14" name="rag-number-2">
-            <a:extLst xmlns:a="http://schemas.openxmlformats.org/drawingml/2006/main">
-              <a:ext uri="{FF2B5EF4-FFF2-40B4-BE49-F238E27FC236}">
-                <a16:creationId xmlns:a16="http://schemas.microsoft.com/office/drawing/2014/main" id="{259FA2B8-4911-49E9-9F7A-2859014B2DE3}"/>
-              </a:ext>
-            </a:extLst>
-          </p:cNvPr>
-          <p:cNvSpPr>
-            <a:spLocks xmlns:a="http://schemas.openxmlformats.org/drawingml/2006/main" noGrp="1"/>
-          </p:cNvSpPr>
-          <p:nvPr/>
-        </p:nvSpPr>
-        <p:spPr>
-          <a:xfrm xmlns:a="http://schemas.openxmlformats.org/drawingml/2006/main">
-            <a:off x="1143000" y="6334125"/>
-            <a:ext cx="904875" cy="619125"/>
-          </a:xfrm>
-          <a:prstGeom xmlns:a="http://schemas.openxmlformats.org/drawingml/2006/main" prst="rect">
-            <a:avLst/>
-          </a:prstGeom>
-          <a:noFill xmlns:a="http://schemas.openxmlformats.org/drawingml/2006/main"/>
-          <a:ln xmlns:a="http://schemas.openxmlformats.org/drawingml/2006/main" w="0">
-            <a:noFill/>
-          </a:ln>
-        </p:spPr>
-        <p:txBody>
-          <a:bodyPr xmlns:a="http://schemas.openxmlformats.org/drawingml/2006/main" wrap="none" lIns="0" tIns="0" rIns="0" bIns="0" anchor="t">
-            <a:noAutofit/>
-          </a:bodyPr>
-          <a:lstStyle xmlns:a="http://schemas.openxmlformats.org/drawingml/2006/main">
-            <a:defPPr algn="l">
-              <a:defRPr sz="3300" b="1">
-                <a:solidFill>
-                  <a:srgbClr val="2B5BEB"/>
-                </a:solidFill>
-                <a:latin typeface="Noto Sans Bold"/>
-                <a:ea typeface="Noto Sans Bold"/>
-                <a:cs typeface="Noto Sans Bold"/>
-              </a:defRPr>
-            </a:defPPr>
-            <a:lvl1pPr algn="l">
-              <a:defRPr sz="3300" b="1">
-                <a:solidFill>
-                  <a:srgbClr val="2B5BEB"/>
-                </a:solidFill>
-                <a:latin typeface="Noto Sans Bold"/>
-                <a:ea typeface="Noto Sans Bold"/>
-                <a:cs typeface="Noto Sans Bold"/>
-              </a:defRPr>
-            </a:lvl1pPr>
-            <a:lvl2pPr algn="l">
-              <a:defRPr sz="3300" b="1">
-                <a:solidFill>
-                  <a:srgbClr val="2B5BEB"/>
-                </a:solidFill>
-                <a:latin typeface="Noto Sans Bold"/>
-                <a:ea typeface="Noto Sans Bold"/>
-                <a:cs typeface="Noto Sans Bold"/>
-              </a:defRPr>
-            </a:lvl2pPr>
-            <a:lvl3pPr algn="l">
-              <a:defRPr sz="3300" b="1">
-                <a:solidFill>
-                  <a:srgbClr val="2B5BEB"/>
-                </a:solidFill>
-                <a:latin typeface="Noto Sans Bold"/>
-                <a:ea typeface="Noto Sans Bold"/>
-                <a:cs typeface="Noto Sans Bold"/>
-              </a:defRPr>
-            </a:lvl3pPr>
-            <a:lvl4pPr algn="l">
-              <a:defRPr sz="3300" b="1">
-                <a:solidFill>
-                  <a:srgbClr val="2B5BEB"/>
-                </a:solidFill>
-                <a:latin typeface="Noto Sans Bold"/>
-                <a:ea typeface="Noto Sans Bold"/>
-                <a:cs typeface="Noto Sans Bold"/>
-              </a:defRPr>
-            </a:lvl4pPr>
-            <a:lvl5pPr algn="l">
-              <a:defRPr sz="3300" b="1">
-                <a:solidFill>
-                  <a:srgbClr val="2B5BEB"/>
-                </a:solidFill>
-                <a:latin typeface="Noto Sans Bold"/>
-                <a:ea typeface="Noto Sans Bold"/>
-                <a:cs typeface="Noto Sans Bold"/>
-              </a:defRPr>
-            </a:lvl5pPr>
-            <a:lvl6pPr algn="l">
-              <a:defRPr sz="3300" b="1">
-                <a:solidFill>
-                  <a:srgbClr val="2B5BEB"/>
-                </a:solidFill>
-                <a:latin typeface="Noto Sans Bold"/>
-                <a:ea typeface="Noto Sans Bold"/>
-                <a:cs typeface="Noto Sans Bold"/>
-              </a:defRPr>
-            </a:lvl6pPr>
-            <a:lvl7pPr algn="l">
-              <a:defRPr sz="3300" b="1">
-                <a:solidFill>
-                  <a:srgbClr val="2B5BEB"/>
-                </a:solidFill>
-                <a:latin typeface="Noto Sans Bold"/>
-                <a:ea typeface="Noto Sans Bold"/>
-                <a:cs typeface="Noto Sans Bold"/>
-              </a:defRPr>
-            </a:lvl7pPr>
-            <a:lvl8pPr algn="l">
-              <a:defRPr sz="3300" b="1">
-                <a:solidFill>
-                  <a:srgbClr val="2B5BEB"/>
-                </a:solidFill>
-                <a:latin typeface="Noto Sans Bold"/>
-                <a:ea typeface="Noto Sans Bold"/>
-                <a:cs typeface="Noto Sans Bold"/>
-              </a:defRPr>
-            </a:lvl8pPr>
-            <a:lvl9pPr algn="l">
-              <a:defRPr sz="3300" b="1">
-                <a:solidFill>
-                  <a:srgbClr val="2B5BEB"/>
-                </a:solidFill>
-                <a:latin typeface="Noto Sans Bold"/>
-                <a:ea typeface="Noto Sans Bold"/>
-                <a:cs typeface="Noto Sans Bold"/>
-              </a:defRPr>
-            </a:lvl9pPr>
-          </a:lstStyle>
-          <a:p xmlns:a="http://schemas.openxmlformats.org/drawingml/2006/main">
-            <a:pPr algn="l">
-              <a:defRPr sz="3300" b="1">
-                <a:solidFill>
-                  <a:srgbClr val="2B5BEB"/>
-                </a:solidFill>
-                <a:latin typeface="Noto Sans Bold"/>
-                <a:ea typeface="Noto Sans Bold"/>
-                <a:cs typeface="Noto Sans Bold"/>
-              </a:defRPr>
-            </a:pPr>
-            <a:r>
-              <a:rPr sz="3300" b="1">
-                <a:solidFill>
-                  <a:srgbClr val="2B5BEB"/>
-                </a:solidFill>
-                <a:latin typeface="Noto Sans Bold"/>
-                <a:ea typeface="Noto Sans Bold"/>
-                <a:cs typeface="Noto Sans Bold"/>
-              </a:rPr>
-              <a:t>03</a:t>
-            </a:r>
-          </a:p>
-        </p:txBody>
-      </p:sp>
-      <p:sp>
-        <p:nvSpPr>
-          <p:cNvPr id="15" name="rag-title-2">
-            <a:extLst xmlns:a="http://schemas.openxmlformats.org/drawingml/2006/main">
-              <a:ext uri="{FF2B5EF4-FFF2-40B4-BE49-F238E27FC236}">
-                <a16:creationId xmlns:a16="http://schemas.microsoft.com/office/drawing/2014/main" id="{7509996B-9347-40B9-AF41-434FA386FD32}"/>
-              </a:ext>
-            </a:extLst>
-          </p:cNvPr>
-          <p:cNvSpPr>
-            <a:spLocks xmlns:a="http://schemas.openxmlformats.org/drawingml/2006/main" noGrp="1"/>
-          </p:cNvSpPr>
-          <p:nvPr/>
-        </p:nvSpPr>
-        <p:spPr>
-          <a:xfrm xmlns:a="http://schemas.openxmlformats.org/drawingml/2006/main">
-            <a:off x="2381250" y="6334125"/>
-            <a:ext cx="5238750" cy="619125"/>
-          </a:xfrm>
-          <a:prstGeom xmlns:a="http://schemas.openxmlformats.org/drawingml/2006/main" prst="rect">
-            <a:avLst/>
-          </a:prstGeom>
-          <a:noFill xmlns:a="http://schemas.openxmlformats.org/drawingml/2006/main"/>
-          <a:ln xmlns:a="http://schemas.openxmlformats.org/drawingml/2006/main" w="0">
-            <a:noFill/>
-          </a:ln>
-        </p:spPr>
-        <p:txBody>
-          <a:bodyPr xmlns:a="http://schemas.openxmlformats.org/drawingml/2006/main" wrap="none" lIns="0" tIns="0" rIns="0" bIns="0" anchor="t">
-            <a:noAutofit/>
-          </a:bodyPr>
-          <a:lstStyle xmlns:a="http://schemas.openxmlformats.org/drawingml/2006/main">
-            <a:defPPr algn="l">
-              <a:defRPr sz="3300" b="1">
-                <a:solidFill>
-                  <a:srgbClr val="122C46"/>
-                </a:solidFill>
-                <a:latin typeface="Noto Sans Bold"/>
-                <a:ea typeface="Noto Sans Bold"/>
-                <a:cs typeface="Noto Sans Bold"/>
-              </a:defRPr>
-            </a:defPPr>
-            <a:lvl1pPr algn="l">
-              <a:defRPr sz="3300" b="1">
-                <a:solidFill>
-                  <a:srgbClr val="122C46"/>
-                </a:solidFill>
-                <a:latin typeface="Noto Sans Bold"/>
-                <a:ea typeface="Noto Sans Bold"/>
-                <a:cs typeface="Noto Sans Bold"/>
-              </a:defRPr>
-            </a:lvl1pPr>
-            <a:lvl2pPr algn="l">
-              <a:defRPr sz="3300" b="1">
-                <a:solidFill>
-                  <a:srgbClr val="122C46"/>
-                </a:solidFill>
-                <a:latin typeface="Noto Sans Bold"/>
-                <a:ea typeface="Noto Sans Bold"/>
-                <a:cs typeface="Noto Sans Bold"/>
-              </a:defRPr>
-            </a:lvl2pPr>
-            <a:lvl3pPr algn="l">
-              <a:defRPr sz="3300" b="1">
-                <a:solidFill>
-                  <a:srgbClr val="122C46"/>
-                </a:solidFill>
-                <a:latin typeface="Noto Sans Bold"/>
-                <a:ea typeface="Noto Sans Bold"/>
-                <a:cs typeface="Noto Sans Bold"/>
-              </a:defRPr>
-            </a:lvl3pPr>
-            <a:lvl4pPr algn="l">
-              <a:defRPr sz="3300" b="1">
-                <a:solidFill>
-                  <a:srgbClr val="122C46"/>
-                </a:solidFill>
-                <a:latin typeface="Noto Sans Bold"/>
-                <a:ea typeface="Noto Sans Bold"/>
-                <a:cs typeface="Noto Sans Bold"/>
-              </a:defRPr>
-            </a:lvl4pPr>
-            <a:lvl5pPr algn="l">
-              <a:defRPr sz="3300" b="1">
-                <a:solidFill>
-                  <a:srgbClr val="122C46"/>
-                </a:solidFill>
-                <a:latin typeface="Noto Sans Bold"/>
-                <a:ea typeface="Noto Sans Bold"/>
-                <a:cs typeface="Noto Sans Bold"/>
-              </a:defRPr>
-            </a:lvl5pPr>
-            <a:lvl6pPr algn="l">
-              <a:defRPr sz="3300" b="1">
-                <a:solidFill>
-                  <a:srgbClr val="122C46"/>
-                </a:solidFill>
-                <a:latin typeface="Noto Sans Bold"/>
-                <a:ea typeface="Noto Sans Bold"/>
-                <a:cs typeface="Noto Sans Bold"/>
-              </a:defRPr>
-            </a:lvl6pPr>
-            <a:lvl7pPr algn="l">
-              <a:defRPr sz="3300" b="1">
-                <a:solidFill>
-                  <a:srgbClr val="122C46"/>
-                </a:solidFill>
-                <a:latin typeface="Noto Sans Bold"/>
-                <a:ea typeface="Noto Sans Bold"/>
-                <a:cs typeface="Noto Sans Bold"/>
-              </a:defRPr>
-            </a:lvl7pPr>
-            <a:lvl8pPr algn="l">
-              <a:defRPr sz="3300" b="1">
-                <a:solidFill>
-                  <a:srgbClr val="122C46"/>
-                </a:solidFill>
-                <a:latin typeface="Noto Sans Bold"/>
-                <a:ea typeface="Noto Sans Bold"/>
-                <a:cs typeface="Noto Sans Bold"/>
-              </a:defRPr>
-            </a:lvl8pPr>
-            <a:lvl9pPr algn="l">
-              <a:defRPr sz="3300" b="1">
-                <a:solidFill>
-                  <a:srgbClr val="122C46"/>
-                </a:solidFill>
-                <a:latin typeface="Noto Sans Bold"/>
-                <a:ea typeface="Noto Sans Bold"/>
-                <a:cs typeface="Noto Sans Bold"/>
-              </a:defRPr>
-            </a:lvl9pPr>
-          </a:lstStyle>
-          <a:p xmlns:a="http://schemas.openxmlformats.org/drawingml/2006/main">
-            <a:pPr algn="l">
-              <a:defRPr sz="3300" b="1">
-                <a:solidFill>
-                  <a:srgbClr val="122C46"/>
-                </a:solidFill>
-                <a:latin typeface="Noto Sans Bold"/>
-                <a:ea typeface="Noto Sans Bold"/>
-                <a:cs typeface="Noto Sans Bold"/>
-              </a:defRPr>
-            </a:pPr>
-            <a:r>
-              <a:rPr sz="3300" b="1">
-                <a:solidFill>
-                  <a:srgbClr val="122C46"/>
-                </a:solidFill>
-                <a:latin typeface="Noto Sans Bold"/>
-                <a:ea typeface="Noto Sans Bold"/>
-                <a:cs typeface="Noto Sans Bold"/>
-              </a:rPr>
-              <a:t>원문 대조</a:t>
-            </a:r>
-          </a:p>
-        </p:txBody>
-      </p:sp>
-      <p:sp>
-        <p:nvSpPr>
-          <p:cNvPr id="16" name="rag-body-2">
-            <a:extLst xmlns:a="http://schemas.openxmlformats.org/drawingml/2006/main">
-              <a:ext uri="{FF2B5EF4-FFF2-40B4-BE49-F238E27FC236}">
-                <a16:creationId xmlns:a16="http://schemas.microsoft.com/office/drawing/2014/main" id="{18508049-E091-4561-B00C-FE51EF0BD940}"/>
-              </a:ext>
-            </a:extLst>
-          </p:cNvPr>
-          <p:cNvSpPr>
-            <a:spLocks xmlns:a="http://schemas.openxmlformats.org/drawingml/2006/main" noGrp="1"/>
-          </p:cNvSpPr>
-          <p:nvPr/>
-        </p:nvSpPr>
-        <p:spPr>
-          <a:xfrm xmlns:a="http://schemas.openxmlformats.org/drawingml/2006/main">
-            <a:off x="8096250" y="6391275"/>
-            <a:ext cx="9048750" cy="619125"/>
-          </a:xfrm>
-          <a:prstGeom xmlns:a="http://schemas.openxmlformats.org/drawingml/2006/main" prst="rect">
-            <a:avLst/>
-          </a:prstGeom>
-          <a:noFill xmlns:a="http://schemas.openxmlformats.org/drawingml/2006/main"/>
-          <a:ln xmlns:a="http://schemas.openxmlformats.org/drawingml/2006/main" w="0">
-            <a:noFill/>
-          </a:ln>
-        </p:spPr>
-        <p:txBody>
-          <a:bodyPr xmlns:a="http://schemas.openxmlformats.org/drawingml/2006/main" wrap="none" lIns="0" tIns="0" rIns="0" bIns="0" anchor="t">
-            <a:noAutofit/>
-          </a:bodyPr>
-          <a:lstStyle xmlns:a="http://schemas.openxmlformats.org/drawingml/2006/main">
-            <a:defPPr algn="l">
-              <a:defRPr sz="2700" b="0">
-                <a:solidFill>
-                  <a:srgbClr val="566A80"/>
-                </a:solidFill>
-                <a:latin typeface="Noto Sans Kr"/>
-                <a:ea typeface="Noto Sans Kr"/>
-                <a:cs typeface="Noto Sans Kr"/>
-              </a:defRPr>
-            </a:defPPr>
-            <a:lvl1pPr algn="l">
-              <a:defRPr sz="2700" b="0">
-                <a:solidFill>
-                  <a:srgbClr val="566A80"/>
-                </a:solidFill>
-                <a:latin typeface="Noto Sans Kr"/>
-                <a:ea typeface="Noto Sans Kr"/>
-                <a:cs typeface="Noto Sans Kr"/>
-              </a:defRPr>
-            </a:lvl1pPr>
-            <a:lvl2pPr algn="l">
-              <a:defRPr sz="2700" b="0">
-                <a:solidFill>
-                  <a:srgbClr val="566A80"/>
-                </a:solidFill>
-                <a:latin typeface="Noto Sans Kr"/>
-                <a:ea typeface="Noto Sans Kr"/>
-                <a:cs typeface="Noto Sans Kr"/>
-              </a:defRPr>
-            </a:lvl2pPr>
-            <a:lvl3pPr algn="l">
-              <a:defRPr sz="2700" b="0">
-                <a:solidFill>
-                  <a:srgbClr val="566A80"/>
-                </a:solidFill>
-                <a:latin typeface="Noto Sans Kr"/>
-                <a:ea typeface="Noto Sans Kr"/>
-                <a:cs typeface="Noto Sans Kr"/>
-              </a:defRPr>
-            </a:lvl3pPr>
-            <a:lvl4pPr algn="l">
-              <a:defRPr sz="2700" b="0">
-                <a:solidFill>
-                  <a:srgbClr val="566A80"/>
-                </a:solidFill>
-                <a:latin typeface="Noto Sans Kr"/>
-                <a:ea typeface="Noto Sans Kr"/>
-                <a:cs typeface="Noto Sans Kr"/>
-              </a:defRPr>
-            </a:lvl4pPr>
-            <a:lvl5pPr algn="l">
-              <a:defRPr sz="2700" b="0">
-                <a:solidFill>
-                  <a:srgbClr val="566A80"/>
-                </a:solidFill>
-                <a:latin typeface="Noto Sans Kr"/>
-                <a:ea typeface="Noto Sans Kr"/>
-                <a:cs typeface="Noto Sans Kr"/>
-              </a:defRPr>
-            </a:lvl5pPr>
-            <a:lvl6pPr algn="l">
-              <a:defRPr sz="2700" b="0">
-                <a:solidFill>
-                  <a:srgbClr val="566A80"/>
-                </a:solidFill>
-                <a:latin typeface="Noto Sans Kr"/>
-                <a:ea typeface="Noto Sans Kr"/>
-                <a:cs typeface="Noto Sans Kr"/>
-              </a:defRPr>
-            </a:lvl6pPr>
-            <a:lvl7pPr algn="l">
-              <a:defRPr sz="2700" b="0">
-                <a:solidFill>
-                  <a:srgbClr val="566A80"/>
-                </a:solidFill>
-                <a:latin typeface="Noto Sans Kr"/>
-                <a:ea typeface="Noto Sans Kr"/>
-                <a:cs typeface="Noto Sans Kr"/>
-              </a:defRPr>
-            </a:lvl7pPr>
-            <a:lvl8pPr algn="l">
-              <a:defRPr sz="2700" b="0">
-                <a:solidFill>
-                  <a:srgbClr val="566A80"/>
-                </a:solidFill>
-                <a:latin typeface="Noto Sans Kr"/>
-                <a:ea typeface="Noto Sans Kr"/>
-                <a:cs typeface="Noto Sans Kr"/>
-              </a:defRPr>
-            </a:lvl8pPr>
-            <a:lvl9pPr algn="l">
-              <a:defRPr sz="2700" b="0">
-                <a:solidFill>
-                  <a:srgbClr val="566A80"/>
-                </a:solidFill>
-                <a:latin typeface="Noto Sans Kr"/>
-                <a:ea typeface="Noto Sans Kr"/>
-                <a:cs typeface="Noto Sans Kr"/>
-              </a:defRPr>
-            </a:lvl9pPr>
-          </a:lstStyle>
-          <a:p xmlns:a="http://schemas.openxmlformats.org/drawingml/2006/main">
-            <a:pPr algn="l">
-              <a:defRPr sz="2700" b="0">
-                <a:solidFill>
-                  <a:srgbClr val="566A80"/>
-                </a:solidFill>
-                <a:latin typeface="Noto Sans Kr"/>
-                <a:ea typeface="Noto Sans Kr"/>
-                <a:cs typeface="Noto Sans Kr"/>
-              </a:defRPr>
-            </a:pPr>
-            <a:r>
-              <a:rPr sz="2700" b="0">
-                <a:solidFill>
-                  <a:srgbClr val="566A80"/>
-                </a:solidFill>
-                <a:latin typeface="Noto Sans Kr"/>
-                <a:ea typeface="Noto Sans Kr"/>
-                <a:cs typeface="Noto Sans Kr"/>
-              </a:rPr>
-              <a:t>MCP 원문 일치 확인 후 근거 주입</a:t>
-            </a:r>
-          </a:p>
-        </p:txBody>
-      </p:sp>
-      <p:sp>
-        <p:nvSpPr>
-          <p:cNvPr id="17" name="rag-storage">
-            <a:extLst xmlns:a="http://schemas.openxmlformats.org/drawingml/2006/main">
-              <a:ext uri="{FF2B5EF4-FFF2-40B4-BE49-F238E27FC236}">
-                <a16:creationId xmlns:a16="http://schemas.microsoft.com/office/drawing/2014/main" id="{143F0773-BFB4-486F-8C00-5804D1215EAC}"/>
-              </a:ext>
-            </a:extLst>
-          </p:cNvPr>
-          <p:cNvSpPr>
-            <a:spLocks xmlns:a="http://schemas.openxmlformats.org/drawingml/2006/main" noGrp="1"/>
-          </p:cNvSpPr>
-          <p:nvPr/>
-        </p:nvSpPr>
-        <p:spPr>
-          <a:xfrm xmlns:a="http://schemas.openxmlformats.org/drawingml/2006/main">
-            <a:off x="1143000" y="8096250"/>
+            <a:off x="1143000" y="8191500"/>
             <a:ext cx="16002000" cy="523875"/>
           </a:xfrm>
           <a:prstGeom xmlns:a="http://schemas.openxmlformats.org/drawingml/2006/main" prst="rect">
@@ -27170,7 +26422,7 @@
             <a:defPPr algn="l">
               <a:defRPr sz="2850" b="1">
                 <a:solidFill>
-                  <a:srgbClr val="087F7A"/>
+                  <a:srgbClr val="122C46"/>
                 </a:solidFill>
                 <a:latin typeface="Noto Sans Bold"/>
                 <a:ea typeface="Noto Sans Bold"/>
@@ -27180,7 +26432,7 @@
             <a:lvl1pPr algn="l">
               <a:defRPr sz="2850" b="1">
                 <a:solidFill>
-                  <a:srgbClr val="087F7A"/>
+                  <a:srgbClr val="122C46"/>
                 </a:solidFill>
                 <a:latin typeface="Noto Sans Bold"/>
                 <a:ea typeface="Noto Sans Bold"/>
@@ -27190,7 +26442,7 @@
             <a:lvl2pPr algn="l">
               <a:defRPr sz="2850" b="1">
                 <a:solidFill>
-                  <a:srgbClr val="087F7A"/>
+                  <a:srgbClr val="122C46"/>
                 </a:solidFill>
                 <a:latin typeface="Noto Sans Bold"/>
                 <a:ea typeface="Noto Sans Bold"/>
@@ -27200,7 +26452,7 @@
             <a:lvl3pPr algn="l">
               <a:defRPr sz="2850" b="1">
                 <a:solidFill>
-                  <a:srgbClr val="087F7A"/>
+                  <a:srgbClr val="122C46"/>
                 </a:solidFill>
                 <a:latin typeface="Noto Sans Bold"/>
                 <a:ea typeface="Noto Sans Bold"/>
@@ -27210,7 +26462,7 @@
             <a:lvl4pPr algn="l">
               <a:defRPr sz="2850" b="1">
                 <a:solidFill>
-                  <a:srgbClr val="087F7A"/>
+                  <a:srgbClr val="122C46"/>
                 </a:solidFill>
                 <a:latin typeface="Noto Sans Bold"/>
                 <a:ea typeface="Noto Sans Bold"/>
@@ -27220,7 +26472,7 @@
             <a:lvl5pPr algn="l">
               <a:defRPr sz="2850" b="1">
                 <a:solidFill>
-                  <a:srgbClr val="087F7A"/>
+                  <a:srgbClr val="122C46"/>
                 </a:solidFill>
                 <a:latin typeface="Noto Sans Bold"/>
                 <a:ea typeface="Noto Sans Bold"/>
@@ -27230,7 +26482,7 @@
             <a:lvl6pPr algn="l">
               <a:defRPr sz="2850" b="1">
                 <a:solidFill>
-                  <a:srgbClr val="087F7A"/>
+                  <a:srgbClr val="122C46"/>
                 </a:solidFill>
                 <a:latin typeface="Noto Sans Bold"/>
                 <a:ea typeface="Noto Sans Bold"/>
@@ -27240,7 +26492,7 @@
             <a:lvl7pPr algn="l">
               <a:defRPr sz="2850" b="1">
                 <a:solidFill>
-                  <a:srgbClr val="087F7A"/>
+                  <a:srgbClr val="122C46"/>
                 </a:solidFill>
                 <a:latin typeface="Noto Sans Bold"/>
                 <a:ea typeface="Noto Sans Bold"/>
@@ -27250,7 +26502,7 @@
             <a:lvl8pPr algn="l">
               <a:defRPr sz="2850" b="1">
                 <a:solidFill>
-                  <a:srgbClr val="087F7A"/>
+                  <a:srgbClr val="122C46"/>
                 </a:solidFill>
                 <a:latin typeface="Noto Sans Bold"/>
                 <a:ea typeface="Noto Sans Bold"/>
@@ -27260,7 +26512,7 @@
             <a:lvl9pPr algn="l">
               <a:defRPr sz="2850" b="1">
                 <a:solidFill>
-                  <a:srgbClr val="087F7A"/>
+                  <a:srgbClr val="122C46"/>
                 </a:solidFill>
                 <a:latin typeface="Noto Sans Bold"/>
                 <a:ea typeface="Noto Sans Bold"/>
@@ -27272,7 +26524,7 @@
             <a:pPr algn="l">
               <a:defRPr sz="2850" b="1">
                 <a:solidFill>
-                  <a:srgbClr val="087F7A"/>
+                  <a:srgbClr val="122C46"/>
                 </a:solidFill>
                 <a:latin typeface="Noto Sans Bold"/>
                 <a:ea typeface="Noto Sans Bold"/>
@@ -27282,13 +26534,13 @@
             <a:r>
               <a:rPr sz="2850" b="1">
                 <a:solidFill>
-                  <a:srgbClr val="087F7A"/>
+                  <a:srgbClr val="122C46"/>
                 </a:solidFill>
                 <a:latin typeface="Noto Sans Bold"/>
                 <a:ea typeface="Noto Sans Bold"/>
                 <a:cs typeface="Noto Sans Bold"/>
               </a:rPr>
-              <a:t>SQLite 벡터 저장·NumPy 유사도 계산</a:t>
+              <a:t>MCP 원문 대조·문서 ID·검색 유사도 기록</a:t>
             </a:r>
           </a:p>
         </p:txBody>
@@ -27296,7 +26548,7 @@
     </p:spTree>
     <p:extLst>
       <p:ext uri="{BB962C8B-B14F-4D97-AF65-F5344CB8AC3E}">
-        <p14:creationId xmlns:p14="http://schemas.microsoft.com/office/powerpoint/2010/main" val="1643803215"/>
+        <p14:creationId xmlns:p14="http://schemas.microsoft.com/office/powerpoint/2010/main" val="1639041552"/>
       </p:ext>
     </p:extLst>
   </p:cSld>
@@ -27327,7 +26579,7 @@
           <p:cNvPr id="13" name="section-label">
             <a:extLst xmlns:a="http://schemas.openxmlformats.org/drawingml/2006/main">
               <a:ext uri="{FF2B5EF4-FFF2-40B4-BE49-F238E27FC236}">
-                <a16:creationId xmlns:a16="http://schemas.microsoft.com/office/drawing/2014/main" id="{A738C02C-AA04-4A7A-80C1-845A0231374F}"/>
+                <a16:creationId xmlns:a16="http://schemas.microsoft.com/office/drawing/2014/main" id="{67345D4B-B26E-4E6F-A565-D8D57FB39A3C}"/>
               </a:ext>
             </a:extLst>
           </p:cNvPr>
@@ -27475,7 +26727,7 @@
                 <a:ea typeface="Noto Sans Bold"/>
                 <a:cs typeface="Noto Sans Bold"/>
               </a:rPr>
-              <a:t>실행 결과: 보고서 검증</a:t>
+              <a:t>개선 5: 보고서 검증과 재작성</a:t>
             </a:r>
           </a:p>
         </p:txBody>
@@ -27485,7 +26737,7 @@
           <p:cNvPr id="2" name="page-number">
             <a:extLst xmlns:a="http://schemas.openxmlformats.org/drawingml/2006/main">
               <a:ext uri="{FF2B5EF4-FFF2-40B4-BE49-F238E27FC236}">
-                <a16:creationId xmlns:a16="http://schemas.microsoft.com/office/drawing/2014/main" id="{802FB6AC-D147-4A57-B2E5-8BF4576CF275}"/>
+                <a16:creationId xmlns:a16="http://schemas.microsoft.com/office/drawing/2014/main" id="{3386A707-F62C-4196-8DE7-6BBF43D5A2CC}"/>
               </a:ext>
             </a:extLst>
           </p:cNvPr>
@@ -27643,7 +26895,7 @@
           <p:cNvPr id="3" name="slide-title">
             <a:extLst xmlns:a="http://schemas.openxmlformats.org/drawingml/2006/main">
               <a:ext uri="{FF2B5EF4-FFF2-40B4-BE49-F238E27FC236}">
-                <a16:creationId xmlns:a16="http://schemas.microsoft.com/office/drawing/2014/main" id="{11795942-A1CA-495C-9A5D-4B0805255EFF}"/>
+                <a16:creationId xmlns:a16="http://schemas.microsoft.com/office/drawing/2014/main" id="{D2642429-C35F-489B-B1D8-6B3721A79989}"/>
               </a:ext>
             </a:extLst>
           </p:cNvPr>
@@ -27791,7 +27043,7 @@
                 <a:ea typeface="Noto Sans Bold"/>
                 <a:cs typeface="Noto Sans Bold"/>
               </a:rPr>
-              <a:t>실제 보고서 검증 화면</a:t>
+              <a:t>형식 검사에서 사실 검증으로</a:t>
             </a:r>
           </a:p>
         </p:txBody>
@@ -27801,7 +27053,7 @@
           <p:cNvPr id="4" name="slide-subtitle">
             <a:extLst xmlns:a="http://schemas.openxmlformats.org/drawingml/2006/main">
               <a:ext uri="{FF2B5EF4-FFF2-40B4-BE49-F238E27FC236}">
-                <a16:creationId xmlns:a16="http://schemas.microsoft.com/office/drawing/2014/main" id="{0DE9F5DA-A0C2-4E4F-9B2A-3D860E91838D}"/>
+                <a16:creationId xmlns:a16="http://schemas.microsoft.com/office/drawing/2014/main" id="{B4C6C44C-EE3A-4C5A-8357-CEAD6D3A20C5}"/>
               </a:ext>
             </a:extLst>
           </p:cNvPr>
@@ -27949,7 +27201,7 @@
                 <a:ea typeface="Noto Sans Kr"/>
                 <a:cs typeface="Noto Sans Kr"/>
               </a:rPr>
-              <a:t>후보 보고서를 검사하고, 누락을 보완해 다시 작성합니다.</a:t>
+              <a:t>길이·번호 검사에 수치·출처·조치 조건 검증을 더했습니다.</a:t>
             </a:r>
           </a:p>
         </p:txBody>
@@ -27959,7 +27211,7 @@
           <p:cNvPr id="5" name="scope-note">
             <a:extLst xmlns:a="http://schemas.openxmlformats.org/drawingml/2006/main">
               <a:ext uri="{FF2B5EF4-FFF2-40B4-BE49-F238E27FC236}">
-                <a16:creationId xmlns:a16="http://schemas.microsoft.com/office/drawing/2014/main" id="{51FFC7C0-4B47-4D38-8A0A-C071CB661999}"/>
+                <a16:creationId xmlns:a16="http://schemas.microsoft.com/office/drawing/2014/main" id="{FAC7B675-09A7-480D-B21B-29C8A17ED375}"/>
               </a:ext>
             </a:extLst>
           </p:cNvPr>
@@ -28117,7 +27369,7 @@
           <p:cNvPr id="6" name="footer-rule">
             <a:extLst xmlns:a="http://schemas.openxmlformats.org/drawingml/2006/main">
               <a:ext uri="{FF2B5EF4-FFF2-40B4-BE49-F238E27FC236}">
-                <a16:creationId xmlns:a16="http://schemas.microsoft.com/office/drawing/2014/main" id="{38EBB03F-DB16-4990-8942-7ABF2EAECA67}"/>
+                <a16:creationId xmlns:a16="http://schemas.microsoft.com/office/drawing/2014/main" id="{505FD9B3-1DE8-4FE3-A980-0E8A79296CDD}"/>
               </a:ext>
             </a:extLst>
           </p:cNvPr>
@@ -28144,7 +27396,7 @@
           <p:cNvPr id="7" name="footer">
             <a:extLst xmlns:a="http://schemas.openxmlformats.org/drawingml/2006/main">
               <a:ext uri="{FF2B5EF4-FFF2-40B4-BE49-F238E27FC236}">
-                <a16:creationId xmlns:a16="http://schemas.microsoft.com/office/drawing/2014/main" id="{BE492E55-E8AA-42FE-A221-03329341C73B}"/>
+                <a16:creationId xmlns:a16="http://schemas.microsoft.com/office/drawing/2014/main" id="{0F34B19E-7516-46C9-9FB4-03A2D7E19980}"/>
               </a:ext>
             </a:extLst>
           </p:cNvPr>
@@ -28302,7 +27554,7 @@
           <p:cNvPr id="8" name="validation-first-title">
             <a:extLst xmlns:a="http://schemas.openxmlformats.org/drawingml/2006/main">
               <a:ext uri="{FF2B5EF4-FFF2-40B4-BE49-F238E27FC236}">
-                <a16:creationId xmlns:a16="http://schemas.microsoft.com/office/drawing/2014/main" id="{74861BB8-908E-4949-BEB6-03C4438A8FDC}"/>
+                <a16:creationId xmlns:a16="http://schemas.microsoft.com/office/drawing/2014/main" id="{9541A65B-1842-48A5-878D-080234A33799}"/>
               </a:ext>
             </a:extLst>
           </p:cNvPr>
@@ -28450,7 +27702,7 @@
                 <a:ea typeface="Noto Sans Bold"/>
                 <a:cs typeface="Noto Sans Bold"/>
               </a:rPr>
-              <a:t>1차 작성</a:t>
+              <a:t>추가한 사실 검증</a:t>
             </a:r>
           </a:p>
         </p:txBody>
@@ -28460,7 +27712,7 @@
           <p:cNvPr id="9" name="validation-first-body">
             <a:extLst xmlns:a="http://schemas.openxmlformats.org/drawingml/2006/main">
               <a:ext uri="{FF2B5EF4-FFF2-40B4-BE49-F238E27FC236}">
-                <a16:creationId xmlns:a16="http://schemas.microsoft.com/office/drawing/2014/main" id="{CD9E3C17-72EB-4281-AFBD-C3DF365BAEB5}"/>
+                <a16:creationId xmlns:a16="http://schemas.microsoft.com/office/drawing/2014/main" id="{0FF732FF-4139-450F-A05B-CC08EDF32296}"/>
               </a:ext>
             </a:extLst>
           </p:cNvPr>
@@ -28608,7 +27860,7 @@
                 <a:ea typeface="Noto Sans Kr"/>
                 <a:cs typeface="Noto Sans Kr"/>
               </a:rPr>
-              <a:t>다음 행동 누락으로 불합격</a:t>
+              <a:t>시스템·수치·출처·조치 조건</a:t>
             </a:r>
           </a:p>
         </p:txBody>
@@ -28618,7 +27870,7 @@
           <p:cNvPr id="10" name="validation-second-title">
             <a:extLst xmlns:a="http://schemas.openxmlformats.org/drawingml/2006/main">
               <a:ext uri="{FF2B5EF4-FFF2-40B4-BE49-F238E27FC236}">
-                <a16:creationId xmlns:a16="http://schemas.microsoft.com/office/drawing/2014/main" id="{D20D96DA-F7B3-4599-84A4-408D6F193C65}"/>
+                <a16:creationId xmlns:a16="http://schemas.microsoft.com/office/drawing/2014/main" id="{A220F795-A985-4996-A7A7-F3BA4ECAFBE2}"/>
               </a:ext>
             </a:extLst>
           </p:cNvPr>
@@ -28766,7 +28018,7 @@
                 <a:ea typeface="Noto Sans Bold"/>
                 <a:cs typeface="Noto Sans Bold"/>
               </a:rPr>
-              <a:t>재작성 후 2차 통과</a:t>
+              <a:t>실제 결과: 2차 통과</a:t>
             </a:r>
           </a:p>
         </p:txBody>
@@ -28776,7 +28028,7 @@
           <p:cNvPr id="11" name="validation-second-body">
             <a:extLst xmlns:a="http://schemas.openxmlformats.org/drawingml/2006/main">
               <a:ext uri="{FF2B5EF4-FFF2-40B4-BE49-F238E27FC236}">
-                <a16:creationId xmlns:a16="http://schemas.microsoft.com/office/drawing/2014/main" id="{2B854578-1238-4BE6-97BD-CC29841474ED}"/>
+                <a16:creationId xmlns:a16="http://schemas.microsoft.com/office/drawing/2014/main" id="{16DA78A8-5035-43B5-8F5F-F7AC26C51765}"/>
               </a:ext>
             </a:extLst>
           </p:cNvPr>
@@ -28924,7 +28176,7 @@
                 <a:ea typeface="Noto Sans Kr"/>
                 <a:cs typeface="Noto Sans Kr"/>
               </a:rPr>
-              <a:t>작성·재작성 횟수를 화면에 기록</a:t>
+              <a:t>다음 행동 누락 보완·재작성 1회</a:t>
             </a:r>
           </a:p>
         </p:txBody>
@@ -28934,7 +28186,7 @@
           <p:cNvPr id="12" name="">
             <a:extLst xmlns:a="http://schemas.openxmlformats.org/drawingml/2006/main">
               <a:ext uri="{FF2B5EF4-FFF2-40B4-BE49-F238E27FC236}">
-                <a16:creationId xmlns:a16="http://schemas.microsoft.com/office/drawing/2014/main" id="{13343CF6-B2F3-4014-8340-05094D72435F}"/>
+                <a16:creationId xmlns:a16="http://schemas.microsoft.com/office/drawing/2014/main" id="{E281FFEF-9005-49B7-9C8D-37928A3A96A2}"/>
               </a:ext>
             </a:extLst>
           </p:cNvPr>
@@ -28944,7 +28196,7 @@
           <p:nvPr/>
         </p:nvPicPr>
         <p:blipFill>
-          <a:blip xmlns:r="http://schemas.openxmlformats.org/officeDocument/2006/relationships" xmlns:a="http://schemas.openxmlformats.org/drawingml/2006/main" r:embed="R4e0c2d9724904459"/>
+          <a:blip xmlns:r="http://schemas.openxmlformats.org/officeDocument/2006/relationships" xmlns:a="http://schemas.openxmlformats.org/drawingml/2006/main" r:embed="Rb1642db8583f48a4"/>
           <a:srcRect xmlns:a="http://schemas.openxmlformats.org/drawingml/2006/main" l="78516" t="35833" r="1953" b="41944"/>
           <a:stretch xmlns:a="http://schemas.openxmlformats.org/drawingml/2006/main"/>
         </p:blipFill>
@@ -28961,7 +28213,7 @@
     </p:spTree>
     <p:extLst>
       <p:ext uri="{BB962C8B-B14F-4D97-AF65-F5344CB8AC3E}">
-        <p14:creationId xmlns:p14="http://schemas.microsoft.com/office/powerpoint/2010/main" val="1386597113"/>
+        <p14:creationId xmlns:p14="http://schemas.microsoft.com/office/powerpoint/2010/main" val="738202859"/>
       </p:ext>
     </p:extLst>
   </p:cSld>

</xml_diff>